<commit_message>
docs: add protocol adapter roadmap and Agent Conf slides
</commit_message>
<xml_diff>
--- a/presentation/Agents_Commander_Protocol.pptx
+++ b/presentation/Agents_Commander_Protocol.pptx
@@ -2,30 +2,32 @@
 <file path=ppt/presentation.xml><?xml version="1.0" encoding="utf-8"?>
 <p:presentation xmlns:p="http://schemas.openxmlformats.org/presentationml/2006/main">
   <p:sldMasterIdLst>
-    <p:sldMasterId xmlns:r="http://schemas.openxmlformats.org/officeDocument/2006/relationships" id="2147483648" r:id="R885442dd8bac4299"/>
+    <p:sldMasterId xmlns:r="http://schemas.openxmlformats.org/officeDocument/2006/relationships" id="2147483648" r:id="Rc5baa0eb05d84145"/>
   </p:sldMasterIdLst>
   <p:notesMasterIdLst>
-    <p:notesMasterId xmlns:r="http://schemas.openxmlformats.org/officeDocument/2006/relationships" r:id="R86df1ab7f8df411a"/>
+    <p:notesMasterId xmlns:r="http://schemas.openxmlformats.org/officeDocument/2006/relationships" r:id="Rcff25e687ad04667"/>
   </p:notesMasterIdLst>
   <p:sldIdLst>
-    <p:sldId xmlns:r="http://schemas.openxmlformats.org/officeDocument/2006/relationships" id="256" r:id="R06d534edb7114b23"/>
-    <p:sldId xmlns:r="http://schemas.openxmlformats.org/officeDocument/2006/relationships" id="257" r:id="R585723233e8248c7"/>
-    <p:sldId xmlns:r="http://schemas.openxmlformats.org/officeDocument/2006/relationships" id="258" r:id="R93cb2ec052534383"/>
-    <p:sldId xmlns:r="http://schemas.openxmlformats.org/officeDocument/2006/relationships" id="259" r:id="R01e0b94df76a4dc5"/>
-    <p:sldId xmlns:r="http://schemas.openxmlformats.org/officeDocument/2006/relationships" id="260" r:id="R091d5df6c2b4494c"/>
-    <p:sldId xmlns:r="http://schemas.openxmlformats.org/officeDocument/2006/relationships" id="261" r:id="R9a5720b5e89746e0"/>
-    <p:sldId xmlns:r="http://schemas.openxmlformats.org/officeDocument/2006/relationships" id="262" r:id="R13b960d3218a47d2"/>
-    <p:sldId xmlns:r="http://schemas.openxmlformats.org/officeDocument/2006/relationships" id="263" r:id="Rafbb96f68b8247ee"/>
-    <p:sldId xmlns:r="http://schemas.openxmlformats.org/officeDocument/2006/relationships" id="264" r:id="R79d4ba08b0f0474a"/>
-    <p:sldId xmlns:r="http://schemas.openxmlformats.org/officeDocument/2006/relationships" id="265" r:id="R0fb61c1a686f48a1"/>
-    <p:sldId xmlns:r="http://schemas.openxmlformats.org/officeDocument/2006/relationships" id="266" r:id="R164300d88f034997"/>
-    <p:sldId xmlns:r="http://schemas.openxmlformats.org/officeDocument/2006/relationships" id="267" r:id="Raf07a07bcb3d48af"/>
-    <p:sldId xmlns:r="http://schemas.openxmlformats.org/officeDocument/2006/relationships" id="268" r:id="R871d26ff71604fe0"/>
-    <p:sldId xmlns:r="http://schemas.openxmlformats.org/officeDocument/2006/relationships" id="269" r:id="Raca458c938234810"/>
-    <p:sldId xmlns:r="http://schemas.openxmlformats.org/officeDocument/2006/relationships" id="270" r:id="R7dbf715fc22e4f48"/>
-    <p:sldId xmlns:r="http://schemas.openxmlformats.org/officeDocument/2006/relationships" id="271" r:id="Rfc502441ba5b46a2"/>
-    <p:sldId xmlns:r="http://schemas.openxmlformats.org/officeDocument/2006/relationships" id="272" r:id="Rc6996c52b2fd42e9"/>
-    <p:sldId xmlns:r="http://schemas.openxmlformats.org/officeDocument/2006/relationships" id="273" r:id="Rd556883fb55d4663"/>
+    <p:sldId xmlns:r="http://schemas.openxmlformats.org/officeDocument/2006/relationships" id="256" r:id="R2da3c1ca2d1a4bbf"/>
+    <p:sldId xmlns:r="http://schemas.openxmlformats.org/officeDocument/2006/relationships" id="257" r:id="Refdb66479f3c4024"/>
+    <p:sldId xmlns:r="http://schemas.openxmlformats.org/officeDocument/2006/relationships" id="258" r:id="Rc6613c40abf44781"/>
+    <p:sldId xmlns:r="http://schemas.openxmlformats.org/officeDocument/2006/relationships" id="259" r:id="R039fa3364c37404d"/>
+    <p:sldId xmlns:r="http://schemas.openxmlformats.org/officeDocument/2006/relationships" id="260" r:id="R83e8e6fe90604c3a"/>
+    <p:sldId xmlns:r="http://schemas.openxmlformats.org/officeDocument/2006/relationships" id="261" r:id="R44dd34c9856846e4"/>
+    <p:sldId xmlns:r="http://schemas.openxmlformats.org/officeDocument/2006/relationships" id="262" r:id="R8070c4a6c9a9417e"/>
+    <p:sldId xmlns:r="http://schemas.openxmlformats.org/officeDocument/2006/relationships" id="263" r:id="R248cf438df9c4505"/>
+    <p:sldId xmlns:r="http://schemas.openxmlformats.org/officeDocument/2006/relationships" id="264" r:id="R88b311454bca456d"/>
+    <p:sldId xmlns:r="http://schemas.openxmlformats.org/officeDocument/2006/relationships" id="265" r:id="Rff90358d008d4226"/>
+    <p:sldId xmlns:r="http://schemas.openxmlformats.org/officeDocument/2006/relationships" id="266" r:id="Rf3abd9dce179473b"/>
+    <p:sldId xmlns:r="http://schemas.openxmlformats.org/officeDocument/2006/relationships" id="267" r:id="R250f607211cb48a0"/>
+    <p:sldId xmlns:r="http://schemas.openxmlformats.org/officeDocument/2006/relationships" id="268" r:id="R840cbd292b6146c4"/>
+    <p:sldId xmlns:r="http://schemas.openxmlformats.org/officeDocument/2006/relationships" id="269" r:id="R0bb49b00d2c34e0a"/>
+    <p:sldId xmlns:r="http://schemas.openxmlformats.org/officeDocument/2006/relationships" id="270" r:id="R370244b085cc4769"/>
+    <p:sldId xmlns:r="http://schemas.openxmlformats.org/officeDocument/2006/relationships" id="271" r:id="R12fbb3a6c0d24426"/>
+    <p:sldId xmlns:r="http://schemas.openxmlformats.org/officeDocument/2006/relationships" id="272" r:id="Re2b650e660ac4b7e"/>
+    <p:sldId xmlns:r="http://schemas.openxmlformats.org/officeDocument/2006/relationships" id="273" r:id="R714c9159328e4936"/>
+    <p:sldId xmlns:r="http://schemas.openxmlformats.org/officeDocument/2006/relationships" id="274" r:id="R519b7dd184634639"/>
+    <p:sldId xmlns:r="http://schemas.openxmlformats.org/officeDocument/2006/relationships" id="275" r:id="R696af1007f7c4378"/>
   </p:sldIdLst>
   <p:sldSz cx="12191695" cy="6858000"/>
   <p:notesSz cx="6858000" cy="9144000"/>
@@ -797,7 +799,7 @@
           </a:p>
           <a:p xmlns:a="http://schemas.openxmlformats.org/drawingml/2006/main">
             <a:r>
-              <a:t>2 minutes</a:t>
+              <a:t>1.5 minutes</a:t>
             </a:r>
           </a:p>
           <a:p xmlns:a="http://schemas.openxmlformats.org/drawingml/2006/main">
@@ -1512,7 +1514,7 @@
           </a:p>
           <a:p xmlns:a="http://schemas.openxmlformats.org/drawingml/2006/main">
             <a:r>
-              <a:t>2 minutes</a:t>
+              <a:t>1.5 minutes</a:t>
             </a:r>
           </a:p>
           <a:p xmlns:a="http://schemas.openxmlformats.org/drawingml/2006/main">
@@ -1522,7 +1524,7 @@
           </a:p>
           <a:p xmlns:a="http://schemas.openxmlformats.org/drawingml/2006/main">
             <a:r>
-              <a:t>2 minutes. This is a recovery policy, not a retry loop. At 45 seconds per response or any auth/provider/routing failure, inspect F12 once, describe only what is visible, and stop waiting. Use the deterministic offline runtime to prove transport; use the prepared slide 13 content to discuss proposal/challenge/refinement, clearly labeled as prepared. If Micro fails, use a normal keyboard; no agent depends on it. Ctrl+K stops an active session. F10 escalates tracked process groups from SIGINT through SIGTERM to SIGKILL, waits, and restores the terminal. Do not clear a running layout accidentally: focus a file panel before Ctrl+E and confirm live sessions.</a:t>
+              <a:t>1.5 minutes. This is a recovery policy, not a retry loop. At 45 seconds per response or any auth/provider/routing failure, inspect F12 once, describe only what is visible, and stop waiting. Use the deterministic offline runtime to prove transport; use the prepared slide 13 content to discuss proposal/challenge/refinement, clearly labeled as prepared. If Micro fails, use a normal keyboard; no agent depends on it. Ctrl+K stops an active session. F10 escalates tracked process groups from SIGINT through SIGTERM to SIGKILL, waits, and restores the terminal. Do not clear a running layout accidentally: focus a file panel before Ctrl+E and confirm live sessions.</a:t>
             </a:r>
           </a:p>
           <a:p xmlns:a="http://schemas.openxmlformats.org/drawingml/2006/main">
@@ -1787,7 +1789,12 @@
           <a:lstStyle xmlns:a="http://schemas.openxmlformats.org/drawingml/2006/main"/>
           <a:p xmlns:a="http://schemas.openxmlformats.org/drawingml/2006/main">
             <a:r>
-              <a:t>[Timing] 5:00</a:t>
+              <a:t>[Timing]</a:t>
+            </a:r>
+          </a:p>
+          <a:p xmlns:a="http://schemas.openxmlformats.org/drawingml/2006/main">
+            <a:r>
+              <a:t>1 minute</a:t>
             </a:r>
           </a:p>
           <a:p xmlns:a="http://schemas.openxmlformats.org/drawingml/2006/main">
@@ -1797,7 +1804,7 @@
           </a:p>
           <a:p xmlns:a="http://schemas.openxmlformats.org/drawingml/2006/main">
             <a:r>
-              <a:t>Use the prompts to structure Q&amp;A: what evidence must survive each handoff, when one agent should challenge another, and where a human interruption is mandatory.</a:t>
+              <a:t>Today, Agents Commander can capture its communication layer with explicit consent and turn reviewed examples into structured training data. The next step is to teach a trainable model the Commander Protocol through a LoRA adapter: how to address another agent, return a reply, and produce a complete frame. The ambition is broad model interoperability, not one universal adapter. The dataset can be reused, but each adapter needs a compatible base model, tokenizer and training configuration. We would compare the adapted model with the prompted base model on unseen project groups: frame validity, routing behavior and useful collaboration. Training and model evaluation are future work, not completed results. Commander’s runtime guards remain in control.</a:t>
             </a:r>
           </a:p>
           <a:p xmlns:a="http://schemas.openxmlformats.org/drawingml/2006/main">
@@ -1807,7 +1814,12 @@
           </a:p>
           <a:p xmlns:a="http://schemas.openxmlformats.org/drawingml/2006/main">
             <a:r>
-              <a:t>If questions are slow, ask: “Would you authorize one agent to broadcast to every other agent automatically? What evidence would make that safe?”</a:t>
+              <a:t>[Caveats]</a:t>
+            </a:r>
+          </a:p>
+          <a:p xmlns:a="http://schemas.openxmlformats.org/drawingml/2006/main">
+            <a:r>
+              <a:t>Capture observes Commander-mediated context, not full provider state or hidden reasoning. Real and synthetic data remain separate. Quality, context, privacy and rights are explicitly reviewed; transport success is not a quality label. Closed models without weight access cannot receive these LoRA weights. No model download, tokenization or training has run.</a:t>
             </a:r>
           </a:p>
           <a:p xmlns:a="http://schemas.openxmlformats.org/drawingml/2006/main">
@@ -1817,7 +1829,32 @@
           </a:p>
           <a:p xmlns:a="http://schemas.openxmlformats.org/drawingml/2006/main">
             <a:r>
-              <a:t>End with the practical boundary: Commander can make transport visible and controllable; it does not make model reasoning correct, disagreement resolved, or history durable by itself.</a:t>
+              <a:t>[Sources]</a:t>
+            </a:r>
+          </a:p>
+          <a:p xmlns:a="http://schemas.openxmlformats.org/drawingml/2006/main">
+            <a:r>
+              <a:t>https://github.com/lech-kalinowski/agents-commander/commit/08d6386 — implemented capture and dataset pipeline.</a:t>
+            </a:r>
+          </a:p>
+          <a:p xmlns:a="http://schemas.openxmlformats.org/drawingml/2006/main">
+            <a:r>
+              <a:t>/Users/lech.kalinowski/products/agents commander/docs/datasets.md — review gates, structured JSONL, splits and model-specific acceptance checks.</a:t>
+            </a:r>
+          </a:p>
+          <a:p xmlns:a="http://schemas.openxmlformats.org/drawingml/2006/main">
+            <a:r>
+              <a:t>https://huggingface.co/docs/trl/sft_trainer — conversational prompt/completion and model-specific chat templating.</a:t>
+            </a:r>
+          </a:p>
+          <a:p xmlns:a="http://schemas.openxmlformats.org/drawingml/2006/main">
+            <a:r>
+              <a:t>https://huggingface.co/docs/peft/developer_guides/checkpoint — adapter configuration and compatible base-model requirement.</a:t>
+            </a:r>
+          </a:p>
+          <a:p xmlns:a="http://schemas.openxmlformats.org/drawingml/2006/main">
+            <a:r>
+              <a:t>https://www.callstack.com/media-kit — inherited Callstack visual identity.</a:t>
             </a:r>
           </a:p>
           <a:p xmlns:a="http://schemas.openxmlformats.org/drawingml/2006/main">
@@ -1825,6 +1862,96 @@
               <a:t/>
             </a:r>
           </a:p>
+        </p:txBody>
+      </p:sp>
+      <p:sp>
+        <p:nvSpPr>
+          <p:cNvPr id="4" name="Slide Number Placeholder 3"/>
+          <p:cNvSpPr>
+            <a:spLocks xmlns:a="http://schemas.openxmlformats.org/drawingml/2006/main" noGrp="1"/>
+          </p:cNvSpPr>
+          <p:nvPr>
+            <p:ph type="sldNum" idx="5"/>
+          </p:nvPr>
+        </p:nvSpPr>
+        <p:spPr/>
+        <p:txBody>
+          <a:bodyPr xmlns:a="http://schemas.openxmlformats.org/drawingml/2006/main"/>
+          <a:lstStyle xmlns:a="http://schemas.openxmlformats.org/drawingml/2006/main"/>
+          <a:p xmlns:a="http://schemas.openxmlformats.org/drawingml/2006/main"/>
+        </p:txBody>
+      </p:sp>
+    </p:spTree>
+  </p:cSld>
+  <p:clrMapOvr>
+    <a:masterClrMapping xmlns:a="http://schemas.openxmlformats.org/drawingml/2006/main"/>
+  </p:clrMapOvr>
+</p:notes>
+</file>
+
+<file path=ppt/notesSlides/notesSlide19.xml><?xml version="1.0" encoding="utf-8"?>
+<p:notes xmlns:p="http://schemas.openxmlformats.org/presentationml/2006/main">
+  <p:cSld>
+    <p:spTree>
+      <p:nvGrpSpPr>
+        <p:cNvPr id="1" name=""/>
+        <p:cNvGrpSpPr/>
+        <p:nvPr/>
+      </p:nvGrpSpPr>
+      <p:grpSpPr>
+        <a:xfrm xmlns:a="http://schemas.openxmlformats.org/drawingml/2006/main"/>
+      </p:grpSpPr>
+      <p:sp>
+        <p:nvSpPr>
+          <p:cNvPr id="2" name="Slide Image Placeholder 1"/>
+          <p:cNvSpPr>
+            <a:spLocks xmlns:a="http://schemas.openxmlformats.org/drawingml/2006/main" noGrp="1"/>
+          </p:cNvSpPr>
+          <p:nvPr>
+            <p:ph type="sldImg" idx="0"/>
+          </p:nvPr>
+        </p:nvSpPr>
+        <p:spPr/>
+      </p:sp>
+      <p:sp>
+        <p:nvSpPr>
+          <p:cNvPr id="3" name="Notes Placeholder 2"/>
+          <p:cNvSpPr>
+            <a:spLocks xmlns:a="http://schemas.openxmlformats.org/drawingml/2006/main" noGrp="1"/>
+          </p:cNvSpPr>
+          <p:nvPr>
+            <p:ph type="body" idx="1"/>
+          </p:nvPr>
+        </p:nvSpPr>
+        <p:spPr/>
+        <p:txBody>
+          <a:bodyPr xmlns:a="http://schemas.openxmlformats.org/drawingml/2006/main"/>
+          <a:lstStyle xmlns:a="http://schemas.openxmlformats.org/drawingml/2006/main"/>
+          <a:p xmlns:a="http://schemas.openxmlformats.org/drawingml/2006/main">
+            <a:r>
+              <a:t>[Timing]</a:t>
+            </a:r>
+          </a:p>
+          <a:p xmlns:a="http://schemas.openxmlformats.org/drawingml/2006/main">
+            <a:r>
+              <a:t>0.5 minutes</a:t>
+            </a:r>
+          </a:p>
+          <a:p xmlns:a="http://schemas.openxmlformats.org/drawingml/2006/main">
+            <a:r>
+              <a:t/>
+            </a:r>
+          </a:p>
+          <a:p xmlns:a="http://schemas.openxmlformats.org/drawingml/2006/main">
+            <a:r>
+              <a:t>If today’s local agent collaboration raises questions you want to keep exploring, join us at Agent Conf in Warsaw on 17–18 September 2026. Callstack is bringing engineers together around agent engineering, multi-agent orchestration and lessons from real adoption. The venue is Crowne Plaza Warsaw [The HUB]. Show the ticket link, then return to questions. No price or discount is promised. Event details checked 2026-09-02; recheck before presenting.</a:t>
+            </a:r>
+          </a:p>
+          <a:p xmlns:a="http://schemas.openxmlformats.org/drawingml/2006/main">
+            <a:r>
+              <a:t/>
+            </a:r>
+          </a:p>
           <a:p xmlns:a="http://schemas.openxmlformats.org/drawingml/2006/main">
             <a:r>
               <a:t>[Sources]</a:t>
@@ -1832,72 +1959,37 @@
           </a:p>
           <a:p xmlns:a="http://schemas.openxmlformats.org/drawingml/2006/main">
             <a:r>
-              <a:t>- https://codeeurope.pl/speakers</a:t>
-            </a:r>
-          </a:p>
-          <a:p xmlns:a="http://schemas.openxmlformats.org/drawingml/2006/main">
-            <a:r>
-              <a:t>- https://www.callstack.com/events/no-framework-no-server-making-ai-agents-collaborate-in-one-terminal</a:t>
-            </a:r>
-          </a:p>
-          <a:p xmlns:a="http://schemas.openxmlformats.org/drawingml/2006/main">
-            <a:r>
-              <a:t>- /Users/lech.kalinowski/products/agents commander/README.md</a:t>
-            </a:r>
-          </a:p>
-          <a:p xmlns:a="http://schemas.openxmlformats.org/drawingml/2006/main">
-            <a:r>
-              <a:t>- /Users/lech.kalinowski/products/agents commander/src/orchestration/protocol.ts</a:t>
-            </a:r>
-          </a:p>
-          <a:p xmlns:a="http://schemas.openxmlformats.org/drawingml/2006/main">
-            <a:r>
-              <a:t>- /Users/lech.kalinowski/products/agents commander/src/orchestration/message-ledger.ts</a:t>
+              <a:t>https://www.agent.sh/ — official event dates, city, venue and program themes.</a:t>
+            </a:r>
+          </a:p>
+          <a:p xmlns:a="http://schemas.openxmlformats.org/drawingml/2006/main">
+            <a:r>
+              <a:t>https://www.agent.sh/tickets — ticket destination.</a:t>
+            </a:r>
+          </a:p>
+          <a:p xmlns:a="http://schemas.openxmlformats.org/drawingml/2006/main">
+            <a:r>
+              <a:t>https://www.callstack.com/events/agent-conf — Callstack organizer, dates and city.</a:t>
+            </a:r>
+          </a:p>
+          <a:p xmlns:a="http://schemas.openxmlformats.org/drawingml/2006/main">
+            <a:r>
+              <a:t>https://www.callstack.com/media-kit — inherited authentic Callstack affiliation mark.</a:t>
+            </a:r>
+          </a:p>
+          <a:p xmlns:a="http://schemas.openxmlformats.org/drawingml/2006/main">
+            <a:r>
+              <a:t>/Users/lech.kalinowski/products/agents commander/assets/logo.png — existing project mark retained; not an Agent Conf logo.</a:t>
+            </a:r>
+          </a:p>
+          <a:p xmlns:a="http://schemas.openxmlformats.org/drawingml/2006/main">
+            <a:r>
+              <a:t>/Users/lech.kalinowski/products/agents commander/assets/BRAND.md — mark provenance.</a:t>
             </a:r>
           </a:p>
           <a:p xmlns:a="http://schemas.openxmlformats.org/drawingml/2006/main">
             <a:r>
               <a:t/>
-            </a:r>
-          </a:p>
-          <a:p xmlns:a="http://schemas.openxmlformats.org/drawingml/2006/main">
-            <a:r>
-              <a:t>[Sources]</a:t>
-            </a:r>
-          </a:p>
-          <a:p xmlns:a="http://schemas.openxmlformats.org/drawingml/2006/main">
-            <a:r>
-              <a:t>https://www.callstack.com/media-kit — inherited Callstack visual identity and affiliation mark.</a:t>
-            </a:r>
-          </a:p>
-          <a:p xmlns:a="http://schemas.openxmlformats.org/drawingml/2006/main">
-            <a:r>
-              <a:t>/Users/lech.kalinowski/products/agents commander/assets/logo.png — Agents Commander project logo.</a:t>
-            </a:r>
-          </a:p>
-          <a:p xmlns:a="http://schemas.openxmlformats.org/drawingml/2006/main">
-            <a:r>
-              <a:t/>
-            </a:r>
-          </a:p>
-          <a:p xmlns:a="http://schemas.openxmlformats.org/drawingml/2006/main">
-            <a:r>
-              <a:t>[Sources — logo refresh]</a:t>
-            </a:r>
-          </a:p>
-          <a:p xmlns:a="http://schemas.openxmlformats.org/drawingml/2006/main">
-            <a:r>
-              <a:t>/Users/lech.kalinowski/products/agents commander/assets/logo.png — original user-requested retro mark, generated with built-in image generation, 2026-09-02.</a:t>
-            </a:r>
-          </a:p>
-          <a:p xmlns:a="http://schemas.openxmlformats.org/drawingml/2006/main">
-            <a:r>
-              <a:t>/Users/lech.kalinowski/products/agents commander/assets/BRAND.md — asset usage and prompt provenance.</a:t>
-            </a:r>
-          </a:p>
-          <a:p xmlns:a="http://schemas.openxmlformats.org/drawingml/2006/main">
-            <a:r>
-              <a:t>Existing Callstack logo and template identity preserved.</a:t>
             </a:r>
           </a:p>
         </p:txBody>
@@ -1972,7 +2064,7 @@
           </a:p>
           <a:p xmlns:a="http://schemas.openxmlformats.org/drawingml/2006/main">
             <a:r>
-              <a:t>2 minutes</a:t>
+              <a:t>1.5 minutes</a:t>
             </a:r>
           </a:p>
           <a:p xmlns:a="http://schemas.openxmlformats.org/drawingml/2006/main">
@@ -2013,6 +2105,186 @@
           <a:p xmlns:a="http://schemas.openxmlformats.org/drawingml/2006/main">
             <a:r>
               <a:t>https://www.callstack.com/media-kit — inherited visual identity; Callstack mark is speaker affiliation.</a:t>
+            </a:r>
+          </a:p>
+        </p:txBody>
+      </p:sp>
+      <p:sp>
+        <p:nvSpPr>
+          <p:cNvPr id="4" name="Slide Number Placeholder 3"/>
+          <p:cNvSpPr>
+            <a:spLocks xmlns:a="http://schemas.openxmlformats.org/drawingml/2006/main" noGrp="1"/>
+          </p:cNvSpPr>
+          <p:nvPr>
+            <p:ph type="sldNum" idx="5"/>
+          </p:nvPr>
+        </p:nvSpPr>
+        <p:spPr/>
+        <p:txBody>
+          <a:bodyPr xmlns:a="http://schemas.openxmlformats.org/drawingml/2006/main"/>
+          <a:lstStyle xmlns:a="http://schemas.openxmlformats.org/drawingml/2006/main"/>
+          <a:p xmlns:a="http://schemas.openxmlformats.org/drawingml/2006/main"/>
+        </p:txBody>
+      </p:sp>
+    </p:spTree>
+  </p:cSld>
+  <p:clrMapOvr>
+    <a:masterClrMapping xmlns:a="http://schemas.openxmlformats.org/drawingml/2006/main"/>
+  </p:clrMapOvr>
+</p:notes>
+</file>
+
+<file path=ppt/notesSlides/notesSlide20.xml><?xml version="1.0" encoding="utf-8"?>
+<p:notes xmlns:p="http://schemas.openxmlformats.org/presentationml/2006/main">
+  <p:cSld>
+    <p:spTree>
+      <p:nvGrpSpPr>
+        <p:cNvPr id="1" name=""/>
+        <p:cNvGrpSpPr/>
+        <p:nvPr/>
+      </p:nvGrpSpPr>
+      <p:grpSpPr>
+        <a:xfrm xmlns:a="http://schemas.openxmlformats.org/drawingml/2006/main"/>
+      </p:grpSpPr>
+      <p:sp>
+        <p:nvSpPr>
+          <p:cNvPr id="2" name="Slide Image Placeholder 1"/>
+          <p:cNvSpPr>
+            <a:spLocks xmlns:a="http://schemas.openxmlformats.org/drawingml/2006/main" noGrp="1"/>
+          </p:cNvSpPr>
+          <p:nvPr>
+            <p:ph type="sldImg" idx="0"/>
+          </p:nvPr>
+        </p:nvSpPr>
+        <p:spPr/>
+      </p:sp>
+      <p:sp>
+        <p:nvSpPr>
+          <p:cNvPr id="3" name="Notes Placeholder 2"/>
+          <p:cNvSpPr>
+            <a:spLocks xmlns:a="http://schemas.openxmlformats.org/drawingml/2006/main" noGrp="1"/>
+          </p:cNvSpPr>
+          <p:nvPr>
+            <p:ph type="body" idx="1"/>
+          </p:nvPr>
+        </p:nvSpPr>
+        <p:spPr/>
+        <p:txBody>
+          <a:bodyPr xmlns:a="http://schemas.openxmlformats.org/drawingml/2006/main"/>
+          <a:lstStyle xmlns:a="http://schemas.openxmlformats.org/drawingml/2006/main"/>
+          <a:p xmlns:a="http://schemas.openxmlformats.org/drawingml/2006/main">
+            <a:r>
+              <a:t>[Timing] 5:00</a:t>
+            </a:r>
+          </a:p>
+          <a:p xmlns:a="http://schemas.openxmlformats.org/drawingml/2006/main">
+            <a:r>
+              <a:t/>
+            </a:r>
+          </a:p>
+          <a:p xmlns:a="http://schemas.openxmlformats.org/drawingml/2006/main">
+            <a:r>
+              <a:t>Use the prompts to structure Q&amp;A: what evidence must survive each handoff, when one agent should challenge another, and where a human interruption is mandatory.</a:t>
+            </a:r>
+          </a:p>
+          <a:p xmlns:a="http://schemas.openxmlformats.org/drawingml/2006/main">
+            <a:r>
+              <a:t/>
+            </a:r>
+          </a:p>
+          <a:p xmlns:a="http://schemas.openxmlformats.org/drawingml/2006/main">
+            <a:r>
+              <a:t>If questions are slow, ask: “Would you authorize one agent to broadcast to every other agent automatically? What evidence would make that safe?”</a:t>
+            </a:r>
+          </a:p>
+          <a:p xmlns:a="http://schemas.openxmlformats.org/drawingml/2006/main">
+            <a:r>
+              <a:t/>
+            </a:r>
+          </a:p>
+          <a:p xmlns:a="http://schemas.openxmlformats.org/drawingml/2006/main">
+            <a:r>
+              <a:t>End with the practical boundary: Commander can make transport visible and controllable; it does not make model reasoning correct, disagreement resolved, or a captured example suitable for training by itself. The F12 ledger remains in memory; opt-in semantic capture is a separate, reviewed path.</a:t>
+            </a:r>
+          </a:p>
+          <a:p xmlns:a="http://schemas.openxmlformats.org/drawingml/2006/main">
+            <a:r>
+              <a:t/>
+            </a:r>
+          </a:p>
+          <a:p xmlns:a="http://schemas.openxmlformats.org/drawingml/2006/main">
+            <a:r>
+              <a:t>[Sources]</a:t>
+            </a:r>
+          </a:p>
+          <a:p xmlns:a="http://schemas.openxmlformats.org/drawingml/2006/main">
+            <a:r>
+              <a:t>- https://codeeurope.pl/speakers</a:t>
+            </a:r>
+          </a:p>
+          <a:p xmlns:a="http://schemas.openxmlformats.org/drawingml/2006/main">
+            <a:r>
+              <a:t>- https://www.callstack.com/events/no-framework-no-server-making-ai-agents-collaborate-in-one-terminal</a:t>
+            </a:r>
+          </a:p>
+          <a:p xmlns:a="http://schemas.openxmlformats.org/drawingml/2006/main">
+            <a:r>
+              <a:t>- /Users/lech.kalinowski/products/agents commander/README.md</a:t>
+            </a:r>
+          </a:p>
+          <a:p xmlns:a="http://schemas.openxmlformats.org/drawingml/2006/main">
+            <a:r>
+              <a:t>- /Users/lech.kalinowski/products/agents commander/src/orchestration/protocol.ts</a:t>
+            </a:r>
+          </a:p>
+          <a:p xmlns:a="http://schemas.openxmlformats.org/drawingml/2006/main">
+            <a:r>
+              <a:t>- /Users/lech.kalinowski/products/agents commander/src/orchestration/message-ledger.ts</a:t>
+            </a:r>
+          </a:p>
+          <a:p xmlns:a="http://schemas.openxmlformats.org/drawingml/2006/main">
+            <a:r>
+              <a:t/>
+            </a:r>
+          </a:p>
+          <a:p xmlns:a="http://schemas.openxmlformats.org/drawingml/2006/main">
+            <a:r>
+              <a:t>[Sources]</a:t>
+            </a:r>
+          </a:p>
+          <a:p xmlns:a="http://schemas.openxmlformats.org/drawingml/2006/main">
+            <a:r>
+              <a:t>https://www.callstack.com/media-kit — inherited Callstack visual identity and affiliation mark.</a:t>
+            </a:r>
+          </a:p>
+          <a:p xmlns:a="http://schemas.openxmlformats.org/drawingml/2006/main">
+            <a:r>
+              <a:t>/Users/lech.kalinowski/products/agents commander/assets/logo.png — Agents Commander project logo.</a:t>
+            </a:r>
+          </a:p>
+          <a:p xmlns:a="http://schemas.openxmlformats.org/drawingml/2006/main">
+            <a:r>
+              <a:t/>
+            </a:r>
+          </a:p>
+          <a:p xmlns:a="http://schemas.openxmlformats.org/drawingml/2006/main">
+            <a:r>
+              <a:t>[Sources — logo refresh]</a:t>
+            </a:r>
+          </a:p>
+          <a:p xmlns:a="http://schemas.openxmlformats.org/drawingml/2006/main">
+            <a:r>
+              <a:t>/Users/lech.kalinowski/products/agents commander/assets/logo.png — original user-requested retro mark, generated with built-in image generation, 2026-09-02.</a:t>
+            </a:r>
+          </a:p>
+          <a:p xmlns:a="http://schemas.openxmlformats.org/drawingml/2006/main">
+            <a:r>
+              <a:t>/Users/lech.kalinowski/products/agents commander/assets/BRAND.md — asset usage and prompt provenance.</a:t>
+            </a:r>
+          </a:p>
+          <a:p xmlns:a="http://schemas.openxmlformats.org/drawingml/2006/main">
+            <a:r>
+              <a:t>Existing Callstack logo and template identity preserved.</a:t>
             </a:r>
           </a:p>
         </p:txBody>
@@ -6243,17 +6515,17 @@
   </p:cSld>
   <p:clrMap bg1="lt1" tx1="dk1" bg2="lt2" tx2="dk2" accent1="accent1" accent2="accent2" accent3="accent3" accent4="accent4" accent5="accent5" accent6="accent6" hlink="hlink" folHlink="folHlink"/>
   <p:sldLayoutIdLst>
-    <p:sldLayoutId xmlns:r="http://schemas.openxmlformats.org/officeDocument/2006/relationships" id="2147483649" r:id="Rf20d6b4b06a2421d"/>
-    <p:sldLayoutId xmlns:r="http://schemas.openxmlformats.org/officeDocument/2006/relationships" id="2147483650" r:id="Reafcd8aaf1ac4f27"/>
-    <p:sldLayoutId xmlns:r="http://schemas.openxmlformats.org/officeDocument/2006/relationships" id="2147483651" r:id="R3731b5ca5e8a4023"/>
-    <p:sldLayoutId xmlns:r="http://schemas.openxmlformats.org/officeDocument/2006/relationships" id="2147483652" r:id="R0f887a98c3dd4e7d"/>
-    <p:sldLayoutId xmlns:r="http://schemas.openxmlformats.org/officeDocument/2006/relationships" id="2147483653" r:id="Rc42dd7d47e7a404a"/>
-    <p:sldLayoutId xmlns:r="http://schemas.openxmlformats.org/officeDocument/2006/relationships" id="2147483654" r:id="Rf01369b5e8f540c3"/>
-    <p:sldLayoutId xmlns:r="http://schemas.openxmlformats.org/officeDocument/2006/relationships" id="2147483655" r:id="Rb720926990bf4894"/>
-    <p:sldLayoutId xmlns:r="http://schemas.openxmlformats.org/officeDocument/2006/relationships" id="2147483656" r:id="Rde48403f9af747f4"/>
-    <p:sldLayoutId xmlns:r="http://schemas.openxmlformats.org/officeDocument/2006/relationships" id="2147483657" r:id="R466a55361f6d4524"/>
-    <p:sldLayoutId xmlns:r="http://schemas.openxmlformats.org/officeDocument/2006/relationships" id="2147483658" r:id="R41d55ebd5b3e493b"/>
-    <p:sldLayoutId xmlns:r="http://schemas.openxmlformats.org/officeDocument/2006/relationships" id="2147483659" r:id="R986350850dfa404b"/>
+    <p:sldLayoutId xmlns:r="http://schemas.openxmlformats.org/officeDocument/2006/relationships" id="2147483649" r:id="Rd771baac107f4716"/>
+    <p:sldLayoutId xmlns:r="http://schemas.openxmlformats.org/officeDocument/2006/relationships" id="2147483650" r:id="Rf6d2525a57a6476b"/>
+    <p:sldLayoutId xmlns:r="http://schemas.openxmlformats.org/officeDocument/2006/relationships" id="2147483651" r:id="R97487071b89a418c"/>
+    <p:sldLayoutId xmlns:r="http://schemas.openxmlformats.org/officeDocument/2006/relationships" id="2147483652" r:id="R63d1ec9acda54983"/>
+    <p:sldLayoutId xmlns:r="http://schemas.openxmlformats.org/officeDocument/2006/relationships" id="2147483653" r:id="R80b672caa4f94bd4"/>
+    <p:sldLayoutId xmlns:r="http://schemas.openxmlformats.org/officeDocument/2006/relationships" id="2147483654" r:id="Re64cc588c8664ea7"/>
+    <p:sldLayoutId xmlns:r="http://schemas.openxmlformats.org/officeDocument/2006/relationships" id="2147483655" r:id="R3e12cc01e78c48f0"/>
+    <p:sldLayoutId xmlns:r="http://schemas.openxmlformats.org/officeDocument/2006/relationships" id="2147483656" r:id="R5b7bc4c34b994ca0"/>
+    <p:sldLayoutId xmlns:r="http://schemas.openxmlformats.org/officeDocument/2006/relationships" id="2147483657" r:id="Rf2e965506dc14836"/>
+    <p:sldLayoutId xmlns:r="http://schemas.openxmlformats.org/officeDocument/2006/relationships" id="2147483658" r:id="R6b754f3d0e304c4f"/>
+    <p:sldLayoutId xmlns:r="http://schemas.openxmlformats.org/officeDocument/2006/relationships" id="2147483659" r:id="Ra28e4e1fb18b4f08"/>
   </p:sldLayoutIdLst>
   <p:txStyles>
     <p:titleStyle>
@@ -6824,7 +7096,7 @@
           <p:nvPr/>
         </p:nvPicPr>
         <p:blipFill>
-          <a:blip xmlns:r="http://schemas.openxmlformats.org/officeDocument/2006/relationships" xmlns:a="http://schemas.openxmlformats.org/drawingml/2006/main" r:embed="Rebff490dc1a242f8"/>
+          <a:blip xmlns:r="http://schemas.openxmlformats.org/officeDocument/2006/relationships" xmlns:a="http://schemas.openxmlformats.org/drawingml/2006/main" r:embed="Rf4420926b81f4569"/>
           <a:stretch xmlns:a="http://schemas.openxmlformats.org/drawingml/2006/main"/>
         </p:blipFill>
         <p:spPr>
@@ -7107,7 +7379,7 @@
                 <a:ea typeface="Consolas"/>
                 <a:cs typeface="Consolas"/>
               </a:rPr>
-              <a:t>1/18</a:t>
+              <a:t>1/20</a:t>
             </a:r>
           </a:p>
         </p:txBody>
@@ -7121,7 +7393,7 @@
           <p:nvPr/>
         </p:nvPicPr>
         <p:blipFill>
-          <a:blip xmlns:r="http://schemas.openxmlformats.org/officeDocument/2006/relationships" xmlns:a="http://schemas.openxmlformats.org/drawingml/2006/main" r:embed="Rd51e0989313f428e"/>
+          <a:blip xmlns:r="http://schemas.openxmlformats.org/officeDocument/2006/relationships" xmlns:a="http://schemas.openxmlformats.org/drawingml/2006/main" r:embed="Radb747008da84e45"/>
           <a:stretch xmlns:a="http://schemas.openxmlformats.org/drawingml/2006/main"/>
         </p:blipFill>
         <p:spPr>
@@ -7323,7 +7595,7 @@
                 <a:ea typeface="Consolas"/>
                 <a:cs typeface="Consolas"/>
               </a:rPr>
-              <a:t>10/18</a:t>
+              <a:t>10/20</a:t>
             </a:r>
           </a:p>
         </p:txBody>
@@ -8400,7 +8672,7 @@
                 <a:ea typeface="Consolas"/>
                 <a:cs typeface="Consolas"/>
               </a:rPr>
-              <a:t>11/18</a:t>
+              <a:t>11/20</a:t>
             </a:r>
           </a:p>
         </p:txBody>
@@ -9212,7 +9484,7 @@
                 <a:ea typeface="Consolas"/>
                 <a:cs typeface="Consolas"/>
               </a:rPr>
-              <a:t>12/18</a:t>
+              <a:t>12/20</a:t>
             </a:r>
           </a:p>
         </p:txBody>
@@ -10029,7 +10301,7 @@
                 <a:ea typeface="Consolas"/>
                 <a:cs typeface="Consolas"/>
               </a:rPr>
-              <a:t>13/18</a:t>
+              <a:t>13/20</a:t>
             </a:r>
           </a:p>
         </p:txBody>
@@ -10933,7 +11205,7 @@
                 <a:ea typeface="Consolas"/>
                 <a:cs typeface="Consolas"/>
               </a:rPr>
-              <a:t>14/18</a:t>
+              <a:t>14/20</a:t>
             </a:r>
           </a:p>
         </p:txBody>
@@ -10980,7 +11252,7 @@
           <p:nvPr/>
         </p:nvPicPr>
         <p:blipFill>
-          <a:blip xmlns:r="http://schemas.openxmlformats.org/officeDocument/2006/relationships" xmlns:a="http://schemas.openxmlformats.org/drawingml/2006/main" r:embed="R23d5b11ea1974773"/>
+          <a:blip xmlns:r="http://schemas.openxmlformats.org/officeDocument/2006/relationships" xmlns:a="http://schemas.openxmlformats.org/drawingml/2006/main" r:embed="R34e7b4c0d95041ac"/>
           <a:stretch xmlns:a="http://schemas.openxmlformats.org/drawingml/2006/main"/>
         </p:blipFill>
         <p:spPr>
@@ -11595,7 +11867,7 @@
                 <a:ea typeface="Consolas"/>
                 <a:cs typeface="Consolas"/>
               </a:rPr>
-              <a:t>15/18</a:t>
+              <a:t>15/20</a:t>
             </a:r>
           </a:p>
         </p:txBody>
@@ -12475,7 +12747,7 @@
                 <a:ea typeface="Consolas"/>
                 <a:cs typeface="Consolas"/>
               </a:rPr>
-              <a:t>16/18</a:t>
+              <a:t>16/20</a:t>
             </a:r>
           </a:p>
         </p:txBody>
@@ -13374,7 +13646,7 @@
           <p:nvPr/>
         </p:nvPicPr>
         <p:blipFill>
-          <a:blip xmlns:r="http://schemas.openxmlformats.org/officeDocument/2006/relationships" xmlns:a="http://schemas.openxmlformats.org/drawingml/2006/main" r:embed="Rcb09bf3a203c454e"/>
+          <a:blip xmlns:r="http://schemas.openxmlformats.org/officeDocument/2006/relationships" xmlns:a="http://schemas.openxmlformats.org/drawingml/2006/main" r:embed="R0eb4718d825d4935"/>
           <a:stretch xmlns:a="http://schemas.openxmlformats.org/drawingml/2006/main"/>
         </p:blipFill>
         <p:spPr>
@@ -13769,7 +14041,7 @@
                 <a:ea typeface="Consolas"/>
                 <a:cs typeface="Consolas"/>
               </a:rPr>
-              <a:t>17/18</a:t>
+              <a:t>17/20</a:t>
             </a:r>
           </a:p>
         </p:txBody>
@@ -13783,7 +14055,7 @@
           <p:nvPr/>
         </p:nvPicPr>
         <p:blipFill>
-          <a:blip xmlns:r="http://schemas.openxmlformats.org/officeDocument/2006/relationships" xmlns:a="http://schemas.openxmlformats.org/drawingml/2006/main" r:embed="Rb19ef964dc414e05"/>
+          <a:blip xmlns:r="http://schemas.openxmlformats.org/officeDocument/2006/relationships" xmlns:a="http://schemas.openxmlformats.org/drawingml/2006/main" r:embed="Rfabe69a9dfaf4339"/>
           <a:stretch xmlns:a="http://schemas.openxmlformats.org/drawingml/2006/main"/>
         </p:blipFill>
         <p:spPr>
@@ -13925,6 +14197,2303 @@
 </file>
 
 <file path=ppt/slides/slide18.xml><?xml version="1.0" encoding="utf-8"?>
+<p:sld xmlns:p="http://schemas.openxmlformats.org/presentationml/2006/main">
+  <p:cSld>
+    <p:bg>
+      <p:bgPr>
+        <a:solidFill xmlns:a="http://schemas.openxmlformats.org/drawingml/2006/main">
+          <a:srgbClr val="201F24"/>
+        </a:solidFill>
+      </p:bgPr>
+    </p:bg>
+    <p:spTree>
+      <p:nvGrpSpPr>
+        <p:cNvPr id="1" name=""/>
+        <p:cNvGrpSpPr/>
+        <p:nvPr/>
+      </p:nvGrpSpPr>
+      <p:grpSpPr>
+        <a:xfrm xmlns:a="http://schemas.openxmlformats.org/drawingml/2006/main"/>
+      </p:grpSpPr>
+      <p:sp>
+        <p:nvSpPr>
+          <p:cNvPr id="2" name="TextBox 1">
+            <a:extLst xmlns:a="http://schemas.openxmlformats.org/drawingml/2006/main">
+              <a:ext uri="{FF2B5EF4-FFF2-40B4-BE49-F238E27FC236}">
+                <a16:creationId xmlns:a16="http://schemas.microsoft.com/office/drawing/2014/main" id="{F7141995-C002-488C-8F2B-E515FB545E84}"/>
+              </a:ext>
+            </a:extLst>
+          </p:cNvPr>
+          <p:cNvSpPr>
+            <a:spLocks xmlns:a="http://schemas.openxmlformats.org/drawingml/2006/main" noGrp="1"/>
+          </p:cNvSpPr>
+          <p:nvPr/>
+        </p:nvSpPr>
+        <p:spPr>
+          <a:xfrm xmlns:a="http://schemas.openxmlformats.org/drawingml/2006/main">
+            <a:off x="731520" y="409575"/>
+            <a:ext cx="10820400" cy="333375"/>
+          </a:xfrm>
+          <a:prstGeom xmlns:a="http://schemas.openxmlformats.org/drawingml/2006/main" prst="rect">
+            <a:avLst/>
+          </a:prstGeom>
+          <a:noFill xmlns:a="http://schemas.openxmlformats.org/drawingml/2006/main"/>
+        </p:spPr>
+        <p:txBody>
+          <a:bodyPr xmlns:a="http://schemas.openxmlformats.org/drawingml/2006/main" wrap="none" lIns="0" tIns="0" rIns="0" bIns="0" anchor="ctr">
+            <a:noAutofit/>
+          </a:bodyPr>
+          <a:lstStyle xmlns:a="http://schemas.openxmlformats.org/drawingml/2006/main"/>
+          <a:p xmlns:a="http://schemas.openxmlformats.org/drawingml/2006/main">
+            <a:pPr algn="l">
+              <a:buNone/>
+              <a:defRPr sz="1200" b="1">
+                <a:solidFill>
+                  <a:srgbClr val="CBAAFF"/>
+                </a:solidFill>
+                <a:latin typeface="Consolas"/>
+                <a:ea typeface="Consolas"/>
+                <a:cs typeface="Consolas"/>
+              </a:defRPr>
+            </a:pPr>
+            <a:r>
+              <a:rPr sz="1200" b="1">
+                <a:solidFill>
+                  <a:srgbClr val="CBAAFF"/>
+                </a:solidFill>
+                <a:latin typeface="Consolas"/>
+                <a:ea typeface="Consolas"/>
+                <a:cs typeface="Consolas"/>
+              </a:rPr>
+              <a:t>FUTURE · PROTOCOL LEARNING</a:t>
+            </a:r>
+          </a:p>
+        </p:txBody>
+      </p:sp>
+      <p:sp>
+        <p:nvSpPr>
+          <p:cNvPr id="3" name="TextBox 2">
+            <a:extLst xmlns:a="http://schemas.openxmlformats.org/drawingml/2006/main">
+              <a:ext uri="{FF2B5EF4-FFF2-40B4-BE49-F238E27FC236}">
+                <a16:creationId xmlns:a16="http://schemas.microsoft.com/office/drawing/2014/main" id="{A126BAEC-F6D3-4875-A4AC-25DD6C136B70}"/>
+              </a:ext>
+            </a:extLst>
+          </p:cNvPr>
+          <p:cNvSpPr>
+            <a:spLocks xmlns:a="http://schemas.openxmlformats.org/drawingml/2006/main" noGrp="1"/>
+          </p:cNvSpPr>
+          <p:nvPr/>
+        </p:nvSpPr>
+        <p:spPr>
+          <a:xfrm xmlns:a="http://schemas.openxmlformats.org/drawingml/2006/main">
+            <a:off x="731520" y="914400"/>
+            <a:ext cx="10820400" cy="704850"/>
+          </a:xfrm>
+          <a:prstGeom xmlns:a="http://schemas.openxmlformats.org/drawingml/2006/main" prst="rect">
+            <a:avLst/>
+          </a:prstGeom>
+          <a:noFill xmlns:a="http://schemas.openxmlformats.org/drawingml/2006/main"/>
+        </p:spPr>
+        <p:txBody>
+          <a:bodyPr xmlns:a="http://schemas.openxmlformats.org/drawingml/2006/main" wrap="none" lIns="0" tIns="0" rIns="0" bIns="0" anchor="ctr">
+            <a:noAutofit/>
+          </a:bodyPr>
+          <a:lstStyle xmlns:a="http://schemas.openxmlformats.org/drawingml/2006/main"/>
+          <a:p xmlns:a="http://schemas.openxmlformats.org/drawingml/2006/main">
+            <a:pPr algn="l">
+              <a:buNone/>
+              <a:defRPr sz="3300" b="0">
+                <a:solidFill>
+                  <a:srgbClr val="F9F8FD"/>
+                </a:solidFill>
+                <a:latin typeface="Alliance No.2"/>
+                <a:ea typeface="Alliance No.2"/>
+                <a:cs typeface="Alliance No.2"/>
+              </a:defRPr>
+            </a:pPr>
+            <a:r>
+              <a:rPr sz="3300" b="0">
+                <a:solidFill>
+                  <a:srgbClr val="F9F8FD"/>
+                </a:solidFill>
+                <a:latin typeface="Alliance No.2"/>
+                <a:ea typeface="Alliance No.2"/>
+                <a:cs typeface="Alliance No.2"/>
+              </a:rPr>
+              <a:t>Teach models the Commander Protocol.</a:t>
+            </a:r>
+          </a:p>
+        </p:txBody>
+      </p:sp>
+      <p:sp>
+        <p:nvSpPr>
+          <p:cNvPr id="49" name="TextBox 48">
+            <a:extLst xmlns:a="http://schemas.openxmlformats.org/drawingml/2006/main">
+              <a:ext uri="{FF2B5EF4-FFF2-40B4-BE49-F238E27FC236}">
+                <a16:creationId xmlns:a16="http://schemas.microsoft.com/office/drawing/2014/main" id="{55083C4D-8CCA-4EA1-B774-DBE100BF8F62}"/>
+              </a:ext>
+            </a:extLst>
+          </p:cNvPr>
+          <p:cNvSpPr>
+            <a:spLocks xmlns:a="http://schemas.openxmlformats.org/drawingml/2006/main" noGrp="1"/>
+          </p:cNvSpPr>
+          <p:nvPr/>
+        </p:nvSpPr>
+        <p:spPr>
+          <a:xfrm xmlns:a="http://schemas.openxmlformats.org/drawingml/2006/main">
+            <a:off x="10668000" y="6419850"/>
+            <a:ext cx="857250" cy="285750"/>
+          </a:xfrm>
+          <a:prstGeom xmlns:a="http://schemas.openxmlformats.org/drawingml/2006/main" prst="rect">
+            <a:avLst/>
+          </a:prstGeom>
+          <a:noFill xmlns:a="http://schemas.openxmlformats.org/drawingml/2006/main"/>
+        </p:spPr>
+        <p:txBody>
+          <a:bodyPr xmlns:a="http://schemas.openxmlformats.org/drawingml/2006/main" wrap="none" lIns="0" tIns="0" rIns="0" bIns="0" anchor="ctr">
+            <a:noAutofit/>
+          </a:bodyPr>
+          <a:lstStyle xmlns:a="http://schemas.openxmlformats.org/drawingml/2006/main"/>
+          <a:p xmlns:a="http://schemas.openxmlformats.org/drawingml/2006/main">
+            <a:pPr algn="r">
+              <a:buNone/>
+              <a:defRPr sz="1200" b="0">
+                <a:solidFill>
+                  <a:srgbClr val="BCBBC2"/>
+                </a:solidFill>
+                <a:latin typeface="Consolas"/>
+                <a:ea typeface="Consolas"/>
+                <a:cs typeface="Consolas"/>
+              </a:defRPr>
+            </a:pPr>
+            <a:r>
+              <a:rPr sz="1200" b="0">
+                <a:solidFill>
+                  <a:srgbClr val="BCBBC2"/>
+                </a:solidFill>
+                <a:latin typeface="Consolas"/>
+                <a:ea typeface="Consolas"/>
+                <a:cs typeface="Consolas"/>
+              </a:rPr>
+              <a:t>18/20</a:t>
+            </a:r>
+          </a:p>
+        </p:txBody>
+      </p:sp>
+      <p:sp>
+        <p:nvSpPr>
+          <p:cNvPr id="50" name="Callstack accent rule">
+            <a:extLst xmlns:a="http://schemas.openxmlformats.org/drawingml/2006/main">
+              <a:ext uri="{FF2B5EF4-FFF2-40B4-BE49-F238E27FC236}">
+                <a16:creationId xmlns:a16="http://schemas.microsoft.com/office/drawing/2014/main" id="{B8DAE6AA-7B94-4D91-9F2C-8316CB9480FB}"/>
+              </a:ext>
+            </a:extLst>
+          </p:cNvPr>
+          <p:cNvSpPr>
+            <a:spLocks xmlns:a="http://schemas.openxmlformats.org/drawingml/2006/main" noGrp="1"/>
+          </p:cNvSpPr>
+          <p:nvPr/>
+        </p:nvSpPr>
+        <p:spPr>
+          <a:xfrm xmlns:a="http://schemas.openxmlformats.org/drawingml/2006/main">
+            <a:off x="0" y="0"/>
+            <a:ext cx="12192000" cy="57150"/>
+          </a:xfrm>
+          <a:prstGeom xmlns:a="http://schemas.openxmlformats.org/drawingml/2006/main" prst="rect">
+            <a:avLst/>
+          </a:prstGeom>
+          <a:solidFill xmlns:a="http://schemas.openxmlformats.org/drawingml/2006/main">
+            <a:srgbClr val="8232FF"/>
+          </a:solidFill>
+          <a:ln xmlns:a="http://schemas.openxmlformats.org/drawingml/2006/main" w="2381">
+            <a:solidFill>
+              <a:srgbClr val="8232FF"/>
+            </a:solidFill>
+            <a:prstDash val="solid"/>
+          </a:ln>
+        </p:spPr>
+      </p:sp>
+      <p:sp>
+        <p:nvSpPr>
+          <p:cNvPr id="51" name="guard-272">
+            <a:extLst xmlns:a="http://schemas.openxmlformats.org/drawingml/2006/main">
+              <a:ext uri="{FF2B5EF4-FFF2-40B4-BE49-F238E27FC236}">
+                <a16:creationId xmlns:a16="http://schemas.microsoft.com/office/drawing/2014/main" id="{5B33431B-A35A-4B5F-BB47-84F22ADED5C2}"/>
+              </a:ext>
+            </a:extLst>
+          </p:cNvPr>
+          <p:cNvSpPr>
+            <a:spLocks xmlns:a="http://schemas.openxmlformats.org/drawingml/2006/main" noGrp="1"/>
+          </p:cNvSpPr>
+          <p:nvPr/>
+        </p:nvSpPr>
+        <p:spPr>
+          <a:xfrm xmlns:a="http://schemas.openxmlformats.org/drawingml/2006/main">
+            <a:off x="2590800" y="2800350"/>
+            <a:ext cx="504825" cy="114300"/>
+          </a:xfrm>
+          <a:prstGeom xmlns:a="http://schemas.openxmlformats.org/drawingml/2006/main" prst="rightArrow">
+            <a:avLst/>
+          </a:prstGeom>
+          <a:solidFill xmlns:a="http://schemas.openxmlformats.org/drawingml/2006/main">
+            <a:srgbClr val="CBAAFF"/>
+          </a:solidFill>
+          <a:ln xmlns:a="http://schemas.openxmlformats.org/drawingml/2006/main" w="0">
+            <a:noFill/>
+            <a:prstDash val="solid"/>
+          </a:ln>
+        </p:spPr>
+      </p:sp>
+      <p:sp>
+        <p:nvSpPr>
+          <p:cNvPr id="52" name="guard-565">
+            <a:extLst xmlns:a="http://schemas.openxmlformats.org/drawingml/2006/main">
+              <a:ext uri="{FF2B5EF4-FFF2-40B4-BE49-F238E27FC236}">
+                <a16:creationId xmlns:a16="http://schemas.microsoft.com/office/drawing/2014/main" id="{CF583F7B-6C4F-4C8E-A510-51E0023DB06F}"/>
+              </a:ext>
+            </a:extLst>
+          </p:cNvPr>
+          <p:cNvSpPr>
+            <a:spLocks xmlns:a="http://schemas.openxmlformats.org/drawingml/2006/main" noGrp="1"/>
+          </p:cNvSpPr>
+          <p:nvPr/>
+        </p:nvSpPr>
+        <p:spPr>
+          <a:xfrm xmlns:a="http://schemas.openxmlformats.org/drawingml/2006/main">
+            <a:off x="5381625" y="2800350"/>
+            <a:ext cx="514350" cy="114300"/>
+          </a:xfrm>
+          <a:prstGeom xmlns:a="http://schemas.openxmlformats.org/drawingml/2006/main" prst="rightArrow">
+            <a:avLst/>
+          </a:prstGeom>
+          <a:solidFill xmlns:a="http://schemas.openxmlformats.org/drawingml/2006/main">
+            <a:srgbClr val="CBAAFF"/>
+          </a:solidFill>
+          <a:ln xmlns:a="http://schemas.openxmlformats.org/drawingml/2006/main" w="0">
+            <a:noFill/>
+            <a:prstDash val="solid"/>
+          </a:ln>
+        </p:spPr>
+      </p:sp>
+      <p:sp>
+        <p:nvSpPr>
+          <p:cNvPr id="53" name="guard-858">
+            <a:extLst xmlns:a="http://schemas.openxmlformats.org/drawingml/2006/main">
+              <a:ext uri="{FF2B5EF4-FFF2-40B4-BE49-F238E27FC236}">
+                <a16:creationId xmlns:a16="http://schemas.microsoft.com/office/drawing/2014/main" id="{E3470387-7060-49C7-88EC-3C9F3110E647}"/>
+              </a:ext>
+            </a:extLst>
+          </p:cNvPr>
+          <p:cNvSpPr>
+            <a:spLocks xmlns:a="http://schemas.openxmlformats.org/drawingml/2006/main" noGrp="1"/>
+          </p:cNvSpPr>
+          <p:nvPr/>
+        </p:nvSpPr>
+        <p:spPr>
+          <a:xfrm xmlns:a="http://schemas.openxmlformats.org/drawingml/2006/main">
+            <a:off x="8172450" y="2800350"/>
+            <a:ext cx="514350" cy="114300"/>
+          </a:xfrm>
+          <a:prstGeom xmlns:a="http://schemas.openxmlformats.org/drawingml/2006/main" prst="rightArrow">
+            <a:avLst/>
+          </a:prstGeom>
+          <a:solidFill xmlns:a="http://schemas.openxmlformats.org/drawingml/2006/main">
+            <a:srgbClr val="CBAAFF"/>
+          </a:solidFill>
+          <a:ln xmlns:a="http://schemas.openxmlformats.org/drawingml/2006/main" w="0">
+            <a:noFill/>
+            <a:prstDash val="solid"/>
+          </a:ln>
+        </p:spPr>
+      </p:sp>
+      <p:sp>
+        <p:nvSpPr>
+          <p:cNvPr id="54" name="source-guard">
+            <a:extLst xmlns:a="http://schemas.openxmlformats.org/drawingml/2006/main">
+              <a:ext uri="{FF2B5EF4-FFF2-40B4-BE49-F238E27FC236}">
+                <a16:creationId xmlns:a16="http://schemas.microsoft.com/office/drawing/2014/main" id="{5D4EEF9F-97C2-4672-A52C-23A9B83956B4}"/>
+              </a:ext>
+            </a:extLst>
+          </p:cNvPr>
+          <p:cNvSpPr>
+            <a:spLocks xmlns:a="http://schemas.openxmlformats.org/drawingml/2006/main" noGrp="1"/>
+          </p:cNvSpPr>
+          <p:nvPr/>
+        </p:nvSpPr>
+        <p:spPr>
+          <a:xfrm xmlns:a="http://schemas.openxmlformats.org/drawingml/2006/main">
+            <a:off x="742950" y="2362200"/>
+            <a:ext cx="1847850" cy="1000125"/>
+          </a:xfrm>
+          <a:prstGeom xmlns:a="http://schemas.openxmlformats.org/drawingml/2006/main" prst="rect">
+            <a:avLst/>
+          </a:prstGeom>
+          <a:solidFill xmlns:a="http://schemas.openxmlformats.org/drawingml/2006/main">
+            <a:srgbClr val="27262B"/>
+          </a:solidFill>
+          <a:ln xmlns:a="http://schemas.openxmlformats.org/drawingml/2006/main" w="13335">
+            <a:solidFill>
+              <a:srgbClr val="CBAAFF"/>
+            </a:solidFill>
+            <a:prstDash val="solid"/>
+          </a:ln>
+        </p:spPr>
+        <p:txBody>
+          <a:bodyPr xmlns:a="http://schemas.openxmlformats.org/drawingml/2006/main" wrap="none" lIns="0" tIns="0" rIns="0" bIns="0" anchor="ctr">
+            <a:noAutofit/>
+          </a:bodyPr>
+          <a:lstStyle xmlns:a="http://schemas.openxmlformats.org/drawingml/2006/main"/>
+          <a:p xmlns:a="http://schemas.openxmlformats.org/drawingml/2006/main">
+            <a:pPr algn="ctr">
+              <a:buNone/>
+              <a:defRPr sz="1725">
+                <a:solidFill>
+                  <a:srgbClr val="F9F8FD"/>
+                </a:solidFill>
+                <a:latin typeface="Switzer"/>
+                <a:ea typeface="Switzer"/>
+                <a:cs typeface="Switzer"/>
+              </a:defRPr>
+            </a:pPr>
+            <a:r>
+              <a:rPr sz="1725">
+                <a:solidFill>
+                  <a:srgbClr val="F9F8FD"/>
+                </a:solidFill>
+                <a:latin typeface="Switzer"/>
+                <a:ea typeface="Switzer"/>
+                <a:cs typeface="Switzer"/>
+              </a:rPr>
+              <a:t>Real agent</a:t>
+            </a:r>
+          </a:p>
+          <a:p xmlns:a="http://schemas.openxmlformats.org/drawingml/2006/main">
+            <a:pPr algn="ctr">
+              <a:buNone/>
+              <a:defRPr sz="1725">
+                <a:solidFill>
+                  <a:srgbClr val="F9F8FD"/>
+                </a:solidFill>
+                <a:latin typeface="Switzer"/>
+                <a:ea typeface="Switzer"/>
+                <a:cs typeface="Switzer"/>
+              </a:defRPr>
+            </a:pPr>
+            <a:r>
+              <a:rPr sz="1725">
+                <a:solidFill>
+                  <a:srgbClr val="F9F8FD"/>
+                </a:solidFill>
+                <a:latin typeface="Switzer"/>
+                <a:ea typeface="Switzer"/>
+                <a:cs typeface="Switzer"/>
+              </a:rPr>
+              <a:t>messages</a:t>
+            </a:r>
+          </a:p>
+        </p:txBody>
+      </p:sp>
+      <p:sp>
+        <p:nvSpPr>
+          <p:cNvPr id="55" name="queue-guard">
+            <a:extLst xmlns:a="http://schemas.openxmlformats.org/drawingml/2006/main">
+              <a:ext uri="{FF2B5EF4-FFF2-40B4-BE49-F238E27FC236}">
+                <a16:creationId xmlns:a16="http://schemas.microsoft.com/office/drawing/2014/main" id="{C16706AD-4485-4B32-8EB3-FAD08C586C33}"/>
+              </a:ext>
+            </a:extLst>
+          </p:cNvPr>
+          <p:cNvSpPr>
+            <a:spLocks xmlns:a="http://schemas.openxmlformats.org/drawingml/2006/main" noGrp="1"/>
+          </p:cNvSpPr>
+          <p:nvPr/>
+        </p:nvSpPr>
+        <p:spPr>
+          <a:xfrm xmlns:a="http://schemas.openxmlformats.org/drawingml/2006/main">
+            <a:off x="3095625" y="2362200"/>
+            <a:ext cx="2286000" cy="1000125"/>
+          </a:xfrm>
+          <a:prstGeom xmlns:a="http://schemas.openxmlformats.org/drawingml/2006/main" prst="rect">
+            <a:avLst/>
+          </a:prstGeom>
+          <a:solidFill xmlns:a="http://schemas.openxmlformats.org/drawingml/2006/main">
+            <a:srgbClr val="27262B"/>
+          </a:solidFill>
+          <a:ln xmlns:a="http://schemas.openxmlformats.org/drawingml/2006/main" w="13335">
+            <a:solidFill>
+              <a:srgbClr val="CBAAFF"/>
+            </a:solidFill>
+            <a:prstDash val="solid"/>
+          </a:ln>
+        </p:spPr>
+        <p:txBody>
+          <a:bodyPr xmlns:a="http://schemas.openxmlformats.org/drawingml/2006/main" wrap="none" lIns="0" tIns="0" rIns="0" bIns="0" anchor="ctr">
+            <a:noAutofit/>
+          </a:bodyPr>
+          <a:lstStyle xmlns:a="http://schemas.openxmlformats.org/drawingml/2006/main"/>
+          <a:p xmlns:a="http://schemas.openxmlformats.org/drawingml/2006/main">
+            <a:pPr algn="ctr">
+              <a:buNone/>
+              <a:defRPr sz="1725">
+                <a:solidFill>
+                  <a:srgbClr val="F9F8FD"/>
+                </a:solidFill>
+                <a:latin typeface="Switzer"/>
+                <a:ea typeface="Switzer"/>
+                <a:cs typeface="Switzer"/>
+              </a:defRPr>
+            </a:pPr>
+            <a:r>
+              <a:rPr sz="1725">
+                <a:solidFill>
+                  <a:srgbClr val="F9F8FD"/>
+                </a:solidFill>
+                <a:latin typeface="Switzer"/>
+                <a:ea typeface="Switzer"/>
+                <a:cs typeface="Switzer"/>
+              </a:rPr>
+              <a:t>Reviewed</a:t>
+            </a:r>
+          </a:p>
+          <a:p xmlns:a="http://schemas.openxmlformats.org/drawingml/2006/main">
+            <a:pPr algn="ctr">
+              <a:buNone/>
+              <a:defRPr sz="1725">
+                <a:solidFill>
+                  <a:srgbClr val="F9F8FD"/>
+                </a:solidFill>
+                <a:latin typeface="Switzer"/>
+                <a:ea typeface="Switzer"/>
+                <a:cs typeface="Switzer"/>
+              </a:defRPr>
+            </a:pPr>
+            <a:r>
+              <a:rPr sz="1725">
+                <a:solidFill>
+                  <a:srgbClr val="F9F8FD"/>
+                </a:solidFill>
+                <a:latin typeface="Switzer"/>
+                <a:ea typeface="Switzer"/>
+                <a:cs typeface="Switzer"/>
+              </a:rPr>
+              <a:t>training data</a:t>
+            </a:r>
+          </a:p>
+        </p:txBody>
+      </p:sp>
+      <p:sp>
+        <p:nvSpPr>
+          <p:cNvPr id="56" name="target-guard">
+            <a:extLst xmlns:a="http://schemas.openxmlformats.org/drawingml/2006/main">
+              <a:ext uri="{FF2B5EF4-FFF2-40B4-BE49-F238E27FC236}">
+                <a16:creationId xmlns:a16="http://schemas.microsoft.com/office/drawing/2014/main" id="{F080771C-DFFF-4AFB-BD58-0BB682726209}"/>
+              </a:ext>
+            </a:extLst>
+          </p:cNvPr>
+          <p:cNvSpPr>
+            <a:spLocks xmlns:a="http://schemas.openxmlformats.org/drawingml/2006/main" noGrp="1"/>
+          </p:cNvSpPr>
+          <p:nvPr/>
+        </p:nvSpPr>
+        <p:spPr>
+          <a:xfrm xmlns:a="http://schemas.openxmlformats.org/drawingml/2006/main">
+            <a:off x="5895975" y="2362200"/>
+            <a:ext cx="2276475" cy="1000125"/>
+          </a:xfrm>
+          <a:prstGeom xmlns:a="http://schemas.openxmlformats.org/drawingml/2006/main" prst="rect">
+            <a:avLst/>
+          </a:prstGeom>
+          <a:solidFill xmlns:a="http://schemas.openxmlformats.org/drawingml/2006/main">
+            <a:srgbClr val="27262B"/>
+          </a:solidFill>
+          <a:ln xmlns:a="http://schemas.openxmlformats.org/drawingml/2006/main" w="13335">
+            <a:solidFill>
+              <a:srgbClr val="CBAAFF"/>
+            </a:solidFill>
+            <a:prstDash val="solid"/>
+          </a:ln>
+        </p:spPr>
+        <p:txBody>
+          <a:bodyPr xmlns:a="http://schemas.openxmlformats.org/drawingml/2006/main" wrap="none" lIns="0" tIns="0" rIns="0" bIns="0" anchor="ctr">
+            <a:noAutofit/>
+          </a:bodyPr>
+          <a:lstStyle xmlns:a="http://schemas.openxmlformats.org/drawingml/2006/main"/>
+          <a:p xmlns:a="http://schemas.openxmlformats.org/drawingml/2006/main">
+            <a:pPr algn="ctr">
+              <a:buNone/>
+              <a:defRPr sz="1725">
+                <a:solidFill>
+                  <a:srgbClr val="F9F8FD"/>
+                </a:solidFill>
+                <a:latin typeface="Switzer"/>
+                <a:ea typeface="Switzer"/>
+                <a:cs typeface="Switzer"/>
+              </a:defRPr>
+            </a:pPr>
+            <a:r>
+              <a:rPr sz="1725">
+                <a:solidFill>
+                  <a:srgbClr val="F9F8FD"/>
+                </a:solidFill>
+                <a:latin typeface="Switzer"/>
+                <a:ea typeface="Switzer"/>
+                <a:cs typeface="Switzer"/>
+              </a:rPr>
+              <a:t>Per-model</a:t>
+            </a:r>
+          </a:p>
+          <a:p xmlns:a="http://schemas.openxmlformats.org/drawingml/2006/main">
+            <a:pPr algn="ctr">
+              <a:buNone/>
+              <a:defRPr sz="1725">
+                <a:solidFill>
+                  <a:srgbClr val="F9F8FD"/>
+                </a:solidFill>
+                <a:latin typeface="Switzer"/>
+                <a:ea typeface="Switzer"/>
+                <a:cs typeface="Switzer"/>
+              </a:defRPr>
+            </a:pPr>
+            <a:r>
+              <a:rPr sz="1725">
+                <a:solidFill>
+                  <a:srgbClr val="F9F8FD"/>
+                </a:solidFill>
+                <a:latin typeface="Switzer"/>
+                <a:ea typeface="Switzer"/>
+                <a:cs typeface="Switzer"/>
+              </a:rPr>
+              <a:t>LoRA adapter</a:t>
+            </a:r>
+          </a:p>
+        </p:txBody>
+      </p:sp>
+      <p:sp>
+        <p:nvSpPr>
+          <p:cNvPr id="57" name="submit-guard">
+            <a:extLst xmlns:a="http://schemas.openxmlformats.org/drawingml/2006/main">
+              <a:ext uri="{FF2B5EF4-FFF2-40B4-BE49-F238E27FC236}">
+                <a16:creationId xmlns:a16="http://schemas.microsoft.com/office/drawing/2014/main" id="{8F101783-9F0B-4881-8E4B-AEB692F74B10}"/>
+              </a:ext>
+            </a:extLst>
+          </p:cNvPr>
+          <p:cNvSpPr>
+            <a:spLocks xmlns:a="http://schemas.openxmlformats.org/drawingml/2006/main" noGrp="1"/>
+          </p:cNvSpPr>
+          <p:nvPr/>
+        </p:nvSpPr>
+        <p:spPr>
+          <a:xfrm xmlns:a="http://schemas.openxmlformats.org/drawingml/2006/main">
+            <a:off x="8686800" y="2362200"/>
+            <a:ext cx="2714625" cy="1000125"/>
+          </a:xfrm>
+          <a:prstGeom xmlns:a="http://schemas.openxmlformats.org/drawingml/2006/main" prst="rect">
+            <a:avLst/>
+          </a:prstGeom>
+          <a:solidFill xmlns:a="http://schemas.openxmlformats.org/drawingml/2006/main">
+            <a:srgbClr val="27262B"/>
+          </a:solidFill>
+          <a:ln xmlns:a="http://schemas.openxmlformats.org/drawingml/2006/main" w="13335">
+            <a:solidFill>
+              <a:srgbClr val="6AE8CD"/>
+            </a:solidFill>
+            <a:prstDash val="solid"/>
+          </a:ln>
+        </p:spPr>
+        <p:txBody>
+          <a:bodyPr xmlns:a="http://schemas.openxmlformats.org/drawingml/2006/main" wrap="none" lIns="0" tIns="0" rIns="0" bIns="0" anchor="ctr">
+            <a:noAutofit/>
+          </a:bodyPr>
+          <a:lstStyle xmlns:a="http://schemas.openxmlformats.org/drawingml/2006/main"/>
+          <a:p xmlns:a="http://schemas.openxmlformats.org/drawingml/2006/main">
+            <a:pPr algn="ctr">
+              <a:buNone/>
+              <a:defRPr sz="1725">
+                <a:solidFill>
+                  <a:srgbClr val="F9F8FD"/>
+                </a:solidFill>
+                <a:latin typeface="Switzer"/>
+                <a:ea typeface="Switzer"/>
+                <a:cs typeface="Switzer"/>
+              </a:defRPr>
+            </a:pPr>
+            <a:r>
+              <a:rPr sz="1725">
+                <a:solidFill>
+                  <a:srgbClr val="F9F8FD"/>
+                </a:solidFill>
+                <a:latin typeface="Switzer"/>
+                <a:ea typeface="Switzer"/>
+                <a:cs typeface="Switzer"/>
+              </a:rPr>
+              <a:t>Held-out</a:t>
+            </a:r>
+          </a:p>
+          <a:p xmlns:a="http://schemas.openxmlformats.org/drawingml/2006/main">
+            <a:pPr algn="ctr">
+              <a:buNone/>
+              <a:defRPr sz="1725">
+                <a:solidFill>
+                  <a:srgbClr val="F9F8FD"/>
+                </a:solidFill>
+                <a:latin typeface="Switzer"/>
+                <a:ea typeface="Switzer"/>
+                <a:cs typeface="Switzer"/>
+              </a:defRPr>
+            </a:pPr>
+            <a:r>
+              <a:rPr sz="1725">
+                <a:solidFill>
+                  <a:srgbClr val="F9F8FD"/>
+                </a:solidFill>
+                <a:latin typeface="Switzer"/>
+                <a:ea typeface="Switzer"/>
+                <a:cs typeface="Switzer"/>
+              </a:rPr>
+              <a:t>protocol evaluation</a:t>
+            </a:r>
+          </a:p>
+        </p:txBody>
+      </p:sp>
+      <p:sp>
+        <p:nvSpPr>
+          <p:cNvPr id="58" name="capacity-label">
+            <a:extLst xmlns:a="http://schemas.openxmlformats.org/drawingml/2006/main">
+              <a:ext uri="{FF2B5EF4-FFF2-40B4-BE49-F238E27FC236}">
+                <a16:creationId xmlns:a16="http://schemas.microsoft.com/office/drawing/2014/main" id="{8D8C2023-E138-4063-847E-6B9C9CEDB863}"/>
+              </a:ext>
+            </a:extLst>
+          </p:cNvPr>
+          <p:cNvSpPr>
+            <a:spLocks xmlns:a="http://schemas.openxmlformats.org/drawingml/2006/main" noGrp="1"/>
+          </p:cNvSpPr>
+          <p:nvPr/>
+        </p:nvSpPr>
+        <p:spPr>
+          <a:xfrm xmlns:a="http://schemas.openxmlformats.org/drawingml/2006/main">
+            <a:off x="742950" y="3771900"/>
+            <a:ext cx="10620375" cy="361950"/>
+          </a:xfrm>
+          <a:prstGeom xmlns:a="http://schemas.openxmlformats.org/drawingml/2006/main" prst="rect">
+            <a:avLst/>
+          </a:prstGeom>
+          <a:noFill xmlns:a="http://schemas.openxmlformats.org/drawingml/2006/main"/>
+          <a:ln xmlns:a="http://schemas.openxmlformats.org/drawingml/2006/main" w="0">
+            <a:noFill/>
+            <a:prstDash val="solid"/>
+          </a:ln>
+        </p:spPr>
+        <p:txBody>
+          <a:bodyPr xmlns:a="http://schemas.openxmlformats.org/drawingml/2006/main" wrap="none" lIns="0" tIns="0" rIns="0" bIns="0" anchor="ctr">
+            <a:noAutofit/>
+          </a:bodyPr>
+          <a:lstStyle xmlns:a="http://schemas.openxmlformats.org/drawingml/2006/main"/>
+          <a:p xmlns:a="http://schemas.openxmlformats.org/drawingml/2006/main">
+            <a:pPr algn="l">
+              <a:buNone/>
+              <a:defRPr sz="1500">
+                <a:solidFill>
+                  <a:srgbClr val="BCBBC2"/>
+                </a:solidFill>
+                <a:latin typeface="Consolas"/>
+                <a:ea typeface="Consolas"/>
+                <a:cs typeface="Consolas"/>
+              </a:defRPr>
+            </a:pPr>
+            <a:r>
+              <a:rPr sz="1500">
+                <a:solidFill>
+                  <a:srgbClr val="BCBBC2"/>
+                </a:solidFill>
+                <a:latin typeface="Consolas"/>
+                <a:ea typeface="Consolas"/>
+                <a:cs typeface="Consolas"/>
+              </a:rPr>
+              <a:t>CAPTURE + EXPORT TODAY · ADAPTER TRAINING NEXT</a:t>
+            </a:r>
+          </a:p>
+        </p:txBody>
+      </p:sp>
+      <p:sp>
+        <p:nvSpPr>
+          <p:cNvPr id="59" name="panel-cap">
+            <a:extLst xmlns:a="http://schemas.openxmlformats.org/drawingml/2006/main">
+              <a:ext uri="{FF2B5EF4-FFF2-40B4-BE49-F238E27FC236}">
+                <a16:creationId xmlns:a16="http://schemas.microsoft.com/office/drawing/2014/main" id="{B3E36E69-0CC3-4DCB-90FD-7E13212D9B63}"/>
+              </a:ext>
+            </a:extLst>
+          </p:cNvPr>
+          <p:cNvSpPr>
+            <a:spLocks xmlns:a="http://schemas.openxmlformats.org/drawingml/2006/main" noGrp="1"/>
+          </p:cNvSpPr>
+          <p:nvPr/>
+        </p:nvSpPr>
+        <p:spPr>
+          <a:xfrm xmlns:a="http://schemas.openxmlformats.org/drawingml/2006/main">
+            <a:off x="742950" y="4276725"/>
+            <a:ext cx="4676775" cy="514350"/>
+          </a:xfrm>
+          <a:prstGeom xmlns:a="http://schemas.openxmlformats.org/drawingml/2006/main" prst="rect">
+            <a:avLst/>
+          </a:prstGeom>
+          <a:noFill xmlns:a="http://schemas.openxmlformats.org/drawingml/2006/main"/>
+          <a:ln xmlns:a="http://schemas.openxmlformats.org/drawingml/2006/main" w="0">
+            <a:noFill/>
+            <a:prstDash val="solid"/>
+          </a:ln>
+        </p:spPr>
+        <p:txBody>
+          <a:bodyPr xmlns:a="http://schemas.openxmlformats.org/drawingml/2006/main" wrap="none" lIns="0" tIns="0" rIns="0" bIns="0" anchor="ctr">
+            <a:noAutofit/>
+          </a:bodyPr>
+          <a:lstStyle xmlns:a="http://schemas.openxmlformats.org/drawingml/2006/main"/>
+          <a:p xmlns:a="http://schemas.openxmlformats.org/drawingml/2006/main">
+            <a:pPr algn="l">
+              <a:buNone/>
+              <a:defRPr sz="2775">
+                <a:solidFill>
+                  <a:srgbClr val="CBAAFF"/>
+                </a:solidFill>
+                <a:latin typeface="Alliance No.2"/>
+                <a:ea typeface="Alliance No.2"/>
+                <a:cs typeface="Alliance No.2"/>
+              </a:defRPr>
+            </a:pPr>
+            <a:r>
+              <a:rPr sz="2775">
+                <a:solidFill>
+                  <a:srgbClr val="CBAAFF"/>
+                </a:solidFill>
+                <a:latin typeface="Alliance No.2"/>
+                <a:ea typeface="Alliance No.2"/>
+                <a:cs typeface="Alliance No.2"/>
+              </a:rPr>
+              <a:t>Implemented</a:t>
+            </a:r>
+          </a:p>
+        </p:txBody>
+      </p:sp>
+      <p:sp>
+        <p:nvSpPr>
+          <p:cNvPr id="60" name="panel-cap-label">
+            <a:extLst xmlns:a="http://schemas.openxmlformats.org/drawingml/2006/main">
+              <a:ext uri="{FF2B5EF4-FFF2-40B4-BE49-F238E27FC236}">
+                <a16:creationId xmlns:a16="http://schemas.microsoft.com/office/drawing/2014/main" id="{61790DCE-DF1C-4820-B630-C077678DB3A1}"/>
+              </a:ext>
+            </a:extLst>
+          </p:cNvPr>
+          <p:cNvSpPr>
+            <a:spLocks xmlns:a="http://schemas.openxmlformats.org/drawingml/2006/main" noGrp="1"/>
+          </p:cNvSpPr>
+          <p:nvPr/>
+        </p:nvSpPr>
+        <p:spPr>
+          <a:xfrm xmlns:a="http://schemas.openxmlformats.org/drawingml/2006/main">
+            <a:off x="742950" y="4867275"/>
+            <a:ext cx="4676775" cy="333375"/>
+          </a:xfrm>
+          <a:prstGeom xmlns:a="http://schemas.openxmlformats.org/drawingml/2006/main" prst="rect">
+            <a:avLst/>
+          </a:prstGeom>
+          <a:noFill xmlns:a="http://schemas.openxmlformats.org/drawingml/2006/main"/>
+          <a:ln xmlns:a="http://schemas.openxmlformats.org/drawingml/2006/main" w="0">
+            <a:noFill/>
+            <a:prstDash val="solid"/>
+          </a:ln>
+        </p:spPr>
+        <p:txBody>
+          <a:bodyPr xmlns:a="http://schemas.openxmlformats.org/drawingml/2006/main" wrap="none" lIns="0" tIns="0" rIns="0" bIns="0" anchor="ctr">
+            <a:noAutofit/>
+          </a:bodyPr>
+          <a:lstStyle xmlns:a="http://schemas.openxmlformats.org/drawingml/2006/main"/>
+          <a:p xmlns:a="http://schemas.openxmlformats.org/drawingml/2006/main">
+            <a:pPr algn="l">
+              <a:buNone/>
+              <a:defRPr sz="1800">
+                <a:solidFill>
+                  <a:srgbClr val="BCBBC2"/>
+                </a:solidFill>
+                <a:latin typeface="Switzer"/>
+                <a:ea typeface="Switzer"/>
+                <a:cs typeface="Switzer"/>
+              </a:defRPr>
+            </a:pPr>
+            <a:r>
+              <a:rPr sz="1800">
+                <a:solidFill>
+                  <a:srgbClr val="BCBBC2"/>
+                </a:solidFill>
+                <a:latin typeface="Switzer"/>
+                <a:ea typeface="Switzer"/>
+                <a:cs typeface="Switzer"/>
+              </a:rPr>
+              <a:t>Private capture · reviewed JSONL</a:t>
+            </a:r>
+          </a:p>
+        </p:txBody>
+      </p:sp>
+      <p:sp>
+        <p:nvSpPr>
+          <p:cNvPr id="61" name="global-cap">
+            <a:extLst xmlns:a="http://schemas.openxmlformats.org/drawingml/2006/main">
+              <a:ext uri="{FF2B5EF4-FFF2-40B4-BE49-F238E27FC236}">
+                <a16:creationId xmlns:a16="http://schemas.microsoft.com/office/drawing/2014/main" id="{D1B973D0-9EDB-4E4D-BE68-B5088A4760D8}"/>
+              </a:ext>
+            </a:extLst>
+          </p:cNvPr>
+          <p:cNvSpPr>
+            <a:spLocks xmlns:a="http://schemas.openxmlformats.org/drawingml/2006/main" noGrp="1"/>
+          </p:cNvSpPr>
+          <p:nvPr/>
+        </p:nvSpPr>
+        <p:spPr>
+          <a:xfrm xmlns:a="http://schemas.openxmlformats.org/drawingml/2006/main">
+            <a:off x="6315075" y="4276725"/>
+            <a:ext cx="5048250" cy="514350"/>
+          </a:xfrm>
+          <a:prstGeom xmlns:a="http://schemas.openxmlformats.org/drawingml/2006/main" prst="rect">
+            <a:avLst/>
+          </a:prstGeom>
+          <a:noFill xmlns:a="http://schemas.openxmlformats.org/drawingml/2006/main"/>
+          <a:ln xmlns:a="http://schemas.openxmlformats.org/drawingml/2006/main" w="0">
+            <a:noFill/>
+            <a:prstDash val="solid"/>
+          </a:ln>
+        </p:spPr>
+        <p:txBody>
+          <a:bodyPr xmlns:a="http://schemas.openxmlformats.org/drawingml/2006/main" wrap="none" lIns="0" tIns="0" rIns="0" bIns="0" anchor="ctr">
+            <a:noAutofit/>
+          </a:bodyPr>
+          <a:lstStyle xmlns:a="http://schemas.openxmlformats.org/drawingml/2006/main"/>
+          <a:p xmlns:a="http://schemas.openxmlformats.org/drawingml/2006/main">
+            <a:pPr algn="l">
+              <a:buNone/>
+              <a:defRPr sz="2775">
+                <a:solidFill>
+                  <a:srgbClr val="6AE8CD"/>
+                </a:solidFill>
+                <a:latin typeface="Alliance No.2"/>
+                <a:ea typeface="Alliance No.2"/>
+                <a:cs typeface="Alliance No.2"/>
+              </a:defRPr>
+            </a:pPr>
+            <a:r>
+              <a:rPr sz="2775">
+                <a:solidFill>
+                  <a:srgbClr val="6AE8CD"/>
+                </a:solidFill>
+                <a:latin typeface="Alliance No.2"/>
+                <a:ea typeface="Alliance No.2"/>
+                <a:cs typeface="Alliance No.2"/>
+              </a:rPr>
+              <a:t>Next milestone</a:t>
+            </a:r>
+          </a:p>
+        </p:txBody>
+      </p:sp>
+      <p:sp>
+        <p:nvSpPr>
+          <p:cNvPr id="62" name="global-cap-label">
+            <a:extLst xmlns:a="http://schemas.openxmlformats.org/drawingml/2006/main">
+              <a:ext uri="{FF2B5EF4-FFF2-40B4-BE49-F238E27FC236}">
+                <a16:creationId xmlns:a16="http://schemas.microsoft.com/office/drawing/2014/main" id="{552E0489-325C-426E-826D-1E7EE30ABA47}"/>
+              </a:ext>
+            </a:extLst>
+          </p:cNvPr>
+          <p:cNvSpPr>
+            <a:spLocks xmlns:a="http://schemas.openxmlformats.org/drawingml/2006/main" noGrp="1"/>
+          </p:cNvSpPr>
+          <p:nvPr/>
+        </p:nvSpPr>
+        <p:spPr>
+          <a:xfrm xmlns:a="http://schemas.openxmlformats.org/drawingml/2006/main">
+            <a:off x="6315075" y="4867275"/>
+            <a:ext cx="5048250" cy="333375"/>
+          </a:xfrm>
+          <a:prstGeom xmlns:a="http://schemas.openxmlformats.org/drawingml/2006/main" prst="rect">
+            <a:avLst/>
+          </a:prstGeom>
+          <a:noFill xmlns:a="http://schemas.openxmlformats.org/drawingml/2006/main"/>
+          <a:ln xmlns:a="http://schemas.openxmlformats.org/drawingml/2006/main" w="0">
+            <a:noFill/>
+            <a:prstDash val="solid"/>
+          </a:ln>
+        </p:spPr>
+        <p:txBody>
+          <a:bodyPr xmlns:a="http://schemas.openxmlformats.org/drawingml/2006/main" wrap="none" lIns="0" tIns="0" rIns="0" bIns="0" anchor="ctr">
+            <a:noAutofit/>
+          </a:bodyPr>
+          <a:lstStyle xmlns:a="http://schemas.openxmlformats.org/drawingml/2006/main"/>
+          <a:p xmlns:a="http://schemas.openxmlformats.org/drawingml/2006/main">
+            <a:pPr algn="l">
+              <a:buNone/>
+              <a:defRPr sz="1800">
+                <a:solidFill>
+                  <a:srgbClr val="BCBBC2"/>
+                </a:solidFill>
+                <a:latin typeface="Switzer"/>
+                <a:ea typeface="Switzer"/>
+                <a:cs typeface="Switzer"/>
+              </a:defRPr>
+            </a:pPr>
+            <a:r>
+              <a:rPr sz="1800">
+                <a:solidFill>
+                  <a:srgbClr val="BCBBC2"/>
+                </a:solidFill>
+                <a:latin typeface="Switzer"/>
+                <a:ea typeface="Switzer"/>
+                <a:cs typeface="Switzer"/>
+              </a:rPr>
+              <a:t>Train, test and compare per model</a:t>
+            </a:r>
+          </a:p>
+        </p:txBody>
+      </p:sp>
+      <p:sp>
+        <p:nvSpPr>
+          <p:cNvPr id="63" name="cap-divider">
+            <a:extLst xmlns:a="http://schemas.openxmlformats.org/drawingml/2006/main">
+              <a:ext uri="{FF2B5EF4-FFF2-40B4-BE49-F238E27FC236}">
+                <a16:creationId xmlns:a16="http://schemas.microsoft.com/office/drawing/2014/main" id="{B7B5CE8F-7949-4D63-9DE3-364604C54DA5}"/>
+              </a:ext>
+            </a:extLst>
+          </p:cNvPr>
+          <p:cNvSpPr>
+            <a:spLocks xmlns:a="http://schemas.openxmlformats.org/drawingml/2006/main" noGrp="1"/>
+          </p:cNvSpPr>
+          <p:nvPr/>
+        </p:nvSpPr>
+        <p:spPr>
+          <a:xfrm xmlns:a="http://schemas.openxmlformats.org/drawingml/2006/main">
+            <a:off x="742950" y="5476875"/>
+            <a:ext cx="10620375" cy="0"/>
+          </a:xfrm>
+          <a:prstGeom xmlns:a="http://schemas.openxmlformats.org/drawingml/2006/main" prst="line">
+            <a:avLst/>
+          </a:prstGeom>
+          <a:noFill xmlns:a="http://schemas.openxmlformats.org/drawingml/2006/main"/>
+          <a:ln xmlns:a="http://schemas.openxmlformats.org/drawingml/2006/main" w="16193">
+            <a:solidFill>
+              <a:srgbClr val="838289"/>
+            </a:solidFill>
+            <a:prstDash val="solid"/>
+          </a:ln>
+        </p:spPr>
+      </p:sp>
+      <p:sp>
+        <p:nvSpPr>
+          <p:cNvPr id="64" name="limits">
+            <a:extLst xmlns:a="http://schemas.openxmlformats.org/drawingml/2006/main">
+              <a:ext uri="{FF2B5EF4-FFF2-40B4-BE49-F238E27FC236}">
+                <a16:creationId xmlns:a16="http://schemas.microsoft.com/office/drawing/2014/main" id="{BDD94E20-CF17-4DF5-AB23-BB97C4CB1F44}"/>
+              </a:ext>
+            </a:extLst>
+          </p:cNvPr>
+          <p:cNvSpPr>
+            <a:spLocks xmlns:a="http://schemas.openxmlformats.org/drawingml/2006/main" noGrp="1"/>
+          </p:cNvSpPr>
+          <p:nvPr/>
+        </p:nvSpPr>
+        <p:spPr>
+          <a:xfrm xmlns:a="http://schemas.openxmlformats.org/drawingml/2006/main">
+            <a:off x="742950" y="5676900"/>
+            <a:ext cx="10668000" cy="581025"/>
+          </a:xfrm>
+          <a:prstGeom xmlns:a="http://schemas.openxmlformats.org/drawingml/2006/main" prst="rect">
+            <a:avLst/>
+          </a:prstGeom>
+          <a:noFill xmlns:a="http://schemas.openxmlformats.org/drawingml/2006/main"/>
+          <a:ln xmlns:a="http://schemas.openxmlformats.org/drawingml/2006/main" w="0">
+            <a:noFill/>
+            <a:prstDash val="solid"/>
+          </a:ln>
+        </p:spPr>
+        <p:txBody>
+          <a:bodyPr xmlns:a="http://schemas.openxmlformats.org/drawingml/2006/main" wrap="none" lIns="0" tIns="0" rIns="0" bIns="0" anchor="ctr">
+            <a:noAutofit/>
+          </a:bodyPr>
+          <a:lstStyle xmlns:a="http://schemas.openxmlformats.org/drawingml/2006/main"/>
+          <a:p xmlns:a="http://schemas.openxmlformats.org/drawingml/2006/main">
+            <a:pPr algn="l">
+              <a:buNone/>
+              <a:defRPr sz="1725">
+                <a:solidFill>
+                  <a:srgbClr val="F9F8FD"/>
+                </a:solidFill>
+                <a:latin typeface="Switzer"/>
+                <a:ea typeface="Switzer"/>
+                <a:cs typeface="Switzer"/>
+              </a:defRPr>
+            </a:pPr>
+            <a:r>
+              <a:rPr sz="1725">
+                <a:solidFill>
+                  <a:srgbClr val="F9F8FD"/>
+                </a:solidFill>
+                <a:latin typeface="Switzer"/>
+                <a:ea typeface="Switzer"/>
+                <a:cs typeface="Switzer"/>
+              </a:rPr>
+              <a:t>Portable data. A separate adapter for each compatible base model.</a:t>
+            </a:r>
+          </a:p>
+          <a:p xmlns:a="http://schemas.openxmlformats.org/drawingml/2006/main">
+            <a:pPr algn="l">
+              <a:buNone/>
+              <a:defRPr sz="1725">
+                <a:solidFill>
+                  <a:srgbClr val="F9F8FD"/>
+                </a:solidFill>
+                <a:latin typeface="Switzer"/>
+                <a:ea typeface="Switzer"/>
+                <a:cs typeface="Switzer"/>
+              </a:defRPr>
+            </a:pPr>
+            <a:r>
+              <a:rPr sz="1725">
+                <a:solidFill>
+                  <a:srgbClr val="F9F8FD"/>
+                </a:solidFill>
+                <a:latin typeface="Switzer"/>
+                <a:ea typeface="Switzer"/>
+                <a:cs typeface="Switzer"/>
+              </a:rPr>
+              <a:t>Fine-tuning is planned; runtime routing guards remain mandatory.</a:t>
+            </a:r>
+          </a:p>
+        </p:txBody>
+      </p:sp>
+    </p:spTree>
+    <p:extLst>
+      <p:ext uri="{BB962C8B-B14F-4D97-AF65-F5344CB8AC3E}">
+        <p14:creationId xmlns:p14="http://schemas.microsoft.com/office/powerpoint/2010/main" val="107637514"/>
+      </p:ext>
+    </p:extLst>
+  </p:cSld>
+</p:sld>
+</file>
+
+<file path=ppt/slides/slide19.xml><?xml version="1.0" encoding="utf-8"?>
+<p:sld xmlns:p="http://schemas.openxmlformats.org/presentationml/2006/main">
+  <p:cSld>
+    <p:bg>
+      <p:bgPr>
+        <a:gradFill xmlns:a="http://schemas.openxmlformats.org/drawingml/2006/main">
+          <a:gsLst>
+            <a:gs pos="0">
+              <a:srgbClr val="201F24"/>
+            </a:gs>
+            <a:gs pos="44000">
+              <a:srgbClr val="201F24"/>
+            </a:gs>
+            <a:gs pos="76000">
+              <a:srgbClr val="35106F"/>
+            </a:gs>
+            <a:gs pos="100000">
+              <a:srgbClr val="8232FF"/>
+            </a:gs>
+          </a:gsLst>
+          <a:lin ang="6480000"/>
+        </a:gradFill>
+      </p:bgPr>
+    </p:bg>
+    <p:spTree>
+      <p:nvGrpSpPr>
+        <p:cNvPr id="1" name=""/>
+        <p:cNvGrpSpPr/>
+        <p:nvPr/>
+      </p:nvGrpSpPr>
+      <p:grpSpPr>
+        <a:xfrm xmlns:a="http://schemas.openxmlformats.org/drawingml/2006/main"/>
+      </p:grpSpPr>
+      <p:pic>
+        <p:nvPicPr>
+          <p:cNvPr id="16" name="Picture 1"/>
+          <p:cNvPicPr>
+            <a:picLocks xmlns:a="http://schemas.openxmlformats.org/drawingml/2006/main" noChangeAspect="1"/>
+          </p:cNvPicPr>
+          <p:nvPr/>
+        </p:nvPicPr>
+        <p:blipFill>
+          <a:blip xmlns:r="http://schemas.openxmlformats.org/officeDocument/2006/relationships" xmlns:a="http://schemas.openxmlformats.org/drawingml/2006/main" r:embed="Rb9e5b12929e0448f"/>
+          <a:stretch xmlns:a="http://schemas.openxmlformats.org/drawingml/2006/main"/>
+        </p:blipFill>
+        <p:spPr>
+          <a:xfrm xmlns:a="http://schemas.openxmlformats.org/drawingml/2006/main">
+            <a:off x="9953625" y="800100"/>
+            <a:ext cx="1143000" cy="1143000"/>
+          </a:xfrm>
+          <a:prstGeom xmlns:a="http://schemas.openxmlformats.org/drawingml/2006/main" prst="rect">
+            <a:avLst/>
+          </a:prstGeom>
+        </p:spPr>
+      </p:pic>
+      <p:sp>
+        <p:nvSpPr>
+          <p:cNvPr id="3" name="TextBox 2">
+            <a:extLst xmlns:a="http://schemas.openxmlformats.org/drawingml/2006/main">
+              <a:ext uri="{FF2B5EF4-FFF2-40B4-BE49-F238E27FC236}">
+                <a16:creationId xmlns:a16="http://schemas.microsoft.com/office/drawing/2014/main" id="{E2B571C4-D7DA-454D-A508-7DF7C4FC585C}"/>
+              </a:ext>
+            </a:extLst>
+          </p:cNvPr>
+          <p:cNvSpPr>
+            <a:spLocks xmlns:a="http://schemas.openxmlformats.org/drawingml/2006/main" noGrp="1"/>
+          </p:cNvSpPr>
+          <p:nvPr/>
+        </p:nvSpPr>
+        <p:spPr>
+          <a:xfrm xmlns:a="http://schemas.openxmlformats.org/drawingml/2006/main">
+            <a:off x="742950" y="1933575"/>
+            <a:ext cx="10477500" cy="752475"/>
+          </a:xfrm>
+          <a:prstGeom xmlns:a="http://schemas.openxmlformats.org/drawingml/2006/main" prst="rect">
+            <a:avLst/>
+          </a:prstGeom>
+          <a:noFill xmlns:a="http://schemas.openxmlformats.org/drawingml/2006/main"/>
+        </p:spPr>
+        <p:txBody>
+          <a:bodyPr xmlns:a="http://schemas.openxmlformats.org/drawingml/2006/main" wrap="none" lIns="0" tIns="0" rIns="0" bIns="0" anchor="ctr">
+            <a:noAutofit/>
+          </a:bodyPr>
+          <a:lstStyle xmlns:a="http://schemas.openxmlformats.org/drawingml/2006/main"/>
+          <a:p xmlns:a="http://schemas.openxmlformats.org/drawingml/2006/main">
+            <a:pPr algn="l">
+              <a:buNone/>
+              <a:defRPr sz="3600" b="0">
+                <a:solidFill>
+                  <a:srgbClr val="F9F8FD"/>
+                </a:solidFill>
+                <a:latin typeface="Alliance No.2"/>
+                <a:ea typeface="Alliance No.2"/>
+                <a:cs typeface="Alliance No.2"/>
+              </a:defRPr>
+            </a:pPr>
+            <a:r>
+              <a:rPr sz="3600" b="0">
+                <a:solidFill>
+                  <a:srgbClr val="F9F8FD"/>
+                </a:solidFill>
+                <a:latin typeface="Alliance No.2"/>
+                <a:ea typeface="Alliance No.2"/>
+                <a:cs typeface="Alliance No.2"/>
+              </a:rPr>
+              <a:t>Meet us at Agent Conf.</a:t>
+            </a:r>
+          </a:p>
+        </p:txBody>
+      </p:sp>
+      <p:sp>
+        <p:nvSpPr>
+          <p:cNvPr id="4" name="TextBox 3">
+            <a:extLst xmlns:a="http://schemas.openxmlformats.org/drawingml/2006/main">
+              <a:ext uri="{FF2B5EF4-FFF2-40B4-BE49-F238E27FC236}">
+                <a16:creationId xmlns:a16="http://schemas.microsoft.com/office/drawing/2014/main" id="{62C4EF88-ADA2-4A0A-AD75-4FC5C49C79CD}"/>
+              </a:ext>
+            </a:extLst>
+          </p:cNvPr>
+          <p:cNvSpPr>
+            <a:spLocks xmlns:a="http://schemas.openxmlformats.org/drawingml/2006/main" noGrp="1"/>
+          </p:cNvSpPr>
+          <p:nvPr/>
+        </p:nvSpPr>
+        <p:spPr>
+          <a:xfrm xmlns:a="http://schemas.openxmlformats.org/drawingml/2006/main">
+            <a:off x="742950" y="2800350"/>
+            <a:ext cx="10610850" cy="466725"/>
+          </a:xfrm>
+          <a:prstGeom xmlns:a="http://schemas.openxmlformats.org/drawingml/2006/main" prst="rect">
+            <a:avLst/>
+          </a:prstGeom>
+          <a:noFill xmlns:a="http://schemas.openxmlformats.org/drawingml/2006/main"/>
+        </p:spPr>
+        <p:txBody>
+          <a:bodyPr xmlns:a="http://schemas.openxmlformats.org/drawingml/2006/main" wrap="none" lIns="0" tIns="0" rIns="0" bIns="0" anchor="ctr">
+            <a:noAutofit/>
+          </a:bodyPr>
+          <a:lstStyle xmlns:a="http://schemas.openxmlformats.org/drawingml/2006/main"/>
+          <a:p xmlns:a="http://schemas.openxmlformats.org/drawingml/2006/main">
+            <a:pPr algn="l">
+              <a:buNone/>
+              <a:defRPr sz="2250" b="0">
+                <a:solidFill>
+                  <a:srgbClr val="CBAAFF"/>
+                </a:solidFill>
+                <a:latin typeface="Consolas"/>
+                <a:ea typeface="Consolas"/>
+                <a:cs typeface="Consolas"/>
+              </a:defRPr>
+            </a:pPr>
+            <a:r>
+              <a:rPr sz="2250" b="0">
+                <a:solidFill>
+                  <a:srgbClr val="CBAAFF"/>
+                </a:solidFill>
+                <a:latin typeface="Consolas"/>
+                <a:ea typeface="Consolas"/>
+                <a:cs typeface="Consolas"/>
+              </a:rPr>
+              <a:t>17–18 September 2026 · Warsaw</a:t>
+            </a:r>
+          </a:p>
+        </p:txBody>
+      </p:sp>
+      <p:sp>
+        <p:nvSpPr>
+          <p:cNvPr id="5" name="Rounded Rectangle 4">
+            <a:extLst xmlns:a="http://schemas.openxmlformats.org/drawingml/2006/main">
+              <a:ext uri="{FF2B5EF4-FFF2-40B4-BE49-F238E27FC236}">
+                <a16:creationId xmlns:a16="http://schemas.microsoft.com/office/drawing/2014/main" id="{68646C1F-A196-4BB4-8193-DFF566382DC4}"/>
+              </a:ext>
+            </a:extLst>
+          </p:cNvPr>
+          <p:cNvSpPr>
+            <a:spLocks xmlns:a="http://schemas.openxmlformats.org/drawingml/2006/main" noGrp="1"/>
+          </p:cNvSpPr>
+          <p:nvPr/>
+        </p:nvSpPr>
+        <p:spPr>
+          <a:xfrm xmlns:a="http://schemas.openxmlformats.org/drawingml/2006/main">
+            <a:off x="742950" y="3476625"/>
+            <a:ext cx="10629900" cy="962025"/>
+          </a:xfrm>
+          <a:prstGeom xmlns:a="http://schemas.openxmlformats.org/drawingml/2006/main" prst="roundRect">
+            <a:avLst>
+              <a:gd name="adj" fmla="val 4630"/>
+            </a:avLst>
+          </a:prstGeom>
+          <a:noFill xmlns:a="http://schemas.openxmlformats.org/drawingml/2006/main"/>
+          <a:ln xmlns:a="http://schemas.openxmlformats.org/drawingml/2006/main" w="9525">
+            <a:solidFill>
+              <a:srgbClr val="CBAAFF"/>
+            </a:solidFill>
+            <a:prstDash val="solid"/>
+          </a:ln>
+        </p:spPr>
+        <p:style>
+          <a:lnRef xmlns:a="http://schemas.openxmlformats.org/drawingml/2006/main" idx="1">
+            <a:schemeClr val="accent1"/>
+          </a:lnRef>
+          <a:fillRef xmlns:a="http://schemas.openxmlformats.org/drawingml/2006/main" idx="3">
+            <a:schemeClr val="accent1"/>
+          </a:fillRef>
+          <a:effectRef xmlns:a="http://schemas.openxmlformats.org/drawingml/2006/main" idx="0"/>
+          <a:fontRef xmlns:a="http://schemas.openxmlformats.org/drawingml/2006/main" idx="minor">
+            <a:schemeClr val="lt1"/>
+          </a:fontRef>
+        </p:style>
+        <p:txBody>
+          <a:bodyPr xmlns:a="http://schemas.openxmlformats.org/drawingml/2006/main" anchor="ctr"/>
+          <a:lstStyle xmlns:a="http://schemas.openxmlformats.org/drawingml/2006/main"/>
+          <a:p xmlns:a="http://schemas.openxmlformats.org/drawingml/2006/main">
+            <a:pPr algn="ctr">
+              <a:buNone/>
+            </a:pPr>
+          </a:p>
+        </p:txBody>
+      </p:sp>
+      <p:sp>
+        <p:nvSpPr>
+          <p:cNvPr id="6" name="TextBox 5">
+            <a:extLst xmlns:a="http://schemas.openxmlformats.org/drawingml/2006/main">
+              <a:ext uri="{FF2B5EF4-FFF2-40B4-BE49-F238E27FC236}">
+                <a16:creationId xmlns:a16="http://schemas.microsoft.com/office/drawing/2014/main" id="{CED7D471-F0C7-46DB-A417-EDEB97E79E41}"/>
+              </a:ext>
+            </a:extLst>
+          </p:cNvPr>
+          <p:cNvSpPr>
+            <a:spLocks xmlns:a="http://schemas.openxmlformats.org/drawingml/2006/main" noGrp="1"/>
+          </p:cNvSpPr>
+          <p:nvPr/>
+        </p:nvSpPr>
+        <p:spPr>
+          <a:xfrm xmlns:a="http://schemas.openxmlformats.org/drawingml/2006/main">
+            <a:off x="990600" y="3705225"/>
+            <a:ext cx="10163175" cy="533400"/>
+          </a:xfrm>
+          <a:prstGeom xmlns:a="http://schemas.openxmlformats.org/drawingml/2006/main" prst="rect">
+            <a:avLst/>
+          </a:prstGeom>
+          <a:noFill xmlns:a="http://schemas.openxmlformats.org/drawingml/2006/main"/>
+        </p:spPr>
+        <p:txBody>
+          <a:bodyPr xmlns:a="http://schemas.openxmlformats.org/drawingml/2006/main" wrap="none" lIns="0" tIns="0" rIns="0" bIns="0" anchor="ctr">
+            <a:noAutofit/>
+          </a:bodyPr>
+          <a:lstStyle xmlns:a="http://schemas.openxmlformats.org/drawingml/2006/main"/>
+          <a:p xmlns:a="http://schemas.openxmlformats.org/drawingml/2006/main">
+            <a:pPr algn="l">
+              <a:spcAft>
+                <a:spcPts val="400"/>
+              </a:spcAft>
+              <a:buNone/>
+              <a:defRPr sz="2550" b="0">
+                <a:solidFill>
+                  <a:srgbClr val="F9F8FD"/>
+                </a:solidFill>
+                <a:latin typeface="Consolas"/>
+                <a:ea typeface="Consolas"/>
+                <a:cs typeface="Consolas"/>
+              </a:defRPr>
+            </a:pPr>
+            <a:r>
+              <a:rPr sz="2550" b="0">
+                <a:solidFill>
+                  <a:srgbClr val="F9F8FD"/>
+                </a:solidFill>
+                <a:latin typeface="Consolas"/>
+                <a:ea typeface="Consolas"/>
+                <a:cs typeface="Consolas"/>
+                <a:hlinkClick xmlns:r="http://schemas.openxmlformats.org/officeDocument/2006/relationships" r:id="Ra417d4ae32164404"/>
+              </a:rPr>
+              <a:t>agent.sh/tickets</a:t>
+            </a:r>
+            <a:r>
+              <a:rPr sz="2550" b="0">
+                <a:solidFill>
+                  <a:srgbClr val="F9F8FD"/>
+                </a:solidFill>
+                <a:latin typeface="Consolas"/>
+                <a:ea typeface="Consolas"/>
+                <a:cs typeface="Consolas"/>
+              </a:rPr>
+              <a:t> →</a:t>
+            </a:r>
+          </a:p>
+        </p:txBody>
+      </p:sp>
+      <p:sp>
+        <p:nvSpPr>
+          <p:cNvPr id="7" name="TextBox 6">
+            <a:extLst xmlns:a="http://schemas.openxmlformats.org/drawingml/2006/main">
+              <a:ext uri="{FF2B5EF4-FFF2-40B4-BE49-F238E27FC236}">
+                <a16:creationId xmlns:a16="http://schemas.microsoft.com/office/drawing/2014/main" id="{7AEC0BD1-4425-4206-AEB3-0B15BB9F0F58}"/>
+              </a:ext>
+            </a:extLst>
+          </p:cNvPr>
+          <p:cNvSpPr>
+            <a:spLocks xmlns:a="http://schemas.openxmlformats.org/drawingml/2006/main" noGrp="1"/>
+          </p:cNvSpPr>
+          <p:nvPr/>
+        </p:nvSpPr>
+        <p:spPr>
+          <a:xfrm xmlns:a="http://schemas.openxmlformats.org/drawingml/2006/main">
+            <a:off x="742950" y="4600575"/>
+            <a:ext cx="10620375" cy="361950"/>
+          </a:xfrm>
+          <a:prstGeom xmlns:a="http://schemas.openxmlformats.org/drawingml/2006/main" prst="rect">
+            <a:avLst/>
+          </a:prstGeom>
+          <a:noFill xmlns:a="http://schemas.openxmlformats.org/drawingml/2006/main"/>
+        </p:spPr>
+        <p:txBody>
+          <a:bodyPr xmlns:a="http://schemas.openxmlformats.org/drawingml/2006/main" wrap="none" lIns="0" tIns="0" rIns="0" bIns="0" anchor="ctr">
+            <a:noAutofit/>
+          </a:bodyPr>
+          <a:lstStyle xmlns:a="http://schemas.openxmlformats.org/drawingml/2006/main"/>
+          <a:p xmlns:a="http://schemas.openxmlformats.org/drawingml/2006/main">
+            <a:pPr algn="l">
+              <a:buNone/>
+              <a:defRPr sz="1800" b="0">
+                <a:solidFill>
+                  <a:srgbClr val="F9F8FD"/>
+                </a:solidFill>
+                <a:latin typeface="Consolas"/>
+                <a:ea typeface="Consolas"/>
+                <a:cs typeface="Consolas"/>
+              </a:defRPr>
+            </a:pPr>
+            <a:r>
+              <a:rPr sz="1800" b="0">
+                <a:solidFill>
+                  <a:srgbClr val="F9F8FD"/>
+                </a:solidFill>
+                <a:latin typeface="Consolas"/>
+                <a:ea typeface="Consolas"/>
+                <a:cs typeface="Consolas"/>
+              </a:rPr>
+              <a:t>Two days for engineers building with AI agents.</a:t>
+            </a:r>
+          </a:p>
+        </p:txBody>
+      </p:sp>
+      <p:sp>
+        <p:nvSpPr>
+          <p:cNvPr id="8" name="TextBox 7">
+            <a:extLst xmlns:a="http://schemas.openxmlformats.org/drawingml/2006/main">
+              <a:ext uri="{FF2B5EF4-FFF2-40B4-BE49-F238E27FC236}">
+                <a16:creationId xmlns:a16="http://schemas.microsoft.com/office/drawing/2014/main" id="{963D474F-FEA2-485F-BA06-028DDF433761}"/>
+              </a:ext>
+            </a:extLst>
+          </p:cNvPr>
+          <p:cNvSpPr>
+            <a:spLocks xmlns:a="http://schemas.openxmlformats.org/drawingml/2006/main" noGrp="1"/>
+          </p:cNvSpPr>
+          <p:nvPr/>
+        </p:nvSpPr>
+        <p:spPr>
+          <a:xfrm xmlns:a="http://schemas.openxmlformats.org/drawingml/2006/main">
+            <a:off x="742950" y="5962650"/>
+            <a:ext cx="10620375" cy="295275"/>
+          </a:xfrm>
+          <a:prstGeom xmlns:a="http://schemas.openxmlformats.org/drawingml/2006/main" prst="rect">
+            <a:avLst/>
+          </a:prstGeom>
+          <a:noFill xmlns:a="http://schemas.openxmlformats.org/drawingml/2006/main"/>
+        </p:spPr>
+        <p:txBody>
+          <a:bodyPr xmlns:a="http://schemas.openxmlformats.org/drawingml/2006/main" wrap="none" lIns="0" tIns="0" rIns="0" bIns="0" anchor="ctr">
+            <a:noAutofit/>
+          </a:bodyPr>
+          <a:lstStyle xmlns:a="http://schemas.openxmlformats.org/drawingml/2006/main"/>
+          <a:p xmlns:a="http://schemas.openxmlformats.org/drawingml/2006/main">
+            <a:pPr algn="l">
+              <a:buNone/>
+              <a:defRPr sz="1500" b="0">
+                <a:solidFill>
+                  <a:srgbClr val="BCBBC2"/>
+                </a:solidFill>
+                <a:latin typeface="Switzer"/>
+                <a:ea typeface="Switzer"/>
+                <a:cs typeface="Switzer"/>
+              </a:defRPr>
+            </a:pPr>
+            <a:r>
+              <a:rPr sz="1500" b="0">
+                <a:solidFill>
+                  <a:srgbClr val="BCBBC2"/>
+                </a:solidFill>
+                <a:latin typeface="Switzer"/>
+                <a:ea typeface="Switzer"/>
+                <a:cs typeface="Switzer"/>
+              </a:rPr>
+              <a:t>Hosted by Callstack · Details: agent.sh</a:t>
+            </a:r>
+          </a:p>
+        </p:txBody>
+      </p:sp>
+      <p:sp>
+        <p:nvSpPr>
+          <p:cNvPr id="9" name="TextBox 8">
+            <a:extLst xmlns:a="http://schemas.openxmlformats.org/drawingml/2006/main">
+              <a:ext uri="{FF2B5EF4-FFF2-40B4-BE49-F238E27FC236}">
+                <a16:creationId xmlns:a16="http://schemas.microsoft.com/office/drawing/2014/main" id="{5251B42F-0482-4A79-9E65-262FA0FD07C6}"/>
+              </a:ext>
+            </a:extLst>
+          </p:cNvPr>
+          <p:cNvSpPr>
+            <a:spLocks xmlns:a="http://schemas.openxmlformats.org/drawingml/2006/main" noGrp="1"/>
+          </p:cNvSpPr>
+          <p:nvPr/>
+        </p:nvSpPr>
+        <p:spPr>
+          <a:xfrm xmlns:a="http://schemas.openxmlformats.org/drawingml/2006/main">
+            <a:off x="10668000" y="6419850"/>
+            <a:ext cx="857250" cy="285750"/>
+          </a:xfrm>
+          <a:prstGeom xmlns:a="http://schemas.openxmlformats.org/drawingml/2006/main" prst="rect">
+            <a:avLst/>
+          </a:prstGeom>
+          <a:noFill xmlns:a="http://schemas.openxmlformats.org/drawingml/2006/main"/>
+        </p:spPr>
+        <p:txBody>
+          <a:bodyPr xmlns:a="http://schemas.openxmlformats.org/drawingml/2006/main" wrap="none" lIns="0" tIns="0" rIns="0" bIns="0" anchor="ctr">
+            <a:noAutofit/>
+          </a:bodyPr>
+          <a:lstStyle xmlns:a="http://schemas.openxmlformats.org/drawingml/2006/main"/>
+          <a:p xmlns:a="http://schemas.openxmlformats.org/drawingml/2006/main">
+            <a:pPr algn="r">
+              <a:buNone/>
+              <a:defRPr sz="1200" b="0">
+                <a:solidFill>
+                  <a:srgbClr val="BCBBC2"/>
+                </a:solidFill>
+                <a:latin typeface="Consolas"/>
+                <a:ea typeface="Consolas"/>
+                <a:cs typeface="Consolas"/>
+              </a:defRPr>
+            </a:pPr>
+            <a:r>
+              <a:rPr sz="1200" b="0">
+                <a:solidFill>
+                  <a:srgbClr val="BCBBC2"/>
+                </a:solidFill>
+                <a:latin typeface="Consolas"/>
+                <a:ea typeface="Consolas"/>
+                <a:cs typeface="Consolas"/>
+              </a:rPr>
+              <a:t>19/20</a:t>
+            </a:r>
+          </a:p>
+        </p:txBody>
+      </p:sp>
+      <p:pic>
+        <p:nvPicPr>
+          <p:cNvPr id="24" name=""/>
+          <p:cNvPicPr>
+            <a:picLocks xmlns:a="http://schemas.openxmlformats.org/drawingml/2006/main" noChangeAspect="1"/>
+          </p:cNvPicPr>
+          <p:nvPr/>
+        </p:nvPicPr>
+        <p:blipFill>
+          <a:blip xmlns:r="http://schemas.openxmlformats.org/officeDocument/2006/relationships" xmlns:a="http://schemas.openxmlformats.org/drawingml/2006/main" r:embed="R2d8e0942d0dd4230"/>
+          <a:stretch xmlns:a="http://schemas.openxmlformats.org/drawingml/2006/main"/>
+        </p:blipFill>
+        <p:spPr>
+          <a:xfrm xmlns:a="http://schemas.openxmlformats.org/drawingml/2006/main">
+            <a:off x="692604" y="342900"/>
+            <a:ext cx="1567543" cy="342900"/>
+          </a:xfrm>
+          <a:prstGeom xmlns:a="http://schemas.openxmlformats.org/drawingml/2006/main" prst="rect">
+            <a:avLst/>
+          </a:prstGeom>
+        </p:spPr>
+      </p:pic>
+      <p:sp>
+        <p:nvSpPr>
+          <p:cNvPr id="12" name="conference-source-label">
+            <a:extLst xmlns:a="http://schemas.openxmlformats.org/drawingml/2006/main">
+              <a:ext uri="{FF2B5EF4-FFF2-40B4-BE49-F238E27FC236}">
+                <a16:creationId xmlns:a16="http://schemas.microsoft.com/office/drawing/2014/main" id="{F6AD476A-8E8A-47D1-B5AB-E79E6FB8E588}"/>
+              </a:ext>
+            </a:extLst>
+          </p:cNvPr>
+          <p:cNvSpPr>
+            <a:spLocks xmlns:a="http://schemas.openxmlformats.org/drawingml/2006/main" noGrp="1"/>
+          </p:cNvSpPr>
+          <p:nvPr/>
+        </p:nvSpPr>
+        <p:spPr>
+          <a:xfrm xmlns:a="http://schemas.openxmlformats.org/drawingml/2006/main">
+            <a:off x="742950" y="5143500"/>
+            <a:ext cx="10610850" cy="304800"/>
+          </a:xfrm>
+          <a:prstGeom xmlns:a="http://schemas.openxmlformats.org/drawingml/2006/main" prst="rect">
+            <a:avLst/>
+          </a:prstGeom>
+          <a:noFill xmlns:a="http://schemas.openxmlformats.org/drawingml/2006/main"/>
+          <a:ln xmlns:a="http://schemas.openxmlformats.org/drawingml/2006/main" w="0">
+            <a:noFill/>
+            <a:prstDash val="solid"/>
+          </a:ln>
+        </p:spPr>
+        <p:txBody>
+          <a:bodyPr xmlns:a="http://schemas.openxmlformats.org/drawingml/2006/main" wrap="none" lIns="0" tIns="0" rIns="0" bIns="0" anchor="ctr">
+            <a:noAutofit/>
+          </a:bodyPr>
+          <a:lstStyle xmlns:a="http://schemas.openxmlformats.org/drawingml/2006/main"/>
+          <a:p xmlns:a="http://schemas.openxmlformats.org/drawingml/2006/main">
+            <a:pPr algn="l">
+              <a:buNone/>
+              <a:defRPr sz="1575">
+                <a:solidFill>
+                  <a:srgbClr val="6AE8CD"/>
+                </a:solidFill>
+                <a:latin typeface="Consolas"/>
+                <a:ea typeface="Consolas"/>
+                <a:cs typeface="Consolas"/>
+              </a:defRPr>
+            </a:pPr>
+            <a:r>
+              <a:rPr sz="1575">
+                <a:solidFill>
+                  <a:srgbClr val="6AE8CD"/>
+                </a:solidFill>
+                <a:latin typeface="Consolas"/>
+                <a:ea typeface="Consolas"/>
+                <a:cs typeface="Consolas"/>
+              </a:rPr>
+              <a:t>ORCHESTRATION · AGENT ENGINEERING · ADOPTION</a:t>
+            </a:r>
+          </a:p>
+        </p:txBody>
+      </p:sp>
+      <p:sp>
+        <p:nvSpPr>
+          <p:cNvPr id="13" name="conference-source-detail">
+            <a:extLst xmlns:a="http://schemas.openxmlformats.org/drawingml/2006/main">
+              <a:ext uri="{FF2B5EF4-FFF2-40B4-BE49-F238E27FC236}">
+                <a16:creationId xmlns:a16="http://schemas.microsoft.com/office/drawing/2014/main" id="{A3FEC5EA-3EAE-4282-AB47-F3C37FFC92F0}"/>
+              </a:ext>
+            </a:extLst>
+          </p:cNvPr>
+          <p:cNvSpPr>
+            <a:spLocks xmlns:a="http://schemas.openxmlformats.org/drawingml/2006/main" noGrp="1"/>
+          </p:cNvSpPr>
+          <p:nvPr/>
+        </p:nvSpPr>
+        <p:spPr>
+          <a:xfrm xmlns:a="http://schemas.openxmlformats.org/drawingml/2006/main">
+            <a:off x="742950" y="5524500"/>
+            <a:ext cx="10610850" cy="314325"/>
+          </a:xfrm>
+          <a:prstGeom xmlns:a="http://schemas.openxmlformats.org/drawingml/2006/main" prst="rect">
+            <a:avLst/>
+          </a:prstGeom>
+          <a:noFill xmlns:a="http://schemas.openxmlformats.org/drawingml/2006/main"/>
+          <a:ln xmlns:a="http://schemas.openxmlformats.org/drawingml/2006/main" w="0">
+            <a:noFill/>
+            <a:prstDash val="solid"/>
+          </a:ln>
+        </p:spPr>
+        <p:txBody>
+          <a:bodyPr xmlns:a="http://schemas.openxmlformats.org/drawingml/2006/main" wrap="none" lIns="0" tIns="0" rIns="0" bIns="0" anchor="ctr">
+            <a:noAutofit/>
+          </a:bodyPr>
+          <a:lstStyle xmlns:a="http://schemas.openxmlformats.org/drawingml/2006/main"/>
+          <a:p xmlns:a="http://schemas.openxmlformats.org/drawingml/2006/main">
+            <a:pPr algn="l">
+              <a:buNone/>
+              <a:defRPr sz="1725">
+                <a:solidFill>
+                  <a:srgbClr val="BCBBC2"/>
+                </a:solidFill>
+                <a:latin typeface="Switzer"/>
+                <a:ea typeface="Switzer"/>
+                <a:cs typeface="Switzer"/>
+              </a:defRPr>
+            </a:pPr>
+            <a:r>
+              <a:rPr sz="1725">
+                <a:solidFill>
+                  <a:srgbClr val="BCBBC2"/>
+                </a:solidFill>
+                <a:latin typeface="Switzer"/>
+                <a:ea typeface="Switzer"/>
+                <a:cs typeface="Switzer"/>
+              </a:rPr>
+              <a:t>Crowne Plaza Warsaw [The HUB]</a:t>
+            </a:r>
+          </a:p>
+        </p:txBody>
+      </p:sp>
+    </p:spTree>
+    <p:extLst>
+      <p:ext uri="{BB962C8B-B14F-4D97-AF65-F5344CB8AC3E}">
+        <p14:creationId xmlns:p14="http://schemas.microsoft.com/office/powerpoint/2010/main" val="1080936326"/>
+      </p:ext>
+    </p:extLst>
+  </p:cSld>
+</p:sld>
+</file>
+
+<file path=ppt/slides/slide2.xml><?xml version="1.0" encoding="utf-8"?>
+<p:sld xmlns:p="http://schemas.openxmlformats.org/presentationml/2006/main">
+  <p:cSld>
+    <p:bg>
+      <p:bgPr>
+        <a:solidFill xmlns:a="http://schemas.openxmlformats.org/drawingml/2006/main">
+          <a:srgbClr val="201F24"/>
+        </a:solidFill>
+      </p:bgPr>
+    </p:bg>
+    <p:spTree>
+      <p:nvGrpSpPr>
+        <p:cNvPr id="1" name=""/>
+        <p:cNvGrpSpPr/>
+        <p:nvPr/>
+      </p:nvGrpSpPr>
+      <p:grpSpPr>
+        <a:xfrm xmlns:a="http://schemas.openxmlformats.org/drawingml/2006/main"/>
+      </p:grpSpPr>
+      <p:sp>
+        <p:nvSpPr>
+          <p:cNvPr id="2" name="TextBox 1">
+            <a:extLst xmlns:a="http://schemas.openxmlformats.org/drawingml/2006/main">
+              <a:ext uri="{FF2B5EF4-FFF2-40B4-BE49-F238E27FC236}">
+                <a16:creationId xmlns:a16="http://schemas.microsoft.com/office/drawing/2014/main" id="{07C4FE56-EF53-4B59-80FD-0556F3ADEF68}"/>
+              </a:ext>
+            </a:extLst>
+          </p:cNvPr>
+          <p:cNvSpPr>
+            <a:spLocks xmlns:a="http://schemas.openxmlformats.org/drawingml/2006/main" noGrp="1"/>
+          </p:cNvSpPr>
+          <p:nvPr/>
+        </p:nvSpPr>
+        <p:spPr>
+          <a:xfrm xmlns:a="http://schemas.openxmlformats.org/drawingml/2006/main">
+            <a:off x="731520" y="409575"/>
+            <a:ext cx="10820400" cy="333375"/>
+          </a:xfrm>
+          <a:prstGeom xmlns:a="http://schemas.openxmlformats.org/drawingml/2006/main" prst="rect">
+            <a:avLst/>
+          </a:prstGeom>
+          <a:noFill xmlns:a="http://schemas.openxmlformats.org/drawingml/2006/main"/>
+        </p:spPr>
+        <p:txBody>
+          <a:bodyPr xmlns:a="http://schemas.openxmlformats.org/drawingml/2006/main" wrap="none" lIns="0" tIns="0" rIns="0" bIns="0" anchor="ctr">
+            <a:noAutofit/>
+          </a:bodyPr>
+          <a:lstStyle xmlns:a="http://schemas.openxmlformats.org/drawingml/2006/main"/>
+          <a:p xmlns:a="http://schemas.openxmlformats.org/drawingml/2006/main">
+            <a:pPr algn="l">
+              <a:buNone/>
+              <a:defRPr sz="1200" b="1">
+                <a:solidFill>
+                  <a:srgbClr val="CBAAFF"/>
+                </a:solidFill>
+                <a:latin typeface="Consolas"/>
+                <a:ea typeface="Consolas"/>
+                <a:cs typeface="Consolas"/>
+              </a:defRPr>
+            </a:pPr>
+            <a:r>
+              <a:rPr sz="1200" b="1">
+                <a:solidFill>
+                  <a:srgbClr val="CBAAFF"/>
+                </a:solidFill>
+                <a:latin typeface="Consolas"/>
+                <a:ea typeface="Consolas"/>
+                <a:cs typeface="Consolas"/>
+              </a:rPr>
+              <a:t>IN THE TERMINAL</a:t>
+            </a:r>
+          </a:p>
+        </p:txBody>
+      </p:sp>
+      <p:sp>
+        <p:nvSpPr>
+          <p:cNvPr id="3" name="TextBox 2">
+            <a:extLst xmlns:a="http://schemas.openxmlformats.org/drawingml/2006/main">
+              <a:ext uri="{FF2B5EF4-FFF2-40B4-BE49-F238E27FC236}">
+                <a16:creationId xmlns:a16="http://schemas.microsoft.com/office/drawing/2014/main" id="{1ADF6C27-524D-429D-963F-7FAB2499F859}"/>
+              </a:ext>
+            </a:extLst>
+          </p:cNvPr>
+          <p:cNvSpPr>
+            <a:spLocks xmlns:a="http://schemas.openxmlformats.org/drawingml/2006/main" noGrp="1"/>
+          </p:cNvSpPr>
+          <p:nvPr/>
+        </p:nvSpPr>
+        <p:spPr>
+          <a:xfrm xmlns:a="http://schemas.openxmlformats.org/drawingml/2006/main">
+            <a:off x="731520" y="914400"/>
+            <a:ext cx="10820400" cy="704850"/>
+          </a:xfrm>
+          <a:prstGeom xmlns:a="http://schemas.openxmlformats.org/drawingml/2006/main" prst="rect">
+            <a:avLst/>
+          </a:prstGeom>
+          <a:noFill xmlns:a="http://schemas.openxmlformats.org/drawingml/2006/main"/>
+        </p:spPr>
+        <p:txBody>
+          <a:bodyPr xmlns:a="http://schemas.openxmlformats.org/drawingml/2006/main" wrap="none" lIns="0" tIns="0" rIns="0" bIns="0" anchor="ctr">
+            <a:noAutofit/>
+          </a:bodyPr>
+          <a:lstStyle xmlns:a="http://schemas.openxmlformats.org/drawingml/2006/main"/>
+          <a:p xmlns:a="http://schemas.openxmlformats.org/drawingml/2006/main">
+            <a:pPr algn="l">
+              <a:buNone/>
+              <a:defRPr sz="3300" b="0">
+                <a:solidFill>
+                  <a:srgbClr val="F9F8FD"/>
+                </a:solidFill>
+                <a:latin typeface="Alliance No.2"/>
+                <a:ea typeface="Alliance No.2"/>
+                <a:cs typeface="Alliance No.2"/>
+              </a:defRPr>
+            </a:pPr>
+            <a:r>
+              <a:rPr sz="3300" b="0">
+                <a:solidFill>
+                  <a:srgbClr val="F9F8FD"/>
+                </a:solidFill>
+                <a:latin typeface="Alliance No.2"/>
+                <a:ea typeface="Alliance No.2"/>
+                <a:cs typeface="Alliance No.2"/>
+              </a:rPr>
+              <a:t>One workspace. Real terminal sessions.</a:t>
+            </a:r>
+          </a:p>
+        </p:txBody>
+      </p:sp>
+      <p:sp>
+        <p:nvSpPr>
+          <p:cNvPr id="28" name="TextBox 27">
+            <a:extLst xmlns:a="http://schemas.openxmlformats.org/drawingml/2006/main">
+              <a:ext uri="{FF2B5EF4-FFF2-40B4-BE49-F238E27FC236}">
+                <a16:creationId xmlns:a16="http://schemas.microsoft.com/office/drawing/2014/main" id="{F407AF73-1128-4BB2-9A9D-E65D3110D560}"/>
+              </a:ext>
+            </a:extLst>
+          </p:cNvPr>
+          <p:cNvSpPr>
+            <a:spLocks xmlns:a="http://schemas.openxmlformats.org/drawingml/2006/main" noGrp="1"/>
+          </p:cNvSpPr>
+          <p:nvPr/>
+        </p:nvSpPr>
+        <p:spPr>
+          <a:xfrm xmlns:a="http://schemas.openxmlformats.org/drawingml/2006/main">
+            <a:off x="10668000" y="6419850"/>
+            <a:ext cx="857250" cy="285750"/>
+          </a:xfrm>
+          <a:prstGeom xmlns:a="http://schemas.openxmlformats.org/drawingml/2006/main" prst="rect">
+            <a:avLst/>
+          </a:prstGeom>
+          <a:noFill xmlns:a="http://schemas.openxmlformats.org/drawingml/2006/main"/>
+        </p:spPr>
+        <p:txBody>
+          <a:bodyPr xmlns:a="http://schemas.openxmlformats.org/drawingml/2006/main" wrap="none" lIns="0" tIns="0" rIns="0" bIns="0" anchor="ctr">
+            <a:noAutofit/>
+          </a:bodyPr>
+          <a:lstStyle xmlns:a="http://schemas.openxmlformats.org/drawingml/2006/main"/>
+          <a:p xmlns:a="http://schemas.openxmlformats.org/drawingml/2006/main">
+            <a:pPr algn="r">
+              <a:buNone/>
+              <a:defRPr sz="1200" b="0">
+                <a:solidFill>
+                  <a:srgbClr val="BCBBC2"/>
+                </a:solidFill>
+                <a:latin typeface="Consolas"/>
+                <a:ea typeface="Consolas"/>
+                <a:cs typeface="Consolas"/>
+              </a:defRPr>
+            </a:pPr>
+            <a:r>
+              <a:rPr sz="1200" b="0">
+                <a:solidFill>
+                  <a:srgbClr val="BCBBC2"/>
+                </a:solidFill>
+                <a:latin typeface="Consolas"/>
+                <a:ea typeface="Consolas"/>
+                <a:cs typeface="Consolas"/>
+              </a:rPr>
+              <a:t>2/20</a:t>
+            </a:r>
+          </a:p>
+        </p:txBody>
+      </p:sp>
+      <p:sp>
+        <p:nvSpPr>
+          <p:cNvPr id="29" name="Callstack accent rule">
+            <a:extLst xmlns:a="http://schemas.openxmlformats.org/drawingml/2006/main">
+              <a:ext uri="{FF2B5EF4-FFF2-40B4-BE49-F238E27FC236}">
+                <a16:creationId xmlns:a16="http://schemas.microsoft.com/office/drawing/2014/main" id="{57ECF28A-4432-486B-B490-F06CEE4625F4}"/>
+              </a:ext>
+            </a:extLst>
+          </p:cNvPr>
+          <p:cNvSpPr>
+            <a:spLocks xmlns:a="http://schemas.openxmlformats.org/drawingml/2006/main" noGrp="1"/>
+          </p:cNvSpPr>
+          <p:nvPr/>
+        </p:nvSpPr>
+        <p:spPr>
+          <a:xfrm xmlns:a="http://schemas.openxmlformats.org/drawingml/2006/main">
+            <a:off x="0" y="0"/>
+            <a:ext cx="12192000" cy="57150"/>
+          </a:xfrm>
+          <a:prstGeom xmlns:a="http://schemas.openxmlformats.org/drawingml/2006/main" prst="rect">
+            <a:avLst/>
+          </a:prstGeom>
+          <a:solidFill xmlns:a="http://schemas.openxmlformats.org/drawingml/2006/main">
+            <a:srgbClr val="8232FF"/>
+          </a:solidFill>
+          <a:ln xmlns:a="http://schemas.openxmlformats.org/drawingml/2006/main" w="2381">
+            <a:solidFill>
+              <a:srgbClr val="8232FF"/>
+            </a:solidFill>
+            <a:prstDash val="solid"/>
+          </a:ln>
+        </p:spPr>
+      </p:sp>
+      <p:pic>
+        <p:nvPicPr>
+          <p:cNvPr id="41" name=""/>
+          <p:cNvPicPr>
+            <a:picLocks xmlns:a="http://schemas.openxmlformats.org/drawingml/2006/main" noChangeAspect="1"/>
+          </p:cNvPicPr>
+          <p:nvPr/>
+        </p:nvPicPr>
+        <p:blipFill>
+          <a:blip xmlns:r="http://schemas.openxmlformats.org/officeDocument/2006/relationships" xmlns:a="http://schemas.openxmlformats.org/drawingml/2006/main" r:embed="Ree9f5bdb1427459a"/>
+          <a:stretch xmlns:a="http://schemas.openxmlformats.org/drawingml/2006/main"/>
+        </p:blipFill>
+        <p:spPr>
+          <a:xfrm xmlns:a="http://schemas.openxmlformats.org/drawingml/2006/main">
+            <a:off x="723900" y="1828800"/>
+            <a:ext cx="8382000" cy="4191000"/>
+          </a:xfrm>
+          <a:prstGeom xmlns:a="http://schemas.openxmlformats.org/drawingml/2006/main" prst="rect">
+            <a:avLst/>
+          </a:prstGeom>
+        </p:spPr>
+      </p:pic>
+      <p:sp>
+        <p:nvSpPr>
+          <p:cNvPr id="31" name="two-panels">
+            <a:extLst xmlns:a="http://schemas.openxmlformats.org/drawingml/2006/main">
+              <a:ext uri="{FF2B5EF4-FFF2-40B4-BE49-F238E27FC236}">
+                <a16:creationId xmlns:a16="http://schemas.microsoft.com/office/drawing/2014/main" id="{1C00BA6A-847B-4539-8995-307AF92E4753}"/>
+              </a:ext>
+            </a:extLst>
+          </p:cNvPr>
+          <p:cNvSpPr>
+            <a:spLocks xmlns:a="http://schemas.openxmlformats.org/drawingml/2006/main" noGrp="1"/>
+          </p:cNvSpPr>
+          <p:nvPr/>
+        </p:nvSpPr>
+        <p:spPr>
+          <a:xfrm xmlns:a="http://schemas.openxmlformats.org/drawingml/2006/main">
+            <a:off x="9353550" y="2028825"/>
+            <a:ext cx="2133600" cy="523875"/>
+          </a:xfrm>
+          <a:prstGeom xmlns:a="http://schemas.openxmlformats.org/drawingml/2006/main" prst="rect">
+            <a:avLst/>
+          </a:prstGeom>
+          <a:noFill xmlns:a="http://schemas.openxmlformats.org/drawingml/2006/main"/>
+          <a:ln xmlns:a="http://schemas.openxmlformats.org/drawingml/2006/main" w="0">
+            <a:noFill/>
+            <a:prstDash val="solid"/>
+          </a:ln>
+        </p:spPr>
+        <p:txBody>
+          <a:bodyPr xmlns:a="http://schemas.openxmlformats.org/drawingml/2006/main" wrap="none" lIns="0" tIns="0" rIns="0" bIns="0" anchor="ctr">
+            <a:noAutofit/>
+          </a:bodyPr>
+          <a:lstStyle xmlns:a="http://schemas.openxmlformats.org/drawingml/2006/main"/>
+          <a:p xmlns:a="http://schemas.openxmlformats.org/drawingml/2006/main">
+            <a:pPr algn="l">
+              <a:buNone/>
+              <a:defRPr sz="2700">
+                <a:solidFill>
+                  <a:srgbClr val="CBAAFF"/>
+                </a:solidFill>
+                <a:latin typeface="Alliance No.2"/>
+                <a:ea typeface="Alliance No.2"/>
+                <a:cs typeface="Alliance No.2"/>
+              </a:defRPr>
+            </a:pPr>
+            <a:r>
+              <a:rPr sz="2700">
+                <a:solidFill>
+                  <a:srgbClr val="CBAAFF"/>
+                </a:solidFill>
+                <a:latin typeface="Alliance No.2"/>
+                <a:ea typeface="Alliance No.2"/>
+                <a:cs typeface="Alliance No.2"/>
+              </a:rPr>
+              <a:t>2 panels</a:t>
+            </a:r>
+          </a:p>
+        </p:txBody>
+      </p:sp>
+      <p:sp>
+        <p:nvSpPr>
+          <p:cNvPr id="32" name="separate-ptys">
+            <a:extLst xmlns:a="http://schemas.openxmlformats.org/drawingml/2006/main">
+              <a:ext uri="{FF2B5EF4-FFF2-40B4-BE49-F238E27FC236}">
+                <a16:creationId xmlns:a16="http://schemas.microsoft.com/office/drawing/2014/main" id="{50344505-F1D9-40D5-B6D3-D892A306EF3C}"/>
+              </a:ext>
+            </a:extLst>
+          </p:cNvPr>
+          <p:cNvSpPr>
+            <a:spLocks xmlns:a="http://schemas.openxmlformats.org/drawingml/2006/main" noGrp="1"/>
+          </p:cNvSpPr>
+          <p:nvPr/>
+        </p:nvSpPr>
+        <p:spPr>
+          <a:xfrm xmlns:a="http://schemas.openxmlformats.org/drawingml/2006/main">
+            <a:off x="9353550" y="2667000"/>
+            <a:ext cx="2190750" cy="704850"/>
+          </a:xfrm>
+          <a:prstGeom xmlns:a="http://schemas.openxmlformats.org/drawingml/2006/main" prst="rect">
+            <a:avLst/>
+          </a:prstGeom>
+          <a:noFill xmlns:a="http://schemas.openxmlformats.org/drawingml/2006/main"/>
+          <a:ln xmlns:a="http://schemas.openxmlformats.org/drawingml/2006/main" w="0">
+            <a:noFill/>
+            <a:prstDash val="solid"/>
+          </a:ln>
+        </p:spPr>
+        <p:txBody>
+          <a:bodyPr xmlns:a="http://schemas.openxmlformats.org/drawingml/2006/main" wrap="none" lIns="0" tIns="0" rIns="0" bIns="0" anchor="ctr">
+            <a:noAutofit/>
+          </a:bodyPr>
+          <a:lstStyle xmlns:a="http://schemas.openxmlformats.org/drawingml/2006/main"/>
+          <a:p xmlns:a="http://schemas.openxmlformats.org/drawingml/2006/main">
+            <a:pPr algn="l">
+              <a:buNone/>
+              <a:defRPr sz="1875">
+                <a:solidFill>
+                  <a:srgbClr val="F9F8FD"/>
+                </a:solidFill>
+                <a:latin typeface="Switzer"/>
+                <a:ea typeface="Switzer"/>
+                <a:cs typeface="Switzer"/>
+              </a:defRPr>
+            </a:pPr>
+            <a:r>
+              <a:rPr sz="1875">
+                <a:solidFill>
+                  <a:srgbClr val="F9F8FD"/>
+                </a:solidFill>
+                <a:latin typeface="Switzer"/>
+                <a:ea typeface="Switzer"/>
+                <a:cs typeface="Switzer"/>
+              </a:rPr>
+              <a:t>Independent PTYs</a:t>
+            </a:r>
+          </a:p>
+          <a:p xmlns:a="http://schemas.openxmlformats.org/drawingml/2006/main">
+            <a:pPr algn="l">
+              <a:buNone/>
+              <a:defRPr sz="1875">
+                <a:solidFill>
+                  <a:srgbClr val="F9F8FD"/>
+                </a:solidFill>
+                <a:latin typeface="Switzer"/>
+                <a:ea typeface="Switzer"/>
+                <a:cs typeface="Switzer"/>
+              </a:defRPr>
+            </a:pPr>
+            <a:r>
+              <a:rPr sz="1875">
+                <a:solidFill>
+                  <a:srgbClr val="F9F8FD"/>
+                </a:solidFill>
+                <a:latin typeface="Switzer"/>
+                <a:ea typeface="Switzer"/>
+                <a:cs typeface="Switzer"/>
+              </a:rPr>
+              <a:t>and CLI contexts</a:t>
+            </a:r>
+          </a:p>
+        </p:txBody>
+      </p:sp>
+      <p:sp>
+        <p:nvSpPr>
+          <p:cNvPr id="33" name="single-workspace">
+            <a:extLst xmlns:a="http://schemas.openxmlformats.org/drawingml/2006/main">
+              <a:ext uri="{FF2B5EF4-FFF2-40B4-BE49-F238E27FC236}">
+                <a16:creationId xmlns:a16="http://schemas.microsoft.com/office/drawing/2014/main" id="{09A34A57-5E25-4E5A-B11A-1FF125997213}"/>
+              </a:ext>
+            </a:extLst>
+          </p:cNvPr>
+          <p:cNvSpPr>
+            <a:spLocks xmlns:a="http://schemas.openxmlformats.org/drawingml/2006/main" noGrp="1"/>
+          </p:cNvSpPr>
+          <p:nvPr/>
+        </p:nvSpPr>
+        <p:spPr>
+          <a:xfrm xmlns:a="http://schemas.openxmlformats.org/drawingml/2006/main">
+            <a:off x="9353550" y="3810000"/>
+            <a:ext cx="2209800" cy="723900"/>
+          </a:xfrm>
+          <a:prstGeom xmlns:a="http://schemas.openxmlformats.org/drawingml/2006/main" prst="rect">
+            <a:avLst/>
+          </a:prstGeom>
+          <a:noFill xmlns:a="http://schemas.openxmlformats.org/drawingml/2006/main"/>
+          <a:ln xmlns:a="http://schemas.openxmlformats.org/drawingml/2006/main" w="0">
+            <a:noFill/>
+            <a:prstDash val="solid"/>
+          </a:ln>
+        </p:spPr>
+        <p:txBody>
+          <a:bodyPr xmlns:a="http://schemas.openxmlformats.org/drawingml/2006/main" wrap="none" lIns="0" tIns="0" rIns="0" bIns="0" anchor="ctr">
+            <a:noAutofit/>
+          </a:bodyPr>
+          <a:lstStyle xmlns:a="http://schemas.openxmlformats.org/drawingml/2006/main"/>
+          <a:p xmlns:a="http://schemas.openxmlformats.org/drawingml/2006/main">
+            <a:pPr algn="l">
+              <a:buNone/>
+              <a:defRPr sz="1875">
+                <a:solidFill>
+                  <a:srgbClr val="6AE8CD"/>
+                </a:solidFill>
+                <a:latin typeface="Switzer"/>
+                <a:ea typeface="Switzer"/>
+                <a:cs typeface="Switzer"/>
+              </a:defRPr>
+            </a:pPr>
+            <a:r>
+              <a:rPr sz="1875">
+                <a:solidFill>
+                  <a:srgbClr val="6AE8CD"/>
+                </a:solidFill>
+                <a:latin typeface="Switzer"/>
+                <a:ea typeface="Switzer"/>
+                <a:cs typeface="Switzer"/>
+              </a:rPr>
+              <a:t>One visible</a:t>
+            </a:r>
+          </a:p>
+          <a:p xmlns:a="http://schemas.openxmlformats.org/drawingml/2006/main">
+            <a:pPr algn="l">
+              <a:buNone/>
+              <a:defRPr sz="1875">
+                <a:solidFill>
+                  <a:srgbClr val="6AE8CD"/>
+                </a:solidFill>
+                <a:latin typeface="Switzer"/>
+                <a:ea typeface="Switzer"/>
+                <a:cs typeface="Switzer"/>
+              </a:defRPr>
+            </a:pPr>
+            <a:r>
+              <a:rPr sz="1875">
+                <a:solidFill>
+                  <a:srgbClr val="6AE8CD"/>
+                </a:solidFill>
+                <a:latin typeface="Switzer"/>
+                <a:ea typeface="Switzer"/>
+                <a:cs typeface="Switzer"/>
+              </a:rPr>
+              <a:t>SEND → REPLY</a:t>
+            </a:r>
+          </a:p>
+        </p:txBody>
+      </p:sp>
+      <p:sp>
+        <p:nvSpPr>
+          <p:cNvPr id="34" name="scale">
+            <a:extLst xmlns:a="http://schemas.openxmlformats.org/drawingml/2006/main">
+              <a:ext uri="{FF2B5EF4-FFF2-40B4-BE49-F238E27FC236}">
+                <a16:creationId xmlns:a16="http://schemas.microsoft.com/office/drawing/2014/main" id="{C0C1C36E-36E4-4DD9-92D5-5D52ABFB9F18}"/>
+              </a:ext>
+            </a:extLst>
+          </p:cNvPr>
+          <p:cNvSpPr>
+            <a:spLocks xmlns:a="http://schemas.openxmlformats.org/drawingml/2006/main" noGrp="1"/>
+          </p:cNvSpPr>
+          <p:nvPr/>
+        </p:nvSpPr>
+        <p:spPr>
+          <a:xfrm xmlns:a="http://schemas.openxmlformats.org/drawingml/2006/main">
+            <a:off x="9353550" y="4991100"/>
+            <a:ext cx="2209800" cy="666750"/>
+          </a:xfrm>
+          <a:prstGeom xmlns:a="http://schemas.openxmlformats.org/drawingml/2006/main" prst="rect">
+            <a:avLst/>
+          </a:prstGeom>
+          <a:noFill xmlns:a="http://schemas.openxmlformats.org/drawingml/2006/main"/>
+          <a:ln xmlns:a="http://schemas.openxmlformats.org/drawingml/2006/main" w="0">
+            <a:noFill/>
+            <a:prstDash val="solid"/>
+          </a:ln>
+        </p:spPr>
+        <p:txBody>
+          <a:bodyPr xmlns:a="http://schemas.openxmlformats.org/drawingml/2006/main" wrap="none" lIns="0" tIns="0" rIns="0" bIns="0" anchor="ctr">
+            <a:noAutofit/>
+          </a:bodyPr>
+          <a:lstStyle xmlns:a="http://schemas.openxmlformats.org/drawingml/2006/main"/>
+          <a:p xmlns:a="http://schemas.openxmlformats.org/drawingml/2006/main">
+            <a:pPr algn="l">
+              <a:buNone/>
+              <a:defRPr sz="1725">
+                <a:solidFill>
+                  <a:srgbClr val="BCBBC2"/>
+                </a:solidFill>
+                <a:latin typeface="Switzer"/>
+                <a:ea typeface="Switzer"/>
+                <a:cs typeface="Switzer"/>
+              </a:defRPr>
+            </a:pPr>
+            <a:r>
+              <a:rPr sz="1725">
+                <a:solidFill>
+                  <a:srgbClr val="BCBBC2"/>
+                </a:solidFill>
+                <a:latin typeface="Switzer"/>
+                <a:ea typeface="Switzer"/>
+                <a:cs typeface="Switzer"/>
+              </a:rPr>
+              <a:t>Up to 100 panels</a:t>
+            </a:r>
+          </a:p>
+          <a:p xmlns:a="http://schemas.openxmlformats.org/drawingml/2006/main">
+            <a:pPr algn="l">
+              <a:buNone/>
+              <a:defRPr sz="1725">
+                <a:solidFill>
+                  <a:srgbClr val="BCBBC2"/>
+                </a:solidFill>
+                <a:latin typeface="Switzer"/>
+                <a:ea typeface="Switzer"/>
+                <a:cs typeface="Switzer"/>
+              </a:defRPr>
+            </a:pPr>
+            <a:r>
+              <a:rPr sz="1725">
+                <a:solidFill>
+                  <a:srgbClr val="BCBBC2"/>
+                </a:solidFill>
+                <a:latin typeface="Switzer"/>
+                <a:ea typeface="Switzer"/>
+                <a:cs typeface="Switzer"/>
+              </a:rPr>
+              <a:t>Paginated by size</a:t>
+            </a:r>
+          </a:p>
+        </p:txBody>
+      </p:sp>
+      <p:sp>
+        <p:nvSpPr>
+          <p:cNvPr id="35" name="capture-caption">
+            <a:extLst xmlns:a="http://schemas.openxmlformats.org/drawingml/2006/main">
+              <a:ext uri="{FF2B5EF4-FFF2-40B4-BE49-F238E27FC236}">
+                <a16:creationId xmlns:a16="http://schemas.microsoft.com/office/drawing/2014/main" id="{28FD5922-7ACD-4E22-9899-D6058E75E5ED}"/>
+              </a:ext>
+            </a:extLst>
+          </p:cNvPr>
+          <p:cNvSpPr>
+            <a:spLocks xmlns:a="http://schemas.openxmlformats.org/drawingml/2006/main" noGrp="1"/>
+          </p:cNvSpPr>
+          <p:nvPr/>
+        </p:nvSpPr>
+        <p:spPr>
+          <a:xfrm xmlns:a="http://schemas.openxmlformats.org/drawingml/2006/main">
+            <a:off x="723900" y="6076950"/>
+            <a:ext cx="10620375" cy="228600"/>
+          </a:xfrm>
+          <a:prstGeom xmlns:a="http://schemas.openxmlformats.org/drawingml/2006/main" prst="rect">
+            <a:avLst/>
+          </a:prstGeom>
+          <a:noFill xmlns:a="http://schemas.openxmlformats.org/drawingml/2006/main"/>
+          <a:ln xmlns:a="http://schemas.openxmlformats.org/drawingml/2006/main" w="0">
+            <a:noFill/>
+            <a:prstDash val="solid"/>
+          </a:ln>
+        </p:spPr>
+        <p:txBody>
+          <a:bodyPr xmlns:a="http://schemas.openxmlformats.org/drawingml/2006/main" wrap="none" lIns="0" tIns="0" rIns="0" bIns="0" anchor="ctr">
+            <a:noAutofit/>
+          </a:bodyPr>
+          <a:lstStyle xmlns:a="http://schemas.openxmlformats.org/drawingml/2006/main"/>
+          <a:p xmlns:a="http://schemas.openxmlformats.org/drawingml/2006/main">
+            <a:pPr algn="l">
+              <a:buNone/>
+              <a:defRPr sz="1200">
+                <a:solidFill>
+                  <a:srgbClr val="BCBBC2"/>
+                </a:solidFill>
+                <a:latin typeface="Switzer"/>
+                <a:ea typeface="Switzer"/>
+                <a:cs typeface="Switzer"/>
+              </a:defRPr>
+            </a:pPr>
+            <a:r>
+              <a:rPr sz="1200">
+                <a:solidFill>
+                  <a:srgbClr val="BCBBC2"/>
+                </a:solidFill>
+                <a:latin typeface="Switzer"/>
+                <a:ea typeface="Switzer"/>
+                <a:cs typeface="Switzer"/>
+              </a:rPr>
+              <a:t>Actual terminal capture · offline demo · session capabilities redacted</a:t>
+            </a:r>
+          </a:p>
+        </p:txBody>
+      </p:sp>
+    </p:spTree>
+    <p:extLst>
+      <p:ext uri="{BB962C8B-B14F-4D97-AF65-F5344CB8AC3E}">
+        <p14:creationId xmlns:p14="http://schemas.microsoft.com/office/powerpoint/2010/main" val="1378249199"/>
+      </p:ext>
+    </p:extLst>
+  </p:cSld>
+</p:sld>
+</file>
+
+<file path=ppt/slides/slide20.xml><?xml version="1.0" encoding="utf-8"?>
 <p:sld xmlns:p="http://schemas.openxmlformats.org/presentationml/2006/main">
   <p:cSld>
     <p:bg>
@@ -13966,7 +16535,7 @@
           <p:nvPr/>
         </p:nvPicPr>
         <p:blipFill>
-          <a:blip xmlns:r="http://schemas.openxmlformats.org/officeDocument/2006/relationships" xmlns:a="http://schemas.openxmlformats.org/drawingml/2006/main" r:embed="R642d93374ae34989"/>
+          <a:blip xmlns:r="http://schemas.openxmlformats.org/officeDocument/2006/relationships" xmlns:a="http://schemas.openxmlformats.org/drawingml/2006/main" r:embed="R5aa193e59f0b4652"/>
           <a:stretch xmlns:a="http://schemas.openxmlformats.org/drawingml/2006/main"/>
         </p:blipFill>
         <p:spPr>
@@ -14417,7 +16986,7 @@
                 <a:ea typeface="Consolas"/>
                 <a:cs typeface="Consolas"/>
               </a:rPr>
-              <a:t>18/18</a:t>
+              <a:t>20/20</a:t>
             </a:r>
           </a:p>
         </p:txBody>
@@ -14431,7 +17000,7 @@
           <p:nvPr/>
         </p:nvPicPr>
         <p:blipFill>
-          <a:blip xmlns:r="http://schemas.openxmlformats.org/officeDocument/2006/relationships" xmlns:a="http://schemas.openxmlformats.org/drawingml/2006/main" r:embed="R36d8b7dbf2144194"/>
+          <a:blip xmlns:r="http://schemas.openxmlformats.org/officeDocument/2006/relationships" xmlns:a="http://schemas.openxmlformats.org/drawingml/2006/main" r:embed="Rb9b18d6b15044d78"/>
           <a:stretch xmlns:a="http://schemas.openxmlformats.org/drawingml/2006/main"/>
         </p:blipFill>
         <p:spPr>
@@ -14448,622 +17017,6 @@
     <p:extLst>
       <p:ext uri="{BB962C8B-B14F-4D97-AF65-F5344CB8AC3E}">
         <p14:creationId xmlns:p14="http://schemas.microsoft.com/office/powerpoint/2010/main" val="1080936326"/>
-      </p:ext>
-    </p:extLst>
-  </p:cSld>
-</p:sld>
-</file>
-
-<file path=ppt/slides/slide2.xml><?xml version="1.0" encoding="utf-8"?>
-<p:sld xmlns:p="http://schemas.openxmlformats.org/presentationml/2006/main">
-  <p:cSld>
-    <p:bg>
-      <p:bgPr>
-        <a:solidFill xmlns:a="http://schemas.openxmlformats.org/drawingml/2006/main">
-          <a:srgbClr val="201F24"/>
-        </a:solidFill>
-      </p:bgPr>
-    </p:bg>
-    <p:spTree>
-      <p:nvGrpSpPr>
-        <p:cNvPr id="1" name=""/>
-        <p:cNvGrpSpPr/>
-        <p:nvPr/>
-      </p:nvGrpSpPr>
-      <p:grpSpPr>
-        <a:xfrm xmlns:a="http://schemas.openxmlformats.org/drawingml/2006/main"/>
-      </p:grpSpPr>
-      <p:sp>
-        <p:nvSpPr>
-          <p:cNvPr id="2" name="TextBox 1">
-            <a:extLst xmlns:a="http://schemas.openxmlformats.org/drawingml/2006/main">
-              <a:ext uri="{FF2B5EF4-FFF2-40B4-BE49-F238E27FC236}">
-                <a16:creationId xmlns:a16="http://schemas.microsoft.com/office/drawing/2014/main" id="{07C4FE56-EF53-4B59-80FD-0556F3ADEF68}"/>
-              </a:ext>
-            </a:extLst>
-          </p:cNvPr>
-          <p:cNvSpPr>
-            <a:spLocks xmlns:a="http://schemas.openxmlformats.org/drawingml/2006/main" noGrp="1"/>
-          </p:cNvSpPr>
-          <p:nvPr/>
-        </p:nvSpPr>
-        <p:spPr>
-          <a:xfrm xmlns:a="http://schemas.openxmlformats.org/drawingml/2006/main">
-            <a:off x="731520" y="409575"/>
-            <a:ext cx="10820400" cy="333375"/>
-          </a:xfrm>
-          <a:prstGeom xmlns:a="http://schemas.openxmlformats.org/drawingml/2006/main" prst="rect">
-            <a:avLst/>
-          </a:prstGeom>
-          <a:noFill xmlns:a="http://schemas.openxmlformats.org/drawingml/2006/main"/>
-        </p:spPr>
-        <p:txBody>
-          <a:bodyPr xmlns:a="http://schemas.openxmlformats.org/drawingml/2006/main" wrap="none" lIns="0" tIns="0" rIns="0" bIns="0" anchor="ctr">
-            <a:noAutofit/>
-          </a:bodyPr>
-          <a:lstStyle xmlns:a="http://schemas.openxmlformats.org/drawingml/2006/main"/>
-          <a:p xmlns:a="http://schemas.openxmlformats.org/drawingml/2006/main">
-            <a:pPr algn="l">
-              <a:buNone/>
-              <a:defRPr sz="1200" b="1">
-                <a:solidFill>
-                  <a:srgbClr val="CBAAFF"/>
-                </a:solidFill>
-                <a:latin typeface="Consolas"/>
-                <a:ea typeface="Consolas"/>
-                <a:cs typeface="Consolas"/>
-              </a:defRPr>
-            </a:pPr>
-            <a:r>
-              <a:rPr sz="1200" b="1">
-                <a:solidFill>
-                  <a:srgbClr val="CBAAFF"/>
-                </a:solidFill>
-                <a:latin typeface="Consolas"/>
-                <a:ea typeface="Consolas"/>
-                <a:cs typeface="Consolas"/>
-              </a:rPr>
-              <a:t>IN THE TERMINAL</a:t>
-            </a:r>
-          </a:p>
-        </p:txBody>
-      </p:sp>
-      <p:sp>
-        <p:nvSpPr>
-          <p:cNvPr id="3" name="TextBox 2">
-            <a:extLst xmlns:a="http://schemas.openxmlformats.org/drawingml/2006/main">
-              <a:ext uri="{FF2B5EF4-FFF2-40B4-BE49-F238E27FC236}">
-                <a16:creationId xmlns:a16="http://schemas.microsoft.com/office/drawing/2014/main" id="{1ADF6C27-524D-429D-963F-7FAB2499F859}"/>
-              </a:ext>
-            </a:extLst>
-          </p:cNvPr>
-          <p:cNvSpPr>
-            <a:spLocks xmlns:a="http://schemas.openxmlformats.org/drawingml/2006/main" noGrp="1"/>
-          </p:cNvSpPr>
-          <p:nvPr/>
-        </p:nvSpPr>
-        <p:spPr>
-          <a:xfrm xmlns:a="http://schemas.openxmlformats.org/drawingml/2006/main">
-            <a:off x="731520" y="914400"/>
-            <a:ext cx="10820400" cy="704850"/>
-          </a:xfrm>
-          <a:prstGeom xmlns:a="http://schemas.openxmlformats.org/drawingml/2006/main" prst="rect">
-            <a:avLst/>
-          </a:prstGeom>
-          <a:noFill xmlns:a="http://schemas.openxmlformats.org/drawingml/2006/main"/>
-        </p:spPr>
-        <p:txBody>
-          <a:bodyPr xmlns:a="http://schemas.openxmlformats.org/drawingml/2006/main" wrap="none" lIns="0" tIns="0" rIns="0" bIns="0" anchor="ctr">
-            <a:noAutofit/>
-          </a:bodyPr>
-          <a:lstStyle xmlns:a="http://schemas.openxmlformats.org/drawingml/2006/main"/>
-          <a:p xmlns:a="http://schemas.openxmlformats.org/drawingml/2006/main">
-            <a:pPr algn="l">
-              <a:buNone/>
-              <a:defRPr sz="3300" b="0">
-                <a:solidFill>
-                  <a:srgbClr val="F9F8FD"/>
-                </a:solidFill>
-                <a:latin typeface="Alliance No.2"/>
-                <a:ea typeface="Alliance No.2"/>
-                <a:cs typeface="Alliance No.2"/>
-              </a:defRPr>
-            </a:pPr>
-            <a:r>
-              <a:rPr sz="3300" b="0">
-                <a:solidFill>
-                  <a:srgbClr val="F9F8FD"/>
-                </a:solidFill>
-                <a:latin typeface="Alliance No.2"/>
-                <a:ea typeface="Alliance No.2"/>
-                <a:cs typeface="Alliance No.2"/>
-              </a:rPr>
-              <a:t>One workspace. Real terminal sessions.</a:t>
-            </a:r>
-          </a:p>
-        </p:txBody>
-      </p:sp>
-      <p:sp>
-        <p:nvSpPr>
-          <p:cNvPr id="28" name="TextBox 27">
-            <a:extLst xmlns:a="http://schemas.openxmlformats.org/drawingml/2006/main">
-              <a:ext uri="{FF2B5EF4-FFF2-40B4-BE49-F238E27FC236}">
-                <a16:creationId xmlns:a16="http://schemas.microsoft.com/office/drawing/2014/main" id="{F407AF73-1128-4BB2-9A9D-E65D3110D560}"/>
-              </a:ext>
-            </a:extLst>
-          </p:cNvPr>
-          <p:cNvSpPr>
-            <a:spLocks xmlns:a="http://schemas.openxmlformats.org/drawingml/2006/main" noGrp="1"/>
-          </p:cNvSpPr>
-          <p:nvPr/>
-        </p:nvSpPr>
-        <p:spPr>
-          <a:xfrm xmlns:a="http://schemas.openxmlformats.org/drawingml/2006/main">
-            <a:off x="10668000" y="6419850"/>
-            <a:ext cx="857250" cy="285750"/>
-          </a:xfrm>
-          <a:prstGeom xmlns:a="http://schemas.openxmlformats.org/drawingml/2006/main" prst="rect">
-            <a:avLst/>
-          </a:prstGeom>
-          <a:noFill xmlns:a="http://schemas.openxmlformats.org/drawingml/2006/main"/>
-        </p:spPr>
-        <p:txBody>
-          <a:bodyPr xmlns:a="http://schemas.openxmlformats.org/drawingml/2006/main" wrap="none" lIns="0" tIns="0" rIns="0" bIns="0" anchor="ctr">
-            <a:noAutofit/>
-          </a:bodyPr>
-          <a:lstStyle xmlns:a="http://schemas.openxmlformats.org/drawingml/2006/main"/>
-          <a:p xmlns:a="http://schemas.openxmlformats.org/drawingml/2006/main">
-            <a:pPr algn="r">
-              <a:buNone/>
-              <a:defRPr sz="1200" b="0">
-                <a:solidFill>
-                  <a:srgbClr val="BCBBC2"/>
-                </a:solidFill>
-                <a:latin typeface="Consolas"/>
-                <a:ea typeface="Consolas"/>
-                <a:cs typeface="Consolas"/>
-              </a:defRPr>
-            </a:pPr>
-            <a:r>
-              <a:rPr sz="1200" b="0">
-                <a:solidFill>
-                  <a:srgbClr val="BCBBC2"/>
-                </a:solidFill>
-                <a:latin typeface="Consolas"/>
-                <a:ea typeface="Consolas"/>
-                <a:cs typeface="Consolas"/>
-              </a:rPr>
-              <a:t>2/18</a:t>
-            </a:r>
-          </a:p>
-        </p:txBody>
-      </p:sp>
-      <p:sp>
-        <p:nvSpPr>
-          <p:cNvPr id="29" name="Callstack accent rule">
-            <a:extLst xmlns:a="http://schemas.openxmlformats.org/drawingml/2006/main">
-              <a:ext uri="{FF2B5EF4-FFF2-40B4-BE49-F238E27FC236}">
-                <a16:creationId xmlns:a16="http://schemas.microsoft.com/office/drawing/2014/main" id="{57ECF28A-4432-486B-B490-F06CEE4625F4}"/>
-              </a:ext>
-            </a:extLst>
-          </p:cNvPr>
-          <p:cNvSpPr>
-            <a:spLocks xmlns:a="http://schemas.openxmlformats.org/drawingml/2006/main" noGrp="1"/>
-          </p:cNvSpPr>
-          <p:nvPr/>
-        </p:nvSpPr>
-        <p:spPr>
-          <a:xfrm xmlns:a="http://schemas.openxmlformats.org/drawingml/2006/main">
-            <a:off x="0" y="0"/>
-            <a:ext cx="12192000" cy="57150"/>
-          </a:xfrm>
-          <a:prstGeom xmlns:a="http://schemas.openxmlformats.org/drawingml/2006/main" prst="rect">
-            <a:avLst/>
-          </a:prstGeom>
-          <a:solidFill xmlns:a="http://schemas.openxmlformats.org/drawingml/2006/main">
-            <a:srgbClr val="8232FF"/>
-          </a:solidFill>
-          <a:ln xmlns:a="http://schemas.openxmlformats.org/drawingml/2006/main" w="2381">
-            <a:solidFill>
-              <a:srgbClr val="8232FF"/>
-            </a:solidFill>
-            <a:prstDash val="solid"/>
-          </a:ln>
-        </p:spPr>
-      </p:sp>
-      <p:pic>
-        <p:nvPicPr>
-          <p:cNvPr id="41" name=""/>
-          <p:cNvPicPr>
-            <a:picLocks xmlns:a="http://schemas.openxmlformats.org/drawingml/2006/main" noChangeAspect="1"/>
-          </p:cNvPicPr>
-          <p:nvPr/>
-        </p:nvPicPr>
-        <p:blipFill>
-          <a:blip xmlns:r="http://schemas.openxmlformats.org/officeDocument/2006/relationships" xmlns:a="http://schemas.openxmlformats.org/drawingml/2006/main" r:embed="R1cf60fdd7dfb4043"/>
-          <a:stretch xmlns:a="http://schemas.openxmlformats.org/drawingml/2006/main"/>
-        </p:blipFill>
-        <p:spPr>
-          <a:xfrm xmlns:a="http://schemas.openxmlformats.org/drawingml/2006/main">
-            <a:off x="723900" y="1828800"/>
-            <a:ext cx="8382000" cy="4191000"/>
-          </a:xfrm>
-          <a:prstGeom xmlns:a="http://schemas.openxmlformats.org/drawingml/2006/main" prst="rect">
-            <a:avLst/>
-          </a:prstGeom>
-        </p:spPr>
-      </p:pic>
-      <p:sp>
-        <p:nvSpPr>
-          <p:cNvPr id="31" name="two-panels">
-            <a:extLst xmlns:a="http://schemas.openxmlformats.org/drawingml/2006/main">
-              <a:ext uri="{FF2B5EF4-FFF2-40B4-BE49-F238E27FC236}">
-                <a16:creationId xmlns:a16="http://schemas.microsoft.com/office/drawing/2014/main" id="{1C00BA6A-847B-4539-8995-307AF92E4753}"/>
-              </a:ext>
-            </a:extLst>
-          </p:cNvPr>
-          <p:cNvSpPr>
-            <a:spLocks xmlns:a="http://schemas.openxmlformats.org/drawingml/2006/main" noGrp="1"/>
-          </p:cNvSpPr>
-          <p:nvPr/>
-        </p:nvSpPr>
-        <p:spPr>
-          <a:xfrm xmlns:a="http://schemas.openxmlformats.org/drawingml/2006/main">
-            <a:off x="9353550" y="2028825"/>
-            <a:ext cx="2133600" cy="523875"/>
-          </a:xfrm>
-          <a:prstGeom xmlns:a="http://schemas.openxmlformats.org/drawingml/2006/main" prst="rect">
-            <a:avLst/>
-          </a:prstGeom>
-          <a:noFill xmlns:a="http://schemas.openxmlformats.org/drawingml/2006/main"/>
-          <a:ln xmlns:a="http://schemas.openxmlformats.org/drawingml/2006/main" w="0">
-            <a:noFill/>
-            <a:prstDash val="solid"/>
-          </a:ln>
-        </p:spPr>
-        <p:txBody>
-          <a:bodyPr xmlns:a="http://schemas.openxmlformats.org/drawingml/2006/main" wrap="none" lIns="0" tIns="0" rIns="0" bIns="0" anchor="ctr">
-            <a:noAutofit/>
-          </a:bodyPr>
-          <a:lstStyle xmlns:a="http://schemas.openxmlformats.org/drawingml/2006/main"/>
-          <a:p xmlns:a="http://schemas.openxmlformats.org/drawingml/2006/main">
-            <a:pPr algn="l">
-              <a:buNone/>
-              <a:defRPr sz="2700">
-                <a:solidFill>
-                  <a:srgbClr val="CBAAFF"/>
-                </a:solidFill>
-                <a:latin typeface="Alliance No.2"/>
-                <a:ea typeface="Alliance No.2"/>
-                <a:cs typeface="Alliance No.2"/>
-              </a:defRPr>
-            </a:pPr>
-            <a:r>
-              <a:rPr sz="2700">
-                <a:solidFill>
-                  <a:srgbClr val="CBAAFF"/>
-                </a:solidFill>
-                <a:latin typeface="Alliance No.2"/>
-                <a:ea typeface="Alliance No.2"/>
-                <a:cs typeface="Alliance No.2"/>
-              </a:rPr>
-              <a:t>2 panels</a:t>
-            </a:r>
-          </a:p>
-        </p:txBody>
-      </p:sp>
-      <p:sp>
-        <p:nvSpPr>
-          <p:cNvPr id="32" name="separate-ptys">
-            <a:extLst xmlns:a="http://schemas.openxmlformats.org/drawingml/2006/main">
-              <a:ext uri="{FF2B5EF4-FFF2-40B4-BE49-F238E27FC236}">
-                <a16:creationId xmlns:a16="http://schemas.microsoft.com/office/drawing/2014/main" id="{50344505-F1D9-40D5-B6D3-D892A306EF3C}"/>
-              </a:ext>
-            </a:extLst>
-          </p:cNvPr>
-          <p:cNvSpPr>
-            <a:spLocks xmlns:a="http://schemas.openxmlformats.org/drawingml/2006/main" noGrp="1"/>
-          </p:cNvSpPr>
-          <p:nvPr/>
-        </p:nvSpPr>
-        <p:spPr>
-          <a:xfrm xmlns:a="http://schemas.openxmlformats.org/drawingml/2006/main">
-            <a:off x="9353550" y="2667000"/>
-            <a:ext cx="2190750" cy="704850"/>
-          </a:xfrm>
-          <a:prstGeom xmlns:a="http://schemas.openxmlformats.org/drawingml/2006/main" prst="rect">
-            <a:avLst/>
-          </a:prstGeom>
-          <a:noFill xmlns:a="http://schemas.openxmlformats.org/drawingml/2006/main"/>
-          <a:ln xmlns:a="http://schemas.openxmlformats.org/drawingml/2006/main" w="0">
-            <a:noFill/>
-            <a:prstDash val="solid"/>
-          </a:ln>
-        </p:spPr>
-        <p:txBody>
-          <a:bodyPr xmlns:a="http://schemas.openxmlformats.org/drawingml/2006/main" wrap="none" lIns="0" tIns="0" rIns="0" bIns="0" anchor="ctr">
-            <a:noAutofit/>
-          </a:bodyPr>
-          <a:lstStyle xmlns:a="http://schemas.openxmlformats.org/drawingml/2006/main"/>
-          <a:p xmlns:a="http://schemas.openxmlformats.org/drawingml/2006/main">
-            <a:pPr algn="l">
-              <a:buNone/>
-              <a:defRPr sz="1875">
-                <a:solidFill>
-                  <a:srgbClr val="F9F8FD"/>
-                </a:solidFill>
-                <a:latin typeface="Switzer"/>
-                <a:ea typeface="Switzer"/>
-                <a:cs typeface="Switzer"/>
-              </a:defRPr>
-            </a:pPr>
-            <a:r>
-              <a:rPr sz="1875">
-                <a:solidFill>
-                  <a:srgbClr val="F9F8FD"/>
-                </a:solidFill>
-                <a:latin typeface="Switzer"/>
-                <a:ea typeface="Switzer"/>
-                <a:cs typeface="Switzer"/>
-              </a:rPr>
-              <a:t>Independent PTYs</a:t>
-            </a:r>
-          </a:p>
-          <a:p xmlns:a="http://schemas.openxmlformats.org/drawingml/2006/main">
-            <a:pPr algn="l">
-              <a:buNone/>
-              <a:defRPr sz="1875">
-                <a:solidFill>
-                  <a:srgbClr val="F9F8FD"/>
-                </a:solidFill>
-                <a:latin typeface="Switzer"/>
-                <a:ea typeface="Switzer"/>
-                <a:cs typeface="Switzer"/>
-              </a:defRPr>
-            </a:pPr>
-            <a:r>
-              <a:rPr sz="1875">
-                <a:solidFill>
-                  <a:srgbClr val="F9F8FD"/>
-                </a:solidFill>
-                <a:latin typeface="Switzer"/>
-                <a:ea typeface="Switzer"/>
-                <a:cs typeface="Switzer"/>
-              </a:rPr>
-              <a:t>and CLI contexts</a:t>
-            </a:r>
-          </a:p>
-        </p:txBody>
-      </p:sp>
-      <p:sp>
-        <p:nvSpPr>
-          <p:cNvPr id="33" name="single-workspace">
-            <a:extLst xmlns:a="http://schemas.openxmlformats.org/drawingml/2006/main">
-              <a:ext uri="{FF2B5EF4-FFF2-40B4-BE49-F238E27FC236}">
-                <a16:creationId xmlns:a16="http://schemas.microsoft.com/office/drawing/2014/main" id="{09A34A57-5E25-4E5A-B11A-1FF125997213}"/>
-              </a:ext>
-            </a:extLst>
-          </p:cNvPr>
-          <p:cNvSpPr>
-            <a:spLocks xmlns:a="http://schemas.openxmlformats.org/drawingml/2006/main" noGrp="1"/>
-          </p:cNvSpPr>
-          <p:nvPr/>
-        </p:nvSpPr>
-        <p:spPr>
-          <a:xfrm xmlns:a="http://schemas.openxmlformats.org/drawingml/2006/main">
-            <a:off x="9353550" y="3810000"/>
-            <a:ext cx="2209800" cy="723900"/>
-          </a:xfrm>
-          <a:prstGeom xmlns:a="http://schemas.openxmlformats.org/drawingml/2006/main" prst="rect">
-            <a:avLst/>
-          </a:prstGeom>
-          <a:noFill xmlns:a="http://schemas.openxmlformats.org/drawingml/2006/main"/>
-          <a:ln xmlns:a="http://schemas.openxmlformats.org/drawingml/2006/main" w="0">
-            <a:noFill/>
-            <a:prstDash val="solid"/>
-          </a:ln>
-        </p:spPr>
-        <p:txBody>
-          <a:bodyPr xmlns:a="http://schemas.openxmlformats.org/drawingml/2006/main" wrap="none" lIns="0" tIns="0" rIns="0" bIns="0" anchor="ctr">
-            <a:noAutofit/>
-          </a:bodyPr>
-          <a:lstStyle xmlns:a="http://schemas.openxmlformats.org/drawingml/2006/main"/>
-          <a:p xmlns:a="http://schemas.openxmlformats.org/drawingml/2006/main">
-            <a:pPr algn="l">
-              <a:buNone/>
-              <a:defRPr sz="1875">
-                <a:solidFill>
-                  <a:srgbClr val="6AE8CD"/>
-                </a:solidFill>
-                <a:latin typeface="Switzer"/>
-                <a:ea typeface="Switzer"/>
-                <a:cs typeface="Switzer"/>
-              </a:defRPr>
-            </a:pPr>
-            <a:r>
-              <a:rPr sz="1875">
-                <a:solidFill>
-                  <a:srgbClr val="6AE8CD"/>
-                </a:solidFill>
-                <a:latin typeface="Switzer"/>
-                <a:ea typeface="Switzer"/>
-                <a:cs typeface="Switzer"/>
-              </a:rPr>
-              <a:t>One visible</a:t>
-            </a:r>
-          </a:p>
-          <a:p xmlns:a="http://schemas.openxmlformats.org/drawingml/2006/main">
-            <a:pPr algn="l">
-              <a:buNone/>
-              <a:defRPr sz="1875">
-                <a:solidFill>
-                  <a:srgbClr val="6AE8CD"/>
-                </a:solidFill>
-                <a:latin typeface="Switzer"/>
-                <a:ea typeface="Switzer"/>
-                <a:cs typeface="Switzer"/>
-              </a:defRPr>
-            </a:pPr>
-            <a:r>
-              <a:rPr sz="1875">
-                <a:solidFill>
-                  <a:srgbClr val="6AE8CD"/>
-                </a:solidFill>
-                <a:latin typeface="Switzer"/>
-                <a:ea typeface="Switzer"/>
-                <a:cs typeface="Switzer"/>
-              </a:rPr>
-              <a:t>SEND → REPLY</a:t>
-            </a:r>
-          </a:p>
-        </p:txBody>
-      </p:sp>
-      <p:sp>
-        <p:nvSpPr>
-          <p:cNvPr id="34" name="scale">
-            <a:extLst xmlns:a="http://schemas.openxmlformats.org/drawingml/2006/main">
-              <a:ext uri="{FF2B5EF4-FFF2-40B4-BE49-F238E27FC236}">
-                <a16:creationId xmlns:a16="http://schemas.microsoft.com/office/drawing/2014/main" id="{C0C1C36E-36E4-4DD9-92D5-5D52ABFB9F18}"/>
-              </a:ext>
-            </a:extLst>
-          </p:cNvPr>
-          <p:cNvSpPr>
-            <a:spLocks xmlns:a="http://schemas.openxmlformats.org/drawingml/2006/main" noGrp="1"/>
-          </p:cNvSpPr>
-          <p:nvPr/>
-        </p:nvSpPr>
-        <p:spPr>
-          <a:xfrm xmlns:a="http://schemas.openxmlformats.org/drawingml/2006/main">
-            <a:off x="9353550" y="4991100"/>
-            <a:ext cx="2209800" cy="666750"/>
-          </a:xfrm>
-          <a:prstGeom xmlns:a="http://schemas.openxmlformats.org/drawingml/2006/main" prst="rect">
-            <a:avLst/>
-          </a:prstGeom>
-          <a:noFill xmlns:a="http://schemas.openxmlformats.org/drawingml/2006/main"/>
-          <a:ln xmlns:a="http://schemas.openxmlformats.org/drawingml/2006/main" w="0">
-            <a:noFill/>
-            <a:prstDash val="solid"/>
-          </a:ln>
-        </p:spPr>
-        <p:txBody>
-          <a:bodyPr xmlns:a="http://schemas.openxmlformats.org/drawingml/2006/main" wrap="none" lIns="0" tIns="0" rIns="0" bIns="0" anchor="ctr">
-            <a:noAutofit/>
-          </a:bodyPr>
-          <a:lstStyle xmlns:a="http://schemas.openxmlformats.org/drawingml/2006/main"/>
-          <a:p xmlns:a="http://schemas.openxmlformats.org/drawingml/2006/main">
-            <a:pPr algn="l">
-              <a:buNone/>
-              <a:defRPr sz="1725">
-                <a:solidFill>
-                  <a:srgbClr val="BCBBC2"/>
-                </a:solidFill>
-                <a:latin typeface="Switzer"/>
-                <a:ea typeface="Switzer"/>
-                <a:cs typeface="Switzer"/>
-              </a:defRPr>
-            </a:pPr>
-            <a:r>
-              <a:rPr sz="1725">
-                <a:solidFill>
-                  <a:srgbClr val="BCBBC2"/>
-                </a:solidFill>
-                <a:latin typeface="Switzer"/>
-                <a:ea typeface="Switzer"/>
-                <a:cs typeface="Switzer"/>
-              </a:rPr>
-              <a:t>Up to 100 panels</a:t>
-            </a:r>
-          </a:p>
-          <a:p xmlns:a="http://schemas.openxmlformats.org/drawingml/2006/main">
-            <a:pPr algn="l">
-              <a:buNone/>
-              <a:defRPr sz="1725">
-                <a:solidFill>
-                  <a:srgbClr val="BCBBC2"/>
-                </a:solidFill>
-                <a:latin typeface="Switzer"/>
-                <a:ea typeface="Switzer"/>
-                <a:cs typeface="Switzer"/>
-              </a:defRPr>
-            </a:pPr>
-            <a:r>
-              <a:rPr sz="1725">
-                <a:solidFill>
-                  <a:srgbClr val="BCBBC2"/>
-                </a:solidFill>
-                <a:latin typeface="Switzer"/>
-                <a:ea typeface="Switzer"/>
-                <a:cs typeface="Switzer"/>
-              </a:rPr>
-              <a:t>Paginated by size</a:t>
-            </a:r>
-          </a:p>
-        </p:txBody>
-      </p:sp>
-      <p:sp>
-        <p:nvSpPr>
-          <p:cNvPr id="35" name="capture-caption">
-            <a:extLst xmlns:a="http://schemas.openxmlformats.org/drawingml/2006/main">
-              <a:ext uri="{FF2B5EF4-FFF2-40B4-BE49-F238E27FC236}">
-                <a16:creationId xmlns:a16="http://schemas.microsoft.com/office/drawing/2014/main" id="{28FD5922-7ACD-4E22-9899-D6058E75E5ED}"/>
-              </a:ext>
-            </a:extLst>
-          </p:cNvPr>
-          <p:cNvSpPr>
-            <a:spLocks xmlns:a="http://schemas.openxmlformats.org/drawingml/2006/main" noGrp="1"/>
-          </p:cNvSpPr>
-          <p:nvPr/>
-        </p:nvSpPr>
-        <p:spPr>
-          <a:xfrm xmlns:a="http://schemas.openxmlformats.org/drawingml/2006/main">
-            <a:off x="723900" y="6076950"/>
-            <a:ext cx="10620375" cy="228600"/>
-          </a:xfrm>
-          <a:prstGeom xmlns:a="http://schemas.openxmlformats.org/drawingml/2006/main" prst="rect">
-            <a:avLst/>
-          </a:prstGeom>
-          <a:noFill xmlns:a="http://schemas.openxmlformats.org/drawingml/2006/main"/>
-          <a:ln xmlns:a="http://schemas.openxmlformats.org/drawingml/2006/main" w="0">
-            <a:noFill/>
-            <a:prstDash val="solid"/>
-          </a:ln>
-        </p:spPr>
-        <p:txBody>
-          <a:bodyPr xmlns:a="http://schemas.openxmlformats.org/drawingml/2006/main" wrap="none" lIns="0" tIns="0" rIns="0" bIns="0" anchor="ctr">
-            <a:noAutofit/>
-          </a:bodyPr>
-          <a:lstStyle xmlns:a="http://schemas.openxmlformats.org/drawingml/2006/main"/>
-          <a:p xmlns:a="http://schemas.openxmlformats.org/drawingml/2006/main">
-            <a:pPr algn="l">
-              <a:buNone/>
-              <a:defRPr sz="1200">
-                <a:solidFill>
-                  <a:srgbClr val="BCBBC2"/>
-                </a:solidFill>
-                <a:latin typeface="Switzer"/>
-                <a:ea typeface="Switzer"/>
-                <a:cs typeface="Switzer"/>
-              </a:defRPr>
-            </a:pPr>
-            <a:r>
-              <a:rPr sz="1200">
-                <a:solidFill>
-                  <a:srgbClr val="BCBBC2"/>
-                </a:solidFill>
-                <a:latin typeface="Switzer"/>
-                <a:ea typeface="Switzer"/>
-                <a:cs typeface="Switzer"/>
-              </a:rPr>
-              <a:t>Actual terminal capture · offline demo · session capabilities redacted</a:t>
-            </a:r>
-          </a:p>
-        </p:txBody>
-      </p:sp>
-    </p:spTree>
-    <p:extLst>
-      <p:ext uri="{BB962C8B-B14F-4D97-AF65-F5344CB8AC3E}">
-        <p14:creationId xmlns:p14="http://schemas.microsoft.com/office/powerpoint/2010/main" val="1378249199"/>
       </p:ext>
     </p:extLst>
   </p:cSld>
@@ -15249,7 +17202,7 @@
                 <a:ea typeface="Consolas"/>
                 <a:cs typeface="Consolas"/>
               </a:rPr>
-              <a:t>3/18</a:t>
+              <a:t>3/20</a:t>
             </a:r>
           </a:p>
         </p:txBody>
@@ -16713,7 +18666,7 @@
                 <a:ea typeface="Consolas"/>
                 <a:cs typeface="Consolas"/>
               </a:rPr>
-              <a:t>4/18</a:t>
+              <a:t>4/20</a:t>
             </a:r>
           </a:p>
         </p:txBody>
@@ -18085,7 +20038,7 @@
                 <a:ea typeface="Consolas"/>
                 <a:cs typeface="Consolas"/>
               </a:rPr>
-              <a:t>5/18</a:t>
+              <a:t>5/20</a:t>
             </a:r>
           </a:p>
         </p:txBody>
@@ -19230,7 +21183,7 @@
                 <a:ea typeface="Consolas"/>
                 <a:cs typeface="Consolas"/>
               </a:rPr>
-              <a:t>6/18</a:t>
+              <a:t>6/20</a:t>
             </a:r>
           </a:p>
         </p:txBody>
@@ -20317,7 +22270,7 @@
                 <a:ea typeface="Consolas"/>
                 <a:cs typeface="Consolas"/>
               </a:rPr>
-              <a:t>7/18</a:t>
+              <a:t>7/20</a:t>
             </a:r>
           </a:p>
         </p:txBody>
@@ -21792,7 +23745,7 @@
                 <a:ea typeface="Consolas"/>
                 <a:cs typeface="Consolas"/>
               </a:rPr>
-              <a:t>8/18</a:t>
+              <a:t>8/20</a:t>
             </a:r>
           </a:p>
         </p:txBody>
@@ -22869,7 +24822,7 @@
                 <a:ea typeface="Consolas"/>
                 <a:cs typeface="Consolas"/>
               </a:rPr>
-              <a:t>9/18</a:t>
+              <a:t>9/20</a:t>
             </a:r>
           </a:p>
         </p:txBody>

</xml_diff>

<commit_message>
style: adopt Classic Blue pixel logo across project and slides
</commit_message>
<xml_diff>
--- a/presentation/Agents_Commander_Protocol.pptx
+++ b/presentation/Agents_Commander_Protocol.pptx
@@ -2,32 +2,32 @@
 <file path=ppt/presentation.xml><?xml version="1.0" encoding="utf-8"?>
 <p:presentation xmlns:p="http://schemas.openxmlformats.org/presentationml/2006/main">
   <p:sldMasterIdLst>
-    <p:sldMasterId xmlns:r="http://schemas.openxmlformats.org/officeDocument/2006/relationships" id="2147483648" r:id="Rc5baa0eb05d84145"/>
+    <p:sldMasterId xmlns:r="http://schemas.openxmlformats.org/officeDocument/2006/relationships" id="2147483648" r:id="R1701462c8bce47a8"/>
   </p:sldMasterIdLst>
   <p:notesMasterIdLst>
-    <p:notesMasterId xmlns:r="http://schemas.openxmlformats.org/officeDocument/2006/relationships" r:id="Rcff25e687ad04667"/>
+    <p:notesMasterId xmlns:r="http://schemas.openxmlformats.org/officeDocument/2006/relationships" r:id="R2e0495e4706546ad"/>
   </p:notesMasterIdLst>
   <p:sldIdLst>
-    <p:sldId xmlns:r="http://schemas.openxmlformats.org/officeDocument/2006/relationships" id="256" r:id="R2da3c1ca2d1a4bbf"/>
-    <p:sldId xmlns:r="http://schemas.openxmlformats.org/officeDocument/2006/relationships" id="257" r:id="Refdb66479f3c4024"/>
-    <p:sldId xmlns:r="http://schemas.openxmlformats.org/officeDocument/2006/relationships" id="258" r:id="Rc6613c40abf44781"/>
-    <p:sldId xmlns:r="http://schemas.openxmlformats.org/officeDocument/2006/relationships" id="259" r:id="R039fa3364c37404d"/>
-    <p:sldId xmlns:r="http://schemas.openxmlformats.org/officeDocument/2006/relationships" id="260" r:id="R83e8e6fe90604c3a"/>
-    <p:sldId xmlns:r="http://schemas.openxmlformats.org/officeDocument/2006/relationships" id="261" r:id="R44dd34c9856846e4"/>
-    <p:sldId xmlns:r="http://schemas.openxmlformats.org/officeDocument/2006/relationships" id="262" r:id="R8070c4a6c9a9417e"/>
-    <p:sldId xmlns:r="http://schemas.openxmlformats.org/officeDocument/2006/relationships" id="263" r:id="R248cf438df9c4505"/>
-    <p:sldId xmlns:r="http://schemas.openxmlformats.org/officeDocument/2006/relationships" id="264" r:id="R88b311454bca456d"/>
-    <p:sldId xmlns:r="http://schemas.openxmlformats.org/officeDocument/2006/relationships" id="265" r:id="Rff90358d008d4226"/>
-    <p:sldId xmlns:r="http://schemas.openxmlformats.org/officeDocument/2006/relationships" id="266" r:id="Rf3abd9dce179473b"/>
-    <p:sldId xmlns:r="http://schemas.openxmlformats.org/officeDocument/2006/relationships" id="267" r:id="R250f607211cb48a0"/>
-    <p:sldId xmlns:r="http://schemas.openxmlformats.org/officeDocument/2006/relationships" id="268" r:id="R840cbd292b6146c4"/>
-    <p:sldId xmlns:r="http://schemas.openxmlformats.org/officeDocument/2006/relationships" id="269" r:id="R0bb49b00d2c34e0a"/>
-    <p:sldId xmlns:r="http://schemas.openxmlformats.org/officeDocument/2006/relationships" id="270" r:id="R370244b085cc4769"/>
-    <p:sldId xmlns:r="http://schemas.openxmlformats.org/officeDocument/2006/relationships" id="271" r:id="R12fbb3a6c0d24426"/>
-    <p:sldId xmlns:r="http://schemas.openxmlformats.org/officeDocument/2006/relationships" id="272" r:id="Re2b650e660ac4b7e"/>
-    <p:sldId xmlns:r="http://schemas.openxmlformats.org/officeDocument/2006/relationships" id="273" r:id="R714c9159328e4936"/>
-    <p:sldId xmlns:r="http://schemas.openxmlformats.org/officeDocument/2006/relationships" id="274" r:id="R519b7dd184634639"/>
-    <p:sldId xmlns:r="http://schemas.openxmlformats.org/officeDocument/2006/relationships" id="275" r:id="R696af1007f7c4378"/>
+    <p:sldId xmlns:r="http://schemas.openxmlformats.org/officeDocument/2006/relationships" id="256" r:id="Re8b42f60b4ca4175"/>
+    <p:sldId xmlns:r="http://schemas.openxmlformats.org/officeDocument/2006/relationships" id="257" r:id="Rfa91623e09274d7e"/>
+    <p:sldId xmlns:r="http://schemas.openxmlformats.org/officeDocument/2006/relationships" id="258" r:id="R6c3dd0adb92c4be0"/>
+    <p:sldId xmlns:r="http://schemas.openxmlformats.org/officeDocument/2006/relationships" id="259" r:id="R85c88cca68414bf6"/>
+    <p:sldId xmlns:r="http://schemas.openxmlformats.org/officeDocument/2006/relationships" id="260" r:id="R4545abaf88bf42e5"/>
+    <p:sldId xmlns:r="http://schemas.openxmlformats.org/officeDocument/2006/relationships" id="261" r:id="Rb33da1ad137b4f1a"/>
+    <p:sldId xmlns:r="http://schemas.openxmlformats.org/officeDocument/2006/relationships" id="262" r:id="R79b562320ed744d9"/>
+    <p:sldId xmlns:r="http://schemas.openxmlformats.org/officeDocument/2006/relationships" id="263" r:id="R96bb147bff454b2a"/>
+    <p:sldId xmlns:r="http://schemas.openxmlformats.org/officeDocument/2006/relationships" id="264" r:id="Rcbe9a413af2b445d"/>
+    <p:sldId xmlns:r="http://schemas.openxmlformats.org/officeDocument/2006/relationships" id="265" r:id="R1040a6ed74434a68"/>
+    <p:sldId xmlns:r="http://schemas.openxmlformats.org/officeDocument/2006/relationships" id="266" r:id="R1cd0ed1aedef4d01"/>
+    <p:sldId xmlns:r="http://schemas.openxmlformats.org/officeDocument/2006/relationships" id="267" r:id="Rfc9578f2576142a0"/>
+    <p:sldId xmlns:r="http://schemas.openxmlformats.org/officeDocument/2006/relationships" id="268" r:id="Rb4300f3ba3a644fc"/>
+    <p:sldId xmlns:r="http://schemas.openxmlformats.org/officeDocument/2006/relationships" id="269" r:id="R9afb2e4fe5444c35"/>
+    <p:sldId xmlns:r="http://schemas.openxmlformats.org/officeDocument/2006/relationships" id="270" r:id="Rbb9148bd24d743f3"/>
+    <p:sldId xmlns:r="http://schemas.openxmlformats.org/officeDocument/2006/relationships" id="271" r:id="R2ceab7e0a8244811"/>
+    <p:sldId xmlns:r="http://schemas.openxmlformats.org/officeDocument/2006/relationships" id="272" r:id="R2a2b7f4e9af543d9"/>
+    <p:sldId xmlns:r="http://schemas.openxmlformats.org/officeDocument/2006/relationships" id="273" r:id="R92ef626e5544447f"/>
+    <p:sldId xmlns:r="http://schemas.openxmlformats.org/officeDocument/2006/relationships" id="274" r:id="Radbd1602103a48e1"/>
+    <p:sldId xmlns:r="http://schemas.openxmlformats.org/officeDocument/2006/relationships" id="275" r:id="R7c6813d4bf2c4452"/>
   </p:sldIdLst>
   <p:sldSz cx="12191695" cy="6858000"/>
   <p:notesSz cx="6858000" cy="9144000"/>
@@ -552,6 +552,21 @@
               <a:t>Existing Callstack logo and template identity preserved.</a:t>
             </a:r>
           </a:p>
+          <a:p xmlns:a="http://schemas.openxmlformats.org/drawingml/2006/main">
+            <a:r>
+              <a:t>[Sources]</a:t>
+            </a:r>
+          </a:p>
+          <a:p xmlns:a="http://schemas.openxmlformats.org/drawingml/2006/main">
+            <a:r>
+              <a:t>Commander logo: user-approved Classic Blue pixel &gt;/&lt; mark, assets/logo.png. Built-in image generation; provenance and exact prompts: assets/BRAND.md.</a:t>
+            </a:r>
+          </a:p>
+          <a:p xmlns:a="http://schemas.openxmlformats.org/drawingml/2006/main">
+            <a:r>
+              <a:t/>
+            </a:r>
+          </a:p>
         </p:txBody>
       </p:sp>
       <p:sp>
@@ -1722,6 +1737,21 @@
               <a:t>Existing Callstack logo and template identity preserved.</a:t>
             </a:r>
           </a:p>
+          <a:p xmlns:a="http://schemas.openxmlformats.org/drawingml/2006/main">
+            <a:r>
+              <a:t>[Sources]</a:t>
+            </a:r>
+          </a:p>
+          <a:p xmlns:a="http://schemas.openxmlformats.org/drawingml/2006/main">
+            <a:r>
+              <a:t>Commander logo: user-approved Classic Blue pixel &gt;/&lt; mark, assets/logo.png. Built-in image generation; provenance and exact prompts: assets/BRAND.md.</a:t>
+            </a:r>
+          </a:p>
+          <a:p xmlns:a="http://schemas.openxmlformats.org/drawingml/2006/main">
+            <a:r>
+              <a:t/>
+            </a:r>
+          </a:p>
         </p:txBody>
       </p:sp>
       <p:sp>
@@ -1992,6 +2022,21 @@
               <a:t/>
             </a:r>
           </a:p>
+          <a:p xmlns:a="http://schemas.openxmlformats.org/drawingml/2006/main">
+            <a:r>
+              <a:t>[Sources]</a:t>
+            </a:r>
+          </a:p>
+          <a:p xmlns:a="http://schemas.openxmlformats.org/drawingml/2006/main">
+            <a:r>
+              <a:t>Commander logo: user-approved Classic Blue pixel &gt;/&lt; mark, assets/logo.png. Built-in image generation; provenance and exact prompts: assets/BRAND.md.</a:t>
+            </a:r>
+          </a:p>
+          <a:p xmlns:a="http://schemas.openxmlformats.org/drawingml/2006/main">
+            <a:r>
+              <a:t/>
+            </a:r>
+          </a:p>
         </p:txBody>
       </p:sp>
       <p:sp>
@@ -2285,6 +2330,21 @@
           <a:p xmlns:a="http://schemas.openxmlformats.org/drawingml/2006/main">
             <a:r>
               <a:t>Existing Callstack logo and template identity preserved.</a:t>
+            </a:r>
+          </a:p>
+          <a:p xmlns:a="http://schemas.openxmlformats.org/drawingml/2006/main">
+            <a:r>
+              <a:t>[Sources]</a:t>
+            </a:r>
+          </a:p>
+          <a:p xmlns:a="http://schemas.openxmlformats.org/drawingml/2006/main">
+            <a:r>
+              <a:t>Commander logo: user-approved Classic Blue pixel &gt;/&lt; mark, assets/logo.png. Built-in image generation; provenance and exact prompts: assets/BRAND.md.</a:t>
+            </a:r>
+          </a:p>
+          <a:p xmlns:a="http://schemas.openxmlformats.org/drawingml/2006/main">
+            <a:r>
+              <a:t/>
             </a:r>
           </a:p>
         </p:txBody>
@@ -6515,17 +6575,17 @@
   </p:cSld>
   <p:clrMap bg1="lt1" tx1="dk1" bg2="lt2" tx2="dk2" accent1="accent1" accent2="accent2" accent3="accent3" accent4="accent4" accent5="accent5" accent6="accent6" hlink="hlink" folHlink="folHlink"/>
   <p:sldLayoutIdLst>
-    <p:sldLayoutId xmlns:r="http://schemas.openxmlformats.org/officeDocument/2006/relationships" id="2147483649" r:id="Rd771baac107f4716"/>
-    <p:sldLayoutId xmlns:r="http://schemas.openxmlformats.org/officeDocument/2006/relationships" id="2147483650" r:id="Rf6d2525a57a6476b"/>
-    <p:sldLayoutId xmlns:r="http://schemas.openxmlformats.org/officeDocument/2006/relationships" id="2147483651" r:id="R97487071b89a418c"/>
-    <p:sldLayoutId xmlns:r="http://schemas.openxmlformats.org/officeDocument/2006/relationships" id="2147483652" r:id="R63d1ec9acda54983"/>
-    <p:sldLayoutId xmlns:r="http://schemas.openxmlformats.org/officeDocument/2006/relationships" id="2147483653" r:id="R80b672caa4f94bd4"/>
-    <p:sldLayoutId xmlns:r="http://schemas.openxmlformats.org/officeDocument/2006/relationships" id="2147483654" r:id="Re64cc588c8664ea7"/>
-    <p:sldLayoutId xmlns:r="http://schemas.openxmlformats.org/officeDocument/2006/relationships" id="2147483655" r:id="R3e12cc01e78c48f0"/>
-    <p:sldLayoutId xmlns:r="http://schemas.openxmlformats.org/officeDocument/2006/relationships" id="2147483656" r:id="R5b7bc4c34b994ca0"/>
-    <p:sldLayoutId xmlns:r="http://schemas.openxmlformats.org/officeDocument/2006/relationships" id="2147483657" r:id="Rf2e965506dc14836"/>
-    <p:sldLayoutId xmlns:r="http://schemas.openxmlformats.org/officeDocument/2006/relationships" id="2147483658" r:id="R6b754f3d0e304c4f"/>
-    <p:sldLayoutId xmlns:r="http://schemas.openxmlformats.org/officeDocument/2006/relationships" id="2147483659" r:id="Ra28e4e1fb18b4f08"/>
+    <p:sldLayoutId xmlns:r="http://schemas.openxmlformats.org/officeDocument/2006/relationships" id="2147483649" r:id="Rb5cb044e15f343ca"/>
+    <p:sldLayoutId xmlns:r="http://schemas.openxmlformats.org/officeDocument/2006/relationships" id="2147483650" r:id="R452f86c8bbab4841"/>
+    <p:sldLayoutId xmlns:r="http://schemas.openxmlformats.org/officeDocument/2006/relationships" id="2147483651" r:id="R27717d9da46d4d6e"/>
+    <p:sldLayoutId xmlns:r="http://schemas.openxmlformats.org/officeDocument/2006/relationships" id="2147483652" r:id="R75a7ccf54d5f4dec"/>
+    <p:sldLayoutId xmlns:r="http://schemas.openxmlformats.org/officeDocument/2006/relationships" id="2147483653" r:id="R6185d3cd4528426a"/>
+    <p:sldLayoutId xmlns:r="http://schemas.openxmlformats.org/officeDocument/2006/relationships" id="2147483654" r:id="R1d377fc11ee74376"/>
+    <p:sldLayoutId xmlns:r="http://schemas.openxmlformats.org/officeDocument/2006/relationships" id="2147483655" r:id="R23d0fd66df474f72"/>
+    <p:sldLayoutId xmlns:r="http://schemas.openxmlformats.org/officeDocument/2006/relationships" id="2147483656" r:id="R4a955948eaeb4398"/>
+    <p:sldLayoutId xmlns:r="http://schemas.openxmlformats.org/officeDocument/2006/relationships" id="2147483657" r:id="R76eee543ad574d68"/>
+    <p:sldLayoutId xmlns:r="http://schemas.openxmlformats.org/officeDocument/2006/relationships" id="2147483658" r:id="R5ac7cf1d3e394084"/>
+    <p:sldLayoutId xmlns:r="http://schemas.openxmlformats.org/officeDocument/2006/relationships" id="2147483659" r:id="R975bab8b2eec4663"/>
   </p:sldLayoutIdLst>
   <p:txStyles>
     <p:titleStyle>
@@ -7096,11 +7156,11 @@
           <p:nvPr/>
         </p:nvPicPr>
         <p:blipFill>
-          <a:blip xmlns:r="http://schemas.openxmlformats.org/officeDocument/2006/relationships" xmlns:a="http://schemas.openxmlformats.org/drawingml/2006/main" r:embed="Rf4420926b81f4569"/>
+          <a:blip xmlns:r="http://schemas.openxmlformats.org/officeDocument/2006/relationships" xmlns:a="http://schemas.openxmlformats.org/drawingml/2006/main" r:embed="R7269f1367b6f4e84"/>
           <a:stretch xmlns:a="http://schemas.openxmlformats.org/drawingml/2006/main"/>
         </p:blipFill>
         <p:spPr>
-          <a:xfrm xmlns:a="http://schemas.openxmlformats.org/drawingml/2006/main">
+          <a:xfrm xmlns:a="http://schemas.openxmlformats.org/drawingml/2006/main" flipH="0" flipV="0">
             <a:off x="9620250" y="1095375"/>
             <a:ext cx="1524000" cy="1524000"/>
           </a:xfrm>
@@ -7393,7 +7453,7 @@
           <p:nvPr/>
         </p:nvPicPr>
         <p:blipFill>
-          <a:blip xmlns:r="http://schemas.openxmlformats.org/officeDocument/2006/relationships" xmlns:a="http://schemas.openxmlformats.org/drawingml/2006/main" r:embed="Radb747008da84e45"/>
+          <a:blip xmlns:r="http://schemas.openxmlformats.org/officeDocument/2006/relationships" xmlns:a="http://schemas.openxmlformats.org/drawingml/2006/main" r:embed="Rc445f6d820f34816"/>
           <a:stretch xmlns:a="http://schemas.openxmlformats.org/drawingml/2006/main"/>
         </p:blipFill>
         <p:spPr>
@@ -11252,7 +11312,7 @@
           <p:nvPr/>
         </p:nvPicPr>
         <p:blipFill>
-          <a:blip xmlns:r="http://schemas.openxmlformats.org/officeDocument/2006/relationships" xmlns:a="http://schemas.openxmlformats.org/drawingml/2006/main" r:embed="R34e7b4c0d95041ac"/>
+          <a:blip xmlns:r="http://schemas.openxmlformats.org/officeDocument/2006/relationships" xmlns:a="http://schemas.openxmlformats.org/drawingml/2006/main" r:embed="Rb9966cd45c8a4d3c"/>
           <a:stretch xmlns:a="http://schemas.openxmlformats.org/drawingml/2006/main"/>
         </p:blipFill>
         <p:spPr>
@@ -13646,11 +13706,11 @@
           <p:nvPr/>
         </p:nvPicPr>
         <p:blipFill>
-          <a:blip xmlns:r="http://schemas.openxmlformats.org/officeDocument/2006/relationships" xmlns:a="http://schemas.openxmlformats.org/drawingml/2006/main" r:embed="R0eb4718d825d4935"/>
+          <a:blip xmlns:r="http://schemas.openxmlformats.org/officeDocument/2006/relationships" xmlns:a="http://schemas.openxmlformats.org/drawingml/2006/main" r:embed="R3246b4abae5c4a30"/>
           <a:stretch xmlns:a="http://schemas.openxmlformats.org/drawingml/2006/main"/>
         </p:blipFill>
         <p:spPr>
-          <a:xfrm xmlns:a="http://schemas.openxmlformats.org/drawingml/2006/main">
+          <a:xfrm xmlns:a="http://schemas.openxmlformats.org/drawingml/2006/main" flipH="0" flipV="0">
             <a:off x="9953625" y="800100"/>
             <a:ext cx="1143000" cy="1143000"/>
           </a:xfrm>
@@ -14055,7 +14115,7 @@
           <p:nvPr/>
         </p:nvPicPr>
         <p:blipFill>
-          <a:blip xmlns:r="http://schemas.openxmlformats.org/officeDocument/2006/relationships" xmlns:a="http://schemas.openxmlformats.org/drawingml/2006/main" r:embed="Rfabe69a9dfaf4339"/>
+          <a:blip xmlns:r="http://schemas.openxmlformats.org/officeDocument/2006/relationships" xmlns:a="http://schemas.openxmlformats.org/drawingml/2006/main" r:embed="R2a162b5b4e6c4c0d"/>
           <a:stretch xmlns:a="http://schemas.openxmlformats.org/drawingml/2006/main"/>
         </p:blipFill>
         <p:spPr>
@@ -15315,11 +15375,11 @@
           <p:nvPr/>
         </p:nvPicPr>
         <p:blipFill>
-          <a:blip xmlns:r="http://schemas.openxmlformats.org/officeDocument/2006/relationships" xmlns:a="http://schemas.openxmlformats.org/drawingml/2006/main" r:embed="Rb9e5b12929e0448f"/>
+          <a:blip xmlns:r="http://schemas.openxmlformats.org/officeDocument/2006/relationships" xmlns:a="http://schemas.openxmlformats.org/drawingml/2006/main" r:embed="Rc540fe4760364259"/>
           <a:stretch xmlns:a="http://schemas.openxmlformats.org/drawingml/2006/main"/>
         </p:blipFill>
         <p:spPr>
-          <a:xfrm xmlns:a="http://schemas.openxmlformats.org/drawingml/2006/main">
+          <a:xfrm xmlns:a="http://schemas.openxmlformats.org/drawingml/2006/main" flipH="0" flipV="0">
             <a:off x="9953625" y="800100"/>
             <a:ext cx="1143000" cy="1143000"/>
           </a:xfrm>
@@ -15544,7 +15604,7 @@
                 <a:latin typeface="Consolas"/>
                 <a:ea typeface="Consolas"/>
                 <a:cs typeface="Consolas"/>
-                <a:hlinkClick xmlns:r="http://schemas.openxmlformats.org/officeDocument/2006/relationships" r:id="Ra417d4ae32164404"/>
+                <a:hlinkClick xmlns:r="http://schemas.openxmlformats.org/officeDocument/2006/relationships" r:id="R5d206fc2ef394609"/>
               </a:rPr>
               <a:t>agent.sh/tickets</a:t>
             </a:r>
@@ -15736,7 +15796,7 @@
           <p:nvPr/>
         </p:nvPicPr>
         <p:blipFill>
-          <a:blip xmlns:r="http://schemas.openxmlformats.org/officeDocument/2006/relationships" xmlns:a="http://schemas.openxmlformats.org/drawingml/2006/main" r:embed="R2d8e0942d0dd4230"/>
+          <a:blip xmlns:r="http://schemas.openxmlformats.org/officeDocument/2006/relationships" xmlns:a="http://schemas.openxmlformats.org/drawingml/2006/main" r:embed="Rfdfbc22b2f0a454e"/>
           <a:stretch xmlns:a="http://schemas.openxmlformats.org/drawingml/2006/main"/>
         </p:blipFill>
         <p:spPr>
@@ -16103,7 +16163,7 @@
           <p:nvPr/>
         </p:nvPicPr>
         <p:blipFill>
-          <a:blip xmlns:r="http://schemas.openxmlformats.org/officeDocument/2006/relationships" xmlns:a="http://schemas.openxmlformats.org/drawingml/2006/main" r:embed="Ree9f5bdb1427459a"/>
+          <a:blip xmlns:r="http://schemas.openxmlformats.org/officeDocument/2006/relationships" xmlns:a="http://schemas.openxmlformats.org/drawingml/2006/main" r:embed="R58f7c73fe82d46f8"/>
           <a:stretch xmlns:a="http://schemas.openxmlformats.org/drawingml/2006/main"/>
         </p:blipFill>
         <p:spPr>
@@ -16535,11 +16595,11 @@
           <p:nvPr/>
         </p:nvPicPr>
         <p:blipFill>
-          <a:blip xmlns:r="http://schemas.openxmlformats.org/officeDocument/2006/relationships" xmlns:a="http://schemas.openxmlformats.org/drawingml/2006/main" r:embed="R5aa193e59f0b4652"/>
+          <a:blip xmlns:r="http://schemas.openxmlformats.org/officeDocument/2006/relationships" xmlns:a="http://schemas.openxmlformats.org/drawingml/2006/main" r:embed="Re9bd2f31735c4891"/>
           <a:stretch xmlns:a="http://schemas.openxmlformats.org/drawingml/2006/main"/>
         </p:blipFill>
         <p:spPr>
-          <a:xfrm xmlns:a="http://schemas.openxmlformats.org/drawingml/2006/main">
+          <a:xfrm xmlns:a="http://schemas.openxmlformats.org/drawingml/2006/main" flipH="0" flipV="0">
             <a:off x="10039350" y="723900"/>
             <a:ext cx="1066800" cy="1066800"/>
           </a:xfrm>
@@ -17000,7 +17060,7 @@
           <p:nvPr/>
         </p:nvPicPr>
         <p:blipFill>
-          <a:blip xmlns:r="http://schemas.openxmlformats.org/officeDocument/2006/relationships" xmlns:a="http://schemas.openxmlformats.org/drawingml/2006/main" r:embed="Rb9b18d6b15044d78"/>
+          <a:blip xmlns:r="http://schemas.openxmlformats.org/officeDocument/2006/relationships" xmlns:a="http://schemas.openxmlformats.org/drawingml/2006/main" r:embed="R615fc281294146df"/>
           <a:stretch xmlns:a="http://schemas.openxmlformats.org/drawingml/2006/main"/>
         </p:blipFill>
         <p:spPr>

</xml_diff>

<commit_message>
docs: explain dataset pipeline in conference architecture slide
</commit_message>
<xml_diff>
--- a/presentation/Agents_Commander_Protocol.pptx
+++ b/presentation/Agents_Commander_Protocol.pptx
@@ -2,32 +2,33 @@
 <file path=ppt/presentation.xml><?xml version="1.0" encoding="utf-8"?>
 <p:presentation xmlns:p="http://schemas.openxmlformats.org/presentationml/2006/main">
   <p:sldMasterIdLst>
-    <p:sldMasterId xmlns:r="http://schemas.openxmlformats.org/officeDocument/2006/relationships" id="2147483648" r:id="R1701462c8bce47a8"/>
+    <p:sldMasterId xmlns:r="http://schemas.openxmlformats.org/officeDocument/2006/relationships" id="2147483648" r:id="R335682ccb1fe49e0"/>
   </p:sldMasterIdLst>
   <p:notesMasterIdLst>
-    <p:notesMasterId xmlns:r="http://schemas.openxmlformats.org/officeDocument/2006/relationships" r:id="R2e0495e4706546ad"/>
+    <p:notesMasterId xmlns:r="http://schemas.openxmlformats.org/officeDocument/2006/relationships" r:id="R238eebe17b82496a"/>
   </p:notesMasterIdLst>
   <p:sldIdLst>
-    <p:sldId xmlns:r="http://schemas.openxmlformats.org/officeDocument/2006/relationships" id="256" r:id="Re8b42f60b4ca4175"/>
-    <p:sldId xmlns:r="http://schemas.openxmlformats.org/officeDocument/2006/relationships" id="257" r:id="Rfa91623e09274d7e"/>
-    <p:sldId xmlns:r="http://schemas.openxmlformats.org/officeDocument/2006/relationships" id="258" r:id="R6c3dd0adb92c4be0"/>
-    <p:sldId xmlns:r="http://schemas.openxmlformats.org/officeDocument/2006/relationships" id="259" r:id="R85c88cca68414bf6"/>
-    <p:sldId xmlns:r="http://schemas.openxmlformats.org/officeDocument/2006/relationships" id="260" r:id="R4545abaf88bf42e5"/>
-    <p:sldId xmlns:r="http://schemas.openxmlformats.org/officeDocument/2006/relationships" id="261" r:id="Rb33da1ad137b4f1a"/>
-    <p:sldId xmlns:r="http://schemas.openxmlformats.org/officeDocument/2006/relationships" id="262" r:id="R79b562320ed744d9"/>
-    <p:sldId xmlns:r="http://schemas.openxmlformats.org/officeDocument/2006/relationships" id="263" r:id="R96bb147bff454b2a"/>
-    <p:sldId xmlns:r="http://schemas.openxmlformats.org/officeDocument/2006/relationships" id="264" r:id="Rcbe9a413af2b445d"/>
-    <p:sldId xmlns:r="http://schemas.openxmlformats.org/officeDocument/2006/relationships" id="265" r:id="R1040a6ed74434a68"/>
-    <p:sldId xmlns:r="http://schemas.openxmlformats.org/officeDocument/2006/relationships" id="266" r:id="R1cd0ed1aedef4d01"/>
-    <p:sldId xmlns:r="http://schemas.openxmlformats.org/officeDocument/2006/relationships" id="267" r:id="Rfc9578f2576142a0"/>
-    <p:sldId xmlns:r="http://schemas.openxmlformats.org/officeDocument/2006/relationships" id="268" r:id="Rb4300f3ba3a644fc"/>
-    <p:sldId xmlns:r="http://schemas.openxmlformats.org/officeDocument/2006/relationships" id="269" r:id="R9afb2e4fe5444c35"/>
-    <p:sldId xmlns:r="http://schemas.openxmlformats.org/officeDocument/2006/relationships" id="270" r:id="Rbb9148bd24d743f3"/>
-    <p:sldId xmlns:r="http://schemas.openxmlformats.org/officeDocument/2006/relationships" id="271" r:id="R2ceab7e0a8244811"/>
-    <p:sldId xmlns:r="http://schemas.openxmlformats.org/officeDocument/2006/relationships" id="272" r:id="R2a2b7f4e9af543d9"/>
-    <p:sldId xmlns:r="http://schemas.openxmlformats.org/officeDocument/2006/relationships" id="273" r:id="R92ef626e5544447f"/>
-    <p:sldId xmlns:r="http://schemas.openxmlformats.org/officeDocument/2006/relationships" id="274" r:id="Radbd1602103a48e1"/>
-    <p:sldId xmlns:r="http://schemas.openxmlformats.org/officeDocument/2006/relationships" id="275" r:id="R7c6813d4bf2c4452"/>
+    <p:sldId xmlns:r="http://schemas.openxmlformats.org/officeDocument/2006/relationships" id="256" r:id="R4193577244c34ad7"/>
+    <p:sldId xmlns:r="http://schemas.openxmlformats.org/officeDocument/2006/relationships" id="257" r:id="Re4b1f1ab57954a0e"/>
+    <p:sldId xmlns:r="http://schemas.openxmlformats.org/officeDocument/2006/relationships" id="258" r:id="R3a8114af639a4a75"/>
+    <p:sldId xmlns:r="http://schemas.openxmlformats.org/officeDocument/2006/relationships" id="259" r:id="R95e23173cc164c20"/>
+    <p:sldId xmlns:r="http://schemas.openxmlformats.org/officeDocument/2006/relationships" id="260" r:id="Ra3fd71e2030b4391"/>
+    <p:sldId xmlns:r="http://schemas.openxmlformats.org/officeDocument/2006/relationships" id="261" r:id="Rd14779339142444c"/>
+    <p:sldId xmlns:r="http://schemas.openxmlformats.org/officeDocument/2006/relationships" id="262" r:id="R42ea585973f9434a"/>
+    <p:sldId xmlns:r="http://schemas.openxmlformats.org/officeDocument/2006/relationships" id="263" r:id="R2814cab3673047a0"/>
+    <p:sldId xmlns:r="http://schemas.openxmlformats.org/officeDocument/2006/relationships" id="264" r:id="R5b35bb4420ad47f7"/>
+    <p:sldId xmlns:r="http://schemas.openxmlformats.org/officeDocument/2006/relationships" id="265" r:id="Rd1f634fe3baa420e"/>
+    <p:sldId xmlns:r="http://schemas.openxmlformats.org/officeDocument/2006/relationships" id="266" r:id="R91802375a3084158"/>
+    <p:sldId xmlns:r="http://schemas.openxmlformats.org/officeDocument/2006/relationships" id="267" r:id="R306f89bbece34fe8"/>
+    <p:sldId xmlns:r="http://schemas.openxmlformats.org/officeDocument/2006/relationships" id="268" r:id="Rebdfdec4ea9840a7"/>
+    <p:sldId xmlns:r="http://schemas.openxmlformats.org/officeDocument/2006/relationships" id="269" r:id="R1de75e951a55453a"/>
+    <p:sldId xmlns:r="http://schemas.openxmlformats.org/officeDocument/2006/relationships" id="270" r:id="Rf36c5c2edf6a4a9d"/>
+    <p:sldId xmlns:r="http://schemas.openxmlformats.org/officeDocument/2006/relationships" id="271" r:id="R748aad4d83834ca2"/>
+    <p:sldId xmlns:r="http://schemas.openxmlformats.org/officeDocument/2006/relationships" id="272" r:id="Reb836141ca534029"/>
+    <p:sldId xmlns:r="http://schemas.openxmlformats.org/officeDocument/2006/relationships" id="273" r:id="R72c1a612a85f4255"/>
+    <p:sldId xmlns:r="http://schemas.openxmlformats.org/officeDocument/2006/relationships" id="274" r:id="R169b05b051d44528"/>
+    <p:sldId xmlns:r="http://schemas.openxmlformats.org/officeDocument/2006/relationships" id="275" r:id="R9c99d9d39cef4d38"/>
+    <p:sldId xmlns:r="http://schemas.openxmlformats.org/officeDocument/2006/relationships" id="276" r:id="R8936b55fcebf4783"/>
   </p:sldIdLst>
   <p:sldSz cx="12191695" cy="6858000"/>
   <p:notesSz cx="6858000" cy="9144000"/>
@@ -1824,7 +1825,7 @@
           </a:p>
           <a:p xmlns:a="http://schemas.openxmlformats.org/drawingml/2006/main">
             <a:r>
-              <a:t>1 minute</a:t>
+              <a:t>1.5 minutes</a:t>
             </a:r>
           </a:p>
           <a:p xmlns:a="http://schemas.openxmlformats.org/drawingml/2006/main">
@@ -1834,7 +1835,7 @@
           </a:p>
           <a:p xmlns:a="http://schemas.openxmlformats.org/drawingml/2006/main">
             <a:r>
-              <a:t>Today, Agents Commander can capture its communication layer with explicit consent and turn reviewed examples into structured training data. The next step is to teach a trainable model the Commander Protocol through a LoRA adapter: how to address another agent, return a reply, and produce a complete frame. The ambition is broad model interoperability, not one universal adapter. The dataset can be reused, but each adapter needs a compatible base model, tokenizer and training configuration. We would compare the adapted model with the prompted base model on unseen project groups: frame validity, routing behavior and useful collaboration. Training and model evaluation are future work, not completed results. Commander’s runtime guards remain in control.</a:t>
+              <a:t>This is the dataset-creation feature implemented today, not the future model-training step. Capture is explicitly enabled for each launch. The running app records semantic Commander events, mediated input and delivery outcomes, not full terminal transcripts, provider state or hidden reasoning. Each agent needs the protocol bootstrap; use Commander-mediated task entry to retain observable context. Raw/manual input marks the session context incomplete.</a:t>
             </a:r>
           </a:p>
           <a:p xmlns:a="http://schemas.openxmlformats.org/drawingml/2006/main">
@@ -1844,12 +1845,7 @@
           </a:p>
           <a:p xmlns:a="http://schemas.openxmlformats.org/drawingml/2006/main">
             <a:r>
-              <a:t>[Caveats]</a:t>
-            </a:r>
-          </a:p>
-          <a:p xmlns:a="http://schemas.openxmlformats.org/drawingml/2006/main">
-            <a:r>
-              <a:t>Capture observes Commander-mediated context, not full provider state or hidden reasoning. Real and synthetic data remain separate. Quality, context, privacy and rights are explicitly reviewed; transport success is not a quality label. Closed models without weight access cannot receive these LoRA weights. No model download, tokenization or training has run.</a:t>
+              <a:t>The private recorder redacts supported secrets, writes segmented JSONL and seals a SHA-256 manifest. Directory/file permissions restrict local access; this is not encryption, and redaction is best effort. Offline capture inspect reports completeness; dataset prepare requires complete captures and strictly checks schemas, segment hashes, counts and order. Preparation constructs at most one focal next-assistant-frame candidate per eligible accepted emission, with observed prompt context. Project-family and detected near-duplicate groups determine frozen train/validation/test assignments before review; small collections with fewer than three independent groups stay train-only.</a:t>
             </a:r>
           </a:p>
           <a:p xmlns:a="http://schemas.openxmlformats.org/drawingml/2006/main">
@@ -1859,27 +1855,72 @@
           </a:p>
           <a:p xmlns:a="http://schemas.openxmlformats.org/drawingml/2006/main">
             <a:r>
+              <a:t>All three human-review branches must pass: useful/correct response quality; sufficient observed context; privacy AND rights to train. The explicit approval record, reviewer and timestamp are bound to the reviewed candidate hash. Delivery success alone is not a quality label. Unreviewed or changed examples cannot silently enter export.</a:t>
+            </a:r>
+          </a:p>
+          <a:p xmlns:a="http://schemas.openxmlformats.org/drawingml/2006/main">
+            <a:r>
+              <a:t/>
+            </a:r>
+          </a:p>
+          <a:p xmlns:a="http://schemas.openxmlformats.org/drawingml/2006/main">
+            <a:r>
+              <a:t>Export replaces symbolic capability references with synthetic keys and writes conversational prompt[] plus one assistant completion[] per row. Real and synthetic examples stay in separate train/validation/test files. Provenance, review evidence, hashes, schemas and a dataset card accompany the rows; they are not injected into model inputs. The validator checks the resulting artifact and split consistency.</a:t>
+            </a:r>
+          </a:p>
+          <a:p xmlns:a="http://schemas.openxmlformats.org/drawingml/2006/main">
+            <a:r>
+              <a:t/>
+            </a:r>
+          </a:p>
+          <a:p xmlns:a="http://schemas.openxmlformats.org/drawingml/2006/main">
+            <a:r>
+              <a:t>Fresh synthetic verification on 2026-09-02 passed 96 targeted tests and the built CLI inspect→prepare→review→export→validate flow. Unreviewed export failed as intended; three reviewed synthetic examples yielded one row in each synthetic split and zero real rows. This proves the feature path, not model quality or a permissioned production dataset. Model-specific tokenization, loss-mask checks, LoRA training and evaluation are the next slide.</a:t>
+            </a:r>
+          </a:p>
+          <a:p xmlns:a="http://schemas.openxmlformats.org/drawingml/2006/main">
+            <a:r>
+              <a:t/>
+            </a:r>
+          </a:p>
+          <a:p xmlns:a="http://schemas.openxmlformats.org/drawingml/2006/main">
+            <a:r>
               <a:t>[Sources]</a:t>
             </a:r>
           </a:p>
           <a:p xmlns:a="http://schemas.openxmlformats.org/drawingml/2006/main">
             <a:r>
-              <a:t>https://github.com/lech-kalinowski/agents-commander/commit/08d6386 — implemented capture and dataset pipeline.</a:t>
-            </a:r>
-          </a:p>
-          <a:p xmlns:a="http://schemas.openxmlformats.org/drawingml/2006/main">
-            <a:r>
-              <a:t>/Users/lech.kalinowski/products/agents commander/docs/datasets.md — review gates, structured JSONL, splits and model-specific acceptance checks.</a:t>
-            </a:r>
-          </a:p>
-          <a:p xmlns:a="http://schemas.openxmlformats.org/drawingml/2006/main">
-            <a:r>
-              <a:t>https://huggingface.co/docs/trl/sft_trainer — conversational prompt/completion and model-specific chat templating.</a:t>
-            </a:r>
-          </a:p>
-          <a:p xmlns:a="http://schemas.openxmlformats.org/drawingml/2006/main">
-            <a:r>
-              <a:t>https://huggingface.co/docs/peft/developer_guides/checkpoint — adapter configuration and compatible base-model requirement.</a:t>
+              <a:t>https://github.com/lech-kalinowski/agents-commander/commit/08d6386 — implemented private capture and reviewed dataset pipeline.</a:t>
+            </a:r>
+          </a:p>
+          <a:p xmlns:a="http://schemas.openxmlformats.org/drawingml/2006/main">
+            <a:r>
+              <a:t>/Users/lech.kalinowski/products/agents commander/docs/datasets.md — supported commands, review gates, data schema, grouping and limitations.</a:t>
+            </a:r>
+          </a:p>
+          <a:p xmlns:a="http://schemas.openxmlformats.org/drawingml/2006/main">
+            <a:r>
+              <a:t>/Users/lech.kalinowski/products/agents commander/src/capture/recorder.ts — redaction, private segments and manifest.</a:t>
+            </a:r>
+          </a:p>
+          <a:p xmlns:a="http://schemas.openxmlformats.org/drawingml/2006/main">
+            <a:r>
+              <a:t>/Users/lech.kalinowski/products/agents commander/src/capture/reader.ts — strict capture validation.</a:t>
+            </a:r>
+          </a:p>
+          <a:p xmlns:a="http://schemas.openxmlformats.org/drawingml/2006/main">
+            <a:r>
+              <a:t>/Users/lech.kalinowski/products/agents commander/src/dataset/index.ts — prepare and export workflow.</a:t>
+            </a:r>
+          </a:p>
+          <a:p xmlns:a="http://schemas.openxmlformats.org/drawingml/2006/main">
+            <a:r>
+              <a:t>/Users/lech.kalinowski/products/agents commander/src/dataset/group.ts — frozen group-aware splits.</a:t>
+            </a:r>
+          </a:p>
+          <a:p xmlns:a="http://schemas.openxmlformats.org/drawingml/2006/main">
+            <a:r>
+              <a:t>/Users/lech.kalinowski/products/agents commander/src/dataset/validate.ts — export validation.</a:t>
             </a:r>
           </a:p>
           <a:p xmlns:a="http://schemas.openxmlformats.org/drawingml/2006/main">
@@ -1964,7 +2005,7 @@
           </a:p>
           <a:p xmlns:a="http://schemas.openxmlformats.org/drawingml/2006/main">
             <a:r>
-              <a:t>0.5 minutes</a:t>
+              <a:t>1 minute</a:t>
             </a:r>
           </a:p>
           <a:p xmlns:a="http://schemas.openxmlformats.org/drawingml/2006/main">
@@ -1974,7 +2015,7 @@
           </a:p>
           <a:p xmlns:a="http://schemas.openxmlformats.org/drawingml/2006/main">
             <a:r>
-              <a:t>If today’s local agent collaboration raises questions you want to keep exploring, join us at Agent Conf in Warsaw on 17–18 September 2026. Callstack is bringing engineers together around agent engineering, multi-agent orchestration and lessons from real adoption. The venue is Crowne Plaza Warsaw [The HUB]. Show the ticket link, then return to questions. No price or discount is promised. Event details checked 2026-09-02; recheck before presenting.</a:t>
+              <a:t>Today, Agents Commander can capture its communication layer with explicit consent and turn reviewed examples into structured training data. The next step is to teach a trainable model the Commander Protocol through a LoRA adapter: how to address another agent, return a reply, and produce a complete frame. The ambition is broad model interoperability, not one universal adapter. The dataset can be reused, but each adapter needs a compatible base model, tokenizer and training configuration. We would compare the adapted model with the prompted base model on unseen project groups: frame validity, routing behavior and useful collaboration. Training and model evaluation are future work, not completed results. Commander’s runtime guards remain in control.</a:t>
             </a:r>
           </a:p>
           <a:p xmlns:a="http://schemas.openxmlformats.org/drawingml/2006/main">
@@ -1984,52 +2025,47 @@
           </a:p>
           <a:p xmlns:a="http://schemas.openxmlformats.org/drawingml/2006/main">
             <a:r>
+              <a:t>[Caveats]</a:t>
+            </a:r>
+          </a:p>
+          <a:p xmlns:a="http://schemas.openxmlformats.org/drawingml/2006/main">
+            <a:r>
+              <a:t>Capture observes Commander-mediated context, not full provider state or hidden reasoning. Real and synthetic data remain separate. Quality, context, privacy and rights are explicitly reviewed; transport success is not a quality label. Closed models without weight access cannot receive these LoRA weights. No model download, tokenization or training has run.</a:t>
+            </a:r>
+          </a:p>
+          <a:p xmlns:a="http://schemas.openxmlformats.org/drawingml/2006/main">
+            <a:r>
+              <a:t/>
+            </a:r>
+          </a:p>
+          <a:p xmlns:a="http://schemas.openxmlformats.org/drawingml/2006/main">
+            <a:r>
               <a:t>[Sources]</a:t>
             </a:r>
           </a:p>
           <a:p xmlns:a="http://schemas.openxmlformats.org/drawingml/2006/main">
             <a:r>
-              <a:t>https://www.agent.sh/ — official event dates, city, venue and program themes.</a:t>
-            </a:r>
-          </a:p>
-          <a:p xmlns:a="http://schemas.openxmlformats.org/drawingml/2006/main">
-            <a:r>
-              <a:t>https://www.agent.sh/tickets — ticket destination.</a:t>
-            </a:r>
-          </a:p>
-          <a:p xmlns:a="http://schemas.openxmlformats.org/drawingml/2006/main">
-            <a:r>
-              <a:t>https://www.callstack.com/events/agent-conf — Callstack organizer, dates and city.</a:t>
-            </a:r>
-          </a:p>
-          <a:p xmlns:a="http://schemas.openxmlformats.org/drawingml/2006/main">
-            <a:r>
-              <a:t>https://www.callstack.com/media-kit — inherited authentic Callstack affiliation mark.</a:t>
-            </a:r>
-          </a:p>
-          <a:p xmlns:a="http://schemas.openxmlformats.org/drawingml/2006/main">
-            <a:r>
-              <a:t>/Users/lech.kalinowski/products/agents commander/assets/logo.png — existing project mark retained; not an Agent Conf logo.</a:t>
-            </a:r>
-          </a:p>
-          <a:p xmlns:a="http://schemas.openxmlformats.org/drawingml/2006/main">
-            <a:r>
-              <a:t>/Users/lech.kalinowski/products/agents commander/assets/BRAND.md — mark provenance.</a:t>
-            </a:r>
-          </a:p>
-          <a:p xmlns:a="http://schemas.openxmlformats.org/drawingml/2006/main">
-            <a:r>
-              <a:t/>
-            </a:r>
-          </a:p>
-          <a:p xmlns:a="http://schemas.openxmlformats.org/drawingml/2006/main">
-            <a:r>
-              <a:t>[Sources]</a:t>
-            </a:r>
-          </a:p>
-          <a:p xmlns:a="http://schemas.openxmlformats.org/drawingml/2006/main">
-            <a:r>
-              <a:t>Commander logo: user-approved Classic Blue pixel &gt;/&lt; mark, assets/logo.png. Built-in image generation; provenance and exact prompts: assets/BRAND.md.</a:t>
+              <a:t>https://github.com/lech-kalinowski/agents-commander/commit/08d6386 — implemented capture and dataset pipeline.</a:t>
+            </a:r>
+          </a:p>
+          <a:p xmlns:a="http://schemas.openxmlformats.org/drawingml/2006/main">
+            <a:r>
+              <a:t>/Users/lech.kalinowski/products/agents commander/docs/datasets.md — review gates, structured JSONL, splits and model-specific acceptance checks.</a:t>
+            </a:r>
+          </a:p>
+          <a:p xmlns:a="http://schemas.openxmlformats.org/drawingml/2006/main">
+            <a:r>
+              <a:t>https://huggingface.co/docs/trl/sft_trainer — conversational prompt/completion and model-specific chat templating.</a:t>
+            </a:r>
+          </a:p>
+          <a:p xmlns:a="http://schemas.openxmlformats.org/drawingml/2006/main">
+            <a:r>
+              <a:t>https://huggingface.co/docs/peft/developer_guides/checkpoint — adapter configuration and compatible base-model requirement.</a:t>
+            </a:r>
+          </a:p>
+          <a:p xmlns:a="http://schemas.openxmlformats.org/drawingml/2006/main">
+            <a:r>
+              <a:t>https://www.callstack.com/media-kit — inherited Callstack visual identity.</a:t>
             </a:r>
           </a:p>
           <a:p xmlns:a="http://schemas.openxmlformats.org/drawingml/2006/main">
@@ -2219,6 +2255,151 @@
           <a:lstStyle xmlns:a="http://schemas.openxmlformats.org/drawingml/2006/main"/>
           <a:p xmlns:a="http://schemas.openxmlformats.org/drawingml/2006/main">
             <a:r>
+              <a:t>[Timing]</a:t>
+            </a:r>
+          </a:p>
+          <a:p xmlns:a="http://schemas.openxmlformats.org/drawingml/2006/main">
+            <a:r>
+              <a:t>0.5 minutes</a:t>
+            </a:r>
+          </a:p>
+          <a:p xmlns:a="http://schemas.openxmlformats.org/drawingml/2006/main">
+            <a:r>
+              <a:t/>
+            </a:r>
+          </a:p>
+          <a:p xmlns:a="http://schemas.openxmlformats.org/drawingml/2006/main">
+            <a:r>
+              <a:t>If today’s local agent collaboration raises questions you want to keep exploring, join us at Agent Conf in Warsaw on 17–18 September 2026. Callstack is bringing engineers together around agent engineering, multi-agent orchestration and lessons from real adoption. The venue is Crowne Plaza Warsaw [The HUB]. Show the ticket link, then return to questions. No price or discount is promised. Event details checked 2026-09-02; recheck before presenting.</a:t>
+            </a:r>
+          </a:p>
+          <a:p xmlns:a="http://schemas.openxmlformats.org/drawingml/2006/main">
+            <a:r>
+              <a:t/>
+            </a:r>
+          </a:p>
+          <a:p xmlns:a="http://schemas.openxmlformats.org/drawingml/2006/main">
+            <a:r>
+              <a:t>[Sources]</a:t>
+            </a:r>
+          </a:p>
+          <a:p xmlns:a="http://schemas.openxmlformats.org/drawingml/2006/main">
+            <a:r>
+              <a:t>https://www.agent.sh/ — official event dates, city, venue and program themes.</a:t>
+            </a:r>
+          </a:p>
+          <a:p xmlns:a="http://schemas.openxmlformats.org/drawingml/2006/main">
+            <a:r>
+              <a:t>https://www.agent.sh/tickets — ticket destination.</a:t>
+            </a:r>
+          </a:p>
+          <a:p xmlns:a="http://schemas.openxmlformats.org/drawingml/2006/main">
+            <a:r>
+              <a:t>https://www.callstack.com/events/agent-conf — Callstack organizer, dates and city.</a:t>
+            </a:r>
+          </a:p>
+          <a:p xmlns:a="http://schemas.openxmlformats.org/drawingml/2006/main">
+            <a:r>
+              <a:t>https://www.callstack.com/media-kit — inherited authentic Callstack affiliation mark.</a:t>
+            </a:r>
+          </a:p>
+          <a:p xmlns:a="http://schemas.openxmlformats.org/drawingml/2006/main">
+            <a:r>
+              <a:t>/Users/lech.kalinowski/products/agents commander/assets/logo.png — existing project mark retained; not an Agent Conf logo.</a:t>
+            </a:r>
+          </a:p>
+          <a:p xmlns:a="http://schemas.openxmlformats.org/drawingml/2006/main">
+            <a:r>
+              <a:t>/Users/lech.kalinowski/products/agents commander/assets/BRAND.md — mark provenance.</a:t>
+            </a:r>
+          </a:p>
+          <a:p xmlns:a="http://schemas.openxmlformats.org/drawingml/2006/main">
+            <a:r>
+              <a:t/>
+            </a:r>
+          </a:p>
+          <a:p xmlns:a="http://schemas.openxmlformats.org/drawingml/2006/main">
+            <a:r>
+              <a:t>[Sources]</a:t>
+            </a:r>
+          </a:p>
+          <a:p xmlns:a="http://schemas.openxmlformats.org/drawingml/2006/main">
+            <a:r>
+              <a:t>Commander logo: user-approved Classic Blue pixel &gt;/&lt; mark, assets/logo.png. Built-in image generation; provenance and exact prompts: assets/BRAND.md.</a:t>
+            </a:r>
+          </a:p>
+          <a:p xmlns:a="http://schemas.openxmlformats.org/drawingml/2006/main">
+            <a:r>
+              <a:t/>
+            </a:r>
+          </a:p>
+        </p:txBody>
+      </p:sp>
+      <p:sp>
+        <p:nvSpPr>
+          <p:cNvPr id="4" name="Slide Number Placeholder 3"/>
+          <p:cNvSpPr>
+            <a:spLocks xmlns:a="http://schemas.openxmlformats.org/drawingml/2006/main" noGrp="1"/>
+          </p:cNvSpPr>
+          <p:nvPr>
+            <p:ph type="sldNum" idx="5"/>
+          </p:nvPr>
+        </p:nvSpPr>
+        <p:spPr/>
+        <p:txBody>
+          <a:bodyPr xmlns:a="http://schemas.openxmlformats.org/drawingml/2006/main"/>
+          <a:lstStyle xmlns:a="http://schemas.openxmlformats.org/drawingml/2006/main"/>
+          <a:p xmlns:a="http://schemas.openxmlformats.org/drawingml/2006/main"/>
+        </p:txBody>
+      </p:sp>
+    </p:spTree>
+  </p:cSld>
+  <p:clrMapOvr>
+    <a:masterClrMapping xmlns:a="http://schemas.openxmlformats.org/drawingml/2006/main"/>
+  </p:clrMapOvr>
+</p:notes>
+</file>
+
+<file path=ppt/notesSlides/notesSlide21.xml><?xml version="1.0" encoding="utf-8"?>
+<p:notes xmlns:p="http://schemas.openxmlformats.org/presentationml/2006/main">
+  <p:cSld>
+    <p:spTree>
+      <p:nvGrpSpPr>
+        <p:cNvPr id="1" name=""/>
+        <p:cNvGrpSpPr/>
+        <p:nvPr/>
+      </p:nvGrpSpPr>
+      <p:grpSpPr>
+        <a:xfrm xmlns:a="http://schemas.openxmlformats.org/drawingml/2006/main"/>
+      </p:grpSpPr>
+      <p:sp>
+        <p:nvSpPr>
+          <p:cNvPr id="2" name="Slide Image Placeholder 1"/>
+          <p:cNvSpPr>
+            <a:spLocks xmlns:a="http://schemas.openxmlformats.org/drawingml/2006/main" noGrp="1"/>
+          </p:cNvSpPr>
+          <p:nvPr>
+            <p:ph type="sldImg" idx="0"/>
+          </p:nvPr>
+        </p:nvSpPr>
+        <p:spPr/>
+      </p:sp>
+      <p:sp>
+        <p:nvSpPr>
+          <p:cNvPr id="3" name="Notes Placeholder 2"/>
+          <p:cNvSpPr>
+            <a:spLocks xmlns:a="http://schemas.openxmlformats.org/drawingml/2006/main" noGrp="1"/>
+          </p:cNvSpPr>
+          <p:nvPr>
+            <p:ph type="body" idx="1"/>
+          </p:nvPr>
+        </p:nvSpPr>
+        <p:spPr/>
+        <p:txBody>
+          <a:bodyPr xmlns:a="http://schemas.openxmlformats.org/drawingml/2006/main"/>
+          <a:lstStyle xmlns:a="http://schemas.openxmlformats.org/drawingml/2006/main"/>
+          <a:p xmlns:a="http://schemas.openxmlformats.org/drawingml/2006/main">
+            <a:r>
               <a:t>[Timing] 5:00</a:t>
             </a:r>
           </a:p>
@@ -2429,7 +2610,7 @@
           </a:p>
           <a:p xmlns:a="http://schemas.openxmlformats.org/drawingml/2006/main">
             <a:r>
-              <a:t>3 minutes (03:00)</a:t>
+              <a:t>2.5 minutes</a:t>
             </a:r>
           </a:p>
           <a:p xmlns:a="http://schemas.openxmlformats.org/drawingml/2006/main">
@@ -2609,7 +2790,7 @@
           </a:p>
           <a:p xmlns:a="http://schemas.openxmlformats.org/drawingml/2006/main">
             <a:r>
-              <a:t>2 minutes (02:00)</a:t>
+              <a:t>1.5 minutes</a:t>
             </a:r>
           </a:p>
           <a:p xmlns:a="http://schemas.openxmlformats.org/drawingml/2006/main">
@@ -3149,7 +3330,7 @@
           </a:p>
           <a:p xmlns:a="http://schemas.openxmlformats.org/drawingml/2006/main">
             <a:r>
-              <a:t>2 minutes (02:00)</a:t>
+              <a:t>1.5 minutes</a:t>
             </a:r>
           </a:p>
           <a:p xmlns:a="http://schemas.openxmlformats.org/drawingml/2006/main">
@@ -6575,17 +6756,17 @@
   </p:cSld>
   <p:clrMap bg1="lt1" tx1="dk1" bg2="lt2" tx2="dk2" accent1="accent1" accent2="accent2" accent3="accent3" accent4="accent4" accent5="accent5" accent6="accent6" hlink="hlink" folHlink="folHlink"/>
   <p:sldLayoutIdLst>
-    <p:sldLayoutId xmlns:r="http://schemas.openxmlformats.org/officeDocument/2006/relationships" id="2147483649" r:id="Rb5cb044e15f343ca"/>
-    <p:sldLayoutId xmlns:r="http://schemas.openxmlformats.org/officeDocument/2006/relationships" id="2147483650" r:id="R452f86c8bbab4841"/>
-    <p:sldLayoutId xmlns:r="http://schemas.openxmlformats.org/officeDocument/2006/relationships" id="2147483651" r:id="R27717d9da46d4d6e"/>
-    <p:sldLayoutId xmlns:r="http://schemas.openxmlformats.org/officeDocument/2006/relationships" id="2147483652" r:id="R75a7ccf54d5f4dec"/>
-    <p:sldLayoutId xmlns:r="http://schemas.openxmlformats.org/officeDocument/2006/relationships" id="2147483653" r:id="R6185d3cd4528426a"/>
-    <p:sldLayoutId xmlns:r="http://schemas.openxmlformats.org/officeDocument/2006/relationships" id="2147483654" r:id="R1d377fc11ee74376"/>
-    <p:sldLayoutId xmlns:r="http://schemas.openxmlformats.org/officeDocument/2006/relationships" id="2147483655" r:id="R23d0fd66df474f72"/>
-    <p:sldLayoutId xmlns:r="http://schemas.openxmlformats.org/officeDocument/2006/relationships" id="2147483656" r:id="R4a955948eaeb4398"/>
-    <p:sldLayoutId xmlns:r="http://schemas.openxmlformats.org/officeDocument/2006/relationships" id="2147483657" r:id="R76eee543ad574d68"/>
-    <p:sldLayoutId xmlns:r="http://schemas.openxmlformats.org/officeDocument/2006/relationships" id="2147483658" r:id="R5ac7cf1d3e394084"/>
-    <p:sldLayoutId xmlns:r="http://schemas.openxmlformats.org/officeDocument/2006/relationships" id="2147483659" r:id="R975bab8b2eec4663"/>
+    <p:sldLayoutId xmlns:r="http://schemas.openxmlformats.org/officeDocument/2006/relationships" id="2147483649" r:id="R2c1cabd33cf7464a"/>
+    <p:sldLayoutId xmlns:r="http://schemas.openxmlformats.org/officeDocument/2006/relationships" id="2147483650" r:id="R54302499837a4bfc"/>
+    <p:sldLayoutId xmlns:r="http://schemas.openxmlformats.org/officeDocument/2006/relationships" id="2147483651" r:id="R453de4b827dd4e28"/>
+    <p:sldLayoutId xmlns:r="http://schemas.openxmlformats.org/officeDocument/2006/relationships" id="2147483652" r:id="Rd0b1bf2a1ecc423d"/>
+    <p:sldLayoutId xmlns:r="http://schemas.openxmlformats.org/officeDocument/2006/relationships" id="2147483653" r:id="Rd4f50fa0fa434899"/>
+    <p:sldLayoutId xmlns:r="http://schemas.openxmlformats.org/officeDocument/2006/relationships" id="2147483654" r:id="R74ca56b5c74f40c3"/>
+    <p:sldLayoutId xmlns:r="http://schemas.openxmlformats.org/officeDocument/2006/relationships" id="2147483655" r:id="R6ccbcfb2a66b4bac"/>
+    <p:sldLayoutId xmlns:r="http://schemas.openxmlformats.org/officeDocument/2006/relationships" id="2147483656" r:id="R8a5010908a0145a0"/>
+    <p:sldLayoutId xmlns:r="http://schemas.openxmlformats.org/officeDocument/2006/relationships" id="2147483657" r:id="R09e688fe4053436b"/>
+    <p:sldLayoutId xmlns:r="http://schemas.openxmlformats.org/officeDocument/2006/relationships" id="2147483658" r:id="R56316ed1130a460c"/>
+    <p:sldLayoutId xmlns:r="http://schemas.openxmlformats.org/officeDocument/2006/relationships" id="2147483659" r:id="R0d6dae78a984410a"/>
   </p:sldLayoutIdLst>
   <p:txStyles>
     <p:titleStyle>
@@ -7156,7 +7337,7 @@
           <p:nvPr/>
         </p:nvPicPr>
         <p:blipFill>
-          <a:blip xmlns:r="http://schemas.openxmlformats.org/officeDocument/2006/relationships" xmlns:a="http://schemas.openxmlformats.org/drawingml/2006/main" r:embed="R7269f1367b6f4e84"/>
+          <a:blip xmlns:r="http://schemas.openxmlformats.org/officeDocument/2006/relationships" xmlns:a="http://schemas.openxmlformats.org/drawingml/2006/main" r:embed="R49eb5c7346a54aac"/>
           <a:stretch xmlns:a="http://schemas.openxmlformats.org/drawingml/2006/main"/>
         </p:blipFill>
         <p:spPr>
@@ -7439,7 +7620,7 @@
                 <a:ea typeface="Consolas"/>
                 <a:cs typeface="Consolas"/>
               </a:rPr>
-              <a:t>1/20</a:t>
+              <a:t>1/21</a:t>
             </a:r>
           </a:p>
         </p:txBody>
@@ -7453,7 +7634,7 @@
           <p:nvPr/>
         </p:nvPicPr>
         <p:blipFill>
-          <a:blip xmlns:r="http://schemas.openxmlformats.org/officeDocument/2006/relationships" xmlns:a="http://schemas.openxmlformats.org/drawingml/2006/main" r:embed="Rc445f6d820f34816"/>
+          <a:blip xmlns:r="http://schemas.openxmlformats.org/officeDocument/2006/relationships" xmlns:a="http://schemas.openxmlformats.org/drawingml/2006/main" r:embed="R5e20979b327a49e0"/>
           <a:stretch xmlns:a="http://schemas.openxmlformats.org/drawingml/2006/main"/>
         </p:blipFill>
         <p:spPr>
@@ -7655,7 +7836,7 @@
                 <a:ea typeface="Consolas"/>
                 <a:cs typeface="Consolas"/>
               </a:rPr>
-              <a:t>10/20</a:t>
+              <a:t>10/21</a:t>
             </a:r>
           </a:p>
         </p:txBody>
@@ -8732,7 +8913,7 @@
                 <a:ea typeface="Consolas"/>
                 <a:cs typeface="Consolas"/>
               </a:rPr>
-              <a:t>11/20</a:t>
+              <a:t>11/21</a:t>
             </a:r>
           </a:p>
         </p:txBody>
@@ -9544,7 +9725,7 @@
                 <a:ea typeface="Consolas"/>
                 <a:cs typeface="Consolas"/>
               </a:rPr>
-              <a:t>12/20</a:t>
+              <a:t>12/21</a:t>
             </a:r>
           </a:p>
         </p:txBody>
@@ -10361,7 +10542,7 @@
                 <a:ea typeface="Consolas"/>
                 <a:cs typeface="Consolas"/>
               </a:rPr>
-              <a:t>13/20</a:t>
+              <a:t>13/21</a:t>
             </a:r>
           </a:p>
         </p:txBody>
@@ -11265,7 +11446,7 @@
                 <a:ea typeface="Consolas"/>
                 <a:cs typeface="Consolas"/>
               </a:rPr>
-              <a:t>14/20</a:t>
+              <a:t>14/21</a:t>
             </a:r>
           </a:p>
         </p:txBody>
@@ -11312,7 +11493,7 @@
           <p:nvPr/>
         </p:nvPicPr>
         <p:blipFill>
-          <a:blip xmlns:r="http://schemas.openxmlformats.org/officeDocument/2006/relationships" xmlns:a="http://schemas.openxmlformats.org/drawingml/2006/main" r:embed="Rb9966cd45c8a4d3c"/>
+          <a:blip xmlns:r="http://schemas.openxmlformats.org/officeDocument/2006/relationships" xmlns:a="http://schemas.openxmlformats.org/drawingml/2006/main" r:embed="R0a552408055f48eb"/>
           <a:stretch xmlns:a="http://schemas.openxmlformats.org/drawingml/2006/main"/>
         </p:blipFill>
         <p:spPr>
@@ -11927,7 +12108,7 @@
                 <a:ea typeface="Consolas"/>
                 <a:cs typeface="Consolas"/>
               </a:rPr>
-              <a:t>15/20</a:t>
+              <a:t>15/21</a:t>
             </a:r>
           </a:p>
         </p:txBody>
@@ -12807,7 +12988,7 @@
                 <a:ea typeface="Consolas"/>
                 <a:cs typeface="Consolas"/>
               </a:rPr>
-              <a:t>16/20</a:t>
+              <a:t>16/21</a:t>
             </a:r>
           </a:p>
         </p:txBody>
@@ -13706,7 +13887,7 @@
           <p:nvPr/>
         </p:nvPicPr>
         <p:blipFill>
-          <a:blip xmlns:r="http://schemas.openxmlformats.org/officeDocument/2006/relationships" xmlns:a="http://schemas.openxmlformats.org/drawingml/2006/main" r:embed="R3246b4abae5c4a30"/>
+          <a:blip xmlns:r="http://schemas.openxmlformats.org/officeDocument/2006/relationships" xmlns:a="http://schemas.openxmlformats.org/drawingml/2006/main" r:embed="R92cdf7657387410d"/>
           <a:stretch xmlns:a="http://schemas.openxmlformats.org/drawingml/2006/main"/>
         </p:blipFill>
         <p:spPr>
@@ -14101,7 +14282,7 @@
                 <a:ea typeface="Consolas"/>
                 <a:cs typeface="Consolas"/>
               </a:rPr>
-              <a:t>17/20</a:t>
+              <a:t>17/21</a:t>
             </a:r>
           </a:p>
         </p:txBody>
@@ -14115,7 +14296,7 @@
           <p:nvPr/>
         </p:nvPicPr>
         <p:blipFill>
-          <a:blip xmlns:r="http://schemas.openxmlformats.org/officeDocument/2006/relationships" xmlns:a="http://schemas.openxmlformats.org/drawingml/2006/main" r:embed="R2a162b5b4e6c4c0d"/>
+          <a:blip xmlns:r="http://schemas.openxmlformats.org/officeDocument/2006/relationships" xmlns:a="http://schemas.openxmlformats.org/drawingml/2006/main" r:embed="R505ba91ddb414331"/>
           <a:stretch xmlns:a="http://schemas.openxmlformats.org/drawingml/2006/main"/>
         </p:blipFill>
         <p:spPr>
@@ -14280,7 +14461,7 @@
           <p:cNvPr id="2" name="TextBox 1">
             <a:extLst xmlns:a="http://schemas.openxmlformats.org/drawingml/2006/main">
               <a:ext uri="{FF2B5EF4-FFF2-40B4-BE49-F238E27FC236}">
-                <a16:creationId xmlns:a16="http://schemas.microsoft.com/office/drawing/2014/main" id="{F7141995-C002-488C-8F2B-E515FB545E84}"/>
+                <a16:creationId xmlns:a16="http://schemas.microsoft.com/office/drawing/2014/main" id="{47BA366A-9237-4F8F-8986-15917BD6D207}"/>
               </a:ext>
             </a:extLst>
           </p:cNvPr>
@@ -14325,7 +14506,7 @@
                 <a:ea typeface="Consolas"/>
                 <a:cs typeface="Consolas"/>
               </a:rPr>
-              <a:t>FUTURE · PROTOCOL LEARNING</a:t>
+              <a:t>IMPLEMENTED · DATASET PIPELINE</a:t>
             </a:r>
           </a:p>
         </p:txBody>
@@ -14335,7 +14516,7 @@
           <p:cNvPr id="3" name="TextBox 2">
             <a:extLst xmlns:a="http://schemas.openxmlformats.org/drawingml/2006/main">
               <a:ext uri="{FF2B5EF4-FFF2-40B4-BE49-F238E27FC236}">
-                <a16:creationId xmlns:a16="http://schemas.microsoft.com/office/drawing/2014/main" id="{A126BAEC-F6D3-4875-A4AC-25DD6C136B70}"/>
+                <a16:creationId xmlns:a16="http://schemas.microsoft.com/office/drawing/2014/main" id="{D8202F8C-732C-4C98-9F82-3027BD53EF0A}"/>
               </a:ext>
             </a:extLst>
           </p:cNvPr>
@@ -14380,17 +14561,17 @@
                 <a:ea typeface="Alliance No.2"/>
                 <a:cs typeface="Alliance No.2"/>
               </a:rPr>
-              <a:t>Teach models the Commander Protocol.</a:t>
-            </a:r>
-          </a:p>
-        </p:txBody>
-      </p:sp>
-      <p:sp>
-        <p:nvSpPr>
-          <p:cNvPr id="49" name="TextBox 48">
-            <a:extLst xmlns:a="http://schemas.openxmlformats.org/drawingml/2006/main">
-              <a:ext uri="{FF2B5EF4-FFF2-40B4-BE49-F238E27FC236}">
-                <a16:creationId xmlns:a16="http://schemas.microsoft.com/office/drawing/2014/main" id="{55083C4D-8CCA-4EA1-B774-DBE100BF8F62}"/>
+              <a:t>Build datasets from observed agent traffic.</a:t>
+            </a:r>
+          </a:p>
+        </p:txBody>
+      </p:sp>
+      <p:sp>
+        <p:nvSpPr>
+          <p:cNvPr id="17" name="TextBox 16">
+            <a:extLst xmlns:a="http://schemas.openxmlformats.org/drawingml/2006/main">
+              <a:ext uri="{FF2B5EF4-FFF2-40B4-BE49-F238E27FC236}">
+                <a16:creationId xmlns:a16="http://schemas.microsoft.com/office/drawing/2014/main" id="{C9D6A176-4572-4BB1-8164-1D95DC5CCB19}"/>
               </a:ext>
             </a:extLst>
           </p:cNvPr>
@@ -14435,17 +14616,17 @@
                 <a:ea typeface="Consolas"/>
                 <a:cs typeface="Consolas"/>
               </a:rPr>
-              <a:t>18/20</a:t>
-            </a:r>
-          </a:p>
-        </p:txBody>
-      </p:sp>
-      <p:sp>
-        <p:nvSpPr>
-          <p:cNvPr id="50" name="Callstack accent rule">
-            <a:extLst xmlns:a="http://schemas.openxmlformats.org/drawingml/2006/main">
-              <a:ext uri="{FF2B5EF4-FFF2-40B4-BE49-F238E27FC236}">
-                <a16:creationId xmlns:a16="http://schemas.microsoft.com/office/drawing/2014/main" id="{B8DAE6AA-7B94-4D91-9F2C-8316CB9480FB}"/>
+              <a:t>18/21</a:t>
+            </a:r>
+          </a:p>
+        </p:txBody>
+      </p:sp>
+      <p:sp>
+        <p:nvSpPr>
+          <p:cNvPr id="18" name="Callstack accent rule">
+            <a:extLst xmlns:a="http://schemas.openxmlformats.org/drawingml/2006/main">
+              <a:ext uri="{FF2B5EF4-FFF2-40B4-BE49-F238E27FC236}">
+                <a16:creationId xmlns:a16="http://schemas.microsoft.com/office/drawing/2014/main" id="{C6B95789-2123-4965-B52B-40FD36F4D748}"/>
               </a:ext>
             </a:extLst>
           </p:cNvPr>
@@ -14475,24 +14656,148 @@
       </p:sp>
       <p:sp>
         <p:nvSpPr>
-          <p:cNvPr id="51" name="guard-272">
-            <a:extLst xmlns:a="http://schemas.openxmlformats.org/drawingml/2006/main">
-              <a:ext uri="{FF2B5EF4-FFF2-40B4-BE49-F238E27FC236}">
-                <a16:creationId xmlns:a16="http://schemas.microsoft.com/office/drawing/2014/main" id="{5B33431B-A35A-4B5F-BB47-84F22ADED5C2}"/>
-              </a:ext>
-            </a:extLst>
-          </p:cNvPr>
-          <p:cNvSpPr>
-            <a:spLocks xmlns:a="http://schemas.openxmlformats.org/drawingml/2006/main" noGrp="1"/>
-          </p:cNvSpPr>
-          <p:nvPr/>
-        </p:nvSpPr>
-        <p:spPr>
-          <a:xfrm xmlns:a="http://schemas.openxmlformats.org/drawingml/2006/main">
-            <a:off x="2590800" y="2800350"/>
-            <a:ext cx="504825" cy="114300"/>
+          <p:cNvPr id="19" name="bytes-to-decode">
+            <a:extLst xmlns:a="http://schemas.openxmlformats.org/drawingml/2006/main">
+              <a:ext uri="{FF2B5EF4-FFF2-40B4-BE49-F238E27FC236}">
+                <a16:creationId xmlns:a16="http://schemas.microsoft.com/office/drawing/2014/main" id="{6AAB505C-A6AD-4AAF-9631-06E32C4E5490}"/>
+              </a:ext>
+            </a:extLst>
+          </p:cNvPr>
+          <p:cNvSpPr>
+            <a:spLocks xmlns:a="http://schemas.openxmlformats.org/drawingml/2006/main" noGrp="1"/>
+          </p:cNvSpPr>
+          <p:nvPr/>
+        </p:nvSpPr>
+        <p:spPr>
+          <a:xfrm xmlns:a="http://schemas.openxmlformats.org/drawingml/2006/main">
+            <a:off x="2524125" y="2276475"/>
+            <a:ext cx="857250" cy="114300"/>
           </a:xfrm>
           <a:prstGeom xmlns:a="http://schemas.openxmlformats.org/drawingml/2006/main" prst="rightArrow">
+            <a:avLst/>
+          </a:prstGeom>
+          <a:solidFill xmlns:a="http://schemas.openxmlformats.org/drawingml/2006/main">
+            <a:srgbClr val="72C6F9"/>
+          </a:solidFill>
+          <a:ln xmlns:a="http://schemas.openxmlformats.org/drawingml/2006/main" w="0">
+            <a:noFill/>
+            <a:prstDash val="solid"/>
+          </a:ln>
+        </p:spPr>
+      </p:sp>
+      <p:sp>
+        <p:nvSpPr>
+          <p:cNvPr id="20" name="decode-to-vterm">
+            <a:extLst xmlns:a="http://schemas.openxmlformats.org/drawingml/2006/main">
+              <a:ext uri="{FF2B5EF4-FFF2-40B4-BE49-F238E27FC236}">
+                <a16:creationId xmlns:a16="http://schemas.microsoft.com/office/drawing/2014/main" id="{A3EDF5C4-A9AD-4DFB-9C3C-3EB2C59256B6}"/>
+              </a:ext>
+            </a:extLst>
+          </p:cNvPr>
+          <p:cNvSpPr>
+            <a:spLocks xmlns:a="http://schemas.openxmlformats.org/drawingml/2006/main" noGrp="1"/>
+          </p:cNvSpPr>
+          <p:nvPr/>
+        </p:nvSpPr>
+        <p:spPr>
+          <a:xfrm xmlns:a="http://schemas.openxmlformats.org/drawingml/2006/main">
+            <a:off x="5962650" y="2276475"/>
+            <a:ext cx="809625" cy="114300"/>
+          </a:xfrm>
+          <a:prstGeom xmlns:a="http://schemas.openxmlformats.org/drawingml/2006/main" prst="rightArrow">
+            <a:avLst/>
+          </a:prstGeom>
+          <a:solidFill xmlns:a="http://schemas.openxmlformats.org/drawingml/2006/main">
+            <a:srgbClr val="72C6F9"/>
+          </a:solidFill>
+          <a:ln xmlns:a="http://schemas.openxmlformats.org/drawingml/2006/main" w="0">
+            <a:noFill/>
+            <a:prstDash val="solid"/>
+          </a:ln>
+        </p:spPr>
+      </p:sp>
+      <p:sp>
+        <p:nvSpPr>
+          <p:cNvPr id="21" name="vterm-to-fan">
+            <a:extLst xmlns:a="http://schemas.openxmlformats.org/drawingml/2006/main">
+              <a:ext uri="{FF2B5EF4-FFF2-40B4-BE49-F238E27FC236}">
+                <a16:creationId xmlns:a16="http://schemas.microsoft.com/office/drawing/2014/main" id="{3A24FEB3-43ED-4989-9FA8-45519473BE57}"/>
+              </a:ext>
+            </a:extLst>
+          </p:cNvPr>
+          <p:cNvSpPr>
+            <a:spLocks xmlns:a="http://schemas.openxmlformats.org/drawingml/2006/main" noGrp="1"/>
+          </p:cNvSpPr>
+          <p:nvPr/>
+        </p:nvSpPr>
+        <p:spPr>
+          <a:xfrm xmlns:a="http://schemas.openxmlformats.org/drawingml/2006/main">
+            <a:off x="9067800" y="2686050"/>
+            <a:ext cx="0" cy="247650"/>
+          </a:xfrm>
+          <a:prstGeom xmlns:a="http://schemas.openxmlformats.org/drawingml/2006/main" prst="line">
+            <a:avLst/>
+          </a:prstGeom>
+          <a:noFill xmlns:a="http://schemas.openxmlformats.org/drawingml/2006/main"/>
+          <a:ln xmlns:a="http://schemas.openxmlformats.org/drawingml/2006/main" w="16193">
+            <a:solidFill>
+              <a:srgbClr val="CBAAFF"/>
+            </a:solidFill>
+            <a:prstDash val="solid"/>
+          </a:ln>
+        </p:spPr>
+      </p:sp>
+      <p:sp>
+        <p:nvSpPr>
+          <p:cNvPr id="22" name="fanout-bar">
+            <a:extLst xmlns:a="http://schemas.openxmlformats.org/drawingml/2006/main">
+              <a:ext uri="{FF2B5EF4-FFF2-40B4-BE49-F238E27FC236}">
+                <a16:creationId xmlns:a16="http://schemas.microsoft.com/office/drawing/2014/main" id="{D5D827A9-4EAC-4670-BC05-54AB53E4421A}"/>
+              </a:ext>
+            </a:extLst>
+          </p:cNvPr>
+          <p:cNvSpPr>
+            <a:spLocks xmlns:a="http://schemas.openxmlformats.org/drawingml/2006/main" noGrp="1"/>
+          </p:cNvSpPr>
+          <p:nvPr/>
+        </p:nvSpPr>
+        <p:spPr>
+          <a:xfrm xmlns:a="http://schemas.openxmlformats.org/drawingml/2006/main">
+            <a:off x="2152650" y="2933700"/>
+            <a:ext cx="7534275" cy="0"/>
+          </a:xfrm>
+          <a:prstGeom xmlns:a="http://schemas.openxmlformats.org/drawingml/2006/main" prst="line">
+            <a:avLst/>
+          </a:prstGeom>
+          <a:noFill xmlns:a="http://schemas.openxmlformats.org/drawingml/2006/main"/>
+          <a:ln xmlns:a="http://schemas.openxmlformats.org/drawingml/2006/main" w="16193">
+            <a:solidFill>
+              <a:srgbClr val="CBAAFF"/>
+            </a:solidFill>
+            <a:prstDash val="solid"/>
+          </a:ln>
+        </p:spPr>
+      </p:sp>
+      <p:sp>
+        <p:nvSpPr>
+          <p:cNvPr id="23" name="scan-in-220">
+            <a:extLst xmlns:a="http://schemas.openxmlformats.org/drawingml/2006/main">
+              <a:ext uri="{FF2B5EF4-FFF2-40B4-BE49-F238E27FC236}">
+                <a16:creationId xmlns:a16="http://schemas.microsoft.com/office/drawing/2014/main" id="{CEBF0AED-C042-4EF9-98CA-38CE4E0C6DBE}"/>
+              </a:ext>
+            </a:extLst>
+          </p:cNvPr>
+          <p:cNvSpPr>
+            <a:spLocks xmlns:a="http://schemas.openxmlformats.org/drawingml/2006/main" noGrp="1"/>
+          </p:cNvSpPr>
+          <p:nvPr/>
+        </p:nvSpPr>
+        <p:spPr>
+          <a:xfrm xmlns:a="http://schemas.openxmlformats.org/drawingml/2006/main">
+            <a:off x="2095500" y="2933700"/>
+            <a:ext cx="114300" cy="342900"/>
+          </a:xfrm>
+          <a:prstGeom xmlns:a="http://schemas.openxmlformats.org/drawingml/2006/main" prst="downArrow">
             <a:avLst/>
           </a:prstGeom>
           <a:solidFill xmlns:a="http://schemas.openxmlformats.org/drawingml/2006/main">
@@ -14506,24 +14811,24 @@
       </p:sp>
       <p:sp>
         <p:nvSpPr>
-          <p:cNvPr id="52" name="guard-565">
-            <a:extLst xmlns:a="http://schemas.openxmlformats.org/drawingml/2006/main">
-              <a:ext uri="{FF2B5EF4-FFF2-40B4-BE49-F238E27FC236}">
-                <a16:creationId xmlns:a16="http://schemas.microsoft.com/office/drawing/2014/main" id="{CF583F7B-6C4F-4C8E-A510-51E0023DB06F}"/>
-              </a:ext>
-            </a:extLst>
-          </p:cNvPr>
-          <p:cNvSpPr>
-            <a:spLocks xmlns:a="http://schemas.openxmlformats.org/drawingml/2006/main" noGrp="1"/>
-          </p:cNvSpPr>
-          <p:nvPr/>
-        </p:nvSpPr>
-        <p:spPr>
-          <a:xfrm xmlns:a="http://schemas.openxmlformats.org/drawingml/2006/main">
-            <a:off x="5381625" y="2800350"/>
-            <a:ext cx="514350" cy="114300"/>
-          </a:xfrm>
-          <a:prstGeom xmlns:a="http://schemas.openxmlformats.org/drawingml/2006/main" prst="rightArrow">
+          <p:cNvPr id="24" name="scan-in-604">
+            <a:extLst xmlns:a="http://schemas.openxmlformats.org/drawingml/2006/main">
+              <a:ext uri="{FF2B5EF4-FFF2-40B4-BE49-F238E27FC236}">
+                <a16:creationId xmlns:a16="http://schemas.microsoft.com/office/drawing/2014/main" id="{C8B56312-BDEA-48BC-81FF-15FCBDE07222}"/>
+              </a:ext>
+            </a:extLst>
+          </p:cNvPr>
+          <p:cNvSpPr>
+            <a:spLocks xmlns:a="http://schemas.openxmlformats.org/drawingml/2006/main" noGrp="1"/>
+          </p:cNvSpPr>
+          <p:nvPr/>
+        </p:nvSpPr>
+        <p:spPr>
+          <a:xfrm xmlns:a="http://schemas.openxmlformats.org/drawingml/2006/main">
+            <a:off x="5753100" y="2933700"/>
+            <a:ext cx="114300" cy="342900"/>
+          </a:xfrm>
+          <a:prstGeom xmlns:a="http://schemas.openxmlformats.org/drawingml/2006/main" prst="downArrow">
             <a:avLst/>
           </a:prstGeom>
           <a:solidFill xmlns:a="http://schemas.openxmlformats.org/drawingml/2006/main">
@@ -14537,24 +14842,24 @@
       </p:sp>
       <p:sp>
         <p:nvSpPr>
-          <p:cNvPr id="53" name="guard-858">
-            <a:extLst xmlns:a="http://schemas.openxmlformats.org/drawingml/2006/main">
-              <a:ext uri="{FF2B5EF4-FFF2-40B4-BE49-F238E27FC236}">
-                <a16:creationId xmlns:a16="http://schemas.microsoft.com/office/drawing/2014/main" id="{E3470387-7060-49C7-88EC-3C9F3110E647}"/>
-              </a:ext>
-            </a:extLst>
-          </p:cNvPr>
-          <p:cNvSpPr>
-            <a:spLocks xmlns:a="http://schemas.openxmlformats.org/drawingml/2006/main" noGrp="1"/>
-          </p:cNvSpPr>
-          <p:nvPr/>
-        </p:nvSpPr>
-        <p:spPr>
-          <a:xfrm xmlns:a="http://schemas.openxmlformats.org/drawingml/2006/main">
-            <a:off x="8172450" y="2800350"/>
-            <a:ext cx="514350" cy="114300"/>
-          </a:xfrm>
-          <a:prstGeom xmlns:a="http://schemas.openxmlformats.org/drawingml/2006/main" prst="rightArrow">
+          <p:cNvPr id="25" name="scan-in-1011">
+            <a:extLst xmlns:a="http://schemas.openxmlformats.org/drawingml/2006/main">
+              <a:ext uri="{FF2B5EF4-FFF2-40B4-BE49-F238E27FC236}">
+                <a16:creationId xmlns:a16="http://schemas.microsoft.com/office/drawing/2014/main" id="{8DF498A5-D0A1-4CFA-9415-AA96923EE9D2}"/>
+              </a:ext>
+            </a:extLst>
+          </p:cNvPr>
+          <p:cNvSpPr>
+            <a:spLocks xmlns:a="http://schemas.openxmlformats.org/drawingml/2006/main" noGrp="1"/>
+          </p:cNvSpPr>
+          <p:nvPr/>
+        </p:nvSpPr>
+        <p:spPr>
+          <a:xfrm xmlns:a="http://schemas.openxmlformats.org/drawingml/2006/main">
+            <a:off x="9629775" y="2933700"/>
+            <a:ext cx="114300" cy="342900"/>
+          </a:xfrm>
+          <a:prstGeom xmlns:a="http://schemas.openxmlformats.org/drawingml/2006/main" prst="downArrow">
             <a:avLst/>
           </a:prstGeom>
           <a:solidFill xmlns:a="http://schemas.openxmlformats.org/drawingml/2006/main">
@@ -14568,22 +14873,423 @@
       </p:sp>
       <p:sp>
         <p:nvSpPr>
-          <p:cNvPr id="54" name="source-guard">
-            <a:extLst xmlns:a="http://schemas.openxmlformats.org/drawingml/2006/main">
-              <a:ext uri="{FF2B5EF4-FFF2-40B4-BE49-F238E27FC236}">
-                <a16:creationId xmlns:a16="http://schemas.microsoft.com/office/drawing/2014/main" id="{5D4EEF9F-97C2-4672-A52C-23A9B83956B4}"/>
-              </a:ext>
-            </a:extLst>
-          </p:cNvPr>
-          <p:cNvSpPr>
-            <a:spLocks xmlns:a="http://schemas.openxmlformats.org/drawingml/2006/main" noGrp="1"/>
-          </p:cNvSpPr>
-          <p:nvPr/>
-        </p:nvSpPr>
-        <p:spPr>
-          <a:xfrm xmlns:a="http://schemas.openxmlformats.org/drawingml/2006/main">
-            <a:off x="742950" y="2362200"/>
-            <a:ext cx="1847850" cy="1000125"/>
+          <p:cNvPr id="26" name="scan-out-226">
+            <a:extLst xmlns:a="http://schemas.openxmlformats.org/drawingml/2006/main">
+              <a:ext uri="{FF2B5EF4-FFF2-40B4-BE49-F238E27FC236}">
+                <a16:creationId xmlns:a16="http://schemas.microsoft.com/office/drawing/2014/main" id="{1C2B8A32-A03E-4052-8DF4-C132ED47CFDE}"/>
+              </a:ext>
+            </a:extLst>
+          </p:cNvPr>
+          <p:cNvSpPr>
+            <a:spLocks xmlns:a="http://schemas.openxmlformats.org/drawingml/2006/main" noGrp="1"/>
+          </p:cNvSpPr>
+          <p:nvPr/>
+        </p:nvSpPr>
+        <p:spPr>
+          <a:xfrm xmlns:a="http://schemas.openxmlformats.org/drawingml/2006/main">
+            <a:off x="2152650" y="4038600"/>
+            <a:ext cx="0" cy="323850"/>
+          </a:xfrm>
+          <a:prstGeom xmlns:a="http://schemas.openxmlformats.org/drawingml/2006/main" prst="line">
+            <a:avLst/>
+          </a:prstGeom>
+          <a:noFill xmlns:a="http://schemas.openxmlformats.org/drawingml/2006/main"/>
+          <a:ln xmlns:a="http://schemas.openxmlformats.org/drawingml/2006/main" w="16193">
+            <a:solidFill>
+              <a:srgbClr val="6AE8CD"/>
+            </a:solidFill>
+            <a:prstDash val="solid"/>
+          </a:ln>
+        </p:spPr>
+      </p:sp>
+      <p:sp>
+        <p:nvSpPr>
+          <p:cNvPr id="27" name="scan-out-610">
+            <a:extLst xmlns:a="http://schemas.openxmlformats.org/drawingml/2006/main">
+              <a:ext uri="{FF2B5EF4-FFF2-40B4-BE49-F238E27FC236}">
+                <a16:creationId xmlns:a16="http://schemas.microsoft.com/office/drawing/2014/main" id="{A466B230-BD9A-45B7-B20E-F1BC473EE022}"/>
+              </a:ext>
+            </a:extLst>
+          </p:cNvPr>
+          <p:cNvSpPr>
+            <a:spLocks xmlns:a="http://schemas.openxmlformats.org/drawingml/2006/main" noGrp="1"/>
+          </p:cNvSpPr>
+          <p:nvPr/>
+        </p:nvSpPr>
+        <p:spPr>
+          <a:xfrm xmlns:a="http://schemas.openxmlformats.org/drawingml/2006/main">
+            <a:off x="5810250" y="4038600"/>
+            <a:ext cx="0" cy="323850"/>
+          </a:xfrm>
+          <a:prstGeom xmlns:a="http://schemas.openxmlformats.org/drawingml/2006/main" prst="line">
+            <a:avLst/>
+          </a:prstGeom>
+          <a:noFill xmlns:a="http://schemas.openxmlformats.org/drawingml/2006/main"/>
+          <a:ln xmlns:a="http://schemas.openxmlformats.org/drawingml/2006/main" w="16193">
+            <a:solidFill>
+              <a:srgbClr val="6AE8CD"/>
+            </a:solidFill>
+            <a:prstDash val="solid"/>
+          </a:ln>
+        </p:spPr>
+      </p:sp>
+      <p:sp>
+        <p:nvSpPr>
+          <p:cNvPr id="28" name="scan-out-1017">
+            <a:extLst xmlns:a="http://schemas.openxmlformats.org/drawingml/2006/main">
+              <a:ext uri="{FF2B5EF4-FFF2-40B4-BE49-F238E27FC236}">
+                <a16:creationId xmlns:a16="http://schemas.microsoft.com/office/drawing/2014/main" id="{3F2D4140-FF74-4B38-8835-B76D1083F932}"/>
+              </a:ext>
+            </a:extLst>
+          </p:cNvPr>
+          <p:cNvSpPr>
+            <a:spLocks xmlns:a="http://schemas.openxmlformats.org/drawingml/2006/main" noGrp="1"/>
+          </p:cNvSpPr>
+          <p:nvPr/>
+        </p:nvSpPr>
+        <p:spPr>
+          <a:xfrm xmlns:a="http://schemas.openxmlformats.org/drawingml/2006/main">
+            <a:off x="9686925" y="4038600"/>
+            <a:ext cx="0" cy="323850"/>
+          </a:xfrm>
+          <a:prstGeom xmlns:a="http://schemas.openxmlformats.org/drawingml/2006/main" prst="line">
+            <a:avLst/>
+          </a:prstGeom>
+          <a:noFill xmlns:a="http://schemas.openxmlformats.org/drawingml/2006/main"/>
+          <a:ln xmlns:a="http://schemas.openxmlformats.org/drawingml/2006/main" w="16193">
+            <a:solidFill>
+              <a:srgbClr val="6AE8CD"/>
+            </a:solidFill>
+            <a:prstDash val="solid"/>
+          </a:ln>
+        </p:spPr>
+      </p:sp>
+      <p:sp>
+        <p:nvSpPr>
+          <p:cNvPr id="29" name="merge-bar">
+            <a:extLst xmlns:a="http://schemas.openxmlformats.org/drawingml/2006/main">
+              <a:ext uri="{FF2B5EF4-FFF2-40B4-BE49-F238E27FC236}">
+                <a16:creationId xmlns:a16="http://schemas.microsoft.com/office/drawing/2014/main" id="{E75D6801-05E6-4FB0-B336-5F3FDFBECF2D}"/>
+              </a:ext>
+            </a:extLst>
+          </p:cNvPr>
+          <p:cNvSpPr>
+            <a:spLocks xmlns:a="http://schemas.openxmlformats.org/drawingml/2006/main" noGrp="1"/>
+          </p:cNvSpPr>
+          <p:nvPr/>
+        </p:nvSpPr>
+        <p:spPr>
+          <a:xfrm xmlns:a="http://schemas.openxmlformats.org/drawingml/2006/main">
+            <a:off x="2152650" y="4362450"/>
+            <a:ext cx="7534275" cy="0"/>
+          </a:xfrm>
+          <a:prstGeom xmlns:a="http://schemas.openxmlformats.org/drawingml/2006/main" prst="line">
+            <a:avLst/>
+          </a:prstGeom>
+          <a:noFill xmlns:a="http://schemas.openxmlformats.org/drawingml/2006/main"/>
+          <a:ln xmlns:a="http://schemas.openxmlformats.org/drawingml/2006/main" w="16193">
+            <a:solidFill>
+              <a:srgbClr val="6AE8CD"/>
+            </a:solidFill>
+            <a:prstDash val="solid"/>
+          </a:ln>
+        </p:spPr>
+      </p:sp>
+      <p:sp>
+        <p:nvSpPr>
+          <p:cNvPr id="30" name="merge-to-dedup">
+            <a:extLst xmlns:a="http://schemas.openxmlformats.org/drawingml/2006/main">
+              <a:ext uri="{FF2B5EF4-FFF2-40B4-BE49-F238E27FC236}">
+                <a16:creationId xmlns:a16="http://schemas.microsoft.com/office/drawing/2014/main" id="{AEC4C37A-8F75-49FD-82C7-E6594582DA25}"/>
+              </a:ext>
+            </a:extLst>
+          </p:cNvPr>
+          <p:cNvSpPr>
+            <a:spLocks xmlns:a="http://schemas.openxmlformats.org/drawingml/2006/main" noGrp="1"/>
+          </p:cNvSpPr>
+          <p:nvPr/>
+        </p:nvSpPr>
+        <p:spPr>
+          <a:xfrm xmlns:a="http://schemas.openxmlformats.org/drawingml/2006/main">
+            <a:off x="5753100" y="4362450"/>
+            <a:ext cx="114300" cy="352425"/>
+          </a:xfrm>
+          <a:prstGeom xmlns:a="http://schemas.openxmlformats.org/drawingml/2006/main" prst="downArrow">
+            <a:avLst/>
+          </a:prstGeom>
+          <a:solidFill xmlns:a="http://schemas.openxmlformats.org/drawingml/2006/main">
+            <a:srgbClr val="6AE8CD"/>
+          </a:solidFill>
+          <a:ln xmlns:a="http://schemas.openxmlformats.org/drawingml/2006/main" w="0">
+            <a:noFill/>
+            <a:prstDash val="solid"/>
+          </a:ln>
+        </p:spPr>
+      </p:sp>
+      <p:sp>
+        <p:nvSpPr>
+          <p:cNvPr id="31" name="dedup-to-route">
+            <a:extLst xmlns:a="http://schemas.openxmlformats.org/drawingml/2006/main">
+              <a:ext uri="{FF2B5EF4-FFF2-40B4-BE49-F238E27FC236}">
+                <a16:creationId xmlns:a16="http://schemas.microsoft.com/office/drawing/2014/main" id="{81D2801F-B609-471A-9C3E-93AC27476D03}"/>
+              </a:ext>
+            </a:extLst>
+          </p:cNvPr>
+          <p:cNvSpPr>
+            <a:spLocks xmlns:a="http://schemas.openxmlformats.org/drawingml/2006/main" noGrp="1"/>
+          </p:cNvSpPr>
+          <p:nvPr/>
+        </p:nvSpPr>
+        <p:spPr>
+          <a:xfrm xmlns:a="http://schemas.openxmlformats.org/drawingml/2006/main">
+            <a:off x="8667750" y="4953000"/>
+            <a:ext cx="714375" cy="114300"/>
+          </a:xfrm>
+          <a:prstGeom xmlns:a="http://schemas.openxmlformats.org/drawingml/2006/main" prst="rightArrow">
+            <a:avLst/>
+          </a:prstGeom>
+          <a:solidFill xmlns:a="http://schemas.openxmlformats.org/drawingml/2006/main">
+            <a:srgbClr val="6AE8CD"/>
+          </a:solidFill>
+          <a:ln xmlns:a="http://schemas.openxmlformats.org/drawingml/2006/main" w="0">
+            <a:noFill/>
+            <a:prstDash val="solid"/>
+          </a:ln>
+        </p:spPr>
+      </p:sp>
+      <p:sp>
+        <p:nvSpPr>
+          <p:cNvPr id="32" name="bytes">
+            <a:extLst xmlns:a="http://schemas.openxmlformats.org/drawingml/2006/main">
+              <a:ext uri="{FF2B5EF4-FFF2-40B4-BE49-F238E27FC236}">
+                <a16:creationId xmlns:a16="http://schemas.microsoft.com/office/drawing/2014/main" id="{8B03B193-2FFA-441A-9D9E-C5B4098C3A8C}"/>
+              </a:ext>
+            </a:extLst>
+          </p:cNvPr>
+          <p:cNvSpPr>
+            <a:spLocks xmlns:a="http://schemas.openxmlformats.org/drawingml/2006/main" noGrp="1"/>
+          </p:cNvSpPr>
+          <p:nvPr/>
+        </p:nvSpPr>
+        <p:spPr>
+          <a:xfrm xmlns:a="http://schemas.openxmlformats.org/drawingml/2006/main">
+            <a:off x="742950" y="2009775"/>
+            <a:ext cx="1781175" cy="676275"/>
+          </a:xfrm>
+          <a:prstGeom xmlns:a="http://schemas.openxmlformats.org/drawingml/2006/main" prst="rect">
+            <a:avLst/>
+          </a:prstGeom>
+          <a:solidFill xmlns:a="http://schemas.openxmlformats.org/drawingml/2006/main">
+            <a:srgbClr val="27262B"/>
+          </a:solidFill>
+          <a:ln xmlns:a="http://schemas.openxmlformats.org/drawingml/2006/main" w="13335">
+            <a:solidFill>
+              <a:srgbClr val="72C6F9"/>
+            </a:solidFill>
+            <a:prstDash val="solid"/>
+          </a:ln>
+        </p:spPr>
+        <p:txBody>
+          <a:bodyPr xmlns:a="http://schemas.openxmlformats.org/drawingml/2006/main" wrap="none" lIns="0" tIns="0" rIns="0" bIns="0" anchor="ctr">
+            <a:noAutofit/>
+          </a:bodyPr>
+          <a:lstStyle xmlns:a="http://schemas.openxmlformats.org/drawingml/2006/main"/>
+          <a:p xmlns:a="http://schemas.openxmlformats.org/drawingml/2006/main">
+            <a:pPr algn="ctr">
+              <a:buNone/>
+              <a:defRPr sz="1875">
+                <a:solidFill>
+                  <a:srgbClr val="F9F8FD"/>
+                </a:solidFill>
+                <a:latin typeface="Switzer"/>
+                <a:ea typeface="Switzer"/>
+                <a:cs typeface="Switzer"/>
+              </a:defRPr>
+            </a:pPr>
+            <a:r>
+              <a:rPr sz="1875">
+                <a:solidFill>
+                  <a:srgbClr val="F9F8FD"/>
+                </a:solidFill>
+                <a:latin typeface="Switzer"/>
+                <a:ea typeface="Switzer"/>
+                <a:cs typeface="Switzer"/>
+              </a:rPr>
+              <a:t>Protocol
+events</a:t>
+            </a:r>
+          </a:p>
+        </p:txBody>
+      </p:sp>
+      <p:sp>
+        <p:nvSpPr>
+          <p:cNvPr id="33" name="decoder">
+            <a:extLst xmlns:a="http://schemas.openxmlformats.org/drawingml/2006/main">
+              <a:ext uri="{FF2B5EF4-FFF2-40B4-BE49-F238E27FC236}">
+                <a16:creationId xmlns:a16="http://schemas.microsoft.com/office/drawing/2014/main" id="{8C820907-2ED5-4C49-89CF-5E70000C9E8E}"/>
+              </a:ext>
+            </a:extLst>
+          </p:cNvPr>
+          <p:cNvSpPr>
+            <a:spLocks xmlns:a="http://schemas.openxmlformats.org/drawingml/2006/main" noGrp="1"/>
+          </p:cNvSpPr>
+          <p:nvPr/>
+        </p:nvSpPr>
+        <p:spPr>
+          <a:xfrm xmlns:a="http://schemas.openxmlformats.org/drawingml/2006/main">
+            <a:off x="3390900" y="1943100"/>
+            <a:ext cx="2571750" cy="742950"/>
+          </a:xfrm>
+          <a:prstGeom xmlns:a="http://schemas.openxmlformats.org/drawingml/2006/main" prst="rect">
+            <a:avLst/>
+          </a:prstGeom>
+          <a:solidFill xmlns:a="http://schemas.openxmlformats.org/drawingml/2006/main">
+            <a:srgbClr val="27262B"/>
+          </a:solidFill>
+          <a:ln xmlns:a="http://schemas.openxmlformats.org/drawingml/2006/main" w="13335">
+            <a:solidFill>
+              <a:srgbClr val="72C6F9"/>
+            </a:solidFill>
+            <a:prstDash val="solid"/>
+          </a:ln>
+        </p:spPr>
+        <p:txBody>
+          <a:bodyPr xmlns:a="http://schemas.openxmlformats.org/drawingml/2006/main" wrap="none" lIns="0" tIns="0" rIns="0" bIns="0" anchor="ctr">
+            <a:noAutofit/>
+          </a:bodyPr>
+          <a:lstStyle xmlns:a="http://schemas.openxmlformats.org/drawingml/2006/main"/>
+          <a:p xmlns:a="http://schemas.openxmlformats.org/drawingml/2006/main">
+            <a:pPr algn="ctr">
+              <a:buNone/>
+              <a:defRPr sz="1725">
+                <a:solidFill>
+                  <a:srgbClr val="F9F8FD"/>
+                </a:solidFill>
+                <a:latin typeface="Switzer"/>
+                <a:ea typeface="Switzer"/>
+                <a:cs typeface="Switzer"/>
+              </a:defRPr>
+            </a:pPr>
+            <a:r>
+              <a:rPr sz="1725">
+                <a:solidFill>
+                  <a:srgbClr val="F9F8FD"/>
+                </a:solidFill>
+                <a:latin typeface="Switzer"/>
+                <a:ea typeface="Switzer"/>
+                <a:cs typeface="Switzer"/>
+              </a:rPr>
+              <a:t>Private recorder</a:t>
+            </a:r>
+          </a:p>
+          <a:p xmlns:a="http://schemas.openxmlformats.org/drawingml/2006/main">
+            <a:pPr algn="ctr">
+              <a:buNone/>
+              <a:defRPr sz="1725">
+                <a:solidFill>
+                  <a:srgbClr val="F9F8FD"/>
+                </a:solidFill>
+                <a:latin typeface="Switzer"/>
+                <a:ea typeface="Switzer"/>
+                <a:cs typeface="Switzer"/>
+              </a:defRPr>
+            </a:pPr>
+            <a:r>
+              <a:rPr sz="1725">
+                <a:solidFill>
+                  <a:srgbClr val="F9F8FD"/>
+                </a:solidFill>
+                <a:latin typeface="Switzer"/>
+                <a:ea typeface="Switzer"/>
+                <a:cs typeface="Switzer"/>
+              </a:rPr>
+              <a:t>redact + seal</a:t>
+            </a:r>
+          </a:p>
+        </p:txBody>
+      </p:sp>
+      <p:sp>
+        <p:nvSpPr>
+          <p:cNvPr id="34" name="vterm">
+            <a:extLst xmlns:a="http://schemas.openxmlformats.org/drawingml/2006/main">
+              <a:ext uri="{FF2B5EF4-FFF2-40B4-BE49-F238E27FC236}">
+                <a16:creationId xmlns:a16="http://schemas.microsoft.com/office/drawing/2014/main" id="{21D3FBBC-8B03-4A4E-A3F6-EFD4E1702578}"/>
+              </a:ext>
+            </a:extLst>
+          </p:cNvPr>
+          <p:cNvSpPr>
+            <a:spLocks xmlns:a="http://schemas.openxmlformats.org/drawingml/2006/main" noGrp="1"/>
+          </p:cNvSpPr>
+          <p:nvPr/>
+        </p:nvSpPr>
+        <p:spPr>
+          <a:xfrm xmlns:a="http://schemas.openxmlformats.org/drawingml/2006/main">
+            <a:off x="6781800" y="1943100"/>
+            <a:ext cx="4600575" cy="742950"/>
+          </a:xfrm>
+          <a:prstGeom xmlns:a="http://schemas.openxmlformats.org/drawingml/2006/main" prst="rect">
+            <a:avLst/>
+          </a:prstGeom>
+          <a:solidFill xmlns:a="http://schemas.openxmlformats.org/drawingml/2006/main">
+            <a:srgbClr val="27262B"/>
+          </a:solidFill>
+          <a:ln xmlns:a="http://schemas.openxmlformats.org/drawingml/2006/main" w="13335">
+            <a:solidFill>
+              <a:srgbClr val="72C6F9"/>
+            </a:solidFill>
+            <a:prstDash val="solid"/>
+          </a:ln>
+        </p:spPr>
+        <p:txBody>
+          <a:bodyPr xmlns:a="http://schemas.openxmlformats.org/drawingml/2006/main" wrap="none" lIns="0" tIns="0" rIns="0" bIns="0" anchor="ctr">
+            <a:noAutofit/>
+          </a:bodyPr>
+          <a:lstStyle xmlns:a="http://schemas.openxmlformats.org/drawingml/2006/main"/>
+          <a:p xmlns:a="http://schemas.openxmlformats.org/drawingml/2006/main">
+            <a:pPr algn="ctr">
+              <a:buNone/>
+              <a:defRPr sz="1875">
+                <a:solidFill>
+                  <a:srgbClr val="F9F8FD"/>
+                </a:solidFill>
+                <a:latin typeface="Switzer"/>
+                <a:ea typeface="Switzer"/>
+                <a:cs typeface="Switzer"/>
+              </a:defRPr>
+            </a:pPr>
+            <a:r>
+              <a:rPr sz="1875">
+                <a:solidFill>
+                  <a:srgbClr val="F9F8FD"/>
+                </a:solidFill>
+                <a:latin typeface="Switzer"/>
+                <a:ea typeface="Switzer"/>
+                <a:cs typeface="Switzer"/>
+              </a:rPr>
+              <a:t>Strict reader + prepare
+context · hashes · split groups</a:t>
+            </a:r>
+          </a:p>
+        </p:txBody>
+      </p:sp>
+      <p:sp>
+        <p:nvSpPr>
+          <p:cNvPr id="35" name="finalized">
+            <a:extLst xmlns:a="http://schemas.openxmlformats.org/drawingml/2006/main">
+              <a:ext uri="{FF2B5EF4-FFF2-40B4-BE49-F238E27FC236}">
+                <a16:creationId xmlns:a16="http://schemas.microsoft.com/office/drawing/2014/main" id="{7DE4008B-E2A7-431E-8EA0-FECDBBD01AB5}"/>
+              </a:ext>
+            </a:extLst>
+          </p:cNvPr>
+          <p:cNvSpPr>
+            <a:spLocks xmlns:a="http://schemas.openxmlformats.org/drawingml/2006/main" noGrp="1"/>
+          </p:cNvSpPr>
+          <p:nvPr/>
+        </p:nvSpPr>
+        <p:spPr>
+          <a:xfrm xmlns:a="http://schemas.openxmlformats.org/drawingml/2006/main">
+            <a:off x="742950" y="3276600"/>
+            <a:ext cx="2819400" cy="762000"/>
           </a:xfrm>
           <a:prstGeom xmlns:a="http://schemas.openxmlformats.org/drawingml/2006/main" prst="rect">
             <a:avLst/>
@@ -14624,7 +15330,7 @@
                 <a:ea typeface="Switzer"/>
                 <a:cs typeface="Switzer"/>
               </a:rPr>
-              <a:t>Real agent</a:t>
+              <a:t>Human: quality</a:t>
             </a:r>
           </a:p>
           <a:p xmlns:a="http://schemas.openxmlformats.org/drawingml/2006/main">
@@ -14648,29 +15354,29 @@
                 <a:ea typeface="Switzer"/>
                 <a:cs typeface="Switzer"/>
               </a:rPr>
-              <a:t>messages</a:t>
-            </a:r>
-          </a:p>
-        </p:txBody>
-      </p:sp>
-      <p:sp>
-        <p:nvSpPr>
-          <p:cNvPr id="55" name="queue-guard">
-            <a:extLst xmlns:a="http://schemas.openxmlformats.org/drawingml/2006/main">
-              <a:ext uri="{FF2B5EF4-FFF2-40B4-BE49-F238E27FC236}">
-                <a16:creationId xmlns:a16="http://schemas.microsoft.com/office/drawing/2014/main" id="{C16706AD-4485-4B32-8EB3-FAD08C586C33}"/>
-              </a:ext>
-            </a:extLst>
-          </p:cNvPr>
-          <p:cNvSpPr>
-            <a:spLocks xmlns:a="http://schemas.openxmlformats.org/drawingml/2006/main" noGrp="1"/>
-          </p:cNvSpPr>
-          <p:nvPr/>
-        </p:nvSpPr>
-        <p:spPr>
-          <a:xfrm xmlns:a="http://schemas.openxmlformats.org/drawingml/2006/main">
-            <a:off x="3095625" y="2362200"/>
-            <a:ext cx="2286000" cy="1000125"/>
+              <a:t>correct + useful</a:t>
+            </a:r>
+          </a:p>
+        </p:txBody>
+      </p:sp>
+      <p:sp>
+        <p:nvSpPr>
+          <p:cNvPr id="36" name="grid">
+            <a:extLst xmlns:a="http://schemas.openxmlformats.org/drawingml/2006/main">
+              <a:ext uri="{FF2B5EF4-FFF2-40B4-BE49-F238E27FC236}">
+                <a16:creationId xmlns:a16="http://schemas.microsoft.com/office/drawing/2014/main" id="{33A82EA1-4D46-4389-8867-FC18F6C4D1CD}"/>
+              </a:ext>
+            </a:extLst>
+          </p:cNvPr>
+          <p:cNvSpPr>
+            <a:spLocks xmlns:a="http://schemas.openxmlformats.org/drawingml/2006/main" noGrp="1"/>
+          </p:cNvSpPr>
+          <p:nvPr/>
+        </p:nvSpPr>
+        <p:spPr>
+          <a:xfrm xmlns:a="http://schemas.openxmlformats.org/drawingml/2006/main">
+            <a:off x="4238625" y="3276600"/>
+            <a:ext cx="3143250" cy="762000"/>
           </a:xfrm>
           <a:prstGeom xmlns:a="http://schemas.openxmlformats.org/drawingml/2006/main" prst="rect">
             <a:avLst/>
@@ -14711,7 +15417,7 @@
                 <a:ea typeface="Switzer"/>
                 <a:cs typeface="Switzer"/>
               </a:rPr>
-              <a:t>Reviewed</a:t>
+              <a:t>Human: context</a:t>
             </a:r>
           </a:p>
           <a:p xmlns:a="http://schemas.openxmlformats.org/drawingml/2006/main">
@@ -14735,29 +15441,29 @@
                 <a:ea typeface="Switzer"/>
                 <a:cs typeface="Switzer"/>
               </a:rPr>
-              <a:t>training data</a:t>
-            </a:r>
-          </a:p>
-        </p:txBody>
-      </p:sp>
-      <p:sp>
-        <p:nvSpPr>
-          <p:cNvPr id="56" name="target-guard">
-            <a:extLst xmlns:a="http://schemas.openxmlformats.org/drawingml/2006/main">
-              <a:ext uri="{FF2B5EF4-FFF2-40B4-BE49-F238E27FC236}">
-                <a16:creationId xmlns:a16="http://schemas.microsoft.com/office/drawing/2014/main" id="{F080771C-DFFF-4AFB-BD58-0BB682726209}"/>
-              </a:ext>
-            </a:extLst>
-          </p:cNvPr>
-          <p:cNvSpPr>
-            <a:spLocks xmlns:a="http://schemas.openxmlformats.org/drawingml/2006/main" noGrp="1"/>
-          </p:cNvSpPr>
-          <p:nvPr/>
-        </p:nvSpPr>
-        <p:spPr>
-          <a:xfrm xmlns:a="http://schemas.openxmlformats.org/drawingml/2006/main">
-            <a:off x="5895975" y="2362200"/>
-            <a:ext cx="2276475" cy="1000125"/>
+              <a:t>sufficient inputs</a:t>
+            </a:r>
+          </a:p>
+        </p:txBody>
+      </p:sp>
+      <p:sp>
+        <p:nvSpPr>
+          <p:cNvPr id="37" name="tail">
+            <a:extLst xmlns:a="http://schemas.openxmlformats.org/drawingml/2006/main">
+              <a:ext uri="{FF2B5EF4-FFF2-40B4-BE49-F238E27FC236}">
+                <a16:creationId xmlns:a16="http://schemas.microsoft.com/office/drawing/2014/main" id="{D28466B7-3CCF-4826-8ACC-B2FC8C4B9A58}"/>
+              </a:ext>
+            </a:extLst>
+          </p:cNvPr>
+          <p:cNvSpPr>
+            <a:spLocks xmlns:a="http://schemas.openxmlformats.org/drawingml/2006/main" noGrp="1"/>
+          </p:cNvSpPr>
+          <p:nvPr/>
+        </p:nvSpPr>
+        <p:spPr>
+          <a:xfrm xmlns:a="http://schemas.openxmlformats.org/drawingml/2006/main">
+            <a:off x="7981950" y="3276600"/>
+            <a:ext cx="3400425" cy="762000"/>
           </a:xfrm>
           <a:prstGeom xmlns:a="http://schemas.openxmlformats.org/drawingml/2006/main" prst="rect">
             <a:avLst/>
@@ -14798,7 +15504,7 @@
                 <a:ea typeface="Switzer"/>
                 <a:cs typeface="Switzer"/>
               </a:rPr>
-              <a:t>Per-model</a:t>
+              <a:t>Human: privacy + rights</a:t>
             </a:r>
           </a:p>
           <a:p xmlns:a="http://schemas.openxmlformats.org/drawingml/2006/main">
@@ -14822,29 +15528,29 @@
                 <a:ea typeface="Switzer"/>
                 <a:cs typeface="Switzer"/>
               </a:rPr>
-              <a:t>LoRA adapter</a:t>
-            </a:r>
-          </a:p>
-        </p:txBody>
-      </p:sp>
-      <p:sp>
-        <p:nvSpPr>
-          <p:cNvPr id="57" name="submit-guard">
-            <a:extLst xmlns:a="http://schemas.openxmlformats.org/drawingml/2006/main">
-              <a:ext uri="{FF2B5EF4-FFF2-40B4-BE49-F238E27FC236}">
-                <a16:creationId xmlns:a16="http://schemas.microsoft.com/office/drawing/2014/main" id="{8F101783-9F0B-4881-8E4B-AEB692F74B10}"/>
-              </a:ext>
-            </a:extLst>
-          </p:cNvPr>
-          <p:cNvSpPr>
-            <a:spLocks xmlns:a="http://schemas.openxmlformats.org/drawingml/2006/main" noGrp="1"/>
-          </p:cNvSpPr>
-          <p:nvPr/>
-        </p:nvSpPr>
-        <p:spPr>
-          <a:xfrm xmlns:a="http://schemas.openxmlformats.org/drawingml/2006/main">
-            <a:off x="8686800" y="2362200"/>
-            <a:ext cx="2714625" cy="1000125"/>
+              <a:t>permission to train</a:t>
+            </a:r>
+          </a:p>
+        </p:txBody>
+      </p:sp>
+      <p:sp>
+        <p:nvSpPr>
+          <p:cNvPr id="38" name="dedup">
+            <a:extLst xmlns:a="http://schemas.openxmlformats.org/drawingml/2006/main">
+              <a:ext uri="{FF2B5EF4-FFF2-40B4-BE49-F238E27FC236}">
+                <a16:creationId xmlns:a16="http://schemas.microsoft.com/office/drawing/2014/main" id="{139D5BA6-9624-4F65-B48F-A5FC2541EFF9}"/>
+              </a:ext>
+            </a:extLst>
+          </p:cNvPr>
+          <p:cNvSpPr>
+            <a:spLocks xmlns:a="http://schemas.openxmlformats.org/drawingml/2006/main" noGrp="1"/>
+          </p:cNvSpPr>
+          <p:nvPr/>
+        </p:nvSpPr>
+        <p:spPr>
+          <a:xfrm xmlns:a="http://schemas.openxmlformats.org/drawingml/2006/main">
+            <a:off x="2943225" y="4714875"/>
+            <a:ext cx="5724525" cy="619125"/>
           </a:xfrm>
           <a:prstGeom xmlns:a="http://schemas.openxmlformats.org/drawingml/2006/main" prst="rect">
             <a:avLst/>
@@ -14867,6 +15573,69 @@
           <a:p xmlns:a="http://schemas.openxmlformats.org/drawingml/2006/main">
             <a:pPr algn="ctr">
               <a:buNone/>
+              <a:defRPr sz="1950">
+                <a:solidFill>
+                  <a:srgbClr val="F9F8FD"/>
+                </a:solidFill>
+                <a:latin typeface="Switzer"/>
+                <a:ea typeface="Switzer"/>
+                <a:cs typeface="Switzer"/>
+              </a:defRPr>
+            </a:pPr>
+            <a:r>
+              <a:rPr sz="1950">
+                <a:solidFill>
+                  <a:srgbClr val="F9F8FD"/>
+                </a:solidFill>
+                <a:latin typeface="Switzer"/>
+                <a:ea typeface="Switzer"/>
+                <a:cs typeface="Switzer"/>
+              </a:rPr>
+              <a:t>Hash-bound human approval</a:t>
+            </a:r>
+          </a:p>
+        </p:txBody>
+      </p:sp>
+      <p:sp>
+        <p:nvSpPr>
+          <p:cNvPr id="39" name="route">
+            <a:extLst xmlns:a="http://schemas.openxmlformats.org/drawingml/2006/main">
+              <a:ext uri="{FF2B5EF4-FFF2-40B4-BE49-F238E27FC236}">
+                <a16:creationId xmlns:a16="http://schemas.microsoft.com/office/drawing/2014/main" id="{64B8F276-F802-4FCE-BDA7-694DA67F167E}"/>
+              </a:ext>
+            </a:extLst>
+          </p:cNvPr>
+          <p:cNvSpPr>
+            <a:spLocks xmlns:a="http://schemas.openxmlformats.org/drawingml/2006/main" noGrp="1"/>
+          </p:cNvSpPr>
+          <p:nvPr/>
+        </p:nvSpPr>
+        <p:spPr>
+          <a:xfrm xmlns:a="http://schemas.openxmlformats.org/drawingml/2006/main">
+            <a:off x="9382125" y="4695825"/>
+            <a:ext cx="2000250" cy="666750"/>
+          </a:xfrm>
+          <a:prstGeom xmlns:a="http://schemas.openxmlformats.org/drawingml/2006/main" prst="rect">
+            <a:avLst/>
+          </a:prstGeom>
+          <a:solidFill xmlns:a="http://schemas.openxmlformats.org/drawingml/2006/main">
+            <a:srgbClr val="27262B"/>
+          </a:solidFill>
+          <a:ln xmlns:a="http://schemas.openxmlformats.org/drawingml/2006/main" w="13335">
+            <a:solidFill>
+              <a:srgbClr val="6AE8CD"/>
+            </a:solidFill>
+            <a:prstDash val="solid"/>
+          </a:ln>
+        </p:spPr>
+        <p:txBody>
+          <a:bodyPr xmlns:a="http://schemas.openxmlformats.org/drawingml/2006/main" wrap="none" lIns="0" tIns="0" rIns="0" bIns="0" anchor="ctr">
+            <a:noAutofit/>
+          </a:bodyPr>
+          <a:lstStyle xmlns:a="http://schemas.openxmlformats.org/drawingml/2006/main"/>
+          <a:p xmlns:a="http://schemas.openxmlformats.org/drawingml/2006/main">
+            <a:pPr algn="ctr">
+              <a:buNone/>
               <a:defRPr sz="1725">
                 <a:solidFill>
                   <a:srgbClr val="F9F8FD"/>
@@ -14885,7 +15654,7 @@
                 <a:ea typeface="Switzer"/>
                 <a:cs typeface="Switzer"/>
               </a:rPr>
-              <a:t>Held-out</a:t>
+              <a:t>Export</a:t>
             </a:r>
           </a:p>
           <a:p xmlns:a="http://schemas.openxmlformats.org/drawingml/2006/main">
@@ -14909,29 +15678,29 @@
                 <a:ea typeface="Switzer"/>
                 <a:cs typeface="Switzer"/>
               </a:rPr>
-              <a:t>protocol evaluation</a:t>
-            </a:r>
-          </a:p>
-        </p:txBody>
-      </p:sp>
-      <p:sp>
-        <p:nvSpPr>
-          <p:cNvPr id="58" name="capacity-label">
-            <a:extLst xmlns:a="http://schemas.openxmlformats.org/drawingml/2006/main">
-              <a:ext uri="{FF2B5EF4-FFF2-40B4-BE49-F238E27FC236}">
-                <a16:creationId xmlns:a16="http://schemas.microsoft.com/office/drawing/2014/main" id="{8D8C2023-E138-4063-847E-6B9C9CEDB863}"/>
-              </a:ext>
-            </a:extLst>
-          </p:cNvPr>
-          <p:cNvSpPr>
-            <a:spLocks xmlns:a="http://schemas.openxmlformats.org/drawingml/2006/main" noGrp="1"/>
-          </p:cNvSpPr>
-          <p:nvPr/>
-        </p:nvSpPr>
-        <p:spPr>
-          <a:xfrm xmlns:a="http://schemas.openxmlformats.org/drawingml/2006/main">
-            <a:off x="742950" y="3771900"/>
-            <a:ext cx="10620375" cy="361950"/>
+              <a:t>+ validate</a:t>
+            </a:r>
+          </a:p>
+        </p:txBody>
+      </p:sp>
+      <p:sp>
+        <p:nvSpPr>
+          <p:cNvPr id="40" name="why-observe">
+            <a:extLst xmlns:a="http://schemas.openxmlformats.org/drawingml/2006/main">
+              <a:ext uri="{FF2B5EF4-FFF2-40B4-BE49-F238E27FC236}">
+                <a16:creationId xmlns:a16="http://schemas.microsoft.com/office/drawing/2014/main" id="{A64B266D-ED99-4A4B-9B97-B28D39D635CE}"/>
+              </a:ext>
+            </a:extLst>
+          </p:cNvPr>
+          <p:cNvSpPr>
+            <a:spLocks xmlns:a="http://schemas.openxmlformats.org/drawingml/2006/main" noGrp="1"/>
+          </p:cNvSpPr>
+          <p:nvPr/>
+        </p:nvSpPr>
+        <p:spPr>
+          <a:xfrm xmlns:a="http://schemas.openxmlformats.org/drawingml/2006/main">
+            <a:off x="742950" y="5610225"/>
+            <a:ext cx="10639425" cy="428625"/>
           </a:xfrm>
           <a:prstGeom xmlns:a="http://schemas.openxmlformats.org/drawingml/2006/main" prst="rect">
             <a:avLst/>
@@ -14950,47 +15719,47 @@
           <a:p xmlns:a="http://schemas.openxmlformats.org/drawingml/2006/main">
             <a:pPr algn="l">
               <a:buNone/>
-              <a:defRPr sz="1500">
-                <a:solidFill>
-                  <a:srgbClr val="BCBBC2"/>
-                </a:solidFill>
-                <a:latin typeface="Consolas"/>
-                <a:ea typeface="Consolas"/>
-                <a:cs typeface="Consolas"/>
-              </a:defRPr>
-            </a:pPr>
-            <a:r>
-              <a:rPr sz="1500">
-                <a:solidFill>
-                  <a:srgbClr val="BCBBC2"/>
-                </a:solidFill>
-                <a:latin typeface="Consolas"/>
-                <a:ea typeface="Consolas"/>
-                <a:cs typeface="Consolas"/>
-              </a:rPr>
-              <a:t>CAPTURE + EXPORT TODAY · ADAPTER TRAINING NEXT</a:t>
-            </a:r>
-          </a:p>
-        </p:txBody>
-      </p:sp>
-      <p:sp>
-        <p:nvSpPr>
-          <p:cNvPr id="59" name="panel-cap">
-            <a:extLst xmlns:a="http://schemas.openxmlformats.org/drawingml/2006/main">
-              <a:ext uri="{FF2B5EF4-FFF2-40B4-BE49-F238E27FC236}">
-                <a16:creationId xmlns:a16="http://schemas.microsoft.com/office/drawing/2014/main" id="{B3E36E69-0CC3-4DCB-90FD-7E13212D9B63}"/>
-              </a:ext>
-            </a:extLst>
-          </p:cNvPr>
-          <p:cNvSpPr>
-            <a:spLocks xmlns:a="http://schemas.openxmlformats.org/drawingml/2006/main" noGrp="1"/>
-          </p:cNvSpPr>
-          <p:nvPr/>
-        </p:nvSpPr>
-        <p:spPr>
-          <a:xfrm xmlns:a="http://schemas.openxmlformats.org/drawingml/2006/main">
-            <a:off x="742950" y="4276725"/>
-            <a:ext cx="4676775" cy="514350"/>
+              <a:defRPr sz="2250">
+                <a:solidFill>
+                  <a:srgbClr val="F9F8FD"/>
+                </a:solidFill>
+                <a:latin typeface="Alliance No.2"/>
+                <a:ea typeface="Alliance No.2"/>
+                <a:cs typeface="Alliance No.2"/>
+              </a:defRPr>
+            </a:pPr>
+            <a:r>
+              <a:rPr sz="2250">
+                <a:solidFill>
+                  <a:srgbClr val="F9F8FD"/>
+                </a:solidFill>
+                <a:latin typeface="Alliance No.2"/>
+                <a:ea typeface="Alliance No.2"/>
+                <a:cs typeface="Alliance No.2"/>
+              </a:rPr>
+              <a:t>train.jsonl · validation.jsonl · test.jsonl</a:t>
+            </a:r>
+          </a:p>
+        </p:txBody>
+      </p:sp>
+      <p:sp>
+        <p:nvSpPr>
+          <p:cNvPr id="41" name="dedup-caveat">
+            <a:extLst xmlns:a="http://schemas.openxmlformats.org/drawingml/2006/main">
+              <a:ext uri="{FF2B5EF4-FFF2-40B4-BE49-F238E27FC236}">
+                <a16:creationId xmlns:a16="http://schemas.microsoft.com/office/drawing/2014/main" id="{D60C6BB7-19BE-4BFD-9356-851F0205F06B}"/>
+              </a:ext>
+            </a:extLst>
+          </p:cNvPr>
+          <p:cNvSpPr>
+            <a:spLocks xmlns:a="http://schemas.openxmlformats.org/drawingml/2006/main" noGrp="1"/>
+          </p:cNvSpPr>
+          <p:nvPr/>
+        </p:nvSpPr>
+        <p:spPr>
+          <a:xfrm xmlns:a="http://schemas.openxmlformats.org/drawingml/2006/main">
+            <a:off x="752475" y="6067425"/>
+            <a:ext cx="10610850" cy="228600"/>
           </a:xfrm>
           <a:prstGeom xmlns:a="http://schemas.openxmlformats.org/drawingml/2006/main" prst="rect">
             <a:avLst/>
@@ -15009,66 +15778,7 @@
           <a:p xmlns:a="http://schemas.openxmlformats.org/drawingml/2006/main">
             <a:pPr algn="l">
               <a:buNone/>
-              <a:defRPr sz="2775">
-                <a:solidFill>
-                  <a:srgbClr val="CBAAFF"/>
-                </a:solidFill>
-                <a:latin typeface="Alliance No.2"/>
-                <a:ea typeface="Alliance No.2"/>
-                <a:cs typeface="Alliance No.2"/>
-              </a:defRPr>
-            </a:pPr>
-            <a:r>
-              <a:rPr sz="2775">
-                <a:solidFill>
-                  <a:srgbClr val="CBAAFF"/>
-                </a:solidFill>
-                <a:latin typeface="Alliance No.2"/>
-                <a:ea typeface="Alliance No.2"/>
-                <a:cs typeface="Alliance No.2"/>
-              </a:rPr>
-              <a:t>Implemented</a:t>
-            </a:r>
-          </a:p>
-        </p:txBody>
-      </p:sp>
-      <p:sp>
-        <p:nvSpPr>
-          <p:cNvPr id="60" name="panel-cap-label">
-            <a:extLst xmlns:a="http://schemas.openxmlformats.org/drawingml/2006/main">
-              <a:ext uri="{FF2B5EF4-FFF2-40B4-BE49-F238E27FC236}">
-                <a16:creationId xmlns:a16="http://schemas.microsoft.com/office/drawing/2014/main" id="{61790DCE-DF1C-4820-B630-C077678DB3A1}"/>
-              </a:ext>
-            </a:extLst>
-          </p:cNvPr>
-          <p:cNvSpPr>
-            <a:spLocks xmlns:a="http://schemas.openxmlformats.org/drawingml/2006/main" noGrp="1"/>
-          </p:cNvSpPr>
-          <p:nvPr/>
-        </p:nvSpPr>
-        <p:spPr>
-          <a:xfrm xmlns:a="http://schemas.openxmlformats.org/drawingml/2006/main">
-            <a:off x="742950" y="4867275"/>
-            <a:ext cx="4676775" cy="333375"/>
-          </a:xfrm>
-          <a:prstGeom xmlns:a="http://schemas.openxmlformats.org/drawingml/2006/main" prst="rect">
-            <a:avLst/>
-          </a:prstGeom>
-          <a:noFill xmlns:a="http://schemas.openxmlformats.org/drawingml/2006/main"/>
-          <a:ln xmlns:a="http://schemas.openxmlformats.org/drawingml/2006/main" w="0">
-            <a:noFill/>
-            <a:prstDash val="solid"/>
-          </a:ln>
-        </p:spPr>
-        <p:txBody>
-          <a:bodyPr xmlns:a="http://schemas.openxmlformats.org/drawingml/2006/main" wrap="none" lIns="0" tIns="0" rIns="0" bIns="0" anchor="ctr">
-            <a:noAutofit/>
-          </a:bodyPr>
-          <a:lstStyle xmlns:a="http://schemas.openxmlformats.org/drawingml/2006/main"/>
-          <a:p xmlns:a="http://schemas.openxmlformats.org/drawingml/2006/main">
-            <a:pPr algn="l">
-              <a:buNone/>
-              <a:defRPr sz="1800">
+              <a:defRPr sz="1350">
                 <a:solidFill>
                   <a:srgbClr val="BCBBC2"/>
                 </a:solidFill>
@@ -15078,7 +15788,7 @@
               </a:defRPr>
             </a:pPr>
             <a:r>
-              <a:rPr sz="1800">
+              <a:rPr sz="1350">
                 <a:solidFill>
                   <a:srgbClr val="BCBBC2"/>
                 </a:solidFill>
@@ -15086,239 +15796,7 @@
                 <a:ea typeface="Switzer"/>
                 <a:cs typeface="Switzer"/>
               </a:rPr>
-              <a:t>Private capture · reviewed JSONL</a:t>
-            </a:r>
-          </a:p>
-        </p:txBody>
-      </p:sp>
-      <p:sp>
-        <p:nvSpPr>
-          <p:cNvPr id="61" name="global-cap">
-            <a:extLst xmlns:a="http://schemas.openxmlformats.org/drawingml/2006/main">
-              <a:ext uri="{FF2B5EF4-FFF2-40B4-BE49-F238E27FC236}">
-                <a16:creationId xmlns:a16="http://schemas.microsoft.com/office/drawing/2014/main" id="{D1B973D0-9EDB-4E4D-BE68-B5088A4760D8}"/>
-              </a:ext>
-            </a:extLst>
-          </p:cNvPr>
-          <p:cNvSpPr>
-            <a:spLocks xmlns:a="http://schemas.openxmlformats.org/drawingml/2006/main" noGrp="1"/>
-          </p:cNvSpPr>
-          <p:nvPr/>
-        </p:nvSpPr>
-        <p:spPr>
-          <a:xfrm xmlns:a="http://schemas.openxmlformats.org/drawingml/2006/main">
-            <a:off x="6315075" y="4276725"/>
-            <a:ext cx="5048250" cy="514350"/>
-          </a:xfrm>
-          <a:prstGeom xmlns:a="http://schemas.openxmlformats.org/drawingml/2006/main" prst="rect">
-            <a:avLst/>
-          </a:prstGeom>
-          <a:noFill xmlns:a="http://schemas.openxmlformats.org/drawingml/2006/main"/>
-          <a:ln xmlns:a="http://schemas.openxmlformats.org/drawingml/2006/main" w="0">
-            <a:noFill/>
-            <a:prstDash val="solid"/>
-          </a:ln>
-        </p:spPr>
-        <p:txBody>
-          <a:bodyPr xmlns:a="http://schemas.openxmlformats.org/drawingml/2006/main" wrap="none" lIns="0" tIns="0" rIns="0" bIns="0" anchor="ctr">
-            <a:noAutofit/>
-          </a:bodyPr>
-          <a:lstStyle xmlns:a="http://schemas.openxmlformats.org/drawingml/2006/main"/>
-          <a:p xmlns:a="http://schemas.openxmlformats.org/drawingml/2006/main">
-            <a:pPr algn="l">
-              <a:buNone/>
-              <a:defRPr sz="2775">
-                <a:solidFill>
-                  <a:srgbClr val="6AE8CD"/>
-                </a:solidFill>
-                <a:latin typeface="Alliance No.2"/>
-                <a:ea typeface="Alliance No.2"/>
-                <a:cs typeface="Alliance No.2"/>
-              </a:defRPr>
-            </a:pPr>
-            <a:r>
-              <a:rPr sz="2775">
-                <a:solidFill>
-                  <a:srgbClr val="6AE8CD"/>
-                </a:solidFill>
-                <a:latin typeface="Alliance No.2"/>
-                <a:ea typeface="Alliance No.2"/>
-                <a:cs typeface="Alliance No.2"/>
-              </a:rPr>
-              <a:t>Next milestone</a:t>
-            </a:r>
-          </a:p>
-        </p:txBody>
-      </p:sp>
-      <p:sp>
-        <p:nvSpPr>
-          <p:cNvPr id="62" name="global-cap-label">
-            <a:extLst xmlns:a="http://schemas.openxmlformats.org/drawingml/2006/main">
-              <a:ext uri="{FF2B5EF4-FFF2-40B4-BE49-F238E27FC236}">
-                <a16:creationId xmlns:a16="http://schemas.microsoft.com/office/drawing/2014/main" id="{552E0489-325C-426E-826D-1E7EE30ABA47}"/>
-              </a:ext>
-            </a:extLst>
-          </p:cNvPr>
-          <p:cNvSpPr>
-            <a:spLocks xmlns:a="http://schemas.openxmlformats.org/drawingml/2006/main" noGrp="1"/>
-          </p:cNvSpPr>
-          <p:nvPr/>
-        </p:nvSpPr>
-        <p:spPr>
-          <a:xfrm xmlns:a="http://schemas.openxmlformats.org/drawingml/2006/main">
-            <a:off x="6315075" y="4867275"/>
-            <a:ext cx="5048250" cy="333375"/>
-          </a:xfrm>
-          <a:prstGeom xmlns:a="http://schemas.openxmlformats.org/drawingml/2006/main" prst="rect">
-            <a:avLst/>
-          </a:prstGeom>
-          <a:noFill xmlns:a="http://schemas.openxmlformats.org/drawingml/2006/main"/>
-          <a:ln xmlns:a="http://schemas.openxmlformats.org/drawingml/2006/main" w="0">
-            <a:noFill/>
-            <a:prstDash val="solid"/>
-          </a:ln>
-        </p:spPr>
-        <p:txBody>
-          <a:bodyPr xmlns:a="http://schemas.openxmlformats.org/drawingml/2006/main" wrap="none" lIns="0" tIns="0" rIns="0" bIns="0" anchor="ctr">
-            <a:noAutofit/>
-          </a:bodyPr>
-          <a:lstStyle xmlns:a="http://schemas.openxmlformats.org/drawingml/2006/main"/>
-          <a:p xmlns:a="http://schemas.openxmlformats.org/drawingml/2006/main">
-            <a:pPr algn="l">
-              <a:buNone/>
-              <a:defRPr sz="1800">
-                <a:solidFill>
-                  <a:srgbClr val="BCBBC2"/>
-                </a:solidFill>
-                <a:latin typeface="Switzer"/>
-                <a:ea typeface="Switzer"/>
-                <a:cs typeface="Switzer"/>
-              </a:defRPr>
-            </a:pPr>
-            <a:r>
-              <a:rPr sz="1800">
-                <a:solidFill>
-                  <a:srgbClr val="BCBBC2"/>
-                </a:solidFill>
-                <a:latin typeface="Switzer"/>
-                <a:ea typeface="Switzer"/>
-                <a:cs typeface="Switzer"/>
-              </a:rPr>
-              <a:t>Train, test and compare per model</a:t>
-            </a:r>
-          </a:p>
-        </p:txBody>
-      </p:sp>
-      <p:sp>
-        <p:nvSpPr>
-          <p:cNvPr id="63" name="cap-divider">
-            <a:extLst xmlns:a="http://schemas.openxmlformats.org/drawingml/2006/main">
-              <a:ext uri="{FF2B5EF4-FFF2-40B4-BE49-F238E27FC236}">
-                <a16:creationId xmlns:a16="http://schemas.microsoft.com/office/drawing/2014/main" id="{B7B5CE8F-7949-4D63-9DE3-364604C54DA5}"/>
-              </a:ext>
-            </a:extLst>
-          </p:cNvPr>
-          <p:cNvSpPr>
-            <a:spLocks xmlns:a="http://schemas.openxmlformats.org/drawingml/2006/main" noGrp="1"/>
-          </p:cNvSpPr>
-          <p:nvPr/>
-        </p:nvSpPr>
-        <p:spPr>
-          <a:xfrm xmlns:a="http://schemas.openxmlformats.org/drawingml/2006/main">
-            <a:off x="742950" y="5476875"/>
-            <a:ext cx="10620375" cy="0"/>
-          </a:xfrm>
-          <a:prstGeom xmlns:a="http://schemas.openxmlformats.org/drawingml/2006/main" prst="line">
-            <a:avLst/>
-          </a:prstGeom>
-          <a:noFill xmlns:a="http://schemas.openxmlformats.org/drawingml/2006/main"/>
-          <a:ln xmlns:a="http://schemas.openxmlformats.org/drawingml/2006/main" w="16193">
-            <a:solidFill>
-              <a:srgbClr val="838289"/>
-            </a:solidFill>
-            <a:prstDash val="solid"/>
-          </a:ln>
-        </p:spPr>
-      </p:sp>
-      <p:sp>
-        <p:nvSpPr>
-          <p:cNvPr id="64" name="limits">
-            <a:extLst xmlns:a="http://schemas.openxmlformats.org/drawingml/2006/main">
-              <a:ext uri="{FF2B5EF4-FFF2-40B4-BE49-F238E27FC236}">
-                <a16:creationId xmlns:a16="http://schemas.microsoft.com/office/drawing/2014/main" id="{BDD94E20-CF17-4DF5-AB23-BB97C4CB1F44}"/>
-              </a:ext>
-            </a:extLst>
-          </p:cNvPr>
-          <p:cNvSpPr>
-            <a:spLocks xmlns:a="http://schemas.openxmlformats.org/drawingml/2006/main" noGrp="1"/>
-          </p:cNvSpPr>
-          <p:nvPr/>
-        </p:nvSpPr>
-        <p:spPr>
-          <a:xfrm xmlns:a="http://schemas.openxmlformats.org/drawingml/2006/main">
-            <a:off x="742950" y="5676900"/>
-            <a:ext cx="10668000" cy="581025"/>
-          </a:xfrm>
-          <a:prstGeom xmlns:a="http://schemas.openxmlformats.org/drawingml/2006/main" prst="rect">
-            <a:avLst/>
-          </a:prstGeom>
-          <a:noFill xmlns:a="http://schemas.openxmlformats.org/drawingml/2006/main"/>
-          <a:ln xmlns:a="http://schemas.openxmlformats.org/drawingml/2006/main" w="0">
-            <a:noFill/>
-            <a:prstDash val="solid"/>
-          </a:ln>
-        </p:spPr>
-        <p:txBody>
-          <a:bodyPr xmlns:a="http://schemas.openxmlformats.org/drawingml/2006/main" wrap="none" lIns="0" tIns="0" rIns="0" bIns="0" anchor="ctr">
-            <a:noAutofit/>
-          </a:bodyPr>
-          <a:lstStyle xmlns:a="http://schemas.openxmlformats.org/drawingml/2006/main"/>
-          <a:p xmlns:a="http://schemas.openxmlformats.org/drawingml/2006/main">
-            <a:pPr algn="l">
-              <a:buNone/>
-              <a:defRPr sz="1725">
-                <a:solidFill>
-                  <a:srgbClr val="F9F8FD"/>
-                </a:solidFill>
-                <a:latin typeface="Switzer"/>
-                <a:ea typeface="Switzer"/>
-                <a:cs typeface="Switzer"/>
-              </a:defRPr>
-            </a:pPr>
-            <a:r>
-              <a:rPr sz="1725">
-                <a:solidFill>
-                  <a:srgbClr val="F9F8FD"/>
-                </a:solidFill>
-                <a:latin typeface="Switzer"/>
-                <a:ea typeface="Switzer"/>
-                <a:cs typeface="Switzer"/>
-              </a:rPr>
-              <a:t>Portable data. A separate adapter for each compatible base model.</a:t>
-            </a:r>
-          </a:p>
-          <a:p xmlns:a="http://schemas.openxmlformats.org/drawingml/2006/main">
-            <a:pPr algn="l">
-              <a:buNone/>
-              <a:defRPr sz="1725">
-                <a:solidFill>
-                  <a:srgbClr val="F9F8FD"/>
-                </a:solidFill>
-                <a:latin typeface="Switzer"/>
-                <a:ea typeface="Switzer"/>
-                <a:cs typeface="Switzer"/>
-              </a:defRPr>
-            </a:pPr>
-            <a:r>
-              <a:rPr sz="1725">
-                <a:solidFill>
-                  <a:srgbClr val="F9F8FD"/>
-                </a:solidFill>
-                <a:latin typeface="Switzer"/>
-                <a:ea typeface="Switzer"/>
-                <a:cs typeface="Switzer"/>
-              </a:rPr>
-              <a:t>Fine-tuning is planned; runtime routing guards remain mandatory.</a:t>
+              <a:t>prompt[] + completion[assistant] · real / synthetic separate · model training is next</a:t>
             </a:r>
           </a:p>
         </p:txBody>
@@ -15326,7 +15804,7 @@
     </p:spTree>
     <p:extLst>
       <p:ext uri="{BB962C8B-B14F-4D97-AF65-F5344CB8AC3E}">
-        <p14:creationId xmlns:p14="http://schemas.microsoft.com/office/powerpoint/2010/main" val="107637514"/>
+        <p14:creationId xmlns:p14="http://schemas.microsoft.com/office/powerpoint/2010/main" val="2090962750"/>
       </p:ext>
     </p:extLst>
   </p:cSld>
@@ -15338,23 +15816,9 @@
   <p:cSld>
     <p:bg>
       <p:bgPr>
-        <a:gradFill xmlns:a="http://schemas.openxmlformats.org/drawingml/2006/main">
-          <a:gsLst>
-            <a:gs pos="0">
-              <a:srgbClr val="201F24"/>
-            </a:gs>
-            <a:gs pos="44000">
-              <a:srgbClr val="201F24"/>
-            </a:gs>
-            <a:gs pos="76000">
-              <a:srgbClr val="35106F"/>
-            </a:gs>
-            <a:gs pos="100000">
-              <a:srgbClr val="8232FF"/>
-            </a:gs>
-          </a:gsLst>
-          <a:lin ang="6480000"/>
-        </a:gradFill>
+        <a:solidFill xmlns:a="http://schemas.openxmlformats.org/drawingml/2006/main">
+          <a:srgbClr val="201F24"/>
+        </a:solidFill>
       </p:bgPr>
     </p:bg>
     <p:spTree>
@@ -15366,46 +15830,24 @@
       <p:grpSpPr>
         <a:xfrm xmlns:a="http://schemas.openxmlformats.org/drawingml/2006/main"/>
       </p:grpSpPr>
-      <p:pic>
-        <p:nvPicPr>
-          <p:cNvPr id="16" name="Picture 1"/>
-          <p:cNvPicPr>
-            <a:picLocks xmlns:a="http://schemas.openxmlformats.org/drawingml/2006/main" noChangeAspect="1"/>
-          </p:cNvPicPr>
-          <p:nvPr/>
-        </p:nvPicPr>
-        <p:blipFill>
-          <a:blip xmlns:r="http://schemas.openxmlformats.org/officeDocument/2006/relationships" xmlns:a="http://schemas.openxmlformats.org/drawingml/2006/main" r:embed="Rc540fe4760364259"/>
-          <a:stretch xmlns:a="http://schemas.openxmlformats.org/drawingml/2006/main"/>
-        </p:blipFill>
-        <p:spPr>
-          <a:xfrm xmlns:a="http://schemas.openxmlformats.org/drawingml/2006/main" flipH="0" flipV="0">
-            <a:off x="9953625" y="800100"/>
-            <a:ext cx="1143000" cy="1143000"/>
-          </a:xfrm>
-          <a:prstGeom xmlns:a="http://schemas.openxmlformats.org/drawingml/2006/main" prst="rect">
-            <a:avLst/>
-          </a:prstGeom>
-        </p:spPr>
-      </p:pic>
-      <p:sp>
-        <p:nvSpPr>
-          <p:cNvPr id="3" name="TextBox 2">
-            <a:extLst xmlns:a="http://schemas.openxmlformats.org/drawingml/2006/main">
-              <a:ext uri="{FF2B5EF4-FFF2-40B4-BE49-F238E27FC236}">
-                <a16:creationId xmlns:a16="http://schemas.microsoft.com/office/drawing/2014/main" id="{E2B571C4-D7DA-454D-A508-7DF7C4FC585C}"/>
-              </a:ext>
-            </a:extLst>
-          </p:cNvPr>
-          <p:cNvSpPr>
-            <a:spLocks xmlns:a="http://schemas.openxmlformats.org/drawingml/2006/main" noGrp="1"/>
-          </p:cNvSpPr>
-          <p:nvPr/>
-        </p:nvSpPr>
-        <p:spPr>
-          <a:xfrm xmlns:a="http://schemas.openxmlformats.org/drawingml/2006/main">
-            <a:off x="742950" y="1933575"/>
-            <a:ext cx="10477500" cy="752475"/>
+      <p:sp>
+        <p:nvSpPr>
+          <p:cNvPr id="2" name="TextBox 1">
+            <a:extLst xmlns:a="http://schemas.openxmlformats.org/drawingml/2006/main">
+              <a:ext uri="{FF2B5EF4-FFF2-40B4-BE49-F238E27FC236}">
+                <a16:creationId xmlns:a16="http://schemas.microsoft.com/office/drawing/2014/main" id="{F7141995-C002-488C-8F2B-E515FB545E84}"/>
+              </a:ext>
+            </a:extLst>
+          </p:cNvPr>
+          <p:cNvSpPr>
+            <a:spLocks xmlns:a="http://schemas.openxmlformats.org/drawingml/2006/main" noGrp="1"/>
+          </p:cNvSpPr>
+          <p:nvPr/>
+        </p:nvSpPr>
+        <p:spPr>
+          <a:xfrm xmlns:a="http://schemas.openxmlformats.org/drawingml/2006/main">
+            <a:off x="731520" y="409575"/>
+            <a:ext cx="10820400" cy="333375"/>
           </a:xfrm>
           <a:prstGeom xmlns:a="http://schemas.openxmlformats.org/drawingml/2006/main" prst="rect">
             <a:avLst/>
@@ -15420,7 +15862,62 @@
           <a:p xmlns:a="http://schemas.openxmlformats.org/drawingml/2006/main">
             <a:pPr algn="l">
               <a:buNone/>
-              <a:defRPr sz="3600" b="0">
+              <a:defRPr sz="1200" b="1">
+                <a:solidFill>
+                  <a:srgbClr val="CBAAFF"/>
+                </a:solidFill>
+                <a:latin typeface="Consolas"/>
+                <a:ea typeface="Consolas"/>
+                <a:cs typeface="Consolas"/>
+              </a:defRPr>
+            </a:pPr>
+            <a:r>
+              <a:rPr sz="1200" b="1">
+                <a:solidFill>
+                  <a:srgbClr val="CBAAFF"/>
+                </a:solidFill>
+                <a:latin typeface="Consolas"/>
+                <a:ea typeface="Consolas"/>
+                <a:cs typeface="Consolas"/>
+              </a:rPr>
+              <a:t>FUTURE · PROTOCOL LEARNING</a:t>
+            </a:r>
+          </a:p>
+        </p:txBody>
+      </p:sp>
+      <p:sp>
+        <p:nvSpPr>
+          <p:cNvPr id="3" name="TextBox 2">
+            <a:extLst xmlns:a="http://schemas.openxmlformats.org/drawingml/2006/main">
+              <a:ext uri="{FF2B5EF4-FFF2-40B4-BE49-F238E27FC236}">
+                <a16:creationId xmlns:a16="http://schemas.microsoft.com/office/drawing/2014/main" id="{A126BAEC-F6D3-4875-A4AC-25DD6C136B70}"/>
+              </a:ext>
+            </a:extLst>
+          </p:cNvPr>
+          <p:cNvSpPr>
+            <a:spLocks xmlns:a="http://schemas.openxmlformats.org/drawingml/2006/main" noGrp="1"/>
+          </p:cNvSpPr>
+          <p:nvPr/>
+        </p:nvSpPr>
+        <p:spPr>
+          <a:xfrm xmlns:a="http://schemas.openxmlformats.org/drawingml/2006/main">
+            <a:off x="731520" y="914400"/>
+            <a:ext cx="10820400" cy="704850"/>
+          </a:xfrm>
+          <a:prstGeom xmlns:a="http://schemas.openxmlformats.org/drawingml/2006/main" prst="rect">
+            <a:avLst/>
+          </a:prstGeom>
+          <a:noFill xmlns:a="http://schemas.openxmlformats.org/drawingml/2006/main"/>
+        </p:spPr>
+        <p:txBody>
+          <a:bodyPr xmlns:a="http://schemas.openxmlformats.org/drawingml/2006/main" wrap="none" lIns="0" tIns="0" rIns="0" bIns="0" anchor="ctr">
+            <a:noAutofit/>
+          </a:bodyPr>
+          <a:lstStyle xmlns:a="http://schemas.openxmlformats.org/drawingml/2006/main"/>
+          <a:p xmlns:a="http://schemas.openxmlformats.org/drawingml/2006/main">
+            <a:pPr algn="l">
+              <a:buNone/>
+              <a:defRPr sz="3300" b="0">
                 <a:solidFill>
                   <a:srgbClr val="F9F8FD"/>
                 </a:solidFill>
@@ -15430,7 +15927,7 @@
               </a:defRPr>
             </a:pPr>
             <a:r>
-              <a:rPr sz="3600" b="0">
+              <a:rPr sz="3300" b="0">
                 <a:solidFill>
                   <a:srgbClr val="F9F8FD"/>
                 </a:solidFill>
@@ -15438,29 +15935,29 @@
                 <a:ea typeface="Alliance No.2"/>
                 <a:cs typeface="Alliance No.2"/>
               </a:rPr>
-              <a:t>Meet us at Agent Conf.</a:t>
-            </a:r>
-          </a:p>
-        </p:txBody>
-      </p:sp>
-      <p:sp>
-        <p:nvSpPr>
-          <p:cNvPr id="4" name="TextBox 3">
-            <a:extLst xmlns:a="http://schemas.openxmlformats.org/drawingml/2006/main">
-              <a:ext uri="{FF2B5EF4-FFF2-40B4-BE49-F238E27FC236}">
-                <a16:creationId xmlns:a16="http://schemas.microsoft.com/office/drawing/2014/main" id="{62C4EF88-ADA2-4A0A-AD75-4FC5C49C79CD}"/>
-              </a:ext>
-            </a:extLst>
-          </p:cNvPr>
-          <p:cNvSpPr>
-            <a:spLocks xmlns:a="http://schemas.openxmlformats.org/drawingml/2006/main" noGrp="1"/>
-          </p:cNvSpPr>
-          <p:nvPr/>
-        </p:nvSpPr>
-        <p:spPr>
-          <a:xfrm xmlns:a="http://schemas.openxmlformats.org/drawingml/2006/main">
-            <a:off x="742950" y="2800350"/>
-            <a:ext cx="10610850" cy="466725"/>
+              <a:t>Teach models the Commander Protocol.</a:t>
+            </a:r>
+          </a:p>
+        </p:txBody>
+      </p:sp>
+      <p:sp>
+        <p:nvSpPr>
+          <p:cNvPr id="49" name="TextBox 48">
+            <a:extLst xmlns:a="http://schemas.openxmlformats.org/drawingml/2006/main">
+              <a:ext uri="{FF2B5EF4-FFF2-40B4-BE49-F238E27FC236}">
+                <a16:creationId xmlns:a16="http://schemas.microsoft.com/office/drawing/2014/main" id="{55083C4D-8CCA-4EA1-B774-DBE100BF8F62}"/>
+              </a:ext>
+            </a:extLst>
+          </p:cNvPr>
+          <p:cNvSpPr>
+            <a:spLocks xmlns:a="http://schemas.openxmlformats.org/drawingml/2006/main" noGrp="1"/>
+          </p:cNvSpPr>
+          <p:nvPr/>
+        </p:nvSpPr>
+        <p:spPr>
+          <a:xfrm xmlns:a="http://schemas.openxmlformats.org/drawingml/2006/main">
+            <a:off x="10668000" y="6419850"/>
+            <a:ext cx="857250" cy="285750"/>
           </a:xfrm>
           <a:prstGeom xmlns:a="http://schemas.openxmlformats.org/drawingml/2006/main" prst="rect">
             <a:avLst/>
@@ -15473,11 +15970,11 @@
           </a:bodyPr>
           <a:lstStyle xmlns:a="http://schemas.openxmlformats.org/drawingml/2006/main"/>
           <a:p xmlns:a="http://schemas.openxmlformats.org/drawingml/2006/main">
-            <a:pPr algn="l">
-              <a:buNone/>
-              <a:defRPr sz="2250" b="0">
-                <a:solidFill>
-                  <a:srgbClr val="CBAAFF"/>
+            <a:pPr algn="r">
+              <a:buNone/>
+              <a:defRPr sz="1200" b="0">
+                <a:solidFill>
+                  <a:srgbClr val="BCBBC2"/>
                 </a:solidFill>
                 <a:latin typeface="Consolas"/>
                 <a:ea typeface="Consolas"/>
@@ -15485,166 +15982,263 @@
               </a:defRPr>
             </a:pPr>
             <a:r>
-              <a:rPr sz="2250" b="0">
-                <a:solidFill>
-                  <a:srgbClr val="CBAAFF"/>
+              <a:rPr sz="1200" b="0">
+                <a:solidFill>
+                  <a:srgbClr val="BCBBC2"/>
                 </a:solidFill>
                 <a:latin typeface="Consolas"/>
                 <a:ea typeface="Consolas"/>
                 <a:cs typeface="Consolas"/>
               </a:rPr>
-              <a:t>17–18 September 2026 · Warsaw</a:t>
-            </a:r>
-          </a:p>
-        </p:txBody>
-      </p:sp>
-      <p:sp>
-        <p:nvSpPr>
-          <p:cNvPr id="5" name="Rounded Rectangle 4">
-            <a:extLst xmlns:a="http://schemas.openxmlformats.org/drawingml/2006/main">
-              <a:ext uri="{FF2B5EF4-FFF2-40B4-BE49-F238E27FC236}">
-                <a16:creationId xmlns:a16="http://schemas.microsoft.com/office/drawing/2014/main" id="{68646C1F-A196-4BB4-8193-DFF566382DC4}"/>
-              </a:ext>
-            </a:extLst>
-          </p:cNvPr>
-          <p:cNvSpPr>
-            <a:spLocks xmlns:a="http://schemas.openxmlformats.org/drawingml/2006/main" noGrp="1"/>
-          </p:cNvSpPr>
-          <p:nvPr/>
-        </p:nvSpPr>
-        <p:spPr>
-          <a:xfrm xmlns:a="http://schemas.openxmlformats.org/drawingml/2006/main">
-            <a:off x="742950" y="3476625"/>
-            <a:ext cx="10629900" cy="962025"/>
-          </a:xfrm>
-          <a:prstGeom xmlns:a="http://schemas.openxmlformats.org/drawingml/2006/main" prst="roundRect">
-            <a:avLst>
-              <a:gd name="adj" fmla="val 4630"/>
-            </a:avLst>
-          </a:prstGeom>
-          <a:noFill xmlns:a="http://schemas.openxmlformats.org/drawingml/2006/main"/>
-          <a:ln xmlns:a="http://schemas.openxmlformats.org/drawingml/2006/main" w="9525">
+              <a:t>19/21</a:t>
+            </a:r>
+          </a:p>
+        </p:txBody>
+      </p:sp>
+      <p:sp>
+        <p:nvSpPr>
+          <p:cNvPr id="50" name="Callstack accent rule">
+            <a:extLst xmlns:a="http://schemas.openxmlformats.org/drawingml/2006/main">
+              <a:ext uri="{FF2B5EF4-FFF2-40B4-BE49-F238E27FC236}">
+                <a16:creationId xmlns:a16="http://schemas.microsoft.com/office/drawing/2014/main" id="{B8DAE6AA-7B94-4D91-9F2C-8316CB9480FB}"/>
+              </a:ext>
+            </a:extLst>
+          </p:cNvPr>
+          <p:cNvSpPr>
+            <a:spLocks xmlns:a="http://schemas.openxmlformats.org/drawingml/2006/main" noGrp="1"/>
+          </p:cNvSpPr>
+          <p:nvPr/>
+        </p:nvSpPr>
+        <p:spPr>
+          <a:xfrm xmlns:a="http://schemas.openxmlformats.org/drawingml/2006/main">
+            <a:off x="0" y="0"/>
+            <a:ext cx="12192000" cy="57150"/>
+          </a:xfrm>
+          <a:prstGeom xmlns:a="http://schemas.openxmlformats.org/drawingml/2006/main" prst="rect">
+            <a:avLst/>
+          </a:prstGeom>
+          <a:solidFill xmlns:a="http://schemas.openxmlformats.org/drawingml/2006/main">
+            <a:srgbClr val="8232FF"/>
+          </a:solidFill>
+          <a:ln xmlns:a="http://schemas.openxmlformats.org/drawingml/2006/main" w="2381">
+            <a:solidFill>
+              <a:srgbClr val="8232FF"/>
+            </a:solidFill>
+            <a:prstDash val="solid"/>
+          </a:ln>
+        </p:spPr>
+      </p:sp>
+      <p:sp>
+        <p:nvSpPr>
+          <p:cNvPr id="51" name="guard-272">
+            <a:extLst xmlns:a="http://schemas.openxmlformats.org/drawingml/2006/main">
+              <a:ext uri="{FF2B5EF4-FFF2-40B4-BE49-F238E27FC236}">
+                <a16:creationId xmlns:a16="http://schemas.microsoft.com/office/drawing/2014/main" id="{5B33431B-A35A-4B5F-BB47-84F22ADED5C2}"/>
+              </a:ext>
+            </a:extLst>
+          </p:cNvPr>
+          <p:cNvSpPr>
+            <a:spLocks xmlns:a="http://schemas.openxmlformats.org/drawingml/2006/main" noGrp="1"/>
+          </p:cNvSpPr>
+          <p:nvPr/>
+        </p:nvSpPr>
+        <p:spPr>
+          <a:xfrm xmlns:a="http://schemas.openxmlformats.org/drawingml/2006/main">
+            <a:off x="2590800" y="2800350"/>
+            <a:ext cx="504825" cy="114300"/>
+          </a:xfrm>
+          <a:prstGeom xmlns:a="http://schemas.openxmlformats.org/drawingml/2006/main" prst="rightArrow">
+            <a:avLst/>
+          </a:prstGeom>
+          <a:solidFill xmlns:a="http://schemas.openxmlformats.org/drawingml/2006/main">
+            <a:srgbClr val="CBAAFF"/>
+          </a:solidFill>
+          <a:ln xmlns:a="http://schemas.openxmlformats.org/drawingml/2006/main" w="0">
+            <a:noFill/>
+            <a:prstDash val="solid"/>
+          </a:ln>
+        </p:spPr>
+      </p:sp>
+      <p:sp>
+        <p:nvSpPr>
+          <p:cNvPr id="52" name="guard-565">
+            <a:extLst xmlns:a="http://schemas.openxmlformats.org/drawingml/2006/main">
+              <a:ext uri="{FF2B5EF4-FFF2-40B4-BE49-F238E27FC236}">
+                <a16:creationId xmlns:a16="http://schemas.microsoft.com/office/drawing/2014/main" id="{CF583F7B-6C4F-4C8E-A510-51E0023DB06F}"/>
+              </a:ext>
+            </a:extLst>
+          </p:cNvPr>
+          <p:cNvSpPr>
+            <a:spLocks xmlns:a="http://schemas.openxmlformats.org/drawingml/2006/main" noGrp="1"/>
+          </p:cNvSpPr>
+          <p:nvPr/>
+        </p:nvSpPr>
+        <p:spPr>
+          <a:xfrm xmlns:a="http://schemas.openxmlformats.org/drawingml/2006/main">
+            <a:off x="5381625" y="2800350"/>
+            <a:ext cx="514350" cy="114300"/>
+          </a:xfrm>
+          <a:prstGeom xmlns:a="http://schemas.openxmlformats.org/drawingml/2006/main" prst="rightArrow">
+            <a:avLst/>
+          </a:prstGeom>
+          <a:solidFill xmlns:a="http://schemas.openxmlformats.org/drawingml/2006/main">
+            <a:srgbClr val="CBAAFF"/>
+          </a:solidFill>
+          <a:ln xmlns:a="http://schemas.openxmlformats.org/drawingml/2006/main" w="0">
+            <a:noFill/>
+            <a:prstDash val="solid"/>
+          </a:ln>
+        </p:spPr>
+      </p:sp>
+      <p:sp>
+        <p:nvSpPr>
+          <p:cNvPr id="53" name="guard-858">
+            <a:extLst xmlns:a="http://schemas.openxmlformats.org/drawingml/2006/main">
+              <a:ext uri="{FF2B5EF4-FFF2-40B4-BE49-F238E27FC236}">
+                <a16:creationId xmlns:a16="http://schemas.microsoft.com/office/drawing/2014/main" id="{E3470387-7060-49C7-88EC-3C9F3110E647}"/>
+              </a:ext>
+            </a:extLst>
+          </p:cNvPr>
+          <p:cNvSpPr>
+            <a:spLocks xmlns:a="http://schemas.openxmlformats.org/drawingml/2006/main" noGrp="1"/>
+          </p:cNvSpPr>
+          <p:nvPr/>
+        </p:nvSpPr>
+        <p:spPr>
+          <a:xfrm xmlns:a="http://schemas.openxmlformats.org/drawingml/2006/main">
+            <a:off x="8172450" y="2800350"/>
+            <a:ext cx="514350" cy="114300"/>
+          </a:xfrm>
+          <a:prstGeom xmlns:a="http://schemas.openxmlformats.org/drawingml/2006/main" prst="rightArrow">
+            <a:avLst/>
+          </a:prstGeom>
+          <a:solidFill xmlns:a="http://schemas.openxmlformats.org/drawingml/2006/main">
+            <a:srgbClr val="CBAAFF"/>
+          </a:solidFill>
+          <a:ln xmlns:a="http://schemas.openxmlformats.org/drawingml/2006/main" w="0">
+            <a:noFill/>
+            <a:prstDash val="solid"/>
+          </a:ln>
+        </p:spPr>
+      </p:sp>
+      <p:sp>
+        <p:nvSpPr>
+          <p:cNvPr id="54" name="source-guard">
+            <a:extLst xmlns:a="http://schemas.openxmlformats.org/drawingml/2006/main">
+              <a:ext uri="{FF2B5EF4-FFF2-40B4-BE49-F238E27FC236}">
+                <a16:creationId xmlns:a16="http://schemas.microsoft.com/office/drawing/2014/main" id="{5D4EEF9F-97C2-4672-A52C-23A9B83956B4}"/>
+              </a:ext>
+            </a:extLst>
+          </p:cNvPr>
+          <p:cNvSpPr>
+            <a:spLocks xmlns:a="http://schemas.openxmlformats.org/drawingml/2006/main" noGrp="1"/>
+          </p:cNvSpPr>
+          <p:nvPr/>
+        </p:nvSpPr>
+        <p:spPr>
+          <a:xfrm xmlns:a="http://schemas.openxmlformats.org/drawingml/2006/main">
+            <a:off x="742950" y="2362200"/>
+            <a:ext cx="1847850" cy="1000125"/>
+          </a:xfrm>
+          <a:prstGeom xmlns:a="http://schemas.openxmlformats.org/drawingml/2006/main" prst="rect">
+            <a:avLst/>
+          </a:prstGeom>
+          <a:solidFill xmlns:a="http://schemas.openxmlformats.org/drawingml/2006/main">
+            <a:srgbClr val="27262B"/>
+          </a:solidFill>
+          <a:ln xmlns:a="http://schemas.openxmlformats.org/drawingml/2006/main" w="13335">
             <a:solidFill>
               <a:srgbClr val="CBAAFF"/>
             </a:solidFill>
             <a:prstDash val="solid"/>
           </a:ln>
         </p:spPr>
-        <p:style>
-          <a:lnRef xmlns:a="http://schemas.openxmlformats.org/drawingml/2006/main" idx="1">
-            <a:schemeClr val="accent1"/>
-          </a:lnRef>
-          <a:fillRef xmlns:a="http://schemas.openxmlformats.org/drawingml/2006/main" idx="3">
-            <a:schemeClr val="accent1"/>
-          </a:fillRef>
-          <a:effectRef xmlns:a="http://schemas.openxmlformats.org/drawingml/2006/main" idx="0"/>
-          <a:fontRef xmlns:a="http://schemas.openxmlformats.org/drawingml/2006/main" idx="minor">
-            <a:schemeClr val="lt1"/>
-          </a:fontRef>
-        </p:style>
-        <p:txBody>
-          <a:bodyPr xmlns:a="http://schemas.openxmlformats.org/drawingml/2006/main" anchor="ctr"/>
-          <a:lstStyle xmlns:a="http://schemas.openxmlformats.org/drawingml/2006/main"/>
-          <a:p xmlns:a="http://schemas.openxmlformats.org/drawingml/2006/main">
-            <a:pPr algn="ctr">
-              <a:buNone/>
-            </a:pPr>
-          </a:p>
-        </p:txBody>
-      </p:sp>
-      <p:sp>
-        <p:nvSpPr>
-          <p:cNvPr id="6" name="TextBox 5">
-            <a:extLst xmlns:a="http://schemas.openxmlformats.org/drawingml/2006/main">
-              <a:ext uri="{FF2B5EF4-FFF2-40B4-BE49-F238E27FC236}">
-                <a16:creationId xmlns:a16="http://schemas.microsoft.com/office/drawing/2014/main" id="{CED7D471-F0C7-46DB-A417-EDEB97E79E41}"/>
-              </a:ext>
-            </a:extLst>
-          </p:cNvPr>
-          <p:cNvSpPr>
-            <a:spLocks xmlns:a="http://schemas.openxmlformats.org/drawingml/2006/main" noGrp="1"/>
-          </p:cNvSpPr>
-          <p:nvPr/>
-        </p:nvSpPr>
-        <p:spPr>
-          <a:xfrm xmlns:a="http://schemas.openxmlformats.org/drawingml/2006/main">
-            <a:off x="990600" y="3705225"/>
-            <a:ext cx="10163175" cy="533400"/>
-          </a:xfrm>
-          <a:prstGeom xmlns:a="http://schemas.openxmlformats.org/drawingml/2006/main" prst="rect">
-            <a:avLst/>
-          </a:prstGeom>
-          <a:noFill xmlns:a="http://schemas.openxmlformats.org/drawingml/2006/main"/>
-        </p:spPr>
         <p:txBody>
           <a:bodyPr xmlns:a="http://schemas.openxmlformats.org/drawingml/2006/main" wrap="none" lIns="0" tIns="0" rIns="0" bIns="0" anchor="ctr">
             <a:noAutofit/>
           </a:bodyPr>
           <a:lstStyle xmlns:a="http://schemas.openxmlformats.org/drawingml/2006/main"/>
           <a:p xmlns:a="http://schemas.openxmlformats.org/drawingml/2006/main">
-            <a:pPr algn="l">
-              <a:spcAft>
-                <a:spcPts val="400"/>
-              </a:spcAft>
-              <a:buNone/>
-              <a:defRPr sz="2550" b="0">
-                <a:solidFill>
-                  <a:srgbClr val="F9F8FD"/>
-                </a:solidFill>
-                <a:latin typeface="Consolas"/>
-                <a:ea typeface="Consolas"/>
-                <a:cs typeface="Consolas"/>
-              </a:defRPr>
-            </a:pPr>
-            <a:r>
-              <a:rPr sz="2550" b="0">
-                <a:solidFill>
-                  <a:srgbClr val="F9F8FD"/>
-                </a:solidFill>
-                <a:latin typeface="Consolas"/>
-                <a:ea typeface="Consolas"/>
-                <a:cs typeface="Consolas"/>
-                <a:hlinkClick xmlns:r="http://schemas.openxmlformats.org/officeDocument/2006/relationships" r:id="R5d206fc2ef394609"/>
-              </a:rPr>
-              <a:t>agent.sh/tickets</a:t>
-            </a:r>
-            <a:r>
-              <a:rPr sz="2550" b="0">
-                <a:solidFill>
-                  <a:srgbClr val="F9F8FD"/>
-                </a:solidFill>
-                <a:latin typeface="Consolas"/>
-                <a:ea typeface="Consolas"/>
-                <a:cs typeface="Consolas"/>
-              </a:rPr>
-              <a:t> →</a:t>
-            </a:r>
-          </a:p>
-        </p:txBody>
-      </p:sp>
-      <p:sp>
-        <p:nvSpPr>
-          <p:cNvPr id="7" name="TextBox 6">
-            <a:extLst xmlns:a="http://schemas.openxmlformats.org/drawingml/2006/main">
-              <a:ext uri="{FF2B5EF4-FFF2-40B4-BE49-F238E27FC236}">
-                <a16:creationId xmlns:a16="http://schemas.microsoft.com/office/drawing/2014/main" id="{7AEC0BD1-4425-4206-AEB3-0B15BB9F0F58}"/>
-              </a:ext>
-            </a:extLst>
-          </p:cNvPr>
-          <p:cNvSpPr>
-            <a:spLocks xmlns:a="http://schemas.openxmlformats.org/drawingml/2006/main" noGrp="1"/>
-          </p:cNvSpPr>
-          <p:nvPr/>
-        </p:nvSpPr>
-        <p:spPr>
-          <a:xfrm xmlns:a="http://schemas.openxmlformats.org/drawingml/2006/main">
-            <a:off x="742950" y="4600575"/>
-            <a:ext cx="10620375" cy="361950"/>
+            <a:pPr algn="ctr">
+              <a:buNone/>
+              <a:defRPr sz="1725">
+                <a:solidFill>
+                  <a:srgbClr val="F9F8FD"/>
+                </a:solidFill>
+                <a:latin typeface="Switzer"/>
+                <a:ea typeface="Switzer"/>
+                <a:cs typeface="Switzer"/>
+              </a:defRPr>
+            </a:pPr>
+            <a:r>
+              <a:rPr sz="1725">
+                <a:solidFill>
+                  <a:srgbClr val="F9F8FD"/>
+                </a:solidFill>
+                <a:latin typeface="Switzer"/>
+                <a:ea typeface="Switzer"/>
+                <a:cs typeface="Switzer"/>
+              </a:rPr>
+              <a:t>Real agent</a:t>
+            </a:r>
+          </a:p>
+          <a:p xmlns:a="http://schemas.openxmlformats.org/drawingml/2006/main">
+            <a:pPr algn="ctr">
+              <a:buNone/>
+              <a:defRPr sz="1725">
+                <a:solidFill>
+                  <a:srgbClr val="F9F8FD"/>
+                </a:solidFill>
+                <a:latin typeface="Switzer"/>
+                <a:ea typeface="Switzer"/>
+                <a:cs typeface="Switzer"/>
+              </a:defRPr>
+            </a:pPr>
+            <a:r>
+              <a:rPr sz="1725">
+                <a:solidFill>
+                  <a:srgbClr val="F9F8FD"/>
+                </a:solidFill>
+                <a:latin typeface="Switzer"/>
+                <a:ea typeface="Switzer"/>
+                <a:cs typeface="Switzer"/>
+              </a:rPr>
+              <a:t>messages</a:t>
+            </a:r>
+          </a:p>
+        </p:txBody>
+      </p:sp>
+      <p:sp>
+        <p:nvSpPr>
+          <p:cNvPr id="55" name="queue-guard">
+            <a:extLst xmlns:a="http://schemas.openxmlformats.org/drawingml/2006/main">
+              <a:ext uri="{FF2B5EF4-FFF2-40B4-BE49-F238E27FC236}">
+                <a16:creationId xmlns:a16="http://schemas.microsoft.com/office/drawing/2014/main" id="{C16706AD-4485-4B32-8EB3-FAD08C586C33}"/>
+              </a:ext>
+            </a:extLst>
+          </p:cNvPr>
+          <p:cNvSpPr>
+            <a:spLocks xmlns:a="http://schemas.openxmlformats.org/drawingml/2006/main" noGrp="1"/>
+          </p:cNvSpPr>
+          <p:nvPr/>
+        </p:nvSpPr>
+        <p:spPr>
+          <a:xfrm xmlns:a="http://schemas.openxmlformats.org/drawingml/2006/main">
+            <a:off x="3095625" y="2362200"/>
+            <a:ext cx="2286000" cy="1000125"/>
           </a:xfrm>
           <a:prstGeom xmlns:a="http://schemas.openxmlformats.org/drawingml/2006/main" prst="rect">
             <a:avLst/>
           </a:prstGeom>
-          <a:noFill xmlns:a="http://schemas.openxmlformats.org/drawingml/2006/main"/>
+          <a:solidFill xmlns:a="http://schemas.openxmlformats.org/drawingml/2006/main">
+            <a:srgbClr val="27262B"/>
+          </a:solidFill>
+          <a:ln xmlns:a="http://schemas.openxmlformats.org/drawingml/2006/main" w="13335">
+            <a:solidFill>
+              <a:srgbClr val="CBAAFF"/>
+            </a:solidFill>
+            <a:prstDash val="solid"/>
+          </a:ln>
         </p:spPr>
         <p:txBody>
           <a:bodyPr xmlns:a="http://schemas.openxmlformats.org/drawingml/2006/main" wrap="none" lIns="0" tIns="0" rIns="0" bIns="0" anchor="ctr">
@@ -15652,54 +16246,86 @@
           </a:bodyPr>
           <a:lstStyle xmlns:a="http://schemas.openxmlformats.org/drawingml/2006/main"/>
           <a:p xmlns:a="http://schemas.openxmlformats.org/drawingml/2006/main">
-            <a:pPr algn="l">
-              <a:buNone/>
-              <a:defRPr sz="1800" b="0">
-                <a:solidFill>
-                  <a:srgbClr val="F9F8FD"/>
-                </a:solidFill>
-                <a:latin typeface="Consolas"/>
-                <a:ea typeface="Consolas"/>
-                <a:cs typeface="Consolas"/>
-              </a:defRPr>
-            </a:pPr>
-            <a:r>
-              <a:rPr sz="1800" b="0">
-                <a:solidFill>
-                  <a:srgbClr val="F9F8FD"/>
-                </a:solidFill>
-                <a:latin typeface="Consolas"/>
-                <a:ea typeface="Consolas"/>
-                <a:cs typeface="Consolas"/>
-              </a:rPr>
-              <a:t>Two days for engineers building with AI agents.</a:t>
-            </a:r>
-          </a:p>
-        </p:txBody>
-      </p:sp>
-      <p:sp>
-        <p:nvSpPr>
-          <p:cNvPr id="8" name="TextBox 7">
-            <a:extLst xmlns:a="http://schemas.openxmlformats.org/drawingml/2006/main">
-              <a:ext uri="{FF2B5EF4-FFF2-40B4-BE49-F238E27FC236}">
-                <a16:creationId xmlns:a16="http://schemas.microsoft.com/office/drawing/2014/main" id="{963D474F-FEA2-485F-BA06-028DDF433761}"/>
-              </a:ext>
-            </a:extLst>
-          </p:cNvPr>
-          <p:cNvSpPr>
-            <a:spLocks xmlns:a="http://schemas.openxmlformats.org/drawingml/2006/main" noGrp="1"/>
-          </p:cNvSpPr>
-          <p:nvPr/>
-        </p:nvSpPr>
-        <p:spPr>
-          <a:xfrm xmlns:a="http://schemas.openxmlformats.org/drawingml/2006/main">
-            <a:off x="742950" y="5962650"/>
-            <a:ext cx="10620375" cy="295275"/>
+            <a:pPr algn="ctr">
+              <a:buNone/>
+              <a:defRPr sz="1725">
+                <a:solidFill>
+                  <a:srgbClr val="F9F8FD"/>
+                </a:solidFill>
+                <a:latin typeface="Switzer"/>
+                <a:ea typeface="Switzer"/>
+                <a:cs typeface="Switzer"/>
+              </a:defRPr>
+            </a:pPr>
+            <a:r>
+              <a:rPr sz="1725">
+                <a:solidFill>
+                  <a:srgbClr val="F9F8FD"/>
+                </a:solidFill>
+                <a:latin typeface="Switzer"/>
+                <a:ea typeface="Switzer"/>
+                <a:cs typeface="Switzer"/>
+              </a:rPr>
+              <a:t>Reviewed</a:t>
+            </a:r>
+          </a:p>
+          <a:p xmlns:a="http://schemas.openxmlformats.org/drawingml/2006/main">
+            <a:pPr algn="ctr">
+              <a:buNone/>
+              <a:defRPr sz="1725">
+                <a:solidFill>
+                  <a:srgbClr val="F9F8FD"/>
+                </a:solidFill>
+                <a:latin typeface="Switzer"/>
+                <a:ea typeface="Switzer"/>
+                <a:cs typeface="Switzer"/>
+              </a:defRPr>
+            </a:pPr>
+            <a:r>
+              <a:rPr sz="1725">
+                <a:solidFill>
+                  <a:srgbClr val="F9F8FD"/>
+                </a:solidFill>
+                <a:latin typeface="Switzer"/>
+                <a:ea typeface="Switzer"/>
+                <a:cs typeface="Switzer"/>
+              </a:rPr>
+              <a:t>training data</a:t>
+            </a:r>
+          </a:p>
+        </p:txBody>
+      </p:sp>
+      <p:sp>
+        <p:nvSpPr>
+          <p:cNvPr id="56" name="target-guard">
+            <a:extLst xmlns:a="http://schemas.openxmlformats.org/drawingml/2006/main">
+              <a:ext uri="{FF2B5EF4-FFF2-40B4-BE49-F238E27FC236}">
+                <a16:creationId xmlns:a16="http://schemas.microsoft.com/office/drawing/2014/main" id="{F080771C-DFFF-4AFB-BD58-0BB682726209}"/>
+              </a:ext>
+            </a:extLst>
+          </p:cNvPr>
+          <p:cNvSpPr>
+            <a:spLocks xmlns:a="http://schemas.openxmlformats.org/drawingml/2006/main" noGrp="1"/>
+          </p:cNvSpPr>
+          <p:nvPr/>
+        </p:nvSpPr>
+        <p:spPr>
+          <a:xfrm xmlns:a="http://schemas.openxmlformats.org/drawingml/2006/main">
+            <a:off x="5895975" y="2362200"/>
+            <a:ext cx="2276475" cy="1000125"/>
           </a:xfrm>
           <a:prstGeom xmlns:a="http://schemas.openxmlformats.org/drawingml/2006/main" prst="rect">
             <a:avLst/>
           </a:prstGeom>
-          <a:noFill xmlns:a="http://schemas.openxmlformats.org/drawingml/2006/main"/>
+          <a:solidFill xmlns:a="http://schemas.openxmlformats.org/drawingml/2006/main">
+            <a:srgbClr val="27262B"/>
+          </a:solidFill>
+          <a:ln xmlns:a="http://schemas.openxmlformats.org/drawingml/2006/main" w="13335">
+            <a:solidFill>
+              <a:srgbClr val="CBAAFF"/>
+            </a:solidFill>
+            <a:prstDash val="solid"/>
+          </a:ln>
         </p:spPr>
         <p:txBody>
           <a:bodyPr xmlns:a="http://schemas.openxmlformats.org/drawingml/2006/main" wrap="none" lIns="0" tIns="0" rIns="0" bIns="0" anchor="ctr">
@@ -15707,54 +16333,86 @@
           </a:bodyPr>
           <a:lstStyle xmlns:a="http://schemas.openxmlformats.org/drawingml/2006/main"/>
           <a:p xmlns:a="http://schemas.openxmlformats.org/drawingml/2006/main">
-            <a:pPr algn="l">
-              <a:buNone/>
-              <a:defRPr sz="1500" b="0">
-                <a:solidFill>
-                  <a:srgbClr val="BCBBC2"/>
-                </a:solidFill>
-                <a:latin typeface="Switzer"/>
-                <a:ea typeface="Switzer"/>
-                <a:cs typeface="Switzer"/>
-              </a:defRPr>
-            </a:pPr>
-            <a:r>
-              <a:rPr sz="1500" b="0">
-                <a:solidFill>
-                  <a:srgbClr val="BCBBC2"/>
-                </a:solidFill>
-                <a:latin typeface="Switzer"/>
-                <a:ea typeface="Switzer"/>
-                <a:cs typeface="Switzer"/>
-              </a:rPr>
-              <a:t>Hosted by Callstack · Details: agent.sh</a:t>
-            </a:r>
-          </a:p>
-        </p:txBody>
-      </p:sp>
-      <p:sp>
-        <p:nvSpPr>
-          <p:cNvPr id="9" name="TextBox 8">
-            <a:extLst xmlns:a="http://schemas.openxmlformats.org/drawingml/2006/main">
-              <a:ext uri="{FF2B5EF4-FFF2-40B4-BE49-F238E27FC236}">
-                <a16:creationId xmlns:a16="http://schemas.microsoft.com/office/drawing/2014/main" id="{5251B42F-0482-4A79-9E65-262FA0FD07C6}"/>
-              </a:ext>
-            </a:extLst>
-          </p:cNvPr>
-          <p:cNvSpPr>
-            <a:spLocks xmlns:a="http://schemas.openxmlformats.org/drawingml/2006/main" noGrp="1"/>
-          </p:cNvSpPr>
-          <p:nvPr/>
-        </p:nvSpPr>
-        <p:spPr>
-          <a:xfrm xmlns:a="http://schemas.openxmlformats.org/drawingml/2006/main">
-            <a:off x="10668000" y="6419850"/>
-            <a:ext cx="857250" cy="285750"/>
+            <a:pPr algn="ctr">
+              <a:buNone/>
+              <a:defRPr sz="1725">
+                <a:solidFill>
+                  <a:srgbClr val="F9F8FD"/>
+                </a:solidFill>
+                <a:latin typeface="Switzer"/>
+                <a:ea typeface="Switzer"/>
+                <a:cs typeface="Switzer"/>
+              </a:defRPr>
+            </a:pPr>
+            <a:r>
+              <a:rPr sz="1725">
+                <a:solidFill>
+                  <a:srgbClr val="F9F8FD"/>
+                </a:solidFill>
+                <a:latin typeface="Switzer"/>
+                <a:ea typeface="Switzer"/>
+                <a:cs typeface="Switzer"/>
+              </a:rPr>
+              <a:t>Per-model</a:t>
+            </a:r>
+          </a:p>
+          <a:p xmlns:a="http://schemas.openxmlformats.org/drawingml/2006/main">
+            <a:pPr algn="ctr">
+              <a:buNone/>
+              <a:defRPr sz="1725">
+                <a:solidFill>
+                  <a:srgbClr val="F9F8FD"/>
+                </a:solidFill>
+                <a:latin typeface="Switzer"/>
+                <a:ea typeface="Switzer"/>
+                <a:cs typeface="Switzer"/>
+              </a:defRPr>
+            </a:pPr>
+            <a:r>
+              <a:rPr sz="1725">
+                <a:solidFill>
+                  <a:srgbClr val="F9F8FD"/>
+                </a:solidFill>
+                <a:latin typeface="Switzer"/>
+                <a:ea typeface="Switzer"/>
+                <a:cs typeface="Switzer"/>
+              </a:rPr>
+              <a:t>LoRA adapter</a:t>
+            </a:r>
+          </a:p>
+        </p:txBody>
+      </p:sp>
+      <p:sp>
+        <p:nvSpPr>
+          <p:cNvPr id="57" name="submit-guard">
+            <a:extLst xmlns:a="http://schemas.openxmlformats.org/drawingml/2006/main">
+              <a:ext uri="{FF2B5EF4-FFF2-40B4-BE49-F238E27FC236}">
+                <a16:creationId xmlns:a16="http://schemas.microsoft.com/office/drawing/2014/main" id="{8F101783-9F0B-4881-8E4B-AEB692F74B10}"/>
+              </a:ext>
+            </a:extLst>
+          </p:cNvPr>
+          <p:cNvSpPr>
+            <a:spLocks xmlns:a="http://schemas.openxmlformats.org/drawingml/2006/main" noGrp="1"/>
+          </p:cNvSpPr>
+          <p:nvPr/>
+        </p:nvSpPr>
+        <p:spPr>
+          <a:xfrm xmlns:a="http://schemas.openxmlformats.org/drawingml/2006/main">
+            <a:off x="8686800" y="2362200"/>
+            <a:ext cx="2714625" cy="1000125"/>
           </a:xfrm>
           <a:prstGeom xmlns:a="http://schemas.openxmlformats.org/drawingml/2006/main" prst="rect">
             <a:avLst/>
           </a:prstGeom>
-          <a:noFill xmlns:a="http://schemas.openxmlformats.org/drawingml/2006/main"/>
+          <a:solidFill xmlns:a="http://schemas.openxmlformats.org/drawingml/2006/main">
+            <a:srgbClr val="27262B"/>
+          </a:solidFill>
+          <a:ln xmlns:a="http://schemas.openxmlformats.org/drawingml/2006/main" w="13335">
+            <a:solidFill>
+              <a:srgbClr val="6AE8CD"/>
+            </a:solidFill>
+            <a:prstDash val="solid"/>
+          </a:ln>
         </p:spPr>
         <p:txBody>
           <a:bodyPr xmlns:a="http://schemas.openxmlformats.org/drawingml/2006/main" wrap="none" lIns="0" tIns="0" rIns="0" bIns="0" anchor="ctr">
@@ -15762,71 +16420,73 @@
           </a:bodyPr>
           <a:lstStyle xmlns:a="http://schemas.openxmlformats.org/drawingml/2006/main"/>
           <a:p xmlns:a="http://schemas.openxmlformats.org/drawingml/2006/main">
-            <a:pPr algn="r">
-              <a:buNone/>
-              <a:defRPr sz="1200" b="0">
-                <a:solidFill>
-                  <a:srgbClr val="BCBBC2"/>
-                </a:solidFill>
-                <a:latin typeface="Consolas"/>
-                <a:ea typeface="Consolas"/>
-                <a:cs typeface="Consolas"/>
-              </a:defRPr>
-            </a:pPr>
-            <a:r>
-              <a:rPr sz="1200" b="0">
-                <a:solidFill>
-                  <a:srgbClr val="BCBBC2"/>
-                </a:solidFill>
-                <a:latin typeface="Consolas"/>
-                <a:ea typeface="Consolas"/>
-                <a:cs typeface="Consolas"/>
-              </a:rPr>
-              <a:t>19/20</a:t>
-            </a:r>
-          </a:p>
-        </p:txBody>
-      </p:sp>
-      <p:pic>
-        <p:nvPicPr>
-          <p:cNvPr id="24" name=""/>
-          <p:cNvPicPr>
-            <a:picLocks xmlns:a="http://schemas.openxmlformats.org/drawingml/2006/main" noChangeAspect="1"/>
-          </p:cNvPicPr>
-          <p:nvPr/>
-        </p:nvPicPr>
-        <p:blipFill>
-          <a:blip xmlns:r="http://schemas.openxmlformats.org/officeDocument/2006/relationships" xmlns:a="http://schemas.openxmlformats.org/drawingml/2006/main" r:embed="Rfdfbc22b2f0a454e"/>
-          <a:stretch xmlns:a="http://schemas.openxmlformats.org/drawingml/2006/main"/>
-        </p:blipFill>
-        <p:spPr>
-          <a:xfrm xmlns:a="http://schemas.openxmlformats.org/drawingml/2006/main">
-            <a:off x="692604" y="342900"/>
-            <a:ext cx="1567543" cy="342900"/>
-          </a:xfrm>
-          <a:prstGeom xmlns:a="http://schemas.openxmlformats.org/drawingml/2006/main" prst="rect">
-            <a:avLst/>
-          </a:prstGeom>
-        </p:spPr>
-      </p:pic>
-      <p:sp>
-        <p:nvSpPr>
-          <p:cNvPr id="12" name="conference-source-label">
-            <a:extLst xmlns:a="http://schemas.openxmlformats.org/drawingml/2006/main">
-              <a:ext uri="{FF2B5EF4-FFF2-40B4-BE49-F238E27FC236}">
-                <a16:creationId xmlns:a16="http://schemas.microsoft.com/office/drawing/2014/main" id="{F6AD476A-8E8A-47D1-B5AB-E79E6FB8E588}"/>
-              </a:ext>
-            </a:extLst>
-          </p:cNvPr>
-          <p:cNvSpPr>
-            <a:spLocks xmlns:a="http://schemas.openxmlformats.org/drawingml/2006/main" noGrp="1"/>
-          </p:cNvSpPr>
-          <p:nvPr/>
-        </p:nvSpPr>
-        <p:spPr>
-          <a:xfrm xmlns:a="http://schemas.openxmlformats.org/drawingml/2006/main">
-            <a:off x="742950" y="5143500"/>
-            <a:ext cx="10610850" cy="304800"/>
+            <a:pPr algn="ctr">
+              <a:buNone/>
+              <a:defRPr sz="1725">
+                <a:solidFill>
+                  <a:srgbClr val="F9F8FD"/>
+                </a:solidFill>
+                <a:latin typeface="Switzer"/>
+                <a:ea typeface="Switzer"/>
+                <a:cs typeface="Switzer"/>
+              </a:defRPr>
+            </a:pPr>
+            <a:r>
+              <a:rPr sz="1725">
+                <a:solidFill>
+                  <a:srgbClr val="F9F8FD"/>
+                </a:solidFill>
+                <a:latin typeface="Switzer"/>
+                <a:ea typeface="Switzer"/>
+                <a:cs typeface="Switzer"/>
+              </a:rPr>
+              <a:t>Held-out</a:t>
+            </a:r>
+          </a:p>
+          <a:p xmlns:a="http://schemas.openxmlformats.org/drawingml/2006/main">
+            <a:pPr algn="ctr">
+              <a:buNone/>
+              <a:defRPr sz="1725">
+                <a:solidFill>
+                  <a:srgbClr val="F9F8FD"/>
+                </a:solidFill>
+                <a:latin typeface="Switzer"/>
+                <a:ea typeface="Switzer"/>
+                <a:cs typeface="Switzer"/>
+              </a:defRPr>
+            </a:pPr>
+            <a:r>
+              <a:rPr sz="1725">
+                <a:solidFill>
+                  <a:srgbClr val="F9F8FD"/>
+                </a:solidFill>
+                <a:latin typeface="Switzer"/>
+                <a:ea typeface="Switzer"/>
+                <a:cs typeface="Switzer"/>
+              </a:rPr>
+              <a:t>protocol evaluation</a:t>
+            </a:r>
+          </a:p>
+        </p:txBody>
+      </p:sp>
+      <p:sp>
+        <p:nvSpPr>
+          <p:cNvPr id="58" name="capacity-label">
+            <a:extLst xmlns:a="http://schemas.openxmlformats.org/drawingml/2006/main">
+              <a:ext uri="{FF2B5EF4-FFF2-40B4-BE49-F238E27FC236}">
+                <a16:creationId xmlns:a16="http://schemas.microsoft.com/office/drawing/2014/main" id="{8D8C2023-E138-4063-847E-6B9C9CEDB863}"/>
+              </a:ext>
+            </a:extLst>
+          </p:cNvPr>
+          <p:cNvSpPr>
+            <a:spLocks xmlns:a="http://schemas.openxmlformats.org/drawingml/2006/main" noGrp="1"/>
+          </p:cNvSpPr>
+          <p:nvPr/>
+        </p:nvSpPr>
+        <p:spPr>
+          <a:xfrm xmlns:a="http://schemas.openxmlformats.org/drawingml/2006/main">
+            <a:off x="742950" y="3771900"/>
+            <a:ext cx="10620375" cy="361950"/>
           </a:xfrm>
           <a:prstGeom xmlns:a="http://schemas.openxmlformats.org/drawingml/2006/main" prst="rect">
             <a:avLst/>
@@ -15845,9 +16505,9 @@
           <a:p xmlns:a="http://schemas.openxmlformats.org/drawingml/2006/main">
             <a:pPr algn="l">
               <a:buNone/>
-              <a:defRPr sz="1575">
-                <a:solidFill>
-                  <a:srgbClr val="6AE8CD"/>
+              <a:defRPr sz="1500">
+                <a:solidFill>
+                  <a:srgbClr val="BCBBC2"/>
                 </a:solidFill>
                 <a:latin typeface="Consolas"/>
                 <a:ea typeface="Consolas"/>
@@ -15855,37 +16515,37 @@
               </a:defRPr>
             </a:pPr>
             <a:r>
-              <a:rPr sz="1575">
-                <a:solidFill>
-                  <a:srgbClr val="6AE8CD"/>
+              <a:rPr sz="1500">
+                <a:solidFill>
+                  <a:srgbClr val="BCBBC2"/>
                 </a:solidFill>
                 <a:latin typeface="Consolas"/>
                 <a:ea typeface="Consolas"/>
                 <a:cs typeface="Consolas"/>
               </a:rPr>
-              <a:t>ORCHESTRATION · AGENT ENGINEERING · ADOPTION</a:t>
-            </a:r>
-          </a:p>
-        </p:txBody>
-      </p:sp>
-      <p:sp>
-        <p:nvSpPr>
-          <p:cNvPr id="13" name="conference-source-detail">
-            <a:extLst xmlns:a="http://schemas.openxmlformats.org/drawingml/2006/main">
-              <a:ext uri="{FF2B5EF4-FFF2-40B4-BE49-F238E27FC236}">
-                <a16:creationId xmlns:a16="http://schemas.microsoft.com/office/drawing/2014/main" id="{A3FEC5EA-3EAE-4282-AB47-F3C37FFC92F0}"/>
-              </a:ext>
-            </a:extLst>
-          </p:cNvPr>
-          <p:cNvSpPr>
-            <a:spLocks xmlns:a="http://schemas.openxmlformats.org/drawingml/2006/main" noGrp="1"/>
-          </p:cNvSpPr>
-          <p:nvPr/>
-        </p:nvSpPr>
-        <p:spPr>
-          <a:xfrm xmlns:a="http://schemas.openxmlformats.org/drawingml/2006/main">
-            <a:off x="742950" y="5524500"/>
-            <a:ext cx="10610850" cy="314325"/>
+              <a:t>CAPTURE + EXPORT TODAY · ADAPTER TRAINING NEXT</a:t>
+            </a:r>
+          </a:p>
+        </p:txBody>
+      </p:sp>
+      <p:sp>
+        <p:nvSpPr>
+          <p:cNvPr id="59" name="panel-cap">
+            <a:extLst xmlns:a="http://schemas.openxmlformats.org/drawingml/2006/main">
+              <a:ext uri="{FF2B5EF4-FFF2-40B4-BE49-F238E27FC236}">
+                <a16:creationId xmlns:a16="http://schemas.microsoft.com/office/drawing/2014/main" id="{B3E36E69-0CC3-4DCB-90FD-7E13212D9B63}"/>
+              </a:ext>
+            </a:extLst>
+          </p:cNvPr>
+          <p:cNvSpPr>
+            <a:spLocks xmlns:a="http://schemas.openxmlformats.org/drawingml/2006/main" noGrp="1"/>
+          </p:cNvSpPr>
+          <p:nvPr/>
+        </p:nvSpPr>
+        <p:spPr>
+          <a:xfrm xmlns:a="http://schemas.openxmlformats.org/drawingml/2006/main">
+            <a:off x="742950" y="4276725"/>
+            <a:ext cx="4676775" cy="514350"/>
           </a:xfrm>
           <a:prstGeom xmlns:a="http://schemas.openxmlformats.org/drawingml/2006/main" prst="rect">
             <a:avLst/>
@@ -15904,9 +16564,276 @@
           <a:p xmlns:a="http://schemas.openxmlformats.org/drawingml/2006/main">
             <a:pPr algn="l">
               <a:buNone/>
+              <a:defRPr sz="2775">
+                <a:solidFill>
+                  <a:srgbClr val="CBAAFF"/>
+                </a:solidFill>
+                <a:latin typeface="Alliance No.2"/>
+                <a:ea typeface="Alliance No.2"/>
+                <a:cs typeface="Alliance No.2"/>
+              </a:defRPr>
+            </a:pPr>
+            <a:r>
+              <a:rPr sz="2775">
+                <a:solidFill>
+                  <a:srgbClr val="CBAAFF"/>
+                </a:solidFill>
+                <a:latin typeface="Alliance No.2"/>
+                <a:ea typeface="Alliance No.2"/>
+                <a:cs typeface="Alliance No.2"/>
+              </a:rPr>
+              <a:t>Implemented</a:t>
+            </a:r>
+          </a:p>
+        </p:txBody>
+      </p:sp>
+      <p:sp>
+        <p:nvSpPr>
+          <p:cNvPr id="60" name="panel-cap-label">
+            <a:extLst xmlns:a="http://schemas.openxmlformats.org/drawingml/2006/main">
+              <a:ext uri="{FF2B5EF4-FFF2-40B4-BE49-F238E27FC236}">
+                <a16:creationId xmlns:a16="http://schemas.microsoft.com/office/drawing/2014/main" id="{61790DCE-DF1C-4820-B630-C077678DB3A1}"/>
+              </a:ext>
+            </a:extLst>
+          </p:cNvPr>
+          <p:cNvSpPr>
+            <a:spLocks xmlns:a="http://schemas.openxmlformats.org/drawingml/2006/main" noGrp="1"/>
+          </p:cNvSpPr>
+          <p:nvPr/>
+        </p:nvSpPr>
+        <p:spPr>
+          <a:xfrm xmlns:a="http://schemas.openxmlformats.org/drawingml/2006/main">
+            <a:off x="742950" y="4867275"/>
+            <a:ext cx="4676775" cy="333375"/>
+          </a:xfrm>
+          <a:prstGeom xmlns:a="http://schemas.openxmlformats.org/drawingml/2006/main" prst="rect">
+            <a:avLst/>
+          </a:prstGeom>
+          <a:noFill xmlns:a="http://schemas.openxmlformats.org/drawingml/2006/main"/>
+          <a:ln xmlns:a="http://schemas.openxmlformats.org/drawingml/2006/main" w="0">
+            <a:noFill/>
+            <a:prstDash val="solid"/>
+          </a:ln>
+        </p:spPr>
+        <p:txBody>
+          <a:bodyPr xmlns:a="http://schemas.openxmlformats.org/drawingml/2006/main" wrap="none" lIns="0" tIns="0" rIns="0" bIns="0" anchor="ctr">
+            <a:noAutofit/>
+          </a:bodyPr>
+          <a:lstStyle xmlns:a="http://schemas.openxmlformats.org/drawingml/2006/main"/>
+          <a:p xmlns:a="http://schemas.openxmlformats.org/drawingml/2006/main">
+            <a:pPr algn="l">
+              <a:buNone/>
+              <a:defRPr sz="1800">
+                <a:solidFill>
+                  <a:srgbClr val="BCBBC2"/>
+                </a:solidFill>
+                <a:latin typeface="Switzer"/>
+                <a:ea typeface="Switzer"/>
+                <a:cs typeface="Switzer"/>
+              </a:defRPr>
+            </a:pPr>
+            <a:r>
+              <a:rPr sz="1800">
+                <a:solidFill>
+                  <a:srgbClr val="BCBBC2"/>
+                </a:solidFill>
+                <a:latin typeface="Switzer"/>
+                <a:ea typeface="Switzer"/>
+                <a:cs typeface="Switzer"/>
+              </a:rPr>
+              <a:t>Private capture · reviewed JSONL</a:t>
+            </a:r>
+          </a:p>
+        </p:txBody>
+      </p:sp>
+      <p:sp>
+        <p:nvSpPr>
+          <p:cNvPr id="61" name="global-cap">
+            <a:extLst xmlns:a="http://schemas.openxmlformats.org/drawingml/2006/main">
+              <a:ext uri="{FF2B5EF4-FFF2-40B4-BE49-F238E27FC236}">
+                <a16:creationId xmlns:a16="http://schemas.microsoft.com/office/drawing/2014/main" id="{D1B973D0-9EDB-4E4D-BE68-B5088A4760D8}"/>
+              </a:ext>
+            </a:extLst>
+          </p:cNvPr>
+          <p:cNvSpPr>
+            <a:spLocks xmlns:a="http://schemas.openxmlformats.org/drawingml/2006/main" noGrp="1"/>
+          </p:cNvSpPr>
+          <p:nvPr/>
+        </p:nvSpPr>
+        <p:spPr>
+          <a:xfrm xmlns:a="http://schemas.openxmlformats.org/drawingml/2006/main">
+            <a:off x="6315075" y="4276725"/>
+            <a:ext cx="5048250" cy="514350"/>
+          </a:xfrm>
+          <a:prstGeom xmlns:a="http://schemas.openxmlformats.org/drawingml/2006/main" prst="rect">
+            <a:avLst/>
+          </a:prstGeom>
+          <a:noFill xmlns:a="http://schemas.openxmlformats.org/drawingml/2006/main"/>
+          <a:ln xmlns:a="http://schemas.openxmlformats.org/drawingml/2006/main" w="0">
+            <a:noFill/>
+            <a:prstDash val="solid"/>
+          </a:ln>
+        </p:spPr>
+        <p:txBody>
+          <a:bodyPr xmlns:a="http://schemas.openxmlformats.org/drawingml/2006/main" wrap="none" lIns="0" tIns="0" rIns="0" bIns="0" anchor="ctr">
+            <a:noAutofit/>
+          </a:bodyPr>
+          <a:lstStyle xmlns:a="http://schemas.openxmlformats.org/drawingml/2006/main"/>
+          <a:p xmlns:a="http://schemas.openxmlformats.org/drawingml/2006/main">
+            <a:pPr algn="l">
+              <a:buNone/>
+              <a:defRPr sz="2775">
+                <a:solidFill>
+                  <a:srgbClr val="6AE8CD"/>
+                </a:solidFill>
+                <a:latin typeface="Alliance No.2"/>
+                <a:ea typeface="Alliance No.2"/>
+                <a:cs typeface="Alliance No.2"/>
+              </a:defRPr>
+            </a:pPr>
+            <a:r>
+              <a:rPr sz="2775">
+                <a:solidFill>
+                  <a:srgbClr val="6AE8CD"/>
+                </a:solidFill>
+                <a:latin typeface="Alliance No.2"/>
+                <a:ea typeface="Alliance No.2"/>
+                <a:cs typeface="Alliance No.2"/>
+              </a:rPr>
+              <a:t>Next milestone</a:t>
+            </a:r>
+          </a:p>
+        </p:txBody>
+      </p:sp>
+      <p:sp>
+        <p:nvSpPr>
+          <p:cNvPr id="62" name="global-cap-label">
+            <a:extLst xmlns:a="http://schemas.openxmlformats.org/drawingml/2006/main">
+              <a:ext uri="{FF2B5EF4-FFF2-40B4-BE49-F238E27FC236}">
+                <a16:creationId xmlns:a16="http://schemas.microsoft.com/office/drawing/2014/main" id="{552E0489-325C-426E-826D-1E7EE30ABA47}"/>
+              </a:ext>
+            </a:extLst>
+          </p:cNvPr>
+          <p:cNvSpPr>
+            <a:spLocks xmlns:a="http://schemas.openxmlformats.org/drawingml/2006/main" noGrp="1"/>
+          </p:cNvSpPr>
+          <p:nvPr/>
+        </p:nvSpPr>
+        <p:spPr>
+          <a:xfrm xmlns:a="http://schemas.openxmlformats.org/drawingml/2006/main">
+            <a:off x="6315075" y="4867275"/>
+            <a:ext cx="5048250" cy="333375"/>
+          </a:xfrm>
+          <a:prstGeom xmlns:a="http://schemas.openxmlformats.org/drawingml/2006/main" prst="rect">
+            <a:avLst/>
+          </a:prstGeom>
+          <a:noFill xmlns:a="http://schemas.openxmlformats.org/drawingml/2006/main"/>
+          <a:ln xmlns:a="http://schemas.openxmlformats.org/drawingml/2006/main" w="0">
+            <a:noFill/>
+            <a:prstDash val="solid"/>
+          </a:ln>
+        </p:spPr>
+        <p:txBody>
+          <a:bodyPr xmlns:a="http://schemas.openxmlformats.org/drawingml/2006/main" wrap="none" lIns="0" tIns="0" rIns="0" bIns="0" anchor="ctr">
+            <a:noAutofit/>
+          </a:bodyPr>
+          <a:lstStyle xmlns:a="http://schemas.openxmlformats.org/drawingml/2006/main"/>
+          <a:p xmlns:a="http://schemas.openxmlformats.org/drawingml/2006/main">
+            <a:pPr algn="l">
+              <a:buNone/>
+              <a:defRPr sz="1800">
+                <a:solidFill>
+                  <a:srgbClr val="BCBBC2"/>
+                </a:solidFill>
+                <a:latin typeface="Switzer"/>
+                <a:ea typeface="Switzer"/>
+                <a:cs typeface="Switzer"/>
+              </a:defRPr>
+            </a:pPr>
+            <a:r>
+              <a:rPr sz="1800">
+                <a:solidFill>
+                  <a:srgbClr val="BCBBC2"/>
+                </a:solidFill>
+                <a:latin typeface="Switzer"/>
+                <a:ea typeface="Switzer"/>
+                <a:cs typeface="Switzer"/>
+              </a:rPr>
+              <a:t>Train, test and compare per model</a:t>
+            </a:r>
+          </a:p>
+        </p:txBody>
+      </p:sp>
+      <p:sp>
+        <p:nvSpPr>
+          <p:cNvPr id="63" name="cap-divider">
+            <a:extLst xmlns:a="http://schemas.openxmlformats.org/drawingml/2006/main">
+              <a:ext uri="{FF2B5EF4-FFF2-40B4-BE49-F238E27FC236}">
+                <a16:creationId xmlns:a16="http://schemas.microsoft.com/office/drawing/2014/main" id="{B7B5CE8F-7949-4D63-9DE3-364604C54DA5}"/>
+              </a:ext>
+            </a:extLst>
+          </p:cNvPr>
+          <p:cNvSpPr>
+            <a:spLocks xmlns:a="http://schemas.openxmlformats.org/drawingml/2006/main" noGrp="1"/>
+          </p:cNvSpPr>
+          <p:nvPr/>
+        </p:nvSpPr>
+        <p:spPr>
+          <a:xfrm xmlns:a="http://schemas.openxmlformats.org/drawingml/2006/main">
+            <a:off x="742950" y="5476875"/>
+            <a:ext cx="10620375" cy="0"/>
+          </a:xfrm>
+          <a:prstGeom xmlns:a="http://schemas.openxmlformats.org/drawingml/2006/main" prst="line">
+            <a:avLst/>
+          </a:prstGeom>
+          <a:noFill xmlns:a="http://schemas.openxmlformats.org/drawingml/2006/main"/>
+          <a:ln xmlns:a="http://schemas.openxmlformats.org/drawingml/2006/main" w="16193">
+            <a:solidFill>
+              <a:srgbClr val="838289"/>
+            </a:solidFill>
+            <a:prstDash val="solid"/>
+          </a:ln>
+        </p:spPr>
+      </p:sp>
+      <p:sp>
+        <p:nvSpPr>
+          <p:cNvPr id="64" name="limits">
+            <a:extLst xmlns:a="http://schemas.openxmlformats.org/drawingml/2006/main">
+              <a:ext uri="{FF2B5EF4-FFF2-40B4-BE49-F238E27FC236}">
+                <a16:creationId xmlns:a16="http://schemas.microsoft.com/office/drawing/2014/main" id="{BDD94E20-CF17-4DF5-AB23-BB97C4CB1F44}"/>
+              </a:ext>
+            </a:extLst>
+          </p:cNvPr>
+          <p:cNvSpPr>
+            <a:spLocks xmlns:a="http://schemas.openxmlformats.org/drawingml/2006/main" noGrp="1"/>
+          </p:cNvSpPr>
+          <p:nvPr/>
+        </p:nvSpPr>
+        <p:spPr>
+          <a:xfrm xmlns:a="http://schemas.openxmlformats.org/drawingml/2006/main">
+            <a:off x="742950" y="5676900"/>
+            <a:ext cx="10668000" cy="581025"/>
+          </a:xfrm>
+          <a:prstGeom xmlns:a="http://schemas.openxmlformats.org/drawingml/2006/main" prst="rect">
+            <a:avLst/>
+          </a:prstGeom>
+          <a:noFill xmlns:a="http://schemas.openxmlformats.org/drawingml/2006/main"/>
+          <a:ln xmlns:a="http://schemas.openxmlformats.org/drawingml/2006/main" w="0">
+            <a:noFill/>
+            <a:prstDash val="solid"/>
+          </a:ln>
+        </p:spPr>
+        <p:txBody>
+          <a:bodyPr xmlns:a="http://schemas.openxmlformats.org/drawingml/2006/main" wrap="none" lIns="0" tIns="0" rIns="0" bIns="0" anchor="ctr">
+            <a:noAutofit/>
+          </a:bodyPr>
+          <a:lstStyle xmlns:a="http://schemas.openxmlformats.org/drawingml/2006/main"/>
+          <a:p xmlns:a="http://schemas.openxmlformats.org/drawingml/2006/main">
+            <a:pPr algn="l">
+              <a:buNone/>
               <a:defRPr sz="1725">
                 <a:solidFill>
-                  <a:srgbClr val="BCBBC2"/>
+                  <a:srgbClr val="F9F8FD"/>
                 </a:solidFill>
                 <a:latin typeface="Switzer"/>
                 <a:ea typeface="Switzer"/>
@@ -15916,13 +16843,37 @@
             <a:r>
               <a:rPr sz="1725">
                 <a:solidFill>
-                  <a:srgbClr val="BCBBC2"/>
-                </a:solidFill>
-                <a:latin typeface="Switzer"/>
-                <a:ea typeface="Switzer"/>
-                <a:cs typeface="Switzer"/>
-              </a:rPr>
-              <a:t>Crowne Plaza Warsaw [The HUB]</a:t>
+                  <a:srgbClr val="F9F8FD"/>
+                </a:solidFill>
+                <a:latin typeface="Switzer"/>
+                <a:ea typeface="Switzer"/>
+                <a:cs typeface="Switzer"/>
+              </a:rPr>
+              <a:t>Portable data. A separate adapter for each compatible base model.</a:t>
+            </a:r>
+          </a:p>
+          <a:p xmlns:a="http://schemas.openxmlformats.org/drawingml/2006/main">
+            <a:pPr algn="l">
+              <a:buNone/>
+              <a:defRPr sz="1725">
+                <a:solidFill>
+                  <a:srgbClr val="F9F8FD"/>
+                </a:solidFill>
+                <a:latin typeface="Switzer"/>
+                <a:ea typeface="Switzer"/>
+                <a:cs typeface="Switzer"/>
+              </a:defRPr>
+            </a:pPr>
+            <a:r>
+              <a:rPr sz="1725">
+                <a:solidFill>
+                  <a:srgbClr val="F9F8FD"/>
+                </a:solidFill>
+                <a:latin typeface="Switzer"/>
+                <a:ea typeface="Switzer"/>
+                <a:cs typeface="Switzer"/>
+              </a:rPr>
+              <a:t>Fine-tuning is planned; runtime routing guards remain mandatory.</a:t>
             </a:r>
           </a:p>
         </p:txBody>
@@ -15930,7 +16881,7 @@
     </p:spTree>
     <p:extLst>
       <p:ext uri="{BB962C8B-B14F-4D97-AF65-F5344CB8AC3E}">
-        <p14:creationId xmlns:p14="http://schemas.microsoft.com/office/powerpoint/2010/main" val="1080936326"/>
+        <p14:creationId xmlns:p14="http://schemas.microsoft.com/office/powerpoint/2010/main" val="107637514"/>
       </p:ext>
     </p:extLst>
   </p:cSld>
@@ -16116,7 +17067,7 @@
                 <a:ea typeface="Consolas"/>
                 <a:cs typeface="Consolas"/>
               </a:rPr>
-              <a:t>2/20</a:t>
+              <a:t>2/21</a:t>
             </a:r>
           </a:p>
         </p:txBody>
@@ -16163,7 +17114,7 @@
           <p:nvPr/>
         </p:nvPicPr>
         <p:blipFill>
-          <a:blip xmlns:r="http://schemas.openxmlformats.org/officeDocument/2006/relationships" xmlns:a="http://schemas.openxmlformats.org/drawingml/2006/main" r:embed="R58f7c73fe82d46f8"/>
+          <a:blip xmlns:r="http://schemas.openxmlformats.org/officeDocument/2006/relationships" xmlns:a="http://schemas.openxmlformats.org/drawingml/2006/main" r:embed="R9485c71ef5c7448c"/>
           <a:stretch xmlns:a="http://schemas.openxmlformats.org/drawingml/2006/main"/>
         </p:blipFill>
         <p:spPr>
@@ -16588,20 +17539,20 @@
       </p:grpSpPr>
       <p:pic>
         <p:nvPicPr>
-          <p:cNvPr id="12" name="Picture 1"/>
+          <p:cNvPr id="16" name="Picture 1"/>
           <p:cNvPicPr>
             <a:picLocks xmlns:a="http://schemas.openxmlformats.org/drawingml/2006/main" noChangeAspect="1"/>
           </p:cNvPicPr>
           <p:nvPr/>
         </p:nvPicPr>
         <p:blipFill>
-          <a:blip xmlns:r="http://schemas.openxmlformats.org/officeDocument/2006/relationships" xmlns:a="http://schemas.openxmlformats.org/drawingml/2006/main" r:embed="Re9bd2f31735c4891"/>
+          <a:blip xmlns:r="http://schemas.openxmlformats.org/officeDocument/2006/relationships" xmlns:a="http://schemas.openxmlformats.org/drawingml/2006/main" r:embed="R3531baf9d6384d67"/>
           <a:stretch xmlns:a="http://schemas.openxmlformats.org/drawingml/2006/main"/>
         </p:blipFill>
         <p:spPr>
           <a:xfrm xmlns:a="http://schemas.openxmlformats.org/drawingml/2006/main" flipH="0" flipV="0">
-            <a:off x="10039350" y="723900"/>
-            <a:ext cx="1066800" cy="1066800"/>
+            <a:off x="9953625" y="800100"/>
+            <a:ext cx="1143000" cy="1143000"/>
           </a:xfrm>
           <a:prstGeom xmlns:a="http://schemas.openxmlformats.org/drawingml/2006/main" prst="rect">
             <a:avLst/>
@@ -16624,8 +17575,8 @@
         </p:nvSpPr>
         <p:spPr>
           <a:xfrm xmlns:a="http://schemas.openxmlformats.org/drawingml/2006/main">
-            <a:off x="609600" y="1952625"/>
-            <a:ext cx="9810750" cy="1234440"/>
+            <a:off x="742950" y="1933575"/>
+            <a:ext cx="10477500" cy="752475"/>
           </a:xfrm>
           <a:prstGeom xmlns:a="http://schemas.openxmlformats.org/drawingml/2006/main" prst="rect">
             <a:avLst/>
@@ -16633,16 +17584,16 @@
           <a:noFill xmlns:a="http://schemas.openxmlformats.org/drawingml/2006/main"/>
         </p:spPr>
         <p:txBody>
-          <a:bodyPr xmlns:a="http://schemas.openxmlformats.org/drawingml/2006/main" wrap="square">
-            <a:spAutoFit/>
+          <a:bodyPr xmlns:a="http://schemas.openxmlformats.org/drawingml/2006/main" wrap="none" lIns="0" tIns="0" rIns="0" bIns="0" anchor="ctr">
+            <a:noAutofit/>
           </a:bodyPr>
           <a:lstStyle xmlns:a="http://schemas.openxmlformats.org/drawingml/2006/main"/>
           <a:p xmlns:a="http://schemas.openxmlformats.org/drawingml/2006/main">
             <a:pPr algn="l">
               <a:buNone/>
-              <a:defRPr sz="3750" b="0">
-                <a:solidFill>
-                  <a:srgbClr val="FFFFFF"/>
+              <a:defRPr sz="3600" b="0">
+                <a:solidFill>
+                  <a:srgbClr val="F9F8FD"/>
                 </a:solidFill>
                 <a:latin typeface="Alliance No.2"/>
                 <a:ea typeface="Alliance No.2"/>
@@ -16650,15 +17601,15 @@
               </a:defRPr>
             </a:pPr>
             <a:r>
-              <a:rPr sz="3750" b="0">
-                <a:solidFill>
-                  <a:srgbClr val="FFFFFF"/>
+              <a:rPr sz="3600" b="0">
+                <a:solidFill>
+                  <a:srgbClr val="F9F8FD"/>
                 </a:solidFill>
                 <a:latin typeface="Alliance No.2"/>
                 <a:ea typeface="Alliance No.2"/>
                 <a:cs typeface="Alliance No.2"/>
               </a:rPr>
-              <a:t>Where should agent collaboration fail closed?</a:t>
+              <a:t>Meet us at Agent Conf.</a:t>
             </a:r>
           </a:p>
         </p:txBody>
@@ -16679,8 +17630,8 @@
         </p:nvSpPr>
         <p:spPr>
           <a:xfrm xmlns:a="http://schemas.openxmlformats.org/drawingml/2006/main">
-            <a:off x="609600" y="3067050"/>
-            <a:ext cx="8858250" cy="457200"/>
+            <a:off x="742950" y="2800350"/>
+            <a:ext cx="10610850" cy="466725"/>
           </a:xfrm>
           <a:prstGeom xmlns:a="http://schemas.openxmlformats.org/drawingml/2006/main" prst="rect">
             <a:avLst/>
@@ -16688,32 +17639,32 @@
           <a:noFill xmlns:a="http://schemas.openxmlformats.org/drawingml/2006/main"/>
         </p:spPr>
         <p:txBody>
-          <a:bodyPr xmlns:a="http://schemas.openxmlformats.org/drawingml/2006/main" wrap="square">
-            <a:spAutoFit/>
+          <a:bodyPr xmlns:a="http://schemas.openxmlformats.org/drawingml/2006/main" wrap="none" lIns="0" tIns="0" rIns="0" bIns="0" anchor="ctr">
+            <a:noAutofit/>
           </a:bodyPr>
           <a:lstStyle xmlns:a="http://schemas.openxmlformats.org/drawingml/2006/main"/>
           <a:p xmlns:a="http://schemas.openxmlformats.org/drawingml/2006/main">
             <a:pPr algn="l">
               <a:buNone/>
-              <a:defRPr sz="1800" b="0">
-                <a:solidFill>
-                  <a:srgbClr val="E9E7EE"/>
-                </a:solidFill>
-                <a:latin typeface="Switzer"/>
-                <a:ea typeface="Switzer"/>
-                <a:cs typeface="Switzer"/>
-              </a:defRPr>
-            </a:pPr>
-            <a:r>
-              <a:rPr sz="1800" b="0">
-                <a:solidFill>
-                  <a:srgbClr val="E9E7EE"/>
-                </a:solidFill>
-                <a:latin typeface="Switzer"/>
-                <a:ea typeface="Switzer"/>
-                <a:cs typeface="Switzer"/>
-              </a:rPr>
-              <a:t>Context • disagreement • auditability • human control</a:t>
+              <a:defRPr sz="2250" b="0">
+                <a:solidFill>
+                  <a:srgbClr val="CBAAFF"/>
+                </a:solidFill>
+                <a:latin typeface="Consolas"/>
+                <a:ea typeface="Consolas"/>
+                <a:cs typeface="Consolas"/>
+              </a:defRPr>
+            </a:pPr>
+            <a:r>
+              <a:rPr sz="2250" b="0">
+                <a:solidFill>
+                  <a:srgbClr val="CBAAFF"/>
+                </a:solidFill>
+                <a:latin typeface="Consolas"/>
+                <a:ea typeface="Consolas"/>
+                <a:cs typeface="Consolas"/>
+              </a:rPr>
+              <a:t>17–18 September 2026 · Warsaw</a:t>
             </a:r>
           </a:p>
         </p:txBody>
@@ -16734,20 +17685,18 @@
         </p:nvSpPr>
         <p:spPr>
           <a:xfrm xmlns:a="http://schemas.openxmlformats.org/drawingml/2006/main">
-            <a:off x="609600" y="3905250"/>
-            <a:ext cx="7524750" cy="1645920"/>
+            <a:off x="742950" y="3476625"/>
+            <a:ext cx="10629900" cy="962025"/>
           </a:xfrm>
           <a:prstGeom xmlns:a="http://schemas.openxmlformats.org/drawingml/2006/main" prst="roundRect">
             <a:avLst>
               <a:gd name="adj" fmla="val 4630"/>
             </a:avLst>
           </a:prstGeom>
-          <a:solidFill xmlns:a="http://schemas.openxmlformats.org/drawingml/2006/main">
-            <a:srgbClr val="000000"/>
-          </a:solidFill>
+          <a:noFill xmlns:a="http://schemas.openxmlformats.org/drawingml/2006/main"/>
           <a:ln xmlns:a="http://schemas.openxmlformats.org/drawingml/2006/main" w="9525">
             <a:solidFill>
-              <a:srgbClr val="8232FF"/>
+              <a:srgbClr val="CBAAFF"/>
             </a:solidFill>
             <a:prstDash val="solid"/>
           </a:ln>
@@ -16790,8 +17739,8 @@
         </p:nvSpPr>
         <p:spPr>
           <a:xfrm xmlns:a="http://schemas.openxmlformats.org/drawingml/2006/main">
-            <a:off x="876300" y="4133850"/>
-            <a:ext cx="6953250" cy="1314450"/>
+            <a:off x="990600" y="3705225"/>
+            <a:ext cx="10163175" cy="533400"/>
           </a:xfrm>
           <a:prstGeom xmlns:a="http://schemas.openxmlformats.org/drawingml/2006/main" prst="rect">
             <a:avLst/>
@@ -16799,8 +17748,8 @@
           <a:noFill xmlns:a="http://schemas.openxmlformats.org/drawingml/2006/main"/>
         </p:spPr>
         <p:txBody>
-          <a:bodyPr xmlns:a="http://schemas.openxmlformats.org/drawingml/2006/main" wrap="square">
-            <a:spAutoFit/>
+          <a:bodyPr xmlns:a="http://schemas.openxmlformats.org/drawingml/2006/main" wrap="none" lIns="0" tIns="0" rIns="0" bIns="0" anchor="ctr">
+            <a:noAutofit/>
           </a:bodyPr>
           <a:lstStyle xmlns:a="http://schemas.openxmlformats.org/drawingml/2006/main"/>
           <a:p xmlns:a="http://schemas.openxmlformats.org/drawingml/2006/main">
@@ -16809,9 +17758,9 @@
                 <a:spcPts val="400"/>
               </a:spcAft>
               <a:buNone/>
-              <a:defRPr sz="1500" b="0">
-                <a:solidFill>
-                  <a:srgbClr val="E9E7EE"/>
+              <a:defRPr sz="2550" b="0">
+                <a:solidFill>
+                  <a:srgbClr val="F9F8FD"/>
                 </a:solidFill>
                 <a:latin typeface="Consolas"/>
                 <a:ea typeface="Consolas"/>
@@ -16819,17 +17768,596 @@
               </a:defRPr>
             </a:pPr>
             <a:r>
-              <a:rPr sz="1500" b="0">
-                <a:solidFill>
-                  <a:srgbClr val="E9E7EE"/>
+              <a:rPr sz="2550" b="0">
+                <a:solidFill>
+                  <a:srgbClr val="F9F8FD"/>
                 </a:solidFill>
                 <a:latin typeface="Consolas"/>
                 <a:ea typeface="Consolas"/>
                 <a:cs typeface="Consolas"/>
-              </a:rPr>
-              <a:t>&gt; What evidence must survive every handoff?</a:t>
-            </a:r>
-          </a:p>
+                <a:hlinkClick xmlns:r="http://schemas.openxmlformats.org/officeDocument/2006/relationships" r:id="R68a19983b6144947"/>
+              </a:rPr>
+              <a:t>agent.sh/tickets</a:t>
+            </a:r>
+            <a:r>
+              <a:rPr sz="2550" b="0">
+                <a:solidFill>
+                  <a:srgbClr val="F9F8FD"/>
+                </a:solidFill>
+                <a:latin typeface="Consolas"/>
+                <a:ea typeface="Consolas"/>
+                <a:cs typeface="Consolas"/>
+              </a:rPr>
+              <a:t> →</a:t>
+            </a:r>
+          </a:p>
+        </p:txBody>
+      </p:sp>
+      <p:sp>
+        <p:nvSpPr>
+          <p:cNvPr id="7" name="TextBox 6">
+            <a:extLst xmlns:a="http://schemas.openxmlformats.org/drawingml/2006/main">
+              <a:ext uri="{FF2B5EF4-FFF2-40B4-BE49-F238E27FC236}">
+                <a16:creationId xmlns:a16="http://schemas.microsoft.com/office/drawing/2014/main" id="{7AEC0BD1-4425-4206-AEB3-0B15BB9F0F58}"/>
+              </a:ext>
+            </a:extLst>
+          </p:cNvPr>
+          <p:cNvSpPr>
+            <a:spLocks xmlns:a="http://schemas.openxmlformats.org/drawingml/2006/main" noGrp="1"/>
+          </p:cNvSpPr>
+          <p:nvPr/>
+        </p:nvSpPr>
+        <p:spPr>
+          <a:xfrm xmlns:a="http://schemas.openxmlformats.org/drawingml/2006/main">
+            <a:off x="742950" y="4600575"/>
+            <a:ext cx="10620375" cy="361950"/>
+          </a:xfrm>
+          <a:prstGeom xmlns:a="http://schemas.openxmlformats.org/drawingml/2006/main" prst="rect">
+            <a:avLst/>
+          </a:prstGeom>
+          <a:noFill xmlns:a="http://schemas.openxmlformats.org/drawingml/2006/main"/>
+        </p:spPr>
+        <p:txBody>
+          <a:bodyPr xmlns:a="http://schemas.openxmlformats.org/drawingml/2006/main" wrap="none" lIns="0" tIns="0" rIns="0" bIns="0" anchor="ctr">
+            <a:noAutofit/>
+          </a:bodyPr>
+          <a:lstStyle xmlns:a="http://schemas.openxmlformats.org/drawingml/2006/main"/>
+          <a:p xmlns:a="http://schemas.openxmlformats.org/drawingml/2006/main">
+            <a:pPr algn="l">
+              <a:buNone/>
+              <a:defRPr sz="1800" b="0">
+                <a:solidFill>
+                  <a:srgbClr val="F9F8FD"/>
+                </a:solidFill>
+                <a:latin typeface="Consolas"/>
+                <a:ea typeface="Consolas"/>
+                <a:cs typeface="Consolas"/>
+              </a:defRPr>
+            </a:pPr>
+            <a:r>
+              <a:rPr sz="1800" b="0">
+                <a:solidFill>
+                  <a:srgbClr val="F9F8FD"/>
+                </a:solidFill>
+                <a:latin typeface="Consolas"/>
+                <a:ea typeface="Consolas"/>
+                <a:cs typeface="Consolas"/>
+              </a:rPr>
+              <a:t>Two days for engineers building with AI agents.</a:t>
+            </a:r>
+          </a:p>
+        </p:txBody>
+      </p:sp>
+      <p:sp>
+        <p:nvSpPr>
+          <p:cNvPr id="8" name="TextBox 7">
+            <a:extLst xmlns:a="http://schemas.openxmlformats.org/drawingml/2006/main">
+              <a:ext uri="{FF2B5EF4-FFF2-40B4-BE49-F238E27FC236}">
+                <a16:creationId xmlns:a16="http://schemas.microsoft.com/office/drawing/2014/main" id="{963D474F-FEA2-485F-BA06-028DDF433761}"/>
+              </a:ext>
+            </a:extLst>
+          </p:cNvPr>
+          <p:cNvSpPr>
+            <a:spLocks xmlns:a="http://schemas.openxmlformats.org/drawingml/2006/main" noGrp="1"/>
+          </p:cNvSpPr>
+          <p:nvPr/>
+        </p:nvSpPr>
+        <p:spPr>
+          <a:xfrm xmlns:a="http://schemas.openxmlformats.org/drawingml/2006/main">
+            <a:off x="742950" y="5962650"/>
+            <a:ext cx="10620375" cy="295275"/>
+          </a:xfrm>
+          <a:prstGeom xmlns:a="http://schemas.openxmlformats.org/drawingml/2006/main" prst="rect">
+            <a:avLst/>
+          </a:prstGeom>
+          <a:noFill xmlns:a="http://schemas.openxmlformats.org/drawingml/2006/main"/>
+        </p:spPr>
+        <p:txBody>
+          <a:bodyPr xmlns:a="http://schemas.openxmlformats.org/drawingml/2006/main" wrap="none" lIns="0" tIns="0" rIns="0" bIns="0" anchor="ctr">
+            <a:noAutofit/>
+          </a:bodyPr>
+          <a:lstStyle xmlns:a="http://schemas.openxmlformats.org/drawingml/2006/main"/>
+          <a:p xmlns:a="http://schemas.openxmlformats.org/drawingml/2006/main">
+            <a:pPr algn="l">
+              <a:buNone/>
+              <a:defRPr sz="1500" b="0">
+                <a:solidFill>
+                  <a:srgbClr val="BCBBC2"/>
+                </a:solidFill>
+                <a:latin typeface="Switzer"/>
+                <a:ea typeface="Switzer"/>
+                <a:cs typeface="Switzer"/>
+              </a:defRPr>
+            </a:pPr>
+            <a:r>
+              <a:rPr sz="1500" b="0">
+                <a:solidFill>
+                  <a:srgbClr val="BCBBC2"/>
+                </a:solidFill>
+                <a:latin typeface="Switzer"/>
+                <a:ea typeface="Switzer"/>
+                <a:cs typeface="Switzer"/>
+              </a:rPr>
+              <a:t>Hosted by Callstack · Details: agent.sh</a:t>
+            </a:r>
+          </a:p>
+        </p:txBody>
+      </p:sp>
+      <p:sp>
+        <p:nvSpPr>
+          <p:cNvPr id="9" name="TextBox 8">
+            <a:extLst xmlns:a="http://schemas.openxmlformats.org/drawingml/2006/main">
+              <a:ext uri="{FF2B5EF4-FFF2-40B4-BE49-F238E27FC236}">
+                <a16:creationId xmlns:a16="http://schemas.microsoft.com/office/drawing/2014/main" id="{5251B42F-0482-4A79-9E65-262FA0FD07C6}"/>
+              </a:ext>
+            </a:extLst>
+          </p:cNvPr>
+          <p:cNvSpPr>
+            <a:spLocks xmlns:a="http://schemas.openxmlformats.org/drawingml/2006/main" noGrp="1"/>
+          </p:cNvSpPr>
+          <p:nvPr/>
+        </p:nvSpPr>
+        <p:spPr>
+          <a:xfrm xmlns:a="http://schemas.openxmlformats.org/drawingml/2006/main">
+            <a:off x="10668000" y="6419850"/>
+            <a:ext cx="857250" cy="285750"/>
+          </a:xfrm>
+          <a:prstGeom xmlns:a="http://schemas.openxmlformats.org/drawingml/2006/main" prst="rect">
+            <a:avLst/>
+          </a:prstGeom>
+          <a:noFill xmlns:a="http://schemas.openxmlformats.org/drawingml/2006/main"/>
+        </p:spPr>
+        <p:txBody>
+          <a:bodyPr xmlns:a="http://schemas.openxmlformats.org/drawingml/2006/main" wrap="none" lIns="0" tIns="0" rIns="0" bIns="0" anchor="ctr">
+            <a:noAutofit/>
+          </a:bodyPr>
+          <a:lstStyle xmlns:a="http://schemas.openxmlformats.org/drawingml/2006/main"/>
+          <a:p xmlns:a="http://schemas.openxmlformats.org/drawingml/2006/main">
+            <a:pPr algn="r">
+              <a:buNone/>
+              <a:defRPr sz="1200" b="0">
+                <a:solidFill>
+                  <a:srgbClr val="BCBBC2"/>
+                </a:solidFill>
+                <a:latin typeface="Consolas"/>
+                <a:ea typeface="Consolas"/>
+                <a:cs typeface="Consolas"/>
+              </a:defRPr>
+            </a:pPr>
+            <a:r>
+              <a:rPr sz="1200" b="0">
+                <a:solidFill>
+                  <a:srgbClr val="BCBBC2"/>
+                </a:solidFill>
+                <a:latin typeface="Consolas"/>
+                <a:ea typeface="Consolas"/>
+                <a:cs typeface="Consolas"/>
+              </a:rPr>
+              <a:t>20/21</a:t>
+            </a:r>
+          </a:p>
+        </p:txBody>
+      </p:sp>
+      <p:pic>
+        <p:nvPicPr>
+          <p:cNvPr id="24" name=""/>
+          <p:cNvPicPr>
+            <a:picLocks xmlns:a="http://schemas.openxmlformats.org/drawingml/2006/main" noChangeAspect="1"/>
+          </p:cNvPicPr>
+          <p:nvPr/>
+        </p:nvPicPr>
+        <p:blipFill>
+          <a:blip xmlns:r="http://schemas.openxmlformats.org/officeDocument/2006/relationships" xmlns:a="http://schemas.openxmlformats.org/drawingml/2006/main" r:embed="R3f560e4a3b904cfa"/>
+          <a:stretch xmlns:a="http://schemas.openxmlformats.org/drawingml/2006/main"/>
+        </p:blipFill>
+        <p:spPr>
+          <a:xfrm xmlns:a="http://schemas.openxmlformats.org/drawingml/2006/main">
+            <a:off x="692604" y="342900"/>
+            <a:ext cx="1567543" cy="342900"/>
+          </a:xfrm>
+          <a:prstGeom xmlns:a="http://schemas.openxmlformats.org/drawingml/2006/main" prst="rect">
+            <a:avLst/>
+          </a:prstGeom>
+        </p:spPr>
+      </p:pic>
+      <p:sp>
+        <p:nvSpPr>
+          <p:cNvPr id="12" name="conference-source-label">
+            <a:extLst xmlns:a="http://schemas.openxmlformats.org/drawingml/2006/main">
+              <a:ext uri="{FF2B5EF4-FFF2-40B4-BE49-F238E27FC236}">
+                <a16:creationId xmlns:a16="http://schemas.microsoft.com/office/drawing/2014/main" id="{F6AD476A-8E8A-47D1-B5AB-E79E6FB8E588}"/>
+              </a:ext>
+            </a:extLst>
+          </p:cNvPr>
+          <p:cNvSpPr>
+            <a:spLocks xmlns:a="http://schemas.openxmlformats.org/drawingml/2006/main" noGrp="1"/>
+          </p:cNvSpPr>
+          <p:nvPr/>
+        </p:nvSpPr>
+        <p:spPr>
+          <a:xfrm xmlns:a="http://schemas.openxmlformats.org/drawingml/2006/main">
+            <a:off x="742950" y="5143500"/>
+            <a:ext cx="10610850" cy="304800"/>
+          </a:xfrm>
+          <a:prstGeom xmlns:a="http://schemas.openxmlformats.org/drawingml/2006/main" prst="rect">
+            <a:avLst/>
+          </a:prstGeom>
+          <a:noFill xmlns:a="http://schemas.openxmlformats.org/drawingml/2006/main"/>
+          <a:ln xmlns:a="http://schemas.openxmlformats.org/drawingml/2006/main" w="0">
+            <a:noFill/>
+            <a:prstDash val="solid"/>
+          </a:ln>
+        </p:spPr>
+        <p:txBody>
+          <a:bodyPr xmlns:a="http://schemas.openxmlformats.org/drawingml/2006/main" wrap="none" lIns="0" tIns="0" rIns="0" bIns="0" anchor="ctr">
+            <a:noAutofit/>
+          </a:bodyPr>
+          <a:lstStyle xmlns:a="http://schemas.openxmlformats.org/drawingml/2006/main"/>
+          <a:p xmlns:a="http://schemas.openxmlformats.org/drawingml/2006/main">
+            <a:pPr algn="l">
+              <a:buNone/>
+              <a:defRPr sz="1575">
+                <a:solidFill>
+                  <a:srgbClr val="6AE8CD"/>
+                </a:solidFill>
+                <a:latin typeface="Consolas"/>
+                <a:ea typeface="Consolas"/>
+                <a:cs typeface="Consolas"/>
+              </a:defRPr>
+            </a:pPr>
+            <a:r>
+              <a:rPr sz="1575">
+                <a:solidFill>
+                  <a:srgbClr val="6AE8CD"/>
+                </a:solidFill>
+                <a:latin typeface="Consolas"/>
+                <a:ea typeface="Consolas"/>
+                <a:cs typeface="Consolas"/>
+              </a:rPr>
+              <a:t>ORCHESTRATION · AGENT ENGINEERING · ADOPTION</a:t>
+            </a:r>
+          </a:p>
+        </p:txBody>
+      </p:sp>
+      <p:sp>
+        <p:nvSpPr>
+          <p:cNvPr id="13" name="conference-source-detail">
+            <a:extLst xmlns:a="http://schemas.openxmlformats.org/drawingml/2006/main">
+              <a:ext uri="{FF2B5EF4-FFF2-40B4-BE49-F238E27FC236}">
+                <a16:creationId xmlns:a16="http://schemas.microsoft.com/office/drawing/2014/main" id="{A3FEC5EA-3EAE-4282-AB47-F3C37FFC92F0}"/>
+              </a:ext>
+            </a:extLst>
+          </p:cNvPr>
+          <p:cNvSpPr>
+            <a:spLocks xmlns:a="http://schemas.openxmlformats.org/drawingml/2006/main" noGrp="1"/>
+          </p:cNvSpPr>
+          <p:nvPr/>
+        </p:nvSpPr>
+        <p:spPr>
+          <a:xfrm xmlns:a="http://schemas.openxmlformats.org/drawingml/2006/main">
+            <a:off x="742950" y="5524500"/>
+            <a:ext cx="10610850" cy="314325"/>
+          </a:xfrm>
+          <a:prstGeom xmlns:a="http://schemas.openxmlformats.org/drawingml/2006/main" prst="rect">
+            <a:avLst/>
+          </a:prstGeom>
+          <a:noFill xmlns:a="http://schemas.openxmlformats.org/drawingml/2006/main"/>
+          <a:ln xmlns:a="http://schemas.openxmlformats.org/drawingml/2006/main" w="0">
+            <a:noFill/>
+            <a:prstDash val="solid"/>
+          </a:ln>
+        </p:spPr>
+        <p:txBody>
+          <a:bodyPr xmlns:a="http://schemas.openxmlformats.org/drawingml/2006/main" wrap="none" lIns="0" tIns="0" rIns="0" bIns="0" anchor="ctr">
+            <a:noAutofit/>
+          </a:bodyPr>
+          <a:lstStyle xmlns:a="http://schemas.openxmlformats.org/drawingml/2006/main"/>
+          <a:p xmlns:a="http://schemas.openxmlformats.org/drawingml/2006/main">
+            <a:pPr algn="l">
+              <a:buNone/>
+              <a:defRPr sz="1725">
+                <a:solidFill>
+                  <a:srgbClr val="BCBBC2"/>
+                </a:solidFill>
+                <a:latin typeface="Switzer"/>
+                <a:ea typeface="Switzer"/>
+                <a:cs typeface="Switzer"/>
+              </a:defRPr>
+            </a:pPr>
+            <a:r>
+              <a:rPr sz="1725">
+                <a:solidFill>
+                  <a:srgbClr val="BCBBC2"/>
+                </a:solidFill>
+                <a:latin typeface="Switzer"/>
+                <a:ea typeface="Switzer"/>
+                <a:cs typeface="Switzer"/>
+              </a:rPr>
+              <a:t>Crowne Plaza Warsaw [The HUB]</a:t>
+            </a:r>
+          </a:p>
+        </p:txBody>
+      </p:sp>
+    </p:spTree>
+    <p:extLst>
+      <p:ext uri="{BB962C8B-B14F-4D97-AF65-F5344CB8AC3E}">
+        <p14:creationId xmlns:p14="http://schemas.microsoft.com/office/powerpoint/2010/main" val="1080936326"/>
+      </p:ext>
+    </p:extLst>
+  </p:cSld>
+</p:sld>
+</file>
+
+<file path=ppt/slides/slide21.xml><?xml version="1.0" encoding="utf-8"?>
+<p:sld xmlns:p="http://schemas.openxmlformats.org/presentationml/2006/main">
+  <p:cSld>
+    <p:bg>
+      <p:bgPr>
+        <a:gradFill xmlns:a="http://schemas.openxmlformats.org/drawingml/2006/main">
+          <a:gsLst>
+            <a:gs pos="0">
+              <a:srgbClr val="201F24"/>
+            </a:gs>
+            <a:gs pos="44000">
+              <a:srgbClr val="201F24"/>
+            </a:gs>
+            <a:gs pos="76000">
+              <a:srgbClr val="35106F"/>
+            </a:gs>
+            <a:gs pos="100000">
+              <a:srgbClr val="8232FF"/>
+            </a:gs>
+          </a:gsLst>
+          <a:lin ang="6480000"/>
+        </a:gradFill>
+      </p:bgPr>
+    </p:bg>
+    <p:spTree>
+      <p:nvGrpSpPr>
+        <p:cNvPr id="1" name=""/>
+        <p:cNvGrpSpPr/>
+        <p:nvPr/>
+      </p:nvGrpSpPr>
+      <p:grpSpPr>
+        <a:xfrm xmlns:a="http://schemas.openxmlformats.org/drawingml/2006/main"/>
+      </p:grpSpPr>
+      <p:pic>
+        <p:nvPicPr>
+          <p:cNvPr id="12" name="Picture 1"/>
+          <p:cNvPicPr>
+            <a:picLocks xmlns:a="http://schemas.openxmlformats.org/drawingml/2006/main" noChangeAspect="1"/>
+          </p:cNvPicPr>
+          <p:nvPr/>
+        </p:nvPicPr>
+        <p:blipFill>
+          <a:blip xmlns:r="http://schemas.openxmlformats.org/officeDocument/2006/relationships" xmlns:a="http://schemas.openxmlformats.org/drawingml/2006/main" r:embed="Rc1a11db87cca4759"/>
+          <a:stretch xmlns:a="http://schemas.openxmlformats.org/drawingml/2006/main"/>
+        </p:blipFill>
+        <p:spPr>
+          <a:xfrm xmlns:a="http://schemas.openxmlformats.org/drawingml/2006/main" flipH="0" flipV="0">
+            <a:off x="10039350" y="723900"/>
+            <a:ext cx="1066800" cy="1066800"/>
+          </a:xfrm>
+          <a:prstGeom xmlns:a="http://schemas.openxmlformats.org/drawingml/2006/main" prst="rect">
+            <a:avLst/>
+          </a:prstGeom>
+        </p:spPr>
+      </p:pic>
+      <p:sp>
+        <p:nvSpPr>
+          <p:cNvPr id="3" name="TextBox 2">
+            <a:extLst xmlns:a="http://schemas.openxmlformats.org/drawingml/2006/main">
+              <a:ext uri="{FF2B5EF4-FFF2-40B4-BE49-F238E27FC236}">
+                <a16:creationId xmlns:a16="http://schemas.microsoft.com/office/drawing/2014/main" id="{E2B571C4-D7DA-454D-A508-7DF7C4FC585C}"/>
+              </a:ext>
+            </a:extLst>
+          </p:cNvPr>
+          <p:cNvSpPr>
+            <a:spLocks xmlns:a="http://schemas.openxmlformats.org/drawingml/2006/main" noGrp="1"/>
+          </p:cNvSpPr>
+          <p:nvPr/>
+        </p:nvSpPr>
+        <p:spPr>
+          <a:xfrm xmlns:a="http://schemas.openxmlformats.org/drawingml/2006/main">
+            <a:off x="609600" y="1952625"/>
+            <a:ext cx="9810750" cy="1234440"/>
+          </a:xfrm>
+          <a:prstGeom xmlns:a="http://schemas.openxmlformats.org/drawingml/2006/main" prst="rect">
+            <a:avLst/>
+          </a:prstGeom>
+          <a:noFill xmlns:a="http://schemas.openxmlformats.org/drawingml/2006/main"/>
+        </p:spPr>
+        <p:txBody>
+          <a:bodyPr xmlns:a="http://schemas.openxmlformats.org/drawingml/2006/main" wrap="square">
+            <a:spAutoFit/>
+          </a:bodyPr>
+          <a:lstStyle xmlns:a="http://schemas.openxmlformats.org/drawingml/2006/main"/>
+          <a:p xmlns:a="http://schemas.openxmlformats.org/drawingml/2006/main">
+            <a:pPr algn="l">
+              <a:buNone/>
+              <a:defRPr sz="3750" b="0">
+                <a:solidFill>
+                  <a:srgbClr val="FFFFFF"/>
+                </a:solidFill>
+                <a:latin typeface="Alliance No.2"/>
+                <a:ea typeface="Alliance No.2"/>
+                <a:cs typeface="Alliance No.2"/>
+              </a:defRPr>
+            </a:pPr>
+            <a:r>
+              <a:rPr sz="3750" b="0">
+                <a:solidFill>
+                  <a:srgbClr val="FFFFFF"/>
+                </a:solidFill>
+                <a:latin typeface="Alliance No.2"/>
+                <a:ea typeface="Alliance No.2"/>
+                <a:cs typeface="Alliance No.2"/>
+              </a:rPr>
+              <a:t>Where should agent collaboration fail closed?</a:t>
+            </a:r>
+          </a:p>
+        </p:txBody>
+      </p:sp>
+      <p:sp>
+        <p:nvSpPr>
+          <p:cNvPr id="4" name="TextBox 3">
+            <a:extLst xmlns:a="http://schemas.openxmlformats.org/drawingml/2006/main">
+              <a:ext uri="{FF2B5EF4-FFF2-40B4-BE49-F238E27FC236}">
+                <a16:creationId xmlns:a16="http://schemas.microsoft.com/office/drawing/2014/main" id="{62C4EF88-ADA2-4A0A-AD75-4FC5C49C79CD}"/>
+              </a:ext>
+            </a:extLst>
+          </p:cNvPr>
+          <p:cNvSpPr>
+            <a:spLocks xmlns:a="http://schemas.openxmlformats.org/drawingml/2006/main" noGrp="1"/>
+          </p:cNvSpPr>
+          <p:nvPr/>
+        </p:nvSpPr>
+        <p:spPr>
+          <a:xfrm xmlns:a="http://schemas.openxmlformats.org/drawingml/2006/main">
+            <a:off x="609600" y="3067050"/>
+            <a:ext cx="8858250" cy="457200"/>
+          </a:xfrm>
+          <a:prstGeom xmlns:a="http://schemas.openxmlformats.org/drawingml/2006/main" prst="rect">
+            <a:avLst/>
+          </a:prstGeom>
+          <a:noFill xmlns:a="http://schemas.openxmlformats.org/drawingml/2006/main"/>
+        </p:spPr>
+        <p:txBody>
+          <a:bodyPr xmlns:a="http://schemas.openxmlformats.org/drawingml/2006/main" wrap="square">
+            <a:spAutoFit/>
+          </a:bodyPr>
+          <a:lstStyle xmlns:a="http://schemas.openxmlformats.org/drawingml/2006/main"/>
+          <a:p xmlns:a="http://schemas.openxmlformats.org/drawingml/2006/main">
+            <a:pPr algn="l">
+              <a:buNone/>
+              <a:defRPr sz="1800" b="0">
+                <a:solidFill>
+                  <a:srgbClr val="E9E7EE"/>
+                </a:solidFill>
+                <a:latin typeface="Switzer"/>
+                <a:ea typeface="Switzer"/>
+                <a:cs typeface="Switzer"/>
+              </a:defRPr>
+            </a:pPr>
+            <a:r>
+              <a:rPr sz="1800" b="0">
+                <a:solidFill>
+                  <a:srgbClr val="E9E7EE"/>
+                </a:solidFill>
+                <a:latin typeface="Switzer"/>
+                <a:ea typeface="Switzer"/>
+                <a:cs typeface="Switzer"/>
+              </a:rPr>
+              <a:t>Context • disagreement • auditability • human control</a:t>
+            </a:r>
+          </a:p>
+        </p:txBody>
+      </p:sp>
+      <p:sp>
+        <p:nvSpPr>
+          <p:cNvPr id="5" name="Rounded Rectangle 4">
+            <a:extLst xmlns:a="http://schemas.openxmlformats.org/drawingml/2006/main">
+              <a:ext uri="{FF2B5EF4-FFF2-40B4-BE49-F238E27FC236}">
+                <a16:creationId xmlns:a16="http://schemas.microsoft.com/office/drawing/2014/main" id="{68646C1F-A196-4BB4-8193-DFF566382DC4}"/>
+              </a:ext>
+            </a:extLst>
+          </p:cNvPr>
+          <p:cNvSpPr>
+            <a:spLocks xmlns:a="http://schemas.openxmlformats.org/drawingml/2006/main" noGrp="1"/>
+          </p:cNvSpPr>
+          <p:nvPr/>
+        </p:nvSpPr>
+        <p:spPr>
+          <a:xfrm xmlns:a="http://schemas.openxmlformats.org/drawingml/2006/main">
+            <a:off x="609600" y="3905250"/>
+            <a:ext cx="7524750" cy="1645920"/>
+          </a:xfrm>
+          <a:prstGeom xmlns:a="http://schemas.openxmlformats.org/drawingml/2006/main" prst="roundRect">
+            <a:avLst>
+              <a:gd name="adj" fmla="val 4630"/>
+            </a:avLst>
+          </a:prstGeom>
+          <a:solidFill xmlns:a="http://schemas.openxmlformats.org/drawingml/2006/main">
+            <a:srgbClr val="000000"/>
+          </a:solidFill>
+          <a:ln xmlns:a="http://schemas.openxmlformats.org/drawingml/2006/main" w="9525">
+            <a:solidFill>
+              <a:srgbClr val="8232FF"/>
+            </a:solidFill>
+            <a:prstDash val="solid"/>
+          </a:ln>
+        </p:spPr>
+        <p:style>
+          <a:lnRef xmlns:a="http://schemas.openxmlformats.org/drawingml/2006/main" idx="1">
+            <a:schemeClr val="accent1"/>
+          </a:lnRef>
+          <a:fillRef xmlns:a="http://schemas.openxmlformats.org/drawingml/2006/main" idx="3">
+            <a:schemeClr val="accent1"/>
+          </a:fillRef>
+          <a:effectRef xmlns:a="http://schemas.openxmlformats.org/drawingml/2006/main" idx="0"/>
+          <a:fontRef xmlns:a="http://schemas.openxmlformats.org/drawingml/2006/main" idx="minor">
+            <a:schemeClr val="lt1"/>
+          </a:fontRef>
+        </p:style>
+        <p:txBody>
+          <a:bodyPr xmlns:a="http://schemas.openxmlformats.org/drawingml/2006/main" anchor="ctr"/>
+          <a:lstStyle xmlns:a="http://schemas.openxmlformats.org/drawingml/2006/main"/>
+          <a:p xmlns:a="http://schemas.openxmlformats.org/drawingml/2006/main">
+            <a:pPr algn="ctr">
+              <a:buNone/>
+            </a:pPr>
+          </a:p>
+        </p:txBody>
+      </p:sp>
+      <p:sp>
+        <p:nvSpPr>
+          <p:cNvPr id="6" name="TextBox 5">
+            <a:extLst xmlns:a="http://schemas.openxmlformats.org/drawingml/2006/main">
+              <a:ext uri="{FF2B5EF4-FFF2-40B4-BE49-F238E27FC236}">
+                <a16:creationId xmlns:a16="http://schemas.microsoft.com/office/drawing/2014/main" id="{CED7D471-F0C7-46DB-A417-EDEB97E79E41}"/>
+              </a:ext>
+            </a:extLst>
+          </p:cNvPr>
+          <p:cNvSpPr>
+            <a:spLocks xmlns:a="http://schemas.openxmlformats.org/drawingml/2006/main" noGrp="1"/>
+          </p:cNvSpPr>
+          <p:nvPr/>
+        </p:nvSpPr>
+        <p:spPr>
+          <a:xfrm xmlns:a="http://schemas.openxmlformats.org/drawingml/2006/main">
+            <a:off x="876300" y="4133850"/>
+            <a:ext cx="6953250" cy="1314450"/>
+          </a:xfrm>
+          <a:prstGeom xmlns:a="http://schemas.openxmlformats.org/drawingml/2006/main" prst="rect">
+            <a:avLst/>
+          </a:prstGeom>
+          <a:noFill xmlns:a="http://schemas.openxmlformats.org/drawingml/2006/main"/>
+        </p:spPr>
+        <p:txBody>
+          <a:bodyPr xmlns:a="http://schemas.openxmlformats.org/drawingml/2006/main" wrap="square">
+            <a:spAutoFit/>
+          </a:bodyPr>
+          <a:lstStyle xmlns:a="http://schemas.openxmlformats.org/drawingml/2006/main"/>
           <a:p xmlns:a="http://schemas.openxmlformats.org/drawingml/2006/main">
             <a:pPr algn="l">
               <a:spcAft>
@@ -16854,7 +18382,7 @@
                 <a:ea typeface="Consolas"/>
                 <a:cs typeface="Consolas"/>
               </a:rPr>
-              <a:t>&gt; When should one agent challenge another?</a:t>
+              <a:t>&gt; What evidence must survive every handoff?</a:t>
             </a:r>
           </a:p>
           <a:p xmlns:a="http://schemas.openxmlformats.org/drawingml/2006/main">
@@ -16881,6 +18409,33 @@
                 <a:ea typeface="Consolas"/>
                 <a:cs typeface="Consolas"/>
               </a:rPr>
+              <a:t>&gt; When should one agent challenge another?</a:t>
+            </a:r>
+          </a:p>
+          <a:p xmlns:a="http://schemas.openxmlformats.org/drawingml/2006/main">
+            <a:pPr algn="l">
+              <a:spcAft>
+                <a:spcPts val="400"/>
+              </a:spcAft>
+              <a:buNone/>
+              <a:defRPr sz="1500" b="0">
+                <a:solidFill>
+                  <a:srgbClr val="E9E7EE"/>
+                </a:solidFill>
+                <a:latin typeface="Consolas"/>
+                <a:ea typeface="Consolas"/>
+                <a:cs typeface="Consolas"/>
+              </a:defRPr>
+            </a:pPr>
+            <a:r>
+              <a:rPr sz="1500" b="0">
+                <a:solidFill>
+                  <a:srgbClr val="E9E7EE"/>
+                </a:solidFill>
+                <a:latin typeface="Consolas"/>
+                <a:ea typeface="Consolas"/>
+                <a:cs typeface="Consolas"/>
+              </a:rPr>
               <a:t>&gt; Where must the human interrupt?</a:t>
             </a:r>
           </a:p>
@@ -17046,7 +18601,7 @@
                 <a:ea typeface="Consolas"/>
                 <a:cs typeface="Consolas"/>
               </a:rPr>
-              <a:t>20/20</a:t>
+              <a:t>21/21</a:t>
             </a:r>
           </a:p>
         </p:txBody>
@@ -17060,7 +18615,7 @@
           <p:nvPr/>
         </p:nvPicPr>
         <p:blipFill>
-          <a:blip xmlns:r="http://schemas.openxmlformats.org/officeDocument/2006/relationships" xmlns:a="http://schemas.openxmlformats.org/drawingml/2006/main" r:embed="R615fc281294146df"/>
+          <a:blip xmlns:r="http://schemas.openxmlformats.org/officeDocument/2006/relationships" xmlns:a="http://schemas.openxmlformats.org/drawingml/2006/main" r:embed="Rd18581a41d174a73"/>
           <a:stretch xmlns:a="http://schemas.openxmlformats.org/drawingml/2006/main"/>
         </p:blipFill>
         <p:spPr>
@@ -17262,7 +18817,7 @@
                 <a:ea typeface="Consolas"/>
                 <a:cs typeface="Consolas"/>
               </a:rPr>
-              <a:t>3/20</a:t>
+              <a:t>3/21</a:t>
             </a:r>
           </a:p>
         </p:txBody>
@@ -18726,7 +20281,7 @@
                 <a:ea typeface="Consolas"/>
                 <a:cs typeface="Consolas"/>
               </a:rPr>
-              <a:t>4/20</a:t>
+              <a:t>4/21</a:t>
             </a:r>
           </a:p>
         </p:txBody>
@@ -20098,7 +21653,7 @@
                 <a:ea typeface="Consolas"/>
                 <a:cs typeface="Consolas"/>
               </a:rPr>
-              <a:t>5/20</a:t>
+              <a:t>5/21</a:t>
             </a:r>
           </a:p>
         </p:txBody>
@@ -21243,7 +22798,7 @@
                 <a:ea typeface="Consolas"/>
                 <a:cs typeface="Consolas"/>
               </a:rPr>
-              <a:t>6/20</a:t>
+              <a:t>6/21</a:t>
             </a:r>
           </a:p>
         </p:txBody>
@@ -22330,7 +23885,7 @@
                 <a:ea typeface="Consolas"/>
                 <a:cs typeface="Consolas"/>
               </a:rPr>
-              <a:t>7/20</a:t>
+              <a:t>7/21</a:t>
             </a:r>
           </a:p>
         </p:txBody>
@@ -23805,7 +25360,7 @@
                 <a:ea typeface="Consolas"/>
                 <a:cs typeface="Consolas"/>
               </a:rPr>
-              <a:t>8/20</a:t>
+              <a:t>8/21</a:t>
             </a:r>
           </a:p>
         </p:txBody>
@@ -24882,7 +26437,7 @@
                 <a:ea typeface="Consolas"/>
                 <a:cs typeface="Consolas"/>
               </a:rPr>
-              <a:t>9/20</a:t>
+              <a:t>9/21</a:t>
             </a:r>
           </a:p>
         </p:txBody>

</xml_diff>

<commit_message>
docs: fit Code Europe session into 40-50 minutes including Q&A
</commit_message>
<xml_diff>
--- a/presentation/Agents_Commander_Protocol.pptx
+++ b/presentation/Agents_Commander_Protocol.pptx
@@ -2,33 +2,33 @@
 <file path=ppt/presentation.xml><?xml version="1.0" encoding="utf-8"?>
 <p:presentation xmlns:p="http://schemas.openxmlformats.org/presentationml/2006/main">
   <p:sldMasterIdLst>
-    <p:sldMasterId xmlns:r="http://schemas.openxmlformats.org/officeDocument/2006/relationships" id="2147483648" r:id="R335682ccb1fe49e0"/>
+    <p:sldMasterId xmlns:r="http://schemas.openxmlformats.org/officeDocument/2006/relationships" id="2147483648" r:id="Rc03397c198b24a17"/>
   </p:sldMasterIdLst>
   <p:notesMasterIdLst>
-    <p:notesMasterId xmlns:r="http://schemas.openxmlformats.org/officeDocument/2006/relationships" r:id="R238eebe17b82496a"/>
+    <p:notesMasterId xmlns:r="http://schemas.openxmlformats.org/officeDocument/2006/relationships" r:id="R518e57fb686f4ce1"/>
   </p:notesMasterIdLst>
   <p:sldIdLst>
-    <p:sldId xmlns:r="http://schemas.openxmlformats.org/officeDocument/2006/relationships" id="256" r:id="R4193577244c34ad7"/>
-    <p:sldId xmlns:r="http://schemas.openxmlformats.org/officeDocument/2006/relationships" id="257" r:id="Re4b1f1ab57954a0e"/>
-    <p:sldId xmlns:r="http://schemas.openxmlformats.org/officeDocument/2006/relationships" id="258" r:id="R3a8114af639a4a75"/>
-    <p:sldId xmlns:r="http://schemas.openxmlformats.org/officeDocument/2006/relationships" id="259" r:id="R95e23173cc164c20"/>
-    <p:sldId xmlns:r="http://schemas.openxmlformats.org/officeDocument/2006/relationships" id="260" r:id="Ra3fd71e2030b4391"/>
-    <p:sldId xmlns:r="http://schemas.openxmlformats.org/officeDocument/2006/relationships" id="261" r:id="Rd14779339142444c"/>
-    <p:sldId xmlns:r="http://schemas.openxmlformats.org/officeDocument/2006/relationships" id="262" r:id="R42ea585973f9434a"/>
-    <p:sldId xmlns:r="http://schemas.openxmlformats.org/officeDocument/2006/relationships" id="263" r:id="R2814cab3673047a0"/>
-    <p:sldId xmlns:r="http://schemas.openxmlformats.org/officeDocument/2006/relationships" id="264" r:id="R5b35bb4420ad47f7"/>
-    <p:sldId xmlns:r="http://schemas.openxmlformats.org/officeDocument/2006/relationships" id="265" r:id="Rd1f634fe3baa420e"/>
-    <p:sldId xmlns:r="http://schemas.openxmlformats.org/officeDocument/2006/relationships" id="266" r:id="R91802375a3084158"/>
-    <p:sldId xmlns:r="http://schemas.openxmlformats.org/officeDocument/2006/relationships" id="267" r:id="R306f89bbece34fe8"/>
-    <p:sldId xmlns:r="http://schemas.openxmlformats.org/officeDocument/2006/relationships" id="268" r:id="Rebdfdec4ea9840a7"/>
-    <p:sldId xmlns:r="http://schemas.openxmlformats.org/officeDocument/2006/relationships" id="269" r:id="R1de75e951a55453a"/>
-    <p:sldId xmlns:r="http://schemas.openxmlformats.org/officeDocument/2006/relationships" id="270" r:id="Rf36c5c2edf6a4a9d"/>
-    <p:sldId xmlns:r="http://schemas.openxmlformats.org/officeDocument/2006/relationships" id="271" r:id="R748aad4d83834ca2"/>
-    <p:sldId xmlns:r="http://schemas.openxmlformats.org/officeDocument/2006/relationships" id="272" r:id="Reb836141ca534029"/>
-    <p:sldId xmlns:r="http://schemas.openxmlformats.org/officeDocument/2006/relationships" id="273" r:id="R72c1a612a85f4255"/>
-    <p:sldId xmlns:r="http://schemas.openxmlformats.org/officeDocument/2006/relationships" id="274" r:id="R169b05b051d44528"/>
-    <p:sldId xmlns:r="http://schemas.openxmlformats.org/officeDocument/2006/relationships" id="275" r:id="R9c99d9d39cef4d38"/>
-    <p:sldId xmlns:r="http://schemas.openxmlformats.org/officeDocument/2006/relationships" id="276" r:id="R8936b55fcebf4783"/>
+    <p:sldId xmlns:r="http://schemas.openxmlformats.org/officeDocument/2006/relationships" id="256" r:id="R30094569934d498a"/>
+    <p:sldId xmlns:r="http://schemas.openxmlformats.org/officeDocument/2006/relationships" id="257" r:id="R25a48255b58041e5"/>
+    <p:sldId xmlns:r="http://schemas.openxmlformats.org/officeDocument/2006/relationships" id="258" r:id="R53ccde2662c84ddd"/>
+    <p:sldId xmlns:r="http://schemas.openxmlformats.org/officeDocument/2006/relationships" id="259" r:id="Rc4c3abd187984aaf"/>
+    <p:sldId xmlns:r="http://schemas.openxmlformats.org/officeDocument/2006/relationships" id="260" r:id="Rfa3752c96434430f"/>
+    <p:sldId xmlns:r="http://schemas.openxmlformats.org/officeDocument/2006/relationships" id="261" r:id="Rc3f8fc92dd794755"/>
+    <p:sldId xmlns:r="http://schemas.openxmlformats.org/officeDocument/2006/relationships" id="262" r:id="Reb8c5307476b4bed"/>
+    <p:sldId xmlns:r="http://schemas.openxmlformats.org/officeDocument/2006/relationships" id="263" r:id="Rdbbc79dc297c41a0"/>
+    <p:sldId xmlns:r="http://schemas.openxmlformats.org/officeDocument/2006/relationships" id="264" r:id="R1d45b35e5e6f45db"/>
+    <p:sldId xmlns:r="http://schemas.openxmlformats.org/officeDocument/2006/relationships" id="265" r:id="R4cabc59fc85a40e6"/>
+    <p:sldId xmlns:r="http://schemas.openxmlformats.org/officeDocument/2006/relationships" id="266" r:id="Rfca145613f5e42e8"/>
+    <p:sldId xmlns:r="http://schemas.openxmlformats.org/officeDocument/2006/relationships" id="267" r:id="Ra32a3f0382134bc1"/>
+    <p:sldId xmlns:r="http://schemas.openxmlformats.org/officeDocument/2006/relationships" id="268" r:id="R568e89da69884340"/>
+    <p:sldId xmlns:r="http://schemas.openxmlformats.org/officeDocument/2006/relationships" id="269" r:id="Rd6032836b1324572"/>
+    <p:sldId xmlns:r="http://schemas.openxmlformats.org/officeDocument/2006/relationships" id="270" r:id="R9337106ef104474c"/>
+    <p:sldId xmlns:r="http://schemas.openxmlformats.org/officeDocument/2006/relationships" id="271" r:id="Rd73059310af04c81"/>
+    <p:sldId xmlns:r="http://schemas.openxmlformats.org/officeDocument/2006/relationships" id="272" r:id="R5ef07fd13ee44499"/>
+    <p:sldId xmlns:r="http://schemas.openxmlformats.org/officeDocument/2006/relationships" id="273" r:id="R913d41f339284660"/>
+    <p:sldId xmlns:r="http://schemas.openxmlformats.org/officeDocument/2006/relationships" id="274" r:id="Rcd07ae1e92e343ae"/>
+    <p:sldId xmlns:r="http://schemas.openxmlformats.org/officeDocument/2006/relationships" id="275" r:id="Rad47b96483da4a7a"/>
+    <p:sldId xmlns:r="http://schemas.openxmlformats.org/officeDocument/2006/relationships" id="276" r:id="Rfe2b8980ebe844cf"/>
   </p:sldIdLst>
   <p:sldSz cx="12191695" cy="6858000"/>
   <p:notesSz cx="6858000" cy="9144000"/>
@@ -490,7 +490,7 @@
           </a:p>
           <a:p xmlns:a="http://schemas.openxmlformats.org/drawingml/2006/main">
             <a:r>
-              <a:t>1 minutes</a:t>
+              <a:t>0.5 minutes</a:t>
             </a:r>
           </a:p>
           <a:p xmlns:a="http://schemas.openxmlformats.org/drawingml/2006/main">
@@ -500,7 +500,22 @@
           </a:p>
           <a:p xmlns:a="http://schemas.openxmlformats.org/drawingml/2006/main">
             <a:r>
-              <a:t>Open with the accepted public title: No Framework, No Server: Making AI Agents Collaborate in One Terminal. Introduce Lech Kalinowski, Senior AI Systems Engineer at Callstack. The 45-minute session examines terminal-native collaboration without a central orchestration server or heavyweight agent framework: architecture and protocol, deterministic transport proof, real-agent challenge/refinement, human control, and five minutes of questions. First, look at a real handoff in the terminal.</a:t>
+              <a:t>[Slot pacing]</a:t>
+            </a:r>
+          </a:p>
+          <a:p xmlns:a="http://schemas.openxmlformats.org/drawingml/2006/main">
+            <a:r>
+              <a:t>40/45-minute slot: 00:00–00:30 (0.5 minutes core).</a:t>
+            </a:r>
+          </a:p>
+          <a:p xmlns:a="http://schemas.openxmlformats.org/drawingml/2006/main">
+            <a:r>
+              <a:t>Confirmed 50-minute slot: 00:00–00:30 (0.5 minutes).</a:t>
+            </a:r>
+          </a:p>
+          <a:p xmlns:a="http://schemas.openxmlformats.org/drawingml/2006/main">
+            <a:r>
+              <a:t>Budgets include transitions and brief clarifications. These are rehearsal targets, not automatic slide advances.</a:t>
             </a:r>
           </a:p>
           <a:p xmlns:a="http://schemas.openxmlformats.org/drawingml/2006/main">
@@ -510,6 +525,61 @@
           </a:p>
           <a:p xmlns:a="http://schemas.openxmlformats.org/drawingml/2006/main">
             <a:r>
+              <a:t>[Core delivery]</a:t>
+            </a:r>
+          </a:p>
+          <a:p xmlns:a="http://schemas.openxmlformats.org/drawingml/2006/main">
+            <a:r>
+              <a:t>Introduce yourself and the accepted title. Give one promise: make agent handoffs observable and human-controlled inside one terminal; move straight to the real workspace.</a:t>
+            </a:r>
+          </a:p>
+          <a:p xmlns:a="http://schemas.openxmlformats.org/drawingml/2006/main">
+            <a:r>
+              <a:t/>
+            </a:r>
+          </a:p>
+          <a:p xmlns:a="http://schemas.openxmlformats.org/drawingml/2006/main">
+            <a:r>
+              <a:t>[Clock discipline]</a:t>
+            </a:r>
+          </a:p>
+          <a:p xmlns:a="http://schemas.openxmlformats.org/drawingml/2006/main">
+            <a:r>
+              <a:t>Confirm the total slot with the moderator before starting. Default is 35 minutes of content + 10 minutes of Q&amp;A. Use optional depth only when 50 minutes is explicitly confirmed and you are on schedule. Elapsed clocks include transitions and brief clarifications; park longer discussions for Q&amp;A.</a:t>
+            </a:r>
+          </a:p>
+          <a:p xmlns:a="http://schemas.openxmlformats.org/drawingml/2006/main">
+            <a:r>
+              <a:t/>
+            </a:r>
+          </a:p>
+          <a:p xmlns:a="http://schemas.openxmlformats.org/drawingml/2006/main">
+            <a:r>
+              <a:t>[Technical reference and source notes]</a:t>
+            </a:r>
+          </a:p>
+          <a:p xmlns:a="http://schemas.openxmlformats.org/drawingml/2006/main">
+            <a:r>
+              <a:t>Use for rehearsal and Q&amp;A; do not read all reference detail aloud. The core-delivery cue above sets the live scope.</a:t>
+            </a:r>
+          </a:p>
+          <a:p xmlns:a="http://schemas.openxmlformats.org/drawingml/2006/main">
+            <a:r>
+              <a:t/>
+            </a:r>
+          </a:p>
+          <a:p xmlns:a="http://schemas.openxmlformats.org/drawingml/2006/main">
+            <a:r>
+              <a:t>Open with the accepted public title: No Framework, No Server: Making AI Agents Collaborate in One Terminal. Introduce Lech Kalinowski, Senior AI Systems Engineer at Callstack. The core talk examines terminal-native collaboration without a central orchestration server or heavyweight agent framework: architecture and protocol, deterministic transport proof, real-agent challenge/refinement, human control, and questions within the agreed 40–50-minute total slot. First, look at a real handoff in the terminal.</a:t>
+            </a:r>
+          </a:p>
+          <a:p xmlns:a="http://schemas.openxmlformats.org/drawingml/2006/main">
+            <a:r>
+              <a:t/>
+            </a:r>
+          </a:p>
+          <a:p xmlns:a="http://schemas.openxmlformats.org/drawingml/2006/main">
+            <a:r>
               <a:t>[Sources]</a:t>
             </a:r>
           </a:p>
@@ -561,11 +631,6 @@
           <a:p xmlns:a="http://schemas.openxmlformats.org/drawingml/2006/main">
             <a:r>
               <a:t>Commander logo: user-approved Classic Blue pixel &gt;/&lt; mark, assets/logo.png. Built-in image generation; provenance and exact prompts: assets/BRAND.md.</a:t>
-            </a:r>
-          </a:p>
-          <a:p xmlns:a="http://schemas.openxmlformats.org/drawingml/2006/main">
-            <a:r>
-              <a:t/>
             </a:r>
           </a:p>
         </p:txBody>
@@ -635,22 +700,77 @@
           <a:lstStyle xmlns:a="http://schemas.openxmlformats.org/drawingml/2006/main"/>
           <a:p xmlns:a="http://schemas.openxmlformats.org/drawingml/2006/main">
             <a:r>
+              <a:t>[Timing]</a:t>
+            </a:r>
+          </a:p>
+          <a:p xmlns:a="http://schemas.openxmlformats.org/drawingml/2006/main">
+            <a:r>
+              <a:t>1.5 minutes</a:t>
+            </a:r>
+          </a:p>
+          <a:p xmlns:a="http://schemas.openxmlformats.org/drawingml/2006/main">
+            <a:r>
+              <a:t/>
+            </a:r>
+          </a:p>
+          <a:p xmlns:a="http://schemas.openxmlformats.org/drawingml/2006/main">
+            <a:r>
+              <a:t>[Slot pacing]</a:t>
+            </a:r>
+          </a:p>
+          <a:p xmlns:a="http://schemas.openxmlformats.org/drawingml/2006/main">
+            <a:r>
+              <a:t>40/45-minute slot: 14:30–16:00 (1.5 minutes core).</a:t>
+            </a:r>
+          </a:p>
+          <a:p xmlns:a="http://schemas.openxmlformats.org/drawingml/2006/main">
+            <a:r>
+              <a:t>Confirmed 50-minute slot: 16:30–18:00 (1.5 minutes).</a:t>
+            </a:r>
+          </a:p>
+          <a:p xmlns:a="http://schemas.openxmlformats.org/drawingml/2006/main">
+            <a:r>
+              <a:t>Budgets include transitions and brief clarifications. These are rehearsal targets, not automatic slide advances.</a:t>
+            </a:r>
+          </a:p>
+          <a:p xmlns:a="http://schemas.openxmlformats.org/drawingml/2006/main">
+            <a:r>
+              <a:t/>
+            </a:r>
+          </a:p>
+          <a:p xmlns:a="http://schemas.openxmlformats.org/drawingml/2006/main">
+            <a:r>
+              <a:t>[Core delivery]</a:t>
+            </a:r>
+          </a:p>
+          <a:p xmlns:a="http://schemas.openxmlformats.org/drawingml/2006/main">
+            <a:r>
+              <a:t>Follow the guards from admission through the session input lane and target revalidation. Name bounded queues, unsafe-control rejection and failure visibility; do not recite every numeric limit.</a:t>
+            </a:r>
+          </a:p>
+          <a:p xmlns:a="http://schemas.openxmlformats.org/drawingml/2006/main">
+            <a:r>
+              <a:t/>
+            </a:r>
+          </a:p>
+          <a:p xmlns:a="http://schemas.openxmlformats.org/drawingml/2006/main">
+            <a:r>
+              <a:t>[Technical reference and source notes]</a:t>
+            </a:r>
+          </a:p>
+          <a:p xmlns:a="http://schemas.openxmlformats.org/drawingml/2006/main">
+            <a:r>
+              <a:t>Use for rehearsal and Q&amp;A; do not read all reference detail aloud. The core-delivery cue above sets the live scope.</a:t>
+            </a:r>
+          </a:p>
+          <a:p xmlns:a="http://schemas.openxmlformats.org/drawingml/2006/main">
+            <a:r>
+              <a:t/>
+            </a:r>
+          </a:p>
+          <a:p xmlns:a="http://schemas.openxmlformats.org/drawingml/2006/main">
+            <a:r>
               <a:t>SLIDE 10 — Bounded queues and revalidation protect terminal input</a:t>
-            </a:r>
-          </a:p>
-          <a:p xmlns:a="http://schemas.openxmlformats.org/drawingml/2006/main">
-            <a:r>
-              <a:t/>
-            </a:r>
-          </a:p>
-          <a:p xmlns:a="http://schemas.openxmlformats.org/drawingml/2006/main">
-            <a:r>
-              <a:t>[Timing]</a:t>
-            </a:r>
-          </a:p>
-          <a:p xmlns:a="http://schemas.openxmlformats.org/drawingml/2006/main">
-            <a:r>
-              <a:t>2 minutes (02:00)</a:t>
             </a:r>
           </a:p>
           <a:p xmlns:a="http://schemas.openxmlformats.org/drawingml/2006/main">
@@ -815,7 +935,77 @@
           </a:p>
           <a:p xmlns:a="http://schemas.openxmlformats.org/drawingml/2006/main">
             <a:r>
-              <a:t>1.5 minutes</a:t>
+              <a:t>1 minutes</a:t>
+            </a:r>
+          </a:p>
+          <a:p xmlns:a="http://schemas.openxmlformats.org/drawingml/2006/main">
+            <a:r>
+              <a:t/>
+            </a:r>
+          </a:p>
+          <a:p xmlns:a="http://schemas.openxmlformats.org/drawingml/2006/main">
+            <a:r>
+              <a:t>[Slot pacing]</a:t>
+            </a:r>
+          </a:p>
+          <a:p xmlns:a="http://schemas.openxmlformats.org/drawingml/2006/main">
+            <a:r>
+              <a:t>40/45-minute slot: 16:00–17:00 (1 minutes core).</a:t>
+            </a:r>
+          </a:p>
+          <a:p xmlns:a="http://schemas.openxmlformats.org/drawingml/2006/main">
+            <a:r>
+              <a:t>Confirmed 50-minute slot: 18:00–19:00 (1 minutes).</a:t>
+            </a:r>
+          </a:p>
+          <a:p xmlns:a="http://schemas.openxmlformats.org/drawingml/2006/main">
+            <a:r>
+              <a:t>Budgets include transitions and brief clarifications. These are rehearsal targets, not automatic slide advances.</a:t>
+            </a:r>
+          </a:p>
+          <a:p xmlns:a="http://schemas.openxmlformats.org/drawingml/2006/main">
+            <a:r>
+              <a:t/>
+            </a:r>
+          </a:p>
+          <a:p xmlns:a="http://schemas.openxmlformats.org/drawingml/2006/main">
+            <a:r>
+              <a:t>[Core delivery]</a:t>
+            </a:r>
+          </a:p>
+          <a:p xmlns:a="http://schemas.openxmlformats.org/drawingml/2006/main">
+            <a:r>
+              <a:t>Give one clear comparison with BAND/Jam and the different coordination boundary. Keep the comparison factual and concise; park product discussion for Q&amp;A.</a:t>
+            </a:r>
+          </a:p>
+          <a:p xmlns:a="http://schemas.openxmlformats.org/drawingml/2006/main">
+            <a:r>
+              <a:t/>
+            </a:r>
+          </a:p>
+          <a:p xmlns:a="http://schemas.openxmlformats.org/drawingml/2006/main">
+            <a:r>
+              <a:t>[Clock discipline]</a:t>
+            </a:r>
+          </a:p>
+          <a:p xmlns:a="http://schemas.openxmlformats.org/drawingml/2006/main">
+            <a:r>
+              <a:t>Checkpoint: finish this slide by 17:00 in a 40/45-minute slot, or 19:00 in the expanded run. If behind, give this comparison in 30 seconds. Drop remaining optional depth before using Q&amp;A time.</a:t>
+            </a:r>
+          </a:p>
+          <a:p xmlns:a="http://schemas.openxmlformats.org/drawingml/2006/main">
+            <a:r>
+              <a:t/>
+            </a:r>
+          </a:p>
+          <a:p xmlns:a="http://schemas.openxmlformats.org/drawingml/2006/main">
+            <a:r>
+              <a:t>[Technical reference and source notes]</a:t>
+            </a:r>
+          </a:p>
+          <a:p xmlns:a="http://schemas.openxmlformats.org/drawingml/2006/main">
+            <a:r>
+              <a:t>Use for rehearsal and Q&amp;A; do not read all reference detail aloud. The core-delivery cue above sets the live scope.</a:t>
             </a:r>
           </a:p>
           <a:p xmlns:a="http://schemas.openxmlformats.org/drawingml/2006/main">
@@ -995,7 +1185,7 @@
           </a:p>
           <a:p xmlns:a="http://schemas.openxmlformats.org/drawingml/2006/main">
             <a:r>
-              <a:t>4 minutes</a:t>
+              <a:t>3 minutes</a:t>
             </a:r>
           </a:p>
           <a:p xmlns:a="http://schemas.openxmlformats.org/drawingml/2006/main">
@@ -1005,12 +1195,97 @@
           </a:p>
           <a:p xmlns:a="http://schemas.openxmlformats.org/drawingml/2006/main">
             <a:r>
-              <a:t>Spend 4 minutes proving the machinery before asking an LLM to use it. Start the built 0.1.5 source with --demo, focus Demo Coordinator and type START. Observe the exact SEND, local STATUS acknowledgement, and REPLY. Verify deterministic calculateTotal([19, 23]) = 42. Open F12 and point to delivered SEND/REPLY with the same thread and different message IDs. STATUS does not appear in routed Activity. No network or credentials are required. These are deterministic fixtures, never describe them as reasoning agents.</a:t>
-            </a:r>
-          </a:p>
-          <a:p xmlns:a="http://schemas.openxmlformats.org/drawingml/2006/main">
-            <a:r>
-              <a:t>Recovery: when both roles have exited, Ctrl+O can offer a newly seeded demo. While either role is live, Ctrl+O is normal Orchestrate; relaunch --demo for a clean reset.</a:t>
+              <a:t>[Slot pacing]</a:t>
+            </a:r>
+          </a:p>
+          <a:p xmlns:a="http://schemas.openxmlformats.org/drawingml/2006/main">
+            <a:r>
+              <a:t>40/45-minute slot: 17:00–20:00 (3 minutes core).</a:t>
+            </a:r>
+          </a:p>
+          <a:p xmlns:a="http://schemas.openxmlformats.org/drawingml/2006/main">
+            <a:r>
+              <a:t>Confirmed 50-minute slot: 19:00–23:00 (4 minutes, including 1 minutes optional depth).</a:t>
+            </a:r>
+          </a:p>
+          <a:p xmlns:a="http://schemas.openxmlformats.org/drawingml/2006/main">
+            <a:r>
+              <a:t>Budgets include transitions and brief clarifications. These are rehearsal targets, not automatic slide advances.</a:t>
+            </a:r>
+          </a:p>
+          <a:p xmlns:a="http://schemas.openxmlformats.org/drawingml/2006/main">
+            <a:r>
+              <a:t/>
+            </a:r>
+          </a:p>
+          <a:p xmlns:a="http://schemas.openxmlformats.org/drawingml/2006/main">
+            <a:r>
+              <a:t>[Core delivery]</a:t>
+            </a:r>
+          </a:p>
+          <a:p xmlns:a="http://schemas.openxmlformats.org/drawingml/2006/main">
+            <a:r>
+              <a:t>Switch to the prestarted offline demo, type START, observe SEND and REPLY, verify 42, then show their shared thread in F12. Label the run as deterministic transport proof, not LLM reasoning.</a:t>
+            </a:r>
+          </a:p>
+          <a:p xmlns:a="http://schemas.openxmlformats.org/drawingml/2006/main">
+            <a:r>
+              <a:t/>
+            </a:r>
+          </a:p>
+          <a:p xmlns:a="http://schemas.openxmlformats.org/drawingml/2006/main">
+            <a:r>
+              <a:t>[Optional — confirmed 50-minute slot only]</a:t>
+            </a:r>
+          </a:p>
+          <a:p xmlns:a="http://schemas.openxmlformats.org/drawingml/2006/main">
+            <a:r>
+              <a:t>Add one minute inspecting the completed handoff and its provenance. Do not rerun or reset the demo. Skip if behind schedule; preserve Q&amp;A.</a:t>
+            </a:r>
+          </a:p>
+          <a:p xmlns:a="http://schemas.openxmlformats.org/drawingml/2006/main">
+            <a:r>
+              <a:t/>
+            </a:r>
+          </a:p>
+          <a:p xmlns:a="http://schemas.openxmlformats.org/drawingml/2006/main">
+            <a:r>
+              <a:t>[Clock discipline]</a:t>
+            </a:r>
+          </a:p>
+          <a:p xmlns:a="http://schemas.openxmlformats.org/drawingml/2006/main">
+            <a:r>
+              <a:t>Hard stop: finish by 20:00 in the core run or 23:00 in the expanded run. Both demo paths must be ready before the audience enters. On failure, inspect F12 once, name the issue and narrate the prepared evidence; no on-stage resets or retries.</a:t>
+            </a:r>
+          </a:p>
+          <a:p xmlns:a="http://schemas.openxmlformats.org/drawingml/2006/main">
+            <a:r>
+              <a:t/>
+            </a:r>
+          </a:p>
+          <a:p xmlns:a="http://schemas.openxmlformats.org/drawingml/2006/main">
+            <a:r>
+              <a:t>[Technical reference and source notes]</a:t>
+            </a:r>
+          </a:p>
+          <a:p xmlns:a="http://schemas.openxmlformats.org/drawingml/2006/main">
+            <a:r>
+              <a:t>Use for rehearsal and Q&amp;A; do not read all reference detail aloud. The core-delivery cue above sets the live scope.</a:t>
+            </a:r>
+          </a:p>
+          <a:p xmlns:a="http://schemas.openxmlformats.org/drawingml/2006/main">
+            <a:r>
+              <a:t/>
+            </a:r>
+          </a:p>
+          <a:p xmlns:a="http://schemas.openxmlformats.org/drawingml/2006/main">
+            <a:r>
+              <a:t>Use the core demo budget to prove the machinery before asking an LLM to use it. Before the session, start the built 0.1.5 source with --demo; during the demo, focus Demo Coordinator and type START. Observe the exact SEND, local STATUS acknowledgement, and REPLY. Verify deterministic calculateTotal([19, 23]) = 42. Open F12 and point to delivered SEND/REPLY with the same thread and different message IDs. STATUS does not appear in routed Activity. No network or credentials are required. These are deterministic fixtures, never describe them as reasoning agents.</a:t>
+            </a:r>
+          </a:p>
+          <a:p xmlns:a="http://schemas.openxmlformats.org/drawingml/2006/main">
+            <a:r>
+              <a:t>Rehearsal/reset reference only (do not spend stage time retrying): when both roles have exited, Ctrl+O can offer a newly seeded demo. While either role is live, Ctrl+O is normal Orchestrate; relaunch --demo for a clean reset.</a:t>
             </a:r>
           </a:p>
           <a:p xmlns:a="http://schemas.openxmlformats.org/drawingml/2006/main">
@@ -1115,7 +1390,7 @@
           </a:p>
           <a:p xmlns:a="http://schemas.openxmlformats.org/drawingml/2006/main">
             <a:r>
-              <a:t>6 minutes</a:t>
+              <a:t>5 minutes</a:t>
             </a:r>
           </a:p>
           <a:p xmlns:a="http://schemas.openxmlformats.org/drawingml/2006/main">
@@ -1125,7 +1400,92 @@
           </a:p>
           <a:p xmlns:a="http://schemas.openxmlformats.org/drawingml/2006/main">
             <a:r>
-              <a:t>6 minutes. Start exactly two authenticated real CLI sessions: Panel 1 Codex CLI, Panel 2 Claude Code. Run --conference --panels 2 from the source checkout. Before the audience enters, finish authentication and press Ctrl+P separately in both panels.</a:t>
+              <a:t>[Slot pacing]</a:t>
+            </a:r>
+          </a:p>
+          <a:p xmlns:a="http://schemas.openxmlformats.org/drawingml/2006/main">
+            <a:r>
+              <a:t>40/45-minute slot: 20:00–25:00 (5 minutes core).</a:t>
+            </a:r>
+          </a:p>
+          <a:p xmlns:a="http://schemas.openxmlformats.org/drawingml/2006/main">
+            <a:r>
+              <a:t>Confirmed 50-minute slot: 23:00–29:00 (6 minutes, including 1 minutes optional depth).</a:t>
+            </a:r>
+          </a:p>
+          <a:p xmlns:a="http://schemas.openxmlformats.org/drawingml/2006/main">
+            <a:r>
+              <a:t>Budgets include transitions and brief clarifications. These are rehearsal targets, not automatic slide advances.</a:t>
+            </a:r>
+          </a:p>
+          <a:p xmlns:a="http://schemas.openxmlformats.org/drawingml/2006/main">
+            <a:r>
+              <a:t/>
+            </a:r>
+          </a:p>
+          <a:p xmlns:a="http://schemas.openxmlformats.org/drawingml/2006/main">
+            <a:r>
+              <a:t>[Core delivery]</a:t>
+            </a:r>
+          </a:p>
+          <a:p xmlns:a="http://schemas.openxmlformats.org/drawingml/2006/main">
+            <a:r>
+              <a:t>Use exactly two preauthenticated agents. Submit the prepared read-only prompt, follow proposal → challenge → refinement, and inspect the shared thread in F12. Three response waits of at most 45 seconds fit inside the five-minute segment; the segment deadline always takes priority.</a:t>
+            </a:r>
+          </a:p>
+          <a:p xmlns:a="http://schemas.openxmlformats.org/drawingml/2006/main">
+            <a:r>
+              <a:t/>
+            </a:r>
+          </a:p>
+          <a:p xmlns:a="http://schemas.openxmlformats.org/drawingml/2006/main">
+            <a:r>
+              <a:t>[Optional — confirmed 50-minute slot only]</a:t>
+            </a:r>
+          </a:p>
+          <a:p xmlns:a="http://schemas.openxmlformats.org/drawingml/2006/main">
+            <a:r>
+              <a:t>Add one minute discussing the challenge/refinement evidence already observed. Do not add agents, prompts, response-wait allowance or retries. Skip if behind schedule; preserve Q&amp;A.</a:t>
+            </a:r>
+          </a:p>
+          <a:p xmlns:a="http://schemas.openxmlformats.org/drawingml/2006/main">
+            <a:r>
+              <a:t/>
+            </a:r>
+          </a:p>
+          <a:p xmlns:a="http://schemas.openxmlformats.org/drawingml/2006/main">
+            <a:r>
+              <a:t>[Clock discipline]</a:t>
+            </a:r>
+          </a:p>
+          <a:p xmlns:a="http://schemas.openxmlformats.org/drawingml/2006/main">
+            <a:r>
+              <a:t>Hard stop: finish by 25:00 in the core run or 29:00 in the expanded run. Wait at most 45 seconds per response, never beyond the segment deadline. On timeout, authentication, provider or routing error, open F12 once, name the visible issue and narrate the prepared proposal/challenge/refinement. Do not debug credentials on stage.</a:t>
+            </a:r>
+          </a:p>
+          <a:p xmlns:a="http://schemas.openxmlformats.org/drawingml/2006/main">
+            <a:r>
+              <a:t/>
+            </a:r>
+          </a:p>
+          <a:p xmlns:a="http://schemas.openxmlformats.org/drawingml/2006/main">
+            <a:r>
+              <a:t>[Technical reference and source notes]</a:t>
+            </a:r>
+          </a:p>
+          <a:p xmlns:a="http://schemas.openxmlformats.org/drawingml/2006/main">
+            <a:r>
+              <a:t>Use for rehearsal and Q&amp;A; do not read all reference detail aloud. The core-delivery cue above sets the live scope.</a:t>
+            </a:r>
+          </a:p>
+          <a:p xmlns:a="http://schemas.openxmlformats.org/drawingml/2006/main">
+            <a:r>
+              <a:t/>
+            </a:r>
+          </a:p>
+          <a:p xmlns:a="http://schemas.openxmlformats.org/drawingml/2006/main">
+            <a:r>
+              <a:t>Before the session, start exactly two authenticated real CLI sessions: Panel 1 Codex CLI, Panel 2 Claude Code. Run --conference --panels 2 from the source checkout. Before the audience enters, finish authentication and press Ctrl+P separately in both panels.</a:t>
             </a:r>
           </a:p>
           <a:p xmlns:a="http://schemas.openxmlformats.org/drawingml/2006/main">
@@ -1310,6 +1670,76 @@
           </a:p>
           <a:p xmlns:a="http://schemas.openxmlformats.org/drawingml/2006/main">
             <a:r>
+              <a:t>[Slot pacing]</a:t>
+            </a:r>
+          </a:p>
+          <a:p xmlns:a="http://schemas.openxmlformats.org/drawingml/2006/main">
+            <a:r>
+              <a:t>40/45-minute slot: 25:00–26:30 (1.5 minutes core).</a:t>
+            </a:r>
+          </a:p>
+          <a:p xmlns:a="http://schemas.openxmlformats.org/drawingml/2006/main">
+            <a:r>
+              <a:t>Confirmed 50-minute slot: 29:00–30:30 (1.5 minutes).</a:t>
+            </a:r>
+          </a:p>
+          <a:p xmlns:a="http://schemas.openxmlformats.org/drawingml/2006/main">
+            <a:r>
+              <a:t>Budgets include transitions and brief clarifications. These are rehearsal targets, not automatic slide advances.</a:t>
+            </a:r>
+          </a:p>
+          <a:p xmlns:a="http://schemas.openxmlformats.org/drawingml/2006/main">
+            <a:r>
+              <a:t/>
+            </a:r>
+          </a:p>
+          <a:p xmlns:a="http://schemas.openxmlformats.org/drawingml/2006/main">
+            <a:r>
+              <a:t>[Core delivery]</a:t>
+            </a:r>
+          </a:p>
+          <a:p xmlns:a="http://schemas.openxmlformats.org/drawingml/2006/main">
+            <a:r>
+              <a:t>Use the genuine Activity capture to identify source, destination, delivery state and thread. Separate transport evidence from semantic quality and from the opt-in capture pipeline.</a:t>
+            </a:r>
+          </a:p>
+          <a:p xmlns:a="http://schemas.openxmlformats.org/drawingml/2006/main">
+            <a:r>
+              <a:t/>
+            </a:r>
+          </a:p>
+          <a:p xmlns:a="http://schemas.openxmlformats.org/drawingml/2006/main">
+            <a:r>
+              <a:t>[Clock discipline]</a:t>
+            </a:r>
+          </a:p>
+          <a:p xmlns:a="http://schemas.openxmlformats.org/drawingml/2006/main">
+            <a:r>
+              <a:t>If behind, give this slide in 30 seconds, recovering one minute. The screenshot is available evidence; there is no need to reproduce it live.</a:t>
+            </a:r>
+          </a:p>
+          <a:p xmlns:a="http://schemas.openxmlformats.org/drawingml/2006/main">
+            <a:r>
+              <a:t/>
+            </a:r>
+          </a:p>
+          <a:p xmlns:a="http://schemas.openxmlformats.org/drawingml/2006/main">
+            <a:r>
+              <a:t>[Technical reference and source notes]</a:t>
+            </a:r>
+          </a:p>
+          <a:p xmlns:a="http://schemas.openxmlformats.org/drawingml/2006/main">
+            <a:r>
+              <a:t>Use for rehearsal and Q&amp;A; do not read all reference detail aloud. The core-delivery cue above sets the live scope.</a:t>
+            </a:r>
+          </a:p>
+          <a:p xmlns:a="http://schemas.openxmlformats.org/drawingml/2006/main">
+            <a:r>
+              <a:t/>
+            </a:r>
+          </a:p>
+          <a:p xmlns:a="http://schemas.openxmlformats.org/drawingml/2006/main">
+            <a:r>
               <a:t>1.5 minutes. Show the proof at readable size: newest-first Activity contains two delivered routed records, one SEND and one REPLY. The thread is thr_000001 for both; msg_000001 and msg_000002 identify different messages. Activity is in memory and bounded. It is not a durable audit log; STATUS and QUERY are local effects and absent here. Delivered is submission, not semantic correctness.</a:t>
             </a:r>
           </a:p>
@@ -1415,7 +1845,7 @@
           </a:p>
           <a:p xmlns:a="http://schemas.openxmlformats.org/drawingml/2006/main">
             <a:r>
-              <a:t>1.5 minutes</a:t>
+              <a:t>2 minutes</a:t>
             </a:r>
           </a:p>
           <a:p xmlns:a="http://schemas.openxmlformats.org/drawingml/2006/main">
@@ -1425,7 +1855,77 @@
           </a:p>
           <a:p xmlns:a="http://schemas.openxmlformats.org/drawingml/2006/main">
             <a:r>
-              <a:t>1.5 minutes. Human controls are primary: F11 finds panels, F12 exposes routed activity, Ctrl+K stops the active session. Optional Codex Micro is an experimental physical control surface, not an autonomous approval agent. Prefer wired USB. Close ChatGPT Desktop or disable its Input Monitoring permission and restart it, then grant the presentation terminal Input Monitoring. Rehearse --doctor --codex-micro and --codex-micro-test first. MICRO:BUSY fails closed and drops device input when another HID reader is detected. This is not OS-enforced exclusive access. Stop pressing controls, close the competing reader and wait for MICRO:USB/GUARD. Guarded decision buttons are off unless --codex-micro-decisions is explicitly enabled. Do not promise arbitrary provider prompt recognition or firmware/RGB control. Keyboard fallback has no reader guard and disables decisions; ChatGPT must stay quit.</a:t>
+              <a:t>[Slot pacing]</a:t>
+            </a:r>
+          </a:p>
+          <a:p xmlns:a="http://schemas.openxmlformats.org/drawingml/2006/main">
+            <a:r>
+              <a:t>40/45-minute slot: 26:30–28:30 (2 minutes core).</a:t>
+            </a:r>
+          </a:p>
+          <a:p xmlns:a="http://schemas.openxmlformats.org/drawingml/2006/main">
+            <a:r>
+              <a:t>Confirmed 50-minute slot: 30:30–32:30 (2 minutes).</a:t>
+            </a:r>
+          </a:p>
+          <a:p xmlns:a="http://schemas.openxmlformats.org/drawingml/2006/main">
+            <a:r>
+              <a:t>Budgets include transitions and brief clarifications. These are rehearsal targets, not automatic slide advances.</a:t>
+            </a:r>
+          </a:p>
+          <a:p xmlns:a="http://schemas.openxmlformats.org/drawingml/2006/main">
+            <a:r>
+              <a:t/>
+            </a:r>
+          </a:p>
+          <a:p xmlns:a="http://schemas.openxmlformats.org/drawingml/2006/main">
+            <a:r>
+              <a:t>[Core delivery]</a:t>
+            </a:r>
+          </a:p>
+          <a:p xmlns:a="http://schemas.openxmlformats.org/drawingml/2006/main">
+            <a:r>
+              <a:t>Demonstrate selecting a panel, inspecting Activity and interrupting an agent. Keep the optional physical-control demonstration brief; if the device is unavailable, demonstrate the keyboard immediately. Hardware setup and permissions are preflight work, not stage content.</a:t>
+            </a:r>
+          </a:p>
+          <a:p xmlns:a="http://schemas.openxmlformats.org/drawingml/2006/main">
+            <a:r>
+              <a:t/>
+            </a:r>
+          </a:p>
+          <a:p xmlns:a="http://schemas.openxmlformats.org/drawingml/2006/main">
+            <a:r>
+              <a:t>[Clock discipline]</a:t>
+            </a:r>
+          </a:p>
+          <a:p xmlns:a="http://schemas.openxmlformats.org/drawingml/2006/main">
+            <a:r>
+              <a:t>If behind, give the human-control message in 30 seconds, recovering 1.5 minutes. Never troubleshoot the device on stage; the keyboard keeps the talk independent of hardware.</a:t>
+            </a:r>
+          </a:p>
+          <a:p xmlns:a="http://schemas.openxmlformats.org/drawingml/2006/main">
+            <a:r>
+              <a:t/>
+            </a:r>
+          </a:p>
+          <a:p xmlns:a="http://schemas.openxmlformats.org/drawingml/2006/main">
+            <a:r>
+              <a:t>[Technical reference and source notes]</a:t>
+            </a:r>
+          </a:p>
+          <a:p xmlns:a="http://schemas.openxmlformats.org/drawingml/2006/main">
+            <a:r>
+              <a:t>Use for rehearsal and Q&amp;A; do not read all reference detail aloud. The core-delivery cue above sets the live scope.</a:t>
+            </a:r>
+          </a:p>
+          <a:p xmlns:a="http://schemas.openxmlformats.org/drawingml/2006/main">
+            <a:r>
+              <a:t/>
+            </a:r>
+          </a:p>
+          <a:p xmlns:a="http://schemas.openxmlformats.org/drawingml/2006/main">
+            <a:r>
+              <a:t>Human controls are primary: F11 finds panels, F12 exposes routed activity, Ctrl+K stops the active session. Optional Codex Micro is an experimental physical control surface, not an autonomous approval agent. Prefer wired USB. Close ChatGPT Desktop or disable its Input Monitoring permission and restart it, then grant the presentation terminal Input Monitoring. Rehearse --doctor --codex-micro and --codex-micro-test first. MICRO:BUSY fails closed and drops device input when another HID reader is detected. This is not OS-enforced exclusive access. Stop pressing controls, close the competing reader and wait for MICRO:USB/GUARD. Guarded decision buttons are off unless --codex-micro-decisions is explicitly enabled. Do not promise arbitrary provider prompt recognition or firmware/RGB control. Keyboard fallback has no reader guard and disables decisions; ChatGPT must stay quit.</a:t>
             </a:r>
           </a:p>
           <a:p xmlns:a="http://schemas.openxmlformats.org/drawingml/2006/main">
@@ -1540,6 +2040,76 @@
           </a:p>
           <a:p xmlns:a="http://schemas.openxmlformats.org/drawingml/2006/main">
             <a:r>
+              <a:t>[Slot pacing]</a:t>
+            </a:r>
+          </a:p>
+          <a:p xmlns:a="http://schemas.openxmlformats.org/drawingml/2006/main">
+            <a:r>
+              <a:t>40/45-minute slot: 28:30–30:00 (1.5 minutes core).</a:t>
+            </a:r>
+          </a:p>
+          <a:p xmlns:a="http://schemas.openxmlformats.org/drawingml/2006/main">
+            <a:r>
+              <a:t>Confirmed 50-minute slot: 32:30–34:00 (1.5 minutes).</a:t>
+            </a:r>
+          </a:p>
+          <a:p xmlns:a="http://schemas.openxmlformats.org/drawingml/2006/main">
+            <a:r>
+              <a:t>Budgets include transitions and brief clarifications. These are rehearsal targets, not automatic slide advances.</a:t>
+            </a:r>
+          </a:p>
+          <a:p xmlns:a="http://schemas.openxmlformats.org/drawingml/2006/main">
+            <a:r>
+              <a:t/>
+            </a:r>
+          </a:p>
+          <a:p xmlns:a="http://schemas.openxmlformats.org/drawingml/2006/main">
+            <a:r>
+              <a:t>[Core delivery]</a:t>
+            </a:r>
+          </a:p>
+          <a:p xmlns:a="http://schemas.openxmlformats.org/drawingml/2006/main">
+            <a:r>
+              <a:t>Walk one branch of the recovery tree: observe the failure, stop waiting, and use the prepared evidence. Emphasize that a visible failure is a valid result; do not launch another demo.</a:t>
+            </a:r>
+          </a:p>
+          <a:p xmlns:a="http://schemas.openxmlformats.org/drawingml/2006/main">
+            <a:r>
+              <a:t/>
+            </a:r>
+          </a:p>
+          <a:p xmlns:a="http://schemas.openxmlformats.org/drawingml/2006/main">
+            <a:r>
+              <a:t>[Clock discipline]</a:t>
+            </a:r>
+          </a:p>
+          <a:p xmlns:a="http://schemas.openxmlformats.org/drawingml/2006/main">
+            <a:r>
+              <a:t>Checkpoint: finish controls and recovery by 30:00 in the core run or 34:00 in the expanded run. If behind, drop optional depth and close remaining points concisely. Preserve the implemented-dataset versus future-training distinction.</a:t>
+            </a:r>
+          </a:p>
+          <a:p xmlns:a="http://schemas.openxmlformats.org/drawingml/2006/main">
+            <a:r>
+              <a:t/>
+            </a:r>
+          </a:p>
+          <a:p xmlns:a="http://schemas.openxmlformats.org/drawingml/2006/main">
+            <a:r>
+              <a:t>[Technical reference and source notes]</a:t>
+            </a:r>
+          </a:p>
+          <a:p xmlns:a="http://schemas.openxmlformats.org/drawingml/2006/main">
+            <a:r>
+              <a:t>Use for rehearsal and Q&amp;A; do not read all reference detail aloud. The core-delivery cue above sets the live scope.</a:t>
+            </a:r>
+          </a:p>
+          <a:p xmlns:a="http://schemas.openxmlformats.org/drawingml/2006/main">
+            <a:r>
+              <a:t/>
+            </a:r>
+          </a:p>
+          <a:p xmlns:a="http://schemas.openxmlformats.org/drawingml/2006/main">
+            <a:r>
               <a:t>1.5 minutes. This is a recovery policy, not a retry loop. At 45 seconds per response or any auth/provider/routing failure, inspect F12 once, describe only what is visible, and stop waiting. Use the deterministic offline runtime to prove transport; use the prepared slide 13 content to discuss proposal/challenge/refinement, clearly labeled as prepared. If Micro fails, use a normal keyboard; no agent depends on it. Ctrl+K stops an active session. F10 escalates tracked process groups from SIGINT through SIGTERM to SIGKILL, waits, and restores the terminal. Do not clear a running layout accidentally: focus a file panel before Ctrl+E and confirm live sessions.</a:t>
             </a:r>
           </a:p>
@@ -1655,6 +2225,61 @@
           </a:p>
           <a:p xmlns:a="http://schemas.openxmlformats.org/drawingml/2006/main">
             <a:r>
+              <a:t>[Slot pacing]</a:t>
+            </a:r>
+          </a:p>
+          <a:p xmlns:a="http://schemas.openxmlformats.org/drawingml/2006/main">
+            <a:r>
+              <a:t>40/45-minute slot: 30:00–31:00 (1 minutes core).</a:t>
+            </a:r>
+          </a:p>
+          <a:p xmlns:a="http://schemas.openxmlformats.org/drawingml/2006/main">
+            <a:r>
+              <a:t>Confirmed 50-minute slot: 34:00–35:00 (1 minutes).</a:t>
+            </a:r>
+          </a:p>
+          <a:p xmlns:a="http://schemas.openxmlformats.org/drawingml/2006/main">
+            <a:r>
+              <a:t>Budgets include transitions and brief clarifications. These are rehearsal targets, not automatic slide advances.</a:t>
+            </a:r>
+          </a:p>
+          <a:p xmlns:a="http://schemas.openxmlformats.org/drawingml/2006/main">
+            <a:r>
+              <a:t/>
+            </a:r>
+          </a:p>
+          <a:p xmlns:a="http://schemas.openxmlformats.org/drawingml/2006/main">
+            <a:r>
+              <a:t>[Core delivery]</a:t>
+            </a:r>
+          </a:p>
+          <a:p xmlns:a="http://schemas.openxmlformats.org/drawingml/2006/main">
+            <a:r>
+              <a:t>Point to the public npm package and distinguish its released version from the conference source build. Invite people to try it after the talk; do not install or authenticate on stage.</a:t>
+            </a:r>
+          </a:p>
+          <a:p xmlns:a="http://schemas.openxmlformats.org/drawingml/2006/main">
+            <a:r>
+              <a:t/>
+            </a:r>
+          </a:p>
+          <a:p xmlns:a="http://schemas.openxmlformats.org/drawingml/2006/main">
+            <a:r>
+              <a:t>[Technical reference and source notes]</a:t>
+            </a:r>
+          </a:p>
+          <a:p xmlns:a="http://schemas.openxmlformats.org/drawingml/2006/main">
+            <a:r>
+              <a:t>Use for rehearsal and Q&amp;A; do not read all reference detail aloud. The core-delivery cue above sets the live scope.</a:t>
+            </a:r>
+          </a:p>
+          <a:p xmlns:a="http://schemas.openxmlformats.org/drawingml/2006/main">
+            <a:r>
+              <a:t/>
+            </a:r>
+          </a:p>
+          <a:p xmlns:a="http://schemas.openxmlformats.org/drawingml/2006/main">
+            <a:r>
               <a:t>1 minute. Public availability is real: npm latest was verified as 0.1.4 on 2026-09-02. Show the pinned, runnable command npx agents-commander@0.1.4 . . That package is the earlier public CLI, not the conference feature set. Public 0.1.4 declares Node &gt;=18 in stale package metadata, but dependencies are stricter; use Node22+ and supports the earlier panel/theme/directory flags; --demo, --doctor and --conference are not public 0.1.4 flags. Today’s technical deck and captures use 0.1.5 built from this source checkout, Node22+ and Python3. Do not claim 0.1.5 is published. Source is CC-BY-NC-4.0: publicly available, not unrestricted commercial use or OSI open source.</a:t>
             </a:r>
           </a:p>
@@ -1746,11 +2371,6 @@
           <a:p xmlns:a="http://schemas.openxmlformats.org/drawingml/2006/main">
             <a:r>
               <a:t>Commander logo: user-approved Classic Blue pixel &gt;/&lt; mark, assets/logo.png. Built-in image generation; provenance and exact prompts: assets/BRAND.md.</a:t>
-            </a:r>
-          </a:p>
-          <a:p xmlns:a="http://schemas.openxmlformats.org/drawingml/2006/main">
-            <a:r>
-              <a:t/>
             </a:r>
           </a:p>
         </p:txBody>
@@ -1825,7 +2445,7 @@
           </a:p>
           <a:p xmlns:a="http://schemas.openxmlformats.org/drawingml/2006/main">
             <a:r>
-              <a:t>1.5 minutes</a:t>
+              <a:t>2 minutes</a:t>
             </a:r>
           </a:p>
           <a:p xmlns:a="http://schemas.openxmlformats.org/drawingml/2006/main">
@@ -1835,6 +2455,76 @@
           </a:p>
           <a:p xmlns:a="http://schemas.openxmlformats.org/drawingml/2006/main">
             <a:r>
+              <a:t>[Slot pacing]</a:t>
+            </a:r>
+          </a:p>
+          <a:p xmlns:a="http://schemas.openxmlformats.org/drawingml/2006/main">
+            <a:r>
+              <a:t>40/45-minute slot: 31:00–33:00 (2 minutes core).</a:t>
+            </a:r>
+          </a:p>
+          <a:p xmlns:a="http://schemas.openxmlformats.org/drawingml/2006/main">
+            <a:r>
+              <a:t>Confirmed 50-minute slot: 35:00–38:00 (3 minutes, including 1 minutes optional depth).</a:t>
+            </a:r>
+          </a:p>
+          <a:p xmlns:a="http://schemas.openxmlformats.org/drawingml/2006/main">
+            <a:r>
+              <a:t>Budgets include transitions and brief clarifications. These are rehearsal targets, not automatic slide advances.</a:t>
+            </a:r>
+          </a:p>
+          <a:p xmlns:a="http://schemas.openxmlformats.org/drawingml/2006/main">
+            <a:r>
+              <a:t/>
+            </a:r>
+          </a:p>
+          <a:p xmlns:a="http://schemas.openxmlformats.org/drawingml/2006/main">
+            <a:r>
+              <a:t>[Core delivery]</a:t>
+            </a:r>
+          </a:p>
+          <a:p xmlns:a="http://schemas.openxmlformats.org/drawingml/2006/main">
+            <a:r>
+              <a:t>Trace capture → validated candidate → human review → split-aware export. Stress explicit capture, observed context, privacy/rights review and the separation between a validated training artifact and a good model.</a:t>
+            </a:r>
+          </a:p>
+          <a:p xmlns:a="http://schemas.openxmlformats.org/drawingml/2006/main">
+            <a:r>
+              <a:t/>
+            </a:r>
+          </a:p>
+          <a:p xmlns:a="http://schemas.openxmlformats.org/drawingml/2006/main">
+            <a:r>
+              <a:t>[Optional — confirmed 50-minute slot only]</a:t>
+            </a:r>
+          </a:p>
+          <a:p xmlns:a="http://schemas.openxmlformats.org/drawingml/2006/main">
+            <a:r>
+              <a:t>Add one minute tracing one candidate: group/split assignment is frozen before review, all review gates must pass, then export and validate. Do not begin model training on stage. Skip if behind schedule; preserve Q&amp;A.</a:t>
+            </a:r>
+          </a:p>
+          <a:p xmlns:a="http://schemas.openxmlformats.org/drawingml/2006/main">
+            <a:r>
+              <a:t/>
+            </a:r>
+          </a:p>
+          <a:p xmlns:a="http://schemas.openxmlformats.org/drawingml/2006/main">
+            <a:r>
+              <a:t>[Technical reference and source notes]</a:t>
+            </a:r>
+          </a:p>
+          <a:p xmlns:a="http://schemas.openxmlformats.org/drawingml/2006/main">
+            <a:r>
+              <a:t>Use for rehearsal and Q&amp;A; do not read all reference detail aloud. The core-delivery cue above sets the live scope.</a:t>
+            </a:r>
+          </a:p>
+          <a:p xmlns:a="http://schemas.openxmlformats.org/drawingml/2006/main">
+            <a:r>
+              <a:t/>
+            </a:r>
+          </a:p>
+          <a:p xmlns:a="http://schemas.openxmlformats.org/drawingml/2006/main">
+            <a:r>
               <a:t>This is the dataset-creation feature implemented today, not the future model-training step. Capture is explicitly enabled for each launch. The running app records semantic Commander events, mediated input and delivery outcomes, not full terminal transcripts, provider state or hidden reasoning. Each agent needs the protocol bootstrap; use Commander-mediated task entry to retain observable context. Raw/manual input marks the session context incomplete.</a:t>
             </a:r>
           </a:p>
@@ -1926,11 +2616,6 @@
           <a:p xmlns:a="http://schemas.openxmlformats.org/drawingml/2006/main">
             <a:r>
               <a:t>https://www.callstack.com/media-kit — inherited Callstack visual identity.</a:t>
-            </a:r>
-          </a:p>
-          <a:p xmlns:a="http://schemas.openxmlformats.org/drawingml/2006/main">
-            <a:r>
-              <a:t/>
             </a:r>
           </a:p>
         </p:txBody>
@@ -2005,7 +2690,7 @@
           </a:p>
           <a:p xmlns:a="http://schemas.openxmlformats.org/drawingml/2006/main">
             <a:r>
-              <a:t>1 minute</a:t>
+              <a:t>1.5 minutes</a:t>
             </a:r>
           </a:p>
           <a:p xmlns:a="http://schemas.openxmlformats.org/drawingml/2006/main">
@@ -2015,6 +2700,61 @@
           </a:p>
           <a:p xmlns:a="http://schemas.openxmlformats.org/drawingml/2006/main">
             <a:r>
+              <a:t>[Slot pacing]</a:t>
+            </a:r>
+          </a:p>
+          <a:p xmlns:a="http://schemas.openxmlformats.org/drawingml/2006/main">
+            <a:r>
+              <a:t>40/45-minute slot: 33:00–34:30 (1.5 minutes core).</a:t>
+            </a:r>
+          </a:p>
+          <a:p xmlns:a="http://schemas.openxmlformats.org/drawingml/2006/main">
+            <a:r>
+              <a:t>Confirmed 50-minute slot: 38:00–39:30 (1.5 minutes).</a:t>
+            </a:r>
+          </a:p>
+          <a:p xmlns:a="http://schemas.openxmlformats.org/drawingml/2006/main">
+            <a:r>
+              <a:t>Budgets include transitions and brief clarifications. These are rehearsal targets, not automatic slide advances.</a:t>
+            </a:r>
+          </a:p>
+          <a:p xmlns:a="http://schemas.openxmlformats.org/drawingml/2006/main">
+            <a:r>
+              <a:t/>
+            </a:r>
+          </a:p>
+          <a:p xmlns:a="http://schemas.openxmlformats.org/drawingml/2006/main">
+            <a:r>
+              <a:t>[Core delivery]</a:t>
+            </a:r>
+          </a:p>
+          <a:p xmlns:a="http://schemas.openxmlformats.org/drawingml/2006/main">
+            <a:r>
+              <a:t>Describe the next step: train and evaluate model-specific adapters on reviewed Commander Protocol examples. State plainly that dataset creation exists today, while LoRA training and measured model quality are future work; one adapter is not universal across every model.</a:t>
+            </a:r>
+          </a:p>
+          <a:p xmlns:a="http://schemas.openxmlformats.org/drawingml/2006/main">
+            <a:r>
+              <a:t/>
+            </a:r>
+          </a:p>
+          <a:p xmlns:a="http://schemas.openxmlformats.org/drawingml/2006/main">
+            <a:r>
+              <a:t>[Technical reference and source notes]</a:t>
+            </a:r>
+          </a:p>
+          <a:p xmlns:a="http://schemas.openxmlformats.org/drawingml/2006/main">
+            <a:r>
+              <a:t>Use for rehearsal and Q&amp;A; do not read all reference detail aloud. The core-delivery cue above sets the live scope.</a:t>
+            </a:r>
+          </a:p>
+          <a:p xmlns:a="http://schemas.openxmlformats.org/drawingml/2006/main">
+            <a:r>
+              <a:t/>
+            </a:r>
+          </a:p>
+          <a:p xmlns:a="http://schemas.openxmlformats.org/drawingml/2006/main">
+            <a:r>
               <a:t>Today, Agents Commander can capture its communication layer with explicit consent and turn reviewed examples into structured training data. The next step is to teach a trainable model the Commander Protocol through a LoRA adapter: how to address another agent, return a reply, and produce a complete frame. The ambition is broad model interoperability, not one universal adapter. The dataset can be reused, but each adapter needs a compatible base model, tokenizer and training configuration. We would compare the adapted model with the prompted base model on unseen project groups: frame validity, routing behavior and useful collaboration. Training and model evaluation are future work, not completed results. Commander’s runtime guards remain in control.</a:t>
             </a:r>
           </a:p>
@@ -2066,11 +2806,6 @@
           <a:p xmlns:a="http://schemas.openxmlformats.org/drawingml/2006/main">
             <a:r>
               <a:t>https://www.callstack.com/media-kit — inherited Callstack visual identity.</a:t>
-            </a:r>
-          </a:p>
-          <a:p xmlns:a="http://schemas.openxmlformats.org/drawingml/2006/main">
-            <a:r>
-              <a:t/>
             </a:r>
           </a:p>
         </p:txBody>
@@ -2145,7 +2880,62 @@
           </a:p>
           <a:p xmlns:a="http://schemas.openxmlformats.org/drawingml/2006/main">
             <a:r>
-              <a:t>1.5 minutes</a:t>
+              <a:t>1 minutes</a:t>
+            </a:r>
+          </a:p>
+          <a:p xmlns:a="http://schemas.openxmlformats.org/drawingml/2006/main">
+            <a:r>
+              <a:t/>
+            </a:r>
+          </a:p>
+          <a:p xmlns:a="http://schemas.openxmlformats.org/drawingml/2006/main">
+            <a:r>
+              <a:t>[Slot pacing]</a:t>
+            </a:r>
+          </a:p>
+          <a:p xmlns:a="http://schemas.openxmlformats.org/drawingml/2006/main">
+            <a:r>
+              <a:t>40/45-minute slot: 00:30–01:30 (1 minutes core).</a:t>
+            </a:r>
+          </a:p>
+          <a:p xmlns:a="http://schemas.openxmlformats.org/drawingml/2006/main">
+            <a:r>
+              <a:t>Confirmed 50-minute slot: 00:30–01:30 (1 minutes).</a:t>
+            </a:r>
+          </a:p>
+          <a:p xmlns:a="http://schemas.openxmlformats.org/drawingml/2006/main">
+            <a:r>
+              <a:t>Budgets include transitions and brief clarifications. These are rehearsal targets, not automatic slide advances.</a:t>
+            </a:r>
+          </a:p>
+          <a:p xmlns:a="http://schemas.openxmlformats.org/drawingml/2006/main">
+            <a:r>
+              <a:t/>
+            </a:r>
+          </a:p>
+          <a:p xmlns:a="http://schemas.openxmlformats.org/drawingml/2006/main">
+            <a:r>
+              <a:t>[Core delivery]</a:t>
+            </a:r>
+          </a:p>
+          <a:p xmlns:a="http://schemas.openxmlformats.org/drawingml/2006/main">
+            <a:r>
+              <a:t>Orient the audience to the running agents, panel navigation and visible terminals. Point to one handoff; leave the full control tour for slide 15.</a:t>
+            </a:r>
+          </a:p>
+          <a:p xmlns:a="http://schemas.openxmlformats.org/drawingml/2006/main">
+            <a:r>
+              <a:t/>
+            </a:r>
+          </a:p>
+          <a:p xmlns:a="http://schemas.openxmlformats.org/drawingml/2006/main">
+            <a:r>
+              <a:t>[Technical reference and source notes]</a:t>
+            </a:r>
+          </a:p>
+          <a:p xmlns:a="http://schemas.openxmlformats.org/drawingml/2006/main">
+            <a:r>
+              <a:t>Use for rehearsal and Q&amp;A; do not read all reference detail aloud. The core-delivery cue above sets the live scope.</a:t>
             </a:r>
           </a:p>
           <a:p xmlns:a="http://schemas.openxmlformats.org/drawingml/2006/main">
@@ -2270,6 +3060,76 @@
           </a:p>
           <a:p xmlns:a="http://schemas.openxmlformats.org/drawingml/2006/main">
             <a:r>
+              <a:t>[Slot pacing]</a:t>
+            </a:r>
+          </a:p>
+          <a:p xmlns:a="http://schemas.openxmlformats.org/drawingml/2006/main">
+            <a:r>
+              <a:t>40/45-minute slot: 34:30–35:00 (0.5 minutes core).</a:t>
+            </a:r>
+          </a:p>
+          <a:p xmlns:a="http://schemas.openxmlformats.org/drawingml/2006/main">
+            <a:r>
+              <a:t>Confirmed 50-minute slot: 39:30–40:00 (0.5 minutes).</a:t>
+            </a:r>
+          </a:p>
+          <a:p xmlns:a="http://schemas.openxmlformats.org/drawingml/2006/main">
+            <a:r>
+              <a:t>Budgets include transitions and brief clarifications. These are rehearsal targets, not automatic slide advances.</a:t>
+            </a:r>
+          </a:p>
+          <a:p xmlns:a="http://schemas.openxmlformats.org/drawingml/2006/main">
+            <a:r>
+              <a:t/>
+            </a:r>
+          </a:p>
+          <a:p xmlns:a="http://schemas.openxmlformats.org/drawingml/2006/main">
+            <a:r>
+              <a:t>[Core delivery]</a:t>
+            </a:r>
+          </a:p>
+          <a:p xmlns:a="http://schemas.openxmlformats.org/drawingml/2006/main">
+            <a:r>
+              <a:t>Give the Agent Conf invitation and point to the event link. Keep it to one short invitation, then hand the remaining slot to audience questions.</a:t>
+            </a:r>
+          </a:p>
+          <a:p xmlns:a="http://schemas.openxmlformats.org/drawingml/2006/main">
+            <a:r>
+              <a:t/>
+            </a:r>
+          </a:p>
+          <a:p xmlns:a="http://schemas.openxmlformats.org/drawingml/2006/main">
+            <a:r>
+              <a:t>[Clock discipline]</a:t>
+            </a:r>
+          </a:p>
+          <a:p xmlns:a="http://schemas.openxmlformats.org/drawingml/2006/main">
+            <a:r>
+              <a:t>Content hard stop: open Q&amp;A at 35:00 unless the moderator explicitly confirmed a 50-minute slot; that expanded run opens Q&amp;A at 40:00. Park unfinished prepared content for questions. Do not assume the upper end of the 40–50-minute range is available.</a:t>
+            </a:r>
+          </a:p>
+          <a:p xmlns:a="http://schemas.openxmlformats.org/drawingml/2006/main">
+            <a:r>
+              <a:t/>
+            </a:r>
+          </a:p>
+          <a:p xmlns:a="http://schemas.openxmlformats.org/drawingml/2006/main">
+            <a:r>
+              <a:t>[Technical reference and source notes]</a:t>
+            </a:r>
+          </a:p>
+          <a:p xmlns:a="http://schemas.openxmlformats.org/drawingml/2006/main">
+            <a:r>
+              <a:t>Use for rehearsal and Q&amp;A; do not read all reference detail aloud. The core-delivery cue above sets the live scope.</a:t>
+            </a:r>
+          </a:p>
+          <a:p xmlns:a="http://schemas.openxmlformats.org/drawingml/2006/main">
+            <a:r>
+              <a:t/>
+            </a:r>
+          </a:p>
+          <a:p xmlns:a="http://schemas.openxmlformats.org/drawingml/2006/main">
+            <a:r>
               <a:t>If today’s local agent collaboration raises questions you want to keep exploring, join us at Agent Conf in Warsaw on 17–18 September 2026. Callstack is bringing engineers together around agent engineering, multi-agent orchestration and lessons from real adoption. The venue is Crowne Plaza Warsaw [The HUB]. Show the ticket link, then return to questions. No price or discount is promised. Event details checked 2026-09-02; recheck before presenting.</a:t>
             </a:r>
           </a:p>
@@ -2326,11 +3186,6 @@
           <a:p xmlns:a="http://schemas.openxmlformats.org/drawingml/2006/main">
             <a:r>
               <a:t>Commander logo: user-approved Classic Blue pixel &gt;/&lt; mark, assets/logo.png. Built-in image generation; provenance and exact prompts: assets/BRAND.md.</a:t>
-            </a:r>
-          </a:p>
-          <a:p xmlns:a="http://schemas.openxmlformats.org/drawingml/2006/main">
-            <a:r>
-              <a:t/>
             </a:r>
           </a:p>
         </p:txBody>
@@ -2400,7 +3255,12 @@
           <a:lstStyle xmlns:a="http://schemas.openxmlformats.org/drawingml/2006/main"/>
           <a:p xmlns:a="http://schemas.openxmlformats.org/drawingml/2006/main">
             <a:r>
-              <a:t>[Timing] 5:00</a:t>
+              <a:t>[Timing]</a:t>
+            </a:r>
+          </a:p>
+          <a:p xmlns:a="http://schemas.openxmlformats.org/drawingml/2006/main">
+            <a:r>
+              <a:t>10 minutes</a:t>
             </a:r>
           </a:p>
           <a:p xmlns:a="http://schemas.openxmlformats.org/drawingml/2006/main">
@@ -2410,6 +3270,81 @@
           </a:p>
           <a:p xmlns:a="http://schemas.openxmlformats.org/drawingml/2006/main">
             <a:r>
+              <a:t>[Slot pacing]</a:t>
+            </a:r>
+          </a:p>
+          <a:p xmlns:a="http://schemas.openxmlformats.org/drawingml/2006/main">
+            <a:r>
+              <a:t>40-minute slot: 35:00–40:00 (5 minutes Q&amp;A).</a:t>
+            </a:r>
+          </a:p>
+          <a:p xmlns:a="http://schemas.openxmlformats.org/drawingml/2006/main">
+            <a:r>
+              <a:t>45-minute slot (default): 35:00–45:00 (10 minutes Q&amp;A).</a:t>
+            </a:r>
+          </a:p>
+          <a:p xmlns:a="http://schemas.openxmlformats.org/drawingml/2006/main">
+            <a:r>
+              <a:t>Confirmed 50-minute slot: 40:00–50:00 (10 minutes Q&amp;A).</a:t>
+            </a:r>
+          </a:p>
+          <a:p xmlns:a="http://schemas.openxmlformats.org/drawingml/2006/main">
+            <a:r>
+              <a:t>Budgets include transitions and brief clarifications. These are rehearsal targets, not automatic slide advances.</a:t>
+            </a:r>
+          </a:p>
+          <a:p xmlns:a="http://schemas.openxmlformats.org/drawingml/2006/main">
+            <a:r>
+              <a:t/>
+            </a:r>
+          </a:p>
+          <a:p xmlns:a="http://schemas.openxmlformats.org/drawingml/2006/main">
+            <a:r>
+              <a:t>[Core delivery]</a:t>
+            </a:r>
+          </a:p>
+          <a:p xmlns:a="http://schemas.openxmlformats.org/drawingml/2006/main">
+            <a:r>
+              <a:t>Invite questions on handoff evidence, agent disagreement and human interruption. If needed, use the prepared broadcast-authorization question. Keep answers focused and finish with the practical boundary: observable transport does not guarantee correct reasoning.</a:t>
+            </a:r>
+          </a:p>
+          <a:p xmlns:a="http://schemas.openxmlformats.org/drawingml/2006/main">
+            <a:r>
+              <a:t/>
+            </a:r>
+          </a:p>
+          <a:p xmlns:a="http://schemas.openxmlformats.org/drawingml/2006/main">
+            <a:r>
+              <a:t>[Clock discipline]</a:t>
+            </a:r>
+          </a:p>
+          <a:p xmlns:a="http://schemas.openxmlformats.org/drawingml/2006/main">
+            <a:r>
+              <a:t>Protect Q&amp;A: 35:00–40:00 for a 40-minute slot; 35:00–45:00 for the default 45-minute slot; 40:00–50:00 for a confirmed 50-minute slot. If content finishes early, start questions early. Finish at the moderator's agreed end; this is not extra time after the slot.</a:t>
+            </a:r>
+          </a:p>
+          <a:p xmlns:a="http://schemas.openxmlformats.org/drawingml/2006/main">
+            <a:r>
+              <a:t/>
+            </a:r>
+          </a:p>
+          <a:p xmlns:a="http://schemas.openxmlformats.org/drawingml/2006/main">
+            <a:r>
+              <a:t>[Technical reference and source notes]</a:t>
+            </a:r>
+          </a:p>
+          <a:p xmlns:a="http://schemas.openxmlformats.org/drawingml/2006/main">
+            <a:r>
+              <a:t>Use for rehearsal and Q&amp;A; do not read all reference detail aloud. The core-delivery cue above sets the live scope.</a:t>
+            </a:r>
+          </a:p>
+          <a:p xmlns:a="http://schemas.openxmlformats.org/drawingml/2006/main">
+            <a:r>
+              <a:t/>
+            </a:r>
+          </a:p>
+          <a:p xmlns:a="http://schemas.openxmlformats.org/drawingml/2006/main">
+            <a:r>
               <a:t>Use the prompts to structure Q&amp;A: what evidence must survive each handoff, when one agent should challenge another, and where a human interruption is mandatory.</a:t>
             </a:r>
           </a:p>
@@ -2521,11 +3456,6 @@
           <a:p xmlns:a="http://schemas.openxmlformats.org/drawingml/2006/main">
             <a:r>
               <a:t>Commander logo: user-approved Classic Blue pixel &gt;/&lt; mark, assets/logo.png. Built-in image generation; provenance and exact prompts: assets/BRAND.md.</a:t>
-            </a:r>
-          </a:p>
-          <a:p xmlns:a="http://schemas.openxmlformats.org/drawingml/2006/main">
-            <a:r>
-              <a:t/>
             </a:r>
           </a:p>
         </p:txBody>
@@ -2595,22 +3525,92 @@
           <a:lstStyle xmlns:a="http://schemas.openxmlformats.org/drawingml/2006/main"/>
           <a:p xmlns:a="http://schemas.openxmlformats.org/drawingml/2006/main">
             <a:r>
+              <a:t>[Timing]</a:t>
+            </a:r>
+          </a:p>
+          <a:p xmlns:a="http://schemas.openxmlformats.org/drawingml/2006/main">
+            <a:r>
+              <a:t>2.5 minutes</a:t>
+            </a:r>
+          </a:p>
+          <a:p xmlns:a="http://schemas.openxmlformats.org/drawingml/2006/main">
+            <a:r>
+              <a:t/>
+            </a:r>
+          </a:p>
+          <a:p xmlns:a="http://schemas.openxmlformats.org/drawingml/2006/main">
+            <a:r>
+              <a:t>[Slot pacing]</a:t>
+            </a:r>
+          </a:p>
+          <a:p xmlns:a="http://schemas.openxmlformats.org/drawingml/2006/main">
+            <a:r>
+              <a:t>40/45-minute slot: 01:30–04:00 (2.5 minutes core).</a:t>
+            </a:r>
+          </a:p>
+          <a:p xmlns:a="http://schemas.openxmlformats.org/drawingml/2006/main">
+            <a:r>
+              <a:t>Confirmed 50-minute slot: 01:30–05:00 (3.5 minutes, including 1 minutes optional depth).</a:t>
+            </a:r>
+          </a:p>
+          <a:p xmlns:a="http://schemas.openxmlformats.org/drawingml/2006/main">
+            <a:r>
+              <a:t>Budgets include transitions and brief clarifications. These are rehearsal targets, not automatic slide advances.</a:t>
+            </a:r>
+          </a:p>
+          <a:p xmlns:a="http://schemas.openxmlformats.org/drawingml/2006/main">
+            <a:r>
+              <a:t/>
+            </a:r>
+          </a:p>
+          <a:p xmlns:a="http://schemas.openxmlformats.org/drawingml/2006/main">
+            <a:r>
+              <a:t>[Core delivery]</a:t>
+            </a:r>
+          </a:p>
+          <a:p xmlns:a="http://schemas.openxmlformats.org/drawingml/2006/main">
+            <a:r>
+              <a:t>Trace one route from a CLI through its PTY to the local Commander process and another CLI. Distinguish the local routing process from each agent's external provider connection; no central Commander server does not mean no network.</a:t>
+            </a:r>
+          </a:p>
+          <a:p xmlns:a="http://schemas.openxmlformats.org/drawingml/2006/main">
+            <a:r>
+              <a:t/>
+            </a:r>
+          </a:p>
+          <a:p xmlns:a="http://schemas.openxmlformats.org/drawingml/2006/main">
+            <a:r>
+              <a:t>[Optional — confirmed 50-minute slot only]</a:t>
+            </a:r>
+          </a:p>
+          <a:p xmlns:a="http://schemas.openxmlformats.org/drawingml/2006/main">
+            <a:r>
+              <a:t>Add one minute tracing the local-process/PTY boundary and the provider connection for the same example. Do not introduce a second architecture. Skip if behind schedule; preserve Q&amp;A.</a:t>
+            </a:r>
+          </a:p>
+          <a:p xmlns:a="http://schemas.openxmlformats.org/drawingml/2006/main">
+            <a:r>
+              <a:t/>
+            </a:r>
+          </a:p>
+          <a:p xmlns:a="http://schemas.openxmlformats.org/drawingml/2006/main">
+            <a:r>
+              <a:t>[Technical reference and source notes]</a:t>
+            </a:r>
+          </a:p>
+          <a:p xmlns:a="http://schemas.openxmlformats.org/drawingml/2006/main">
+            <a:r>
+              <a:t>Use for rehearsal and Q&amp;A; do not read all reference detail aloud. The core-delivery cue above sets the live scope.</a:t>
+            </a:r>
+          </a:p>
+          <a:p xmlns:a="http://schemas.openxmlformats.org/drawingml/2006/main">
+            <a:r>
+              <a:t/>
+            </a:r>
+          </a:p>
+          <a:p xmlns:a="http://schemas.openxmlformats.org/drawingml/2006/main">
+            <a:r>
               <a:t>SLIDE 3 — Architecture: a local terminal control plane</a:t>
-            </a:r>
-          </a:p>
-          <a:p xmlns:a="http://schemas.openxmlformats.org/drawingml/2006/main">
-            <a:r>
-              <a:t/>
-            </a:r>
-          </a:p>
-          <a:p xmlns:a="http://schemas.openxmlformats.org/drawingml/2006/main">
-            <a:r>
-              <a:t>[Timing]</a:t>
-            </a:r>
-          </a:p>
-          <a:p xmlns:a="http://schemas.openxmlformats.org/drawingml/2006/main">
-            <a:r>
-              <a:t>2.5 minutes</a:t>
             </a:r>
           </a:p>
           <a:p xmlns:a="http://schemas.openxmlformats.org/drawingml/2006/main">
@@ -2775,22 +3775,77 @@
           <a:lstStyle xmlns:a="http://schemas.openxmlformats.org/drawingml/2006/main"/>
           <a:p xmlns:a="http://schemas.openxmlformats.org/drawingml/2006/main">
             <a:r>
+              <a:t>[Timing]</a:t>
+            </a:r>
+          </a:p>
+          <a:p xmlns:a="http://schemas.openxmlformats.org/drawingml/2006/main">
+            <a:r>
+              <a:t>1.5 minutes</a:t>
+            </a:r>
+          </a:p>
+          <a:p xmlns:a="http://schemas.openxmlformats.org/drawingml/2006/main">
+            <a:r>
+              <a:t/>
+            </a:r>
+          </a:p>
+          <a:p xmlns:a="http://schemas.openxmlformats.org/drawingml/2006/main">
+            <a:r>
+              <a:t>[Slot pacing]</a:t>
+            </a:r>
+          </a:p>
+          <a:p xmlns:a="http://schemas.openxmlformats.org/drawingml/2006/main">
+            <a:r>
+              <a:t>40/45-minute slot: 04:00–05:30 (1.5 minutes core).</a:t>
+            </a:r>
+          </a:p>
+          <a:p xmlns:a="http://schemas.openxmlformats.org/drawingml/2006/main">
+            <a:r>
+              <a:t>Confirmed 50-minute slot: 05:00–06:30 (1.5 minutes).</a:t>
+            </a:r>
+          </a:p>
+          <a:p xmlns:a="http://schemas.openxmlformats.org/drawingml/2006/main">
+            <a:r>
+              <a:t>Budgets include transitions and brief clarifications. These are rehearsal targets, not automatic slide advances.</a:t>
+            </a:r>
+          </a:p>
+          <a:p xmlns:a="http://schemas.openxmlformats.org/drawingml/2006/main">
+            <a:r>
+              <a:t/>
+            </a:r>
+          </a:p>
+          <a:p xmlns:a="http://schemas.openxmlformats.org/drawingml/2006/main">
+            <a:r>
+              <a:t>[Core delivery]</a:t>
+            </a:r>
+          </a:p>
+          <a:p xmlns:a="http://schemas.openxmlformats.org/drawingml/2006/main">
+            <a:r>
+              <a:t>Follow the observation pipeline from rendered terminal state to a candidate frame and guarded delivery. Explain why raw escape codes and terminal redraws are not safe message boundaries.</a:t>
+            </a:r>
+          </a:p>
+          <a:p xmlns:a="http://schemas.openxmlformats.org/drawingml/2006/main">
+            <a:r>
+              <a:t/>
+            </a:r>
+          </a:p>
+          <a:p xmlns:a="http://schemas.openxmlformats.org/drawingml/2006/main">
+            <a:r>
+              <a:t>[Technical reference and source notes]</a:t>
+            </a:r>
+          </a:p>
+          <a:p xmlns:a="http://schemas.openxmlformats.org/drawingml/2006/main">
+            <a:r>
+              <a:t>Use for rehearsal and Q&amp;A; do not read all reference detail aloud. The core-delivery cue above sets the live scope.</a:t>
+            </a:r>
+          </a:p>
+          <a:p xmlns:a="http://schemas.openxmlformats.org/drawingml/2006/main">
+            <a:r>
+              <a:t/>
+            </a:r>
+          </a:p>
+          <a:p xmlns:a="http://schemas.openxmlformats.org/drawingml/2006/main">
+            <a:r>
               <a:t>SLIDE 4 — Observe the terminal state, not escape-filled output</a:t>
-            </a:r>
-          </a:p>
-          <a:p xmlns:a="http://schemas.openxmlformats.org/drawingml/2006/main">
-            <a:r>
-              <a:t/>
-            </a:r>
-          </a:p>
-          <a:p xmlns:a="http://schemas.openxmlformats.org/drawingml/2006/main">
-            <a:r>
-              <a:t>[Timing]</a:t>
-            </a:r>
-          </a:p>
-          <a:p xmlns:a="http://schemas.openxmlformats.org/drawingml/2006/main">
-            <a:r>
-              <a:t>1.5 minutes</a:t>
             </a:r>
           </a:p>
           <a:p xmlns:a="http://schemas.openxmlformats.org/drawingml/2006/main">
@@ -2955,22 +4010,77 @@
           <a:lstStyle xmlns:a="http://schemas.openxmlformats.org/drawingml/2006/main"/>
           <a:p xmlns:a="http://schemas.openxmlformats.org/drawingml/2006/main">
             <a:r>
+              <a:t>[Timing]</a:t>
+            </a:r>
+          </a:p>
+          <a:p xmlns:a="http://schemas.openxmlformats.org/drawingml/2006/main">
+            <a:r>
+              <a:t>2.5 minutes</a:t>
+            </a:r>
+          </a:p>
+          <a:p xmlns:a="http://schemas.openxmlformats.org/drawingml/2006/main">
+            <a:r>
+              <a:t/>
+            </a:r>
+          </a:p>
+          <a:p xmlns:a="http://schemas.openxmlformats.org/drawingml/2006/main">
+            <a:r>
+              <a:t>[Slot pacing]</a:t>
+            </a:r>
+          </a:p>
+          <a:p xmlns:a="http://schemas.openxmlformats.org/drawingml/2006/main">
+            <a:r>
+              <a:t>40/45-minute slot: 05:30–08:00 (2.5 minutes core).</a:t>
+            </a:r>
+          </a:p>
+          <a:p xmlns:a="http://schemas.openxmlformats.org/drawingml/2006/main">
+            <a:r>
+              <a:t>Confirmed 50-minute slot: 06:30–09:00 (2.5 minutes).</a:t>
+            </a:r>
+          </a:p>
+          <a:p xmlns:a="http://schemas.openxmlformats.org/drawingml/2006/main">
+            <a:r>
+              <a:t>Budgets include transitions and brief clarifications. These are rehearsal targets, not automatic slide advances.</a:t>
+            </a:r>
+          </a:p>
+          <a:p xmlns:a="http://schemas.openxmlformats.org/drawingml/2006/main">
+            <a:r>
+              <a:t/>
+            </a:r>
+          </a:p>
+          <a:p xmlns:a="http://schemas.openxmlformats.org/drawingml/2006/main">
+            <a:r>
+              <a:t>[Core delivery]</a:t>
+            </a:r>
+          </a:p>
+          <a:p xmlns:a="http://schemas.openxmlformats.org/drawingml/2006/main">
+            <a:r>
+              <a:t>Read one annotated frame: intent, destination, session-bound capability, content and matching END. Explain authority separately from correctness; the capability is not a judgment that the task is safe.</a:t>
+            </a:r>
+          </a:p>
+          <a:p xmlns:a="http://schemas.openxmlformats.org/drawingml/2006/main">
+            <a:r>
+              <a:t/>
+            </a:r>
+          </a:p>
+          <a:p xmlns:a="http://schemas.openxmlformats.org/drawingml/2006/main">
+            <a:r>
+              <a:t>[Technical reference and source notes]</a:t>
+            </a:r>
+          </a:p>
+          <a:p xmlns:a="http://schemas.openxmlformats.org/drawingml/2006/main">
+            <a:r>
+              <a:t>Use for rehearsal and Q&amp;A; do not read all reference detail aloud. The core-delivery cue above sets the live scope.</a:t>
+            </a:r>
+          </a:p>
+          <a:p xmlns:a="http://schemas.openxmlformats.org/drawingml/2006/main">
+            <a:r>
+              <a:t/>
+            </a:r>
+          </a:p>
+          <a:p xmlns:a="http://schemas.openxmlformats.org/drawingml/2006/main">
+            <a:r>
               <a:t>SLIDE 5 — The frame carries intent; Commander supplies identity</a:t>
-            </a:r>
-          </a:p>
-          <a:p xmlns:a="http://schemas.openxmlformats.org/drawingml/2006/main">
-            <a:r>
-              <a:t/>
-            </a:r>
-          </a:p>
-          <a:p xmlns:a="http://schemas.openxmlformats.org/drawingml/2006/main">
-            <a:r>
-              <a:t>[Timing]</a:t>
-            </a:r>
-          </a:p>
-          <a:p xmlns:a="http://schemas.openxmlformats.org/drawingml/2006/main">
-            <a:r>
-              <a:t>3 minutes (03:00)</a:t>
             </a:r>
           </a:p>
           <a:p xmlns:a="http://schemas.openxmlformats.org/drawingml/2006/main">
@@ -3140,22 +4250,92 @@
           <a:lstStyle xmlns:a="http://schemas.openxmlformats.org/drawingml/2006/main"/>
           <a:p xmlns:a="http://schemas.openxmlformats.org/drawingml/2006/main">
             <a:r>
+              <a:t>[Timing]</a:t>
+            </a:r>
+          </a:p>
+          <a:p xmlns:a="http://schemas.openxmlformats.org/drawingml/2006/main">
+            <a:r>
+              <a:t>1.5 minutes</a:t>
+            </a:r>
+          </a:p>
+          <a:p xmlns:a="http://schemas.openxmlformats.org/drawingml/2006/main">
+            <a:r>
+              <a:t/>
+            </a:r>
+          </a:p>
+          <a:p xmlns:a="http://schemas.openxmlformats.org/drawingml/2006/main">
+            <a:r>
+              <a:t>[Slot pacing]</a:t>
+            </a:r>
+          </a:p>
+          <a:p xmlns:a="http://schemas.openxmlformats.org/drawingml/2006/main">
+            <a:r>
+              <a:t>40/45-minute slot: 08:00–09:30 (1.5 minutes core).</a:t>
+            </a:r>
+          </a:p>
+          <a:p xmlns:a="http://schemas.openxmlformats.org/drawingml/2006/main">
+            <a:r>
+              <a:t>Confirmed 50-minute slot: 09:00–11:00 (2 minutes, including 0.5 minutes optional depth).</a:t>
+            </a:r>
+          </a:p>
+          <a:p xmlns:a="http://schemas.openxmlformats.org/drawingml/2006/main">
+            <a:r>
+              <a:t>Budgets include transitions and brief clarifications. These are rehearsal targets, not automatic slide advances.</a:t>
+            </a:r>
+          </a:p>
+          <a:p xmlns:a="http://schemas.openxmlformats.org/drawingml/2006/main">
+            <a:r>
+              <a:t/>
+            </a:r>
+          </a:p>
+          <a:p xmlns:a="http://schemas.openxmlformats.org/drawingml/2006/main">
+            <a:r>
+              <a:t>[Core delivery]</a:t>
+            </a:r>
+          </a:p>
+          <a:p xmlns:a="http://schemas.openxmlformats.org/drawingml/2006/main">
+            <a:r>
+              <a:t>Show the parser waiting for a matching END before emission. Cover fragmented output and bounded state with one transition, leaving edge cases in the reference notes.</a:t>
+            </a:r>
+          </a:p>
+          <a:p xmlns:a="http://schemas.openxmlformats.org/drawingml/2006/main">
+            <a:r>
+              <a:t/>
+            </a:r>
+          </a:p>
+          <a:p xmlns:a="http://schemas.openxmlformats.org/drawingml/2006/main">
+            <a:r>
+              <a:t>[Optional — confirmed 50-minute slot only]</a:t>
+            </a:r>
+          </a:p>
+          <a:p xmlns:a="http://schemas.openxmlformats.org/drawingml/2006/main">
+            <a:r>
+              <a:t>Add 30 seconds on one incomplete-frame transition and the matching END condition. Skip if behind schedule; preserve Q&amp;A.</a:t>
+            </a:r>
+          </a:p>
+          <a:p xmlns:a="http://schemas.openxmlformats.org/drawingml/2006/main">
+            <a:r>
+              <a:t/>
+            </a:r>
+          </a:p>
+          <a:p xmlns:a="http://schemas.openxmlformats.org/drawingml/2006/main">
+            <a:r>
+              <a:t>[Technical reference and source notes]</a:t>
+            </a:r>
+          </a:p>
+          <a:p xmlns:a="http://schemas.openxmlformats.org/drawingml/2006/main">
+            <a:r>
+              <a:t>Use for rehearsal and Q&amp;A; do not read all reference detail aloud. The core-delivery cue above sets the live scope.</a:t>
+            </a:r>
+          </a:p>
+          <a:p xmlns:a="http://schemas.openxmlformats.org/drawingml/2006/main">
+            <a:r>
+              <a:t/>
+            </a:r>
+          </a:p>
+          <a:p xmlns:a="http://schemas.openxmlformats.org/drawingml/2006/main">
+            <a:r>
               <a:t>SLIDE 6 — A small streaming state machine reconstructs a frame</a:t>
-            </a:r>
-          </a:p>
-          <a:p xmlns:a="http://schemas.openxmlformats.org/drawingml/2006/main">
-            <a:r>
-              <a:t/>
-            </a:r>
-          </a:p>
-          <a:p xmlns:a="http://schemas.openxmlformats.org/drawingml/2006/main">
-            <a:r>
-              <a:t>[Timing]</a:t>
-            </a:r>
-          </a:p>
-          <a:p xmlns:a="http://schemas.openxmlformats.org/drawingml/2006/main">
-            <a:r>
-              <a:t>2 minutes (02:00)</a:t>
             </a:r>
           </a:p>
           <a:p xmlns:a="http://schemas.openxmlformats.org/drawingml/2006/main">
@@ -3315,22 +4495,77 @@
           <a:lstStyle xmlns:a="http://schemas.openxmlformats.org/drawingml/2006/main"/>
           <a:p xmlns:a="http://schemas.openxmlformats.org/drawingml/2006/main">
             <a:r>
+              <a:t>[Timing]</a:t>
+            </a:r>
+          </a:p>
+          <a:p xmlns:a="http://schemas.openxmlformats.org/drawingml/2006/main">
+            <a:r>
+              <a:t>1 minutes</a:t>
+            </a:r>
+          </a:p>
+          <a:p xmlns:a="http://schemas.openxmlformats.org/drawingml/2006/main">
+            <a:r>
+              <a:t/>
+            </a:r>
+          </a:p>
+          <a:p xmlns:a="http://schemas.openxmlformats.org/drawingml/2006/main">
+            <a:r>
+              <a:t>[Slot pacing]</a:t>
+            </a:r>
+          </a:p>
+          <a:p xmlns:a="http://schemas.openxmlformats.org/drawingml/2006/main">
+            <a:r>
+              <a:t>40/45-minute slot: 09:30–10:30 (1 minutes core).</a:t>
+            </a:r>
+          </a:p>
+          <a:p xmlns:a="http://schemas.openxmlformats.org/drawingml/2006/main">
+            <a:r>
+              <a:t>Confirmed 50-minute slot: 11:00–12:00 (1 minutes).</a:t>
+            </a:r>
+          </a:p>
+          <a:p xmlns:a="http://schemas.openxmlformats.org/drawingml/2006/main">
+            <a:r>
+              <a:t>Budgets include transitions and brief clarifications. These are rehearsal targets, not automatic slide advances.</a:t>
+            </a:r>
+          </a:p>
+          <a:p xmlns:a="http://schemas.openxmlformats.org/drawingml/2006/main">
+            <a:r>
+              <a:t/>
+            </a:r>
+          </a:p>
+          <a:p xmlns:a="http://schemas.openxmlformats.org/drawingml/2006/main">
+            <a:r>
+              <a:t>[Core delivery]</a:t>
+            </a:r>
+          </a:p>
+          <a:p xmlns:a="http://schemas.openxmlformats.org/drawingml/2006/main">
+            <a:r>
+              <a:t>Group the five verbs by effect: SEND/REPLY/BROADCAST route work, STATUS/QUERY report locally. Use the graph rather than reading five definitions.</a:t>
+            </a:r>
+          </a:p>
+          <a:p xmlns:a="http://schemas.openxmlformats.org/drawingml/2006/main">
+            <a:r>
+              <a:t/>
+            </a:r>
+          </a:p>
+          <a:p xmlns:a="http://schemas.openxmlformats.org/drawingml/2006/main">
+            <a:r>
+              <a:t>[Technical reference and source notes]</a:t>
+            </a:r>
+          </a:p>
+          <a:p xmlns:a="http://schemas.openxmlformats.org/drawingml/2006/main">
+            <a:r>
+              <a:t>Use for rehearsal and Q&amp;A; do not read all reference detail aloud. The core-delivery cue above sets the live scope.</a:t>
+            </a:r>
+          </a:p>
+          <a:p xmlns:a="http://schemas.openxmlformats.org/drawingml/2006/main">
+            <a:r>
+              <a:t/>
+            </a:r>
+          </a:p>
+          <a:p xmlns:a="http://schemas.openxmlformats.org/drawingml/2006/main">
+            <a:r>
               <a:t>SLIDE 7 — Five verbs, three different kinds of effect</a:t>
-            </a:r>
-          </a:p>
-          <a:p xmlns:a="http://schemas.openxmlformats.org/drawingml/2006/main">
-            <a:r>
-              <a:t/>
-            </a:r>
-          </a:p>
-          <a:p xmlns:a="http://schemas.openxmlformats.org/drawingml/2006/main">
-            <a:r>
-              <a:t>[Timing]</a:t>
-            </a:r>
-          </a:p>
-          <a:p xmlns:a="http://schemas.openxmlformats.org/drawingml/2006/main">
-            <a:r>
-              <a:t>1.5 minutes</a:t>
             </a:r>
           </a:p>
           <a:p xmlns:a="http://schemas.openxmlformats.org/drawingml/2006/main">
@@ -3495,22 +4730,92 @@
           <a:lstStyle xmlns:a="http://schemas.openxmlformats.org/drawingml/2006/main"/>
           <a:p xmlns:a="http://schemas.openxmlformats.org/drawingml/2006/main">
             <a:r>
+              <a:t>[Timing]</a:t>
+            </a:r>
+          </a:p>
+          <a:p xmlns:a="http://schemas.openxmlformats.org/drawingml/2006/main">
+            <a:r>
+              <a:t>2.5 minutes</a:t>
+            </a:r>
+          </a:p>
+          <a:p xmlns:a="http://schemas.openxmlformats.org/drawingml/2006/main">
+            <a:r>
+              <a:t/>
+            </a:r>
+          </a:p>
+          <a:p xmlns:a="http://schemas.openxmlformats.org/drawingml/2006/main">
+            <a:r>
+              <a:t>[Slot pacing]</a:t>
+            </a:r>
+          </a:p>
+          <a:p xmlns:a="http://schemas.openxmlformats.org/drawingml/2006/main">
+            <a:r>
+              <a:t>40/45-minute slot: 10:30–13:00 (2.5 minutes core).</a:t>
+            </a:r>
+          </a:p>
+          <a:p xmlns:a="http://schemas.openxmlformats.org/drawingml/2006/main">
+            <a:r>
+              <a:t>Confirmed 50-minute slot: 12:00–15:00 (3 minutes, including 0.5 minutes optional depth).</a:t>
+            </a:r>
+          </a:p>
+          <a:p xmlns:a="http://schemas.openxmlformats.org/drawingml/2006/main">
+            <a:r>
+              <a:t>Budgets include transitions and brief clarifications. These are rehearsal targets, not automatic slide advances.</a:t>
+            </a:r>
+          </a:p>
+          <a:p xmlns:a="http://schemas.openxmlformats.org/drawingml/2006/main">
+            <a:r>
+              <a:t/>
+            </a:r>
+          </a:p>
+          <a:p xmlns:a="http://schemas.openxmlformats.org/drawingml/2006/main">
+            <a:r>
+              <a:t>[Core delivery]</a:t>
+            </a:r>
+          </a:p>
+          <a:p xmlns:a="http://schemas.openxmlformats.org/drawingml/2006/main">
+            <a:r>
+              <a:t>Trace SEND, input-delivery ACK and the later semantic REPLY. Emphasize that successful terminal submission is not task completion, and point to the same thread with distinct message IDs.</a:t>
+            </a:r>
+          </a:p>
+          <a:p xmlns:a="http://schemas.openxmlformats.org/drawingml/2006/main">
+            <a:r>
+              <a:t/>
+            </a:r>
+          </a:p>
+          <a:p xmlns:a="http://schemas.openxmlformats.org/drawingml/2006/main">
+            <a:r>
+              <a:t>[Optional — confirmed 50-minute slot only]</a:t>
+            </a:r>
+          </a:p>
+          <a:p xmlns:a="http://schemas.openxmlformats.org/drawingml/2006/main">
+            <a:r>
+              <a:t>Add 30 seconds contrasting the delivery acknowledgement with the agent's later answer; keep the existing sequence diagram. Skip if behind schedule; preserve Q&amp;A.</a:t>
+            </a:r>
+          </a:p>
+          <a:p xmlns:a="http://schemas.openxmlformats.org/drawingml/2006/main">
+            <a:r>
+              <a:t/>
+            </a:r>
+          </a:p>
+          <a:p xmlns:a="http://schemas.openxmlformats.org/drawingml/2006/main">
+            <a:r>
+              <a:t>[Technical reference and source notes]</a:t>
+            </a:r>
+          </a:p>
+          <a:p xmlns:a="http://schemas.openxmlformats.org/drawingml/2006/main">
+            <a:r>
+              <a:t>Use for rehearsal and Q&amp;A; do not read all reference detail aloud. The core-delivery cue above sets the live scope.</a:t>
+            </a:r>
+          </a:p>
+          <a:p xmlns:a="http://schemas.openxmlformats.org/drawingml/2006/main">
+            <a:r>
+              <a:t/>
+            </a:r>
+          </a:p>
+          <a:p xmlns:a="http://schemas.openxmlformats.org/drawingml/2006/main">
+            <a:r>
               <a:t>SLIDE 8 — SEND → delivery ACK → REPLY is not a completion handshake</a:t>
-            </a:r>
-          </a:p>
-          <a:p xmlns:a="http://schemas.openxmlformats.org/drawingml/2006/main">
-            <a:r>
-              <a:t/>
-            </a:r>
-          </a:p>
-          <a:p xmlns:a="http://schemas.openxmlformats.org/drawingml/2006/main">
-            <a:r>
-              <a:t>[Timing]</a:t>
-            </a:r>
-          </a:p>
-          <a:p xmlns:a="http://schemas.openxmlformats.org/drawingml/2006/main">
-            <a:r>
-              <a:t>3 minutes (03:00)</a:t>
             </a:r>
           </a:p>
           <a:p xmlns:a="http://schemas.openxmlformats.org/drawingml/2006/main">
@@ -3680,22 +4985,77 @@
           <a:lstStyle xmlns:a="http://schemas.openxmlformats.org/drawingml/2006/main"/>
           <a:p xmlns:a="http://schemas.openxmlformats.org/drawingml/2006/main">
             <a:r>
+              <a:t>[Timing]</a:t>
+            </a:r>
+          </a:p>
+          <a:p xmlns:a="http://schemas.openxmlformats.org/drawingml/2006/main">
+            <a:r>
+              <a:t>1.5 minutes</a:t>
+            </a:r>
+          </a:p>
+          <a:p xmlns:a="http://schemas.openxmlformats.org/drawingml/2006/main">
+            <a:r>
+              <a:t/>
+            </a:r>
+          </a:p>
+          <a:p xmlns:a="http://schemas.openxmlformats.org/drawingml/2006/main">
+            <a:r>
+              <a:t>[Slot pacing]</a:t>
+            </a:r>
+          </a:p>
+          <a:p xmlns:a="http://schemas.openxmlformats.org/drawingml/2006/main">
+            <a:r>
+              <a:t>40/45-minute slot: 13:00–14:30 (1.5 minutes core).</a:t>
+            </a:r>
+          </a:p>
+          <a:p xmlns:a="http://schemas.openxmlformats.org/drawingml/2006/main">
+            <a:r>
+              <a:t>Confirmed 50-minute slot: 15:00–16:30 (1.5 minutes).</a:t>
+            </a:r>
+          </a:p>
+          <a:p xmlns:a="http://schemas.openxmlformats.org/drawingml/2006/main">
+            <a:r>
+              <a:t>Budgets include transitions and brief clarifications. These are rehearsal targets, not automatic slide advances.</a:t>
+            </a:r>
+          </a:p>
+          <a:p xmlns:a="http://schemas.openxmlformats.org/drawingml/2006/main">
+            <a:r>
+              <a:t/>
+            </a:r>
+          </a:p>
+          <a:p xmlns:a="http://schemas.openxmlformats.org/drawingml/2006/main">
+            <a:r>
+              <a:t>[Core delivery]</a:t>
+            </a:r>
+          </a:p>
+          <a:p xmlns:a="http://schemas.openxmlformats.org/drawingml/2006/main">
+            <a:r>
+              <a:t>Separate stable panel address, running session identity and routed-message identity. Use a same-profile restart to explain why queued work cannot silently reach the replacement session.</a:t>
+            </a:r>
+          </a:p>
+          <a:p xmlns:a="http://schemas.openxmlformats.org/drawingml/2006/main">
+            <a:r>
+              <a:t/>
+            </a:r>
+          </a:p>
+          <a:p xmlns:a="http://schemas.openxmlformats.org/drawingml/2006/main">
+            <a:r>
+              <a:t>[Technical reference and source notes]</a:t>
+            </a:r>
+          </a:p>
+          <a:p xmlns:a="http://schemas.openxmlformats.org/drawingml/2006/main">
+            <a:r>
+              <a:t>Use for rehearsal and Q&amp;A; do not read all reference detail aloud. The core-delivery cue above sets the live scope.</a:t>
+            </a:r>
+          </a:p>
+          <a:p xmlns:a="http://schemas.openxmlformats.org/drawingml/2006/main">
+            <a:r>
+              <a:t/>
+            </a:r>
+          </a:p>
+          <a:p xmlns:a="http://schemas.openxmlformats.org/drawingml/2006/main">
+            <a:r>
               <a:t>SLIDE 9 — A panel address is stable; its agent session can change</a:t>
-            </a:r>
-          </a:p>
-          <a:p xmlns:a="http://schemas.openxmlformats.org/drawingml/2006/main">
-            <a:r>
-              <a:t/>
-            </a:r>
-          </a:p>
-          <a:p xmlns:a="http://schemas.openxmlformats.org/drawingml/2006/main">
-            <a:r>
-              <a:t>[Timing]</a:t>
-            </a:r>
-          </a:p>
-          <a:p xmlns:a="http://schemas.openxmlformats.org/drawingml/2006/main">
-            <a:r>
-              <a:t>2 minutes (02:00)</a:t>
             </a:r>
           </a:p>
           <a:p xmlns:a="http://schemas.openxmlformats.org/drawingml/2006/main">
@@ -6756,17 +8116,17 @@
   </p:cSld>
   <p:clrMap bg1="lt1" tx1="dk1" bg2="lt2" tx2="dk2" accent1="accent1" accent2="accent2" accent3="accent3" accent4="accent4" accent5="accent5" accent6="accent6" hlink="hlink" folHlink="folHlink"/>
   <p:sldLayoutIdLst>
-    <p:sldLayoutId xmlns:r="http://schemas.openxmlformats.org/officeDocument/2006/relationships" id="2147483649" r:id="R2c1cabd33cf7464a"/>
-    <p:sldLayoutId xmlns:r="http://schemas.openxmlformats.org/officeDocument/2006/relationships" id="2147483650" r:id="R54302499837a4bfc"/>
-    <p:sldLayoutId xmlns:r="http://schemas.openxmlformats.org/officeDocument/2006/relationships" id="2147483651" r:id="R453de4b827dd4e28"/>
-    <p:sldLayoutId xmlns:r="http://schemas.openxmlformats.org/officeDocument/2006/relationships" id="2147483652" r:id="Rd0b1bf2a1ecc423d"/>
-    <p:sldLayoutId xmlns:r="http://schemas.openxmlformats.org/officeDocument/2006/relationships" id="2147483653" r:id="Rd4f50fa0fa434899"/>
-    <p:sldLayoutId xmlns:r="http://schemas.openxmlformats.org/officeDocument/2006/relationships" id="2147483654" r:id="R74ca56b5c74f40c3"/>
-    <p:sldLayoutId xmlns:r="http://schemas.openxmlformats.org/officeDocument/2006/relationships" id="2147483655" r:id="R6ccbcfb2a66b4bac"/>
-    <p:sldLayoutId xmlns:r="http://schemas.openxmlformats.org/officeDocument/2006/relationships" id="2147483656" r:id="R8a5010908a0145a0"/>
-    <p:sldLayoutId xmlns:r="http://schemas.openxmlformats.org/officeDocument/2006/relationships" id="2147483657" r:id="R09e688fe4053436b"/>
-    <p:sldLayoutId xmlns:r="http://schemas.openxmlformats.org/officeDocument/2006/relationships" id="2147483658" r:id="R56316ed1130a460c"/>
-    <p:sldLayoutId xmlns:r="http://schemas.openxmlformats.org/officeDocument/2006/relationships" id="2147483659" r:id="R0d6dae78a984410a"/>
+    <p:sldLayoutId xmlns:r="http://schemas.openxmlformats.org/officeDocument/2006/relationships" id="2147483649" r:id="R6aa1f5a9088f4a8d"/>
+    <p:sldLayoutId xmlns:r="http://schemas.openxmlformats.org/officeDocument/2006/relationships" id="2147483650" r:id="Rc90c728f08d5422f"/>
+    <p:sldLayoutId xmlns:r="http://schemas.openxmlformats.org/officeDocument/2006/relationships" id="2147483651" r:id="Rb2641fb2032b4604"/>
+    <p:sldLayoutId xmlns:r="http://schemas.openxmlformats.org/officeDocument/2006/relationships" id="2147483652" r:id="Re23953d4f18c44ad"/>
+    <p:sldLayoutId xmlns:r="http://schemas.openxmlformats.org/officeDocument/2006/relationships" id="2147483653" r:id="R88da4c17c4934394"/>
+    <p:sldLayoutId xmlns:r="http://schemas.openxmlformats.org/officeDocument/2006/relationships" id="2147483654" r:id="Ra689a3bbc511403a"/>
+    <p:sldLayoutId xmlns:r="http://schemas.openxmlformats.org/officeDocument/2006/relationships" id="2147483655" r:id="Re29ea043e377490b"/>
+    <p:sldLayoutId xmlns:r="http://schemas.openxmlformats.org/officeDocument/2006/relationships" id="2147483656" r:id="R0b2349180ebd40fa"/>
+    <p:sldLayoutId xmlns:r="http://schemas.openxmlformats.org/officeDocument/2006/relationships" id="2147483657" r:id="R9b234994e69f438a"/>
+    <p:sldLayoutId xmlns:r="http://schemas.openxmlformats.org/officeDocument/2006/relationships" id="2147483658" r:id="Rd594391db81445a6"/>
+    <p:sldLayoutId xmlns:r="http://schemas.openxmlformats.org/officeDocument/2006/relationships" id="2147483659" r:id="R28675b5d2f404a7d"/>
   </p:sldLayoutIdLst>
   <p:txStyles>
     <p:titleStyle>
@@ -7337,7 +8697,7 @@
           <p:nvPr/>
         </p:nvPicPr>
         <p:blipFill>
-          <a:blip xmlns:r="http://schemas.openxmlformats.org/officeDocument/2006/relationships" xmlns:a="http://schemas.openxmlformats.org/drawingml/2006/main" r:embed="R49eb5c7346a54aac"/>
+          <a:blip xmlns:r="http://schemas.openxmlformats.org/officeDocument/2006/relationships" xmlns:a="http://schemas.openxmlformats.org/drawingml/2006/main" r:embed="Rdd8ab4eb0fbe4d70"/>
           <a:stretch xmlns:a="http://schemas.openxmlformats.org/drawingml/2006/main"/>
         </p:blipFill>
         <p:spPr>
@@ -7634,7 +8994,7 @@
           <p:nvPr/>
         </p:nvPicPr>
         <p:blipFill>
-          <a:blip xmlns:r="http://schemas.openxmlformats.org/officeDocument/2006/relationships" xmlns:a="http://schemas.openxmlformats.org/drawingml/2006/main" r:embed="R5e20979b327a49e0"/>
+          <a:blip xmlns:r="http://schemas.openxmlformats.org/officeDocument/2006/relationships" xmlns:a="http://schemas.openxmlformats.org/drawingml/2006/main" r:embed="R86178c23a91a465b"/>
           <a:stretch xmlns:a="http://schemas.openxmlformats.org/drawingml/2006/main"/>
         </p:blipFill>
         <p:spPr>
@@ -11493,7 +12853,7 @@
           <p:nvPr/>
         </p:nvPicPr>
         <p:blipFill>
-          <a:blip xmlns:r="http://schemas.openxmlformats.org/officeDocument/2006/relationships" xmlns:a="http://schemas.openxmlformats.org/drawingml/2006/main" r:embed="R0a552408055f48eb"/>
+          <a:blip xmlns:r="http://schemas.openxmlformats.org/officeDocument/2006/relationships" xmlns:a="http://schemas.openxmlformats.org/drawingml/2006/main" r:embed="R402ba8b8fb8d4072"/>
           <a:stretch xmlns:a="http://schemas.openxmlformats.org/drawingml/2006/main"/>
         </p:blipFill>
         <p:spPr>
@@ -13887,7 +15247,7 @@
           <p:nvPr/>
         </p:nvPicPr>
         <p:blipFill>
-          <a:blip xmlns:r="http://schemas.openxmlformats.org/officeDocument/2006/relationships" xmlns:a="http://schemas.openxmlformats.org/drawingml/2006/main" r:embed="R92cdf7657387410d"/>
+          <a:blip xmlns:r="http://schemas.openxmlformats.org/officeDocument/2006/relationships" xmlns:a="http://schemas.openxmlformats.org/drawingml/2006/main" r:embed="R97e7b08d01ce44cb"/>
           <a:stretch xmlns:a="http://schemas.openxmlformats.org/drawingml/2006/main"/>
         </p:blipFill>
         <p:spPr>
@@ -14296,7 +15656,7 @@
           <p:nvPr/>
         </p:nvPicPr>
         <p:blipFill>
-          <a:blip xmlns:r="http://schemas.openxmlformats.org/officeDocument/2006/relationships" xmlns:a="http://schemas.openxmlformats.org/drawingml/2006/main" r:embed="R505ba91ddb414331"/>
+          <a:blip xmlns:r="http://schemas.openxmlformats.org/officeDocument/2006/relationships" xmlns:a="http://schemas.openxmlformats.org/drawingml/2006/main" r:embed="Rab900fccecaf4fca"/>
           <a:stretch xmlns:a="http://schemas.openxmlformats.org/drawingml/2006/main"/>
         </p:blipFill>
         <p:spPr>
@@ -17114,7 +18474,7 @@
           <p:nvPr/>
         </p:nvPicPr>
         <p:blipFill>
-          <a:blip xmlns:r="http://schemas.openxmlformats.org/officeDocument/2006/relationships" xmlns:a="http://schemas.openxmlformats.org/drawingml/2006/main" r:embed="R9485c71ef5c7448c"/>
+          <a:blip xmlns:r="http://schemas.openxmlformats.org/officeDocument/2006/relationships" xmlns:a="http://schemas.openxmlformats.org/drawingml/2006/main" r:embed="R1567f00e50324125"/>
           <a:stretch xmlns:a="http://schemas.openxmlformats.org/drawingml/2006/main"/>
         </p:blipFill>
         <p:spPr>
@@ -17546,7 +18906,7 @@
           <p:nvPr/>
         </p:nvPicPr>
         <p:blipFill>
-          <a:blip xmlns:r="http://schemas.openxmlformats.org/officeDocument/2006/relationships" xmlns:a="http://schemas.openxmlformats.org/drawingml/2006/main" r:embed="R3531baf9d6384d67"/>
+          <a:blip xmlns:r="http://schemas.openxmlformats.org/officeDocument/2006/relationships" xmlns:a="http://schemas.openxmlformats.org/drawingml/2006/main" r:embed="R8abf9f13ad644ace"/>
           <a:stretch xmlns:a="http://schemas.openxmlformats.org/drawingml/2006/main"/>
         </p:blipFill>
         <p:spPr>
@@ -17775,7 +19135,7 @@
                 <a:latin typeface="Consolas"/>
                 <a:ea typeface="Consolas"/>
                 <a:cs typeface="Consolas"/>
-                <a:hlinkClick xmlns:r="http://schemas.openxmlformats.org/officeDocument/2006/relationships" r:id="R68a19983b6144947"/>
+                <a:hlinkClick xmlns:r="http://schemas.openxmlformats.org/officeDocument/2006/relationships" r:id="R2907a8687a9a46f1"/>
               </a:rPr>
               <a:t>agent.sh/tickets</a:t>
             </a:r>
@@ -17967,7 +19327,7 @@
           <p:nvPr/>
         </p:nvPicPr>
         <p:blipFill>
-          <a:blip xmlns:r="http://schemas.openxmlformats.org/officeDocument/2006/relationships" xmlns:a="http://schemas.openxmlformats.org/drawingml/2006/main" r:embed="R3f560e4a3b904cfa"/>
+          <a:blip xmlns:r="http://schemas.openxmlformats.org/officeDocument/2006/relationships" xmlns:a="http://schemas.openxmlformats.org/drawingml/2006/main" r:embed="Rd3b2382fede44b32"/>
           <a:stretch xmlns:a="http://schemas.openxmlformats.org/drawingml/2006/main"/>
         </p:blipFill>
         <p:spPr>
@@ -18150,7 +19510,7 @@
           <p:nvPr/>
         </p:nvPicPr>
         <p:blipFill>
-          <a:blip xmlns:r="http://schemas.openxmlformats.org/officeDocument/2006/relationships" xmlns:a="http://schemas.openxmlformats.org/drawingml/2006/main" r:embed="Rc1a11db87cca4759"/>
+          <a:blip xmlns:r="http://schemas.openxmlformats.org/officeDocument/2006/relationships" xmlns:a="http://schemas.openxmlformats.org/drawingml/2006/main" r:embed="R0cabc25813594f22"/>
           <a:stretch xmlns:a="http://schemas.openxmlformats.org/drawingml/2006/main"/>
         </p:blipFill>
         <p:spPr>
@@ -18615,7 +19975,7 @@
           <p:nvPr/>
         </p:nvPicPr>
         <p:blipFill>
-          <a:blip xmlns:r="http://schemas.openxmlformats.org/officeDocument/2006/relationships" xmlns:a="http://schemas.openxmlformats.org/drawingml/2006/main" r:embed="Rd18581a41d174a73"/>
+          <a:blip xmlns:r="http://schemas.openxmlformats.org/officeDocument/2006/relationships" xmlns:a="http://schemas.openxmlformats.org/drawingml/2006/main" r:embed="Rfa4c0357a5e94867"/>
           <a:stretch xmlns:a="http://schemas.openxmlformats.org/drawingml/2006/main"/>
         </p:blipFill>
         <p:spPr>

</xml_diff>